<commit_message>
Clase 5: regresion logistica para clasificar (¿que hogares tienen auto?)
Seccion nueva antes de la advertencia: la recta no sirve para un si o no
(predice 1,39 a 5 millones), la sigmoide con su leyenda, GLM binomial
ponderado (odds ratio 8,9 por millon), la curva leida en probabilidades y
la clasificacion con umbral 0,5: exactitud 70,5% contra 60,6% de la clase
mayoritaria, con la matriz de confusion via crosstab. El titulo de la
seccion de probabilidad queda sin el 'lo justo'. Deck en 38 slides,
notebook en 52 celdas.

Co-Authored-By: Claude Fable 5 <noreply@anthropic.com>
</commit_message>
<xml_diff>
--- a/presentaciones/clase05_probabilidad_inferencia.pptx
+++ b/presentaciones/clase05_probabilidad_inferencia.pptx
@@ -38,6 +38,11 @@
     <p:sldId id="286" r:id="rId37"/>
     <p:sldId id="287" r:id="rId38"/>
     <p:sldId id="288" r:id="rId39"/>
+    <p:sldId id="289" r:id="rId40"/>
+    <p:sldId id="290" r:id="rId41"/>
+    <p:sldId id="291" r:id="rId42"/>
+    <p:sldId id="292" r:id="rId43"/>
+    <p:sldId id="293" r:id="rId44"/>
   </p:sldIdLst>
   <p:sldSz cx="9144000" cy="5138928" type="screen4x3"/>
   <p:notesSz cx="6858000" cy="9144000"/>
@@ -6434,7 +6439,7 @@
                 </a:solidFill>
                 <a:latin typeface="Fira Sans"/>
               </a:rPr>
-              <a:t>La trampa de las comparaciones múltiples</a:t>
+              <a:t>¿Qué hogares tienen auto?</a:t>
             </a:r>
           </a:p>
           <a:p>
@@ -6445,7 +6450,7 @@
                 </a:solidFill>
                 <a:latin typeface="Fira Sans"/>
               </a:rPr>
-              <a:t>Qué pasa con el valor p cuando se prueba de todo</a:t>
+              <a:t>Explicar un sí o no (tiene auto) con el ingreso del hogar: la regresión logística, y con ella, clasificar</a:t>
             </a:r>
           </a:p>
         </p:txBody>
@@ -6541,14 +6546,14 @@
                 </a:solidFill>
                 <a:latin typeface="Fira Sans"/>
               </a:rPr>
-              <a:t>20 variables de puro ruido</a:t>
+              <a:t>La recta no sirve para un sí o no</a:t>
             </a:r>
           </a:p>
         </p:txBody>
       </p:sp>
       <p:pic>
         <p:nvPicPr>
-          <p:cNvPr id="4" name="Picture 3" descr="c5_14_comparaciones_multiples.png"/>
+          <p:cNvPr id="4" name="Picture 3" descr="c5_15_recta_vs_logistica.png"/>
           <p:cNvPicPr>
             <a:picLocks noChangeAspect="1"/>
           </p:cNvPicPr>
@@ -6562,8 +6567,8 @@
         </p:blipFill>
         <p:spPr>
           <a:xfrm>
-            <a:off x="759392" y="1143000"/>
-            <a:ext cx="7625215" cy="3154680"/>
+            <a:off x="1208992" y="1143000"/>
+            <a:ext cx="6726015" cy="3154680"/>
           </a:xfrm>
           <a:prstGeom prst="rect">
             <a:avLst/>
@@ -6599,7 +6604,7 @@
                 </a:solidFill>
                 <a:latin typeface="Fira Sans"/>
               </a:rPr>
-              <a:t>Números al azar, sin relación con nada, probados contra la duración por comuna: con 20 intentos y umbral 0,05 se espera una falsa alarma. Es lo que pasa al recorrer una matriz de correlación buscando la que dé.</a:t>
+              <a:t>Sobre un 0/1, la recta predice 1,39 a los 5 millones y valores negativos abajo: no respeta que la respuesta vive entre 0 y 1. La logística pasa la recta por una S y queda siempre en el rango.</a:t>
             </a:r>
           </a:p>
         </p:txBody>
@@ -6695,21 +6700,45 @@
                 </a:solidFill>
                 <a:latin typeface="Fira Sans"/>
               </a:rPr>
-              <a:t>Reglas para el EDA del proyecto</a:t>
-            </a:r>
-          </a:p>
-        </p:txBody>
-      </p:sp>
-      <p:sp>
-        <p:nvSpPr>
-          <p:cNvPr id="4" name="TextBox 3"/>
+              <a:t>La regresión logística</a:t>
+            </a:r>
+          </a:p>
+        </p:txBody>
+      </p:sp>
+      <p:pic>
+        <p:nvPicPr>
+          <p:cNvPr id="4" name="Picture 3" descr="c5_16_formula_logistica.png"/>
+          <p:cNvPicPr>
+            <a:picLocks noChangeAspect="1"/>
+          </p:cNvPicPr>
+          <p:nvPr/>
+        </p:nvPicPr>
+        <p:blipFill>
+          <a:blip r:embed="rId2"/>
+          <a:stretch>
+            <a:fillRect/>
+          </a:stretch>
+        </p:blipFill>
+        <p:spPr>
+          <a:xfrm>
+            <a:off x="699515" y="1262245"/>
+            <a:ext cx="7744968" cy="2916190"/>
+          </a:xfrm>
+          <a:prstGeom prst="rect">
+            <a:avLst/>
+          </a:prstGeom>
+        </p:spPr>
+      </p:pic>
+      <p:sp>
+        <p:nvSpPr>
+          <p:cNvPr id="5" name="TextBox 4"/>
           <p:cNvSpPr txBox="1"/>
           <p:nvPr/>
         </p:nvSpPr>
         <p:spPr>
           <a:xfrm>
-            <a:off x="704088" y="1353312"/>
-            <a:ext cx="7744968" cy="3300984"/>
+            <a:off x="704088" y="4434840"/>
+            <a:ext cx="7744968" cy="457200"/>
           </a:xfrm>
           <a:prstGeom prst="rect">
             <a:avLst/>
@@ -6722,115 +6751,14 @@
           </a:bodyPr>
           <a:lstStyle/>
           <a:p>
-            <a:pPr>
-              <a:lnSpc>
-                <a:spcPct val="112000"/>
-              </a:lnSpc>
-              <a:spcAft>
-                <a:spcPts val="900"/>
-              </a:spcAft>
-            </a:pPr>
-            <a:r>
-              <a:rPr sz="1800" b="1">
-                <a:solidFill>
-                  <a:srgbClr val="E0A437"/>
-                </a:solidFill>
-                <a:latin typeface="Fira Sans"/>
-              </a:rPr>
-              <a:t>▸ </a:t>
-            </a:r>
-            <a:r>
-              <a:rPr sz="1800" b="1">
-                <a:solidFill>
-                  <a:srgbClr val="1D3557"/>
-                </a:solidFill>
-                <a:latin typeface="Fira Sans"/>
-              </a:rPr>
-              <a:t>Reportar cuántas pruebas se hicieron; un hallazgo aislado entre muchos intentos merece desconfianza.</a:t>
-            </a:r>
-          </a:p>
-          <a:p>
-            <a:pPr>
-              <a:lnSpc>
-                <a:spcPct val="112000"/>
-              </a:lnSpc>
-              <a:spcAft>
-                <a:spcPts val="900"/>
-              </a:spcAft>
-            </a:pPr>
-            <a:r>
-              <a:rPr sz="1800" b="1">
-                <a:solidFill>
-                  <a:srgbClr val="E0A437"/>
-                </a:solidFill>
-                <a:latin typeface="Fira Sans"/>
-              </a:rPr>
-              <a:t>▸ </a:t>
-            </a:r>
-            <a:r>
-              <a:rPr sz="1800" b="0">
-                <a:solidFill>
-                  <a:srgbClr val="000000"/>
-                </a:solidFill>
-                <a:latin typeface="Fira Sans"/>
-              </a:rPr>
-              <a:t>La corrección más simple, Bonferroni: dividir el umbral por el número de pruebas (0,05 / 20 = 0,0025).</a:t>
-            </a:r>
-          </a:p>
-          <a:p>
-            <a:pPr>
-              <a:lnSpc>
-                <a:spcPct val="112000"/>
-              </a:lnSpc>
-              <a:spcAft>
-                <a:spcPts val="900"/>
-              </a:spcAft>
-            </a:pPr>
-            <a:r>
-              <a:rPr sz="1800" b="1">
-                <a:solidFill>
-                  <a:srgbClr val="E0A437"/>
-                </a:solidFill>
-                <a:latin typeface="Fira Sans"/>
-              </a:rPr>
-              <a:t>▸ </a:t>
-            </a:r>
-            <a:r>
-              <a:rPr sz="1800" b="0">
-                <a:solidFill>
-                  <a:srgbClr val="000000"/>
-                </a:solidFill>
-                <a:latin typeface="Fira Sans"/>
-              </a:rPr>
-              <a:t>Preferir el intervalo de confianza al valor p: muestra el tamaño del efecto y su precisión.</a:t>
-            </a:r>
-          </a:p>
-          <a:p>
-            <a:pPr>
-              <a:lnSpc>
-                <a:spcPct val="112000"/>
-              </a:lnSpc>
-              <a:spcAft>
-                <a:spcPts val="900"/>
-              </a:spcAft>
-            </a:pPr>
-            <a:r>
-              <a:rPr sz="1800" b="1">
-                <a:solidFill>
-                  <a:srgbClr val="E0A437"/>
-                </a:solidFill>
-                <a:latin typeface="Fira Sans"/>
-              </a:rPr>
-              <a:t>▸ </a:t>
-            </a:r>
-            <a:r>
-              <a:rPr sz="1800" b="0">
-                <a:solidFill>
-                  <a:srgbClr val="000000"/>
-                </a:solidFill>
-                <a:latin typeface="Fira Sans"/>
-              </a:rPr>
-              <a:t>Significativo no es importante, y correlación no es causalidad.</a:t>
+            <a:r>
+              <a:rPr sz="1300" b="0">
+                <a:solidFill>
+                  <a:srgbClr val="333333"/>
+                </a:solidFill>
+                <a:latin typeface="Fira Sans"/>
+              </a:rPr>
+              <a:t>La misma recta a + b·x, pero dentro de la sigmoide. La respuesta es una Bernoulli (la binomial con n = 1) cuya probabilidad depende de x.</a:t>
             </a:r>
           </a:p>
         </p:txBody>
@@ -6977,7 +6905,7 @@
                 </a:solidFill>
                 <a:latin typeface="Fira Sans"/>
               </a:rPr>
-              <a:t>1. Probabilidad, lo justo: variables aleatorias y distribuciones.</a:t>
+              <a:t>1. Probabilidad: variables aleatorias y distribuciones.</a:t>
             </a:r>
           </a:p>
           <a:p>
@@ -7089,7 +7017,35 @@
                 </a:solidFill>
                 <a:latin typeface="Fira Sans"/>
               </a:rPr>
-              <a:t>5. Bootstrap, y la trampa de las comparaciones múltiples.</a:t>
+              <a:t>5. Bootstrap, y regresión logística: clasificar un sí o no.</a:t>
+            </a:r>
+          </a:p>
+          <a:p>
+            <a:pPr>
+              <a:lnSpc>
+                <a:spcPct val="112000"/>
+              </a:lnSpc>
+              <a:spcAft>
+                <a:spcPts val="900"/>
+              </a:spcAft>
+            </a:pPr>
+            <a:r>
+              <a:rPr sz="1800" b="1">
+                <a:solidFill>
+                  <a:srgbClr val="E0A437"/>
+                </a:solidFill>
+                <a:latin typeface="Fira Sans"/>
+              </a:rPr>
+              <a:t>▸ </a:t>
+            </a:r>
+            <a:r>
+              <a:rPr sz="1800" b="0">
+                <a:solidFill>
+                  <a:srgbClr val="000000"/>
+                </a:solidFill>
+                <a:latin typeface="Fira Sans"/>
+              </a:rPr>
+              <a:t>6. La trampa de las comparaciones múltiples.</a:t>
             </a:r>
           </a:p>
         </p:txBody>
@@ -7185,21 +7141,124 @@
                 </a:solidFill>
                 <a:latin typeface="Fira Sans"/>
               </a:rPr>
-              <a:t>Síntesis</a:t>
-            </a:r>
-          </a:p>
-        </p:txBody>
-      </p:sp>
-      <p:sp>
-        <p:nvSpPr>
-          <p:cNvPr id="4" name="TextBox 3"/>
+              <a:t>La logística en statsmodels</a:t>
+            </a:r>
+          </a:p>
+        </p:txBody>
+      </p:sp>
+      <p:sp>
+        <p:nvSpPr>
+          <p:cNvPr id="4" name="Rectangle 3"/>
+          <p:cNvSpPr/>
+          <p:nvPr/>
+        </p:nvSpPr>
+        <p:spPr>
+          <a:xfrm>
+            <a:off x="704088" y="1280160"/>
+            <a:ext cx="7744968" cy="2880360"/>
+          </a:xfrm>
+          <a:prstGeom prst="rect">
+            <a:avLst/>
+          </a:prstGeom>
+          <a:solidFill>
+            <a:srgbClr val="F0F2F5"/>
+          </a:solidFill>
+          <a:ln>
+            <a:solidFill>
+              <a:srgbClr val="D8DDE3"/>
+            </a:solidFill>
+          </a:ln>
+          <a:effectLst/>
+        </p:spPr>
+        <p:style>
+          <a:lnRef idx="1">
+            <a:schemeClr val="accent1"/>
+          </a:lnRef>
+          <a:fillRef idx="3">
+            <a:schemeClr val="accent1"/>
+          </a:fillRef>
+          <a:effectRef idx="2">
+            <a:schemeClr val="accent1"/>
+          </a:effectRef>
+          <a:fontRef idx="minor">
+            <a:schemeClr val="lt1"/>
+          </a:fontRef>
+        </p:style>
+        <p:txBody>
+          <a:bodyPr rtlCol="0" anchor="ctr" wrap="square" lIns="228600" tIns="137160"/>
+          <a:lstStyle/>
+          <a:p>
+            <a:pPr/>
+            <a:r>
+              <a:rPr sz="1500" b="0">
+                <a:solidFill>
+                  <a:srgbClr val="1D3557"/>
+                </a:solidFill>
+                <a:latin typeface="Menlo"/>
+              </a:rPr>
+              <a:t>logistica = sm.GLM(h["tiene_auto"], sm.add_constant(ingreso),</a:t>
+            </a:r>
+          </a:p>
+          <a:p>
+            <a:pPr/>
+            <a:r>
+              <a:rPr sz="1500" b="0">
+                <a:solidFill>
+                  <a:srgbClr val="1D3557"/>
+                </a:solidFill>
+                <a:latin typeface="Menlo"/>
+              </a:rPr>
+              <a:t>                   family=sm.families.Binomial(),</a:t>
+            </a:r>
+          </a:p>
+          <a:p>
+            <a:pPr/>
+            <a:r>
+              <a:rPr sz="1500" b="0">
+                <a:solidFill>
+                  <a:srgbClr val="1D3557"/>
+                </a:solidFill>
+                <a:latin typeface="Menlo"/>
+              </a:rPr>
+              <a:t>                   freq_weights=h["Factor"]).fit()</a:t>
+            </a:r>
+          </a:p>
+          <a:p>
+            <a:pPr/>
+            <a:r>
+              <a:rPr sz="1500" b="0">
+                <a:solidFill>
+                  <a:srgbClr val="1D3557"/>
+                </a:solidFill>
+                <a:latin typeface="Menlo"/>
+              </a:rPr>
+              <a:t/>
+            </a:r>
+          </a:p>
+          <a:p>
+            <a:pPr/>
+            <a:r>
+              <a:rPr sz="1500" b="0">
+                <a:solidFill>
+                  <a:srgbClr val="1D3557"/>
+                </a:solidFill>
+                <a:latin typeface="Menlo"/>
+              </a:rPr>
+              <a:t>np.exp(logistica.params["IngresoHogar"])   # 8.9</a:t>
+            </a:r>
+          </a:p>
+        </p:txBody>
+      </p:sp>
+      <p:sp>
+        <p:nvSpPr>
+          <p:cNvPr id="5" name="TextBox 4"/>
           <p:cNvSpPr txBox="1"/>
           <p:nvPr/>
         </p:nvSpPr>
         <p:spPr>
           <a:xfrm>
-            <a:off x="704088" y="1353312"/>
-            <a:ext cx="7744968" cy="3300984"/>
+            <a:off x="704088" y="4389120"/>
+            <a:ext cx="7744968" cy="1097280"/>
           </a:xfrm>
           <a:prstGeom prst="rect">
             <a:avLst/>
@@ -7221,7 +7280,7 @@
               </a:spcAft>
             </a:pPr>
             <a:r>
-              <a:rPr sz="1800" b="1">
+              <a:rPr sz="1600" b="1">
                 <a:solidFill>
                   <a:srgbClr val="E0A437"/>
                 </a:solidFill>
@@ -7230,125 +7289,13 @@
               <a:t>▸ </a:t>
             </a:r>
             <a:r>
-              <a:rPr sz="1800" b="0">
+              <a:rPr sz="1600" b="0">
                 <a:solidFill>
                   <a:srgbClr val="000000"/>
                 </a:solidFill>
                 <a:latin typeface="Fira Sans"/>
               </a:rPr>
-              <a:t>Una muestra es una de muchas: todo número calculado se movería con otra muestra, y el error estándar mide cuánto.</a:t>
-            </a:r>
-          </a:p>
-          <a:p>
-            <a:pPr>
-              <a:lnSpc>
-                <a:spcPct val="112000"/>
-              </a:lnSpc>
-              <a:spcAft>
-                <a:spcPts val="900"/>
-              </a:spcAft>
-            </a:pPr>
-            <a:r>
-              <a:rPr sz="1800" b="1">
-                <a:solidFill>
-                  <a:srgbClr val="E0A437"/>
-                </a:solidFill>
-                <a:latin typeface="Fira Sans"/>
-              </a:rPr>
-              <a:t>▸ </a:t>
-            </a:r>
-            <a:r>
-              <a:rPr sz="1800" b="0">
-                <a:solidFill>
-                  <a:srgbClr val="000000"/>
-                </a:solidFill>
-                <a:latin typeface="Fira Sans"/>
-              </a:rPr>
-              <a:t>El teorema central del límite: los promedios se distribuyen normal, aunque los datos no.</a:t>
-            </a:r>
-          </a:p>
-          <a:p>
-            <a:pPr>
-              <a:lnSpc>
-                <a:spcPct val="112000"/>
-              </a:lnSpc>
-              <a:spcAft>
-                <a:spcPts val="900"/>
-              </a:spcAft>
-            </a:pPr>
-            <a:r>
-              <a:rPr sz="1800" b="1">
-                <a:solidFill>
-                  <a:srgbClr val="E0A437"/>
-                </a:solidFill>
-                <a:latin typeface="Fira Sans"/>
-              </a:rPr>
-              <a:t>▸ </a:t>
-            </a:r>
-            <a:r>
-              <a:rPr sz="1800" b="0">
-                <a:solidFill>
-                  <a:srgbClr val="000000"/>
-                </a:solidFill>
-                <a:latin typeface="Fira Sans"/>
-              </a:rPr>
-              <a:t>El intervalo de confianza convierte el error estándar en un rango que atrapa el valor real el 95% de las veces.</a:t>
-            </a:r>
-          </a:p>
-          <a:p>
-            <a:pPr>
-              <a:lnSpc>
-                <a:spcPct val="112000"/>
-              </a:lnSpc>
-              <a:spcAft>
-                <a:spcPts val="900"/>
-              </a:spcAft>
-            </a:pPr>
-            <a:r>
-              <a:rPr sz="1800" b="1">
-                <a:solidFill>
-                  <a:srgbClr val="E0A437"/>
-                </a:solidFill>
-                <a:latin typeface="Fira Sans"/>
-              </a:rPr>
-              <a:t>▸ </a:t>
-            </a:r>
-            <a:r>
-              <a:rPr sz="1800" b="0">
-                <a:solidFill>
-                  <a:srgbClr val="000000"/>
-                </a:solidFill>
-                <a:latin typeface="Fira Sans"/>
-              </a:rPr>
-              <a:t>El valor p responde: si el efecto real fuera cero, ¿qué tan raro sería lo observado? Con p &lt; 0,05, la pendiente de −4,8 es real.</a:t>
-            </a:r>
-          </a:p>
-          <a:p>
-            <a:pPr>
-              <a:lnSpc>
-                <a:spcPct val="112000"/>
-              </a:lnSpc>
-              <a:spcAft>
-                <a:spcPts val="900"/>
-              </a:spcAft>
-            </a:pPr>
-            <a:r>
-              <a:rPr sz="1800" b="1">
-                <a:solidFill>
-                  <a:srgbClr val="E0A437"/>
-                </a:solidFill>
-                <a:latin typeface="Fira Sans"/>
-              </a:rPr>
-              <a:t>▸ </a:t>
-            </a:r>
-            <a:r>
-              <a:rPr sz="1800" b="1">
-                <a:solidFill>
-                  <a:srgbClr val="1D3557"/>
-                </a:solidFill>
-                <a:latin typeface="Fira Sans"/>
-              </a:rPr>
-              <a:t>Para el EDA del lunes 15: intervalos, y cuidado con probar de todo.</a:t>
+              <a:t>GLM con familia binomial, ponderado con el factor. Lectura multiplicativa, como el log de la clase 4: cada millón multiplica las chances de tener auto por 8,9.</a:t>
             </a:r>
           </a:p>
         </p:txBody>
@@ -7386,7 +7333,7 @@
             <a:avLst/>
           </a:prstGeom>
           <a:solidFill>
-            <a:srgbClr val="1D3557"/>
+            <a:srgbClr val="FAFBFC"/>
           </a:solidFill>
           <a:ln>
             <a:noFill/>
@@ -7423,8 +7370,8 @@
         </p:nvSpPr>
         <p:spPr>
           <a:xfrm>
-            <a:off x="603504" y="1847088"/>
-            <a:ext cx="7946136" cy="1399032"/>
+            <a:off x="402336" y="301752"/>
+            <a:ext cx="8348472" cy="795528"/>
           </a:xfrm>
           <a:prstGeom prst="rect">
             <a:avLst/>
@@ -7438,24 +7385,71 @@
           <a:lstStyle/>
           <a:p>
             <a:r>
-              <a:rPr sz="3400" b="1">
-                <a:solidFill>
-                  <a:srgbClr val="FFFFFF"/>
-                </a:solidFill>
-                <a:latin typeface="Fira Sans"/>
-              </a:rPr>
-              <a:t>Recreo</a:t>
-            </a:r>
-          </a:p>
-          <a:p>
-            <a:r>
-              <a:rPr sz="1800" b="0">
-                <a:solidFill>
-                  <a:srgbClr val="E0A437"/>
-                </a:solidFill>
-                <a:latin typeface="Fira Sans"/>
-              </a:rPr>
-              <a:t>10 minutos · al volver: manos al teclado, con el notebook</a:t>
+              <a:rPr sz="2800" b="1">
+                <a:solidFill>
+                  <a:srgbClr val="0F0F0F"/>
+                </a:solidFill>
+                <a:latin typeface="Fira Sans"/>
+              </a:rPr>
+              <a:t>Clasificar: de la probabilidad a la decisión</a:t>
+            </a:r>
+          </a:p>
+        </p:txBody>
+      </p:sp>
+      <p:pic>
+        <p:nvPicPr>
+          <p:cNvPr id="4" name="Picture 3" descr="c5_17_clasificacion.png"/>
+          <p:cNvPicPr>
+            <a:picLocks noChangeAspect="1"/>
+          </p:cNvPicPr>
+          <p:nvPr/>
+        </p:nvPicPr>
+        <p:blipFill>
+          <a:blip r:embed="rId2"/>
+          <a:stretch>
+            <a:fillRect/>
+          </a:stretch>
+        </p:blipFill>
+        <p:spPr>
+          <a:xfrm>
+            <a:off x="1042506" y="1143000"/>
+            <a:ext cx="7058986" cy="3154680"/>
+          </a:xfrm>
+          <a:prstGeom prst="rect">
+            <a:avLst/>
+          </a:prstGeom>
+        </p:spPr>
+      </p:pic>
+      <p:sp>
+        <p:nvSpPr>
+          <p:cNvPr id="5" name="TextBox 4"/>
+          <p:cNvSpPr txBox="1"/>
+          <p:nvPr/>
+        </p:nvSpPr>
+        <p:spPr>
+          <a:xfrm>
+            <a:off x="704088" y="4434840"/>
+            <a:ext cx="7744968" cy="457200"/>
+          </a:xfrm>
+          <a:prstGeom prst="rect">
+            <a:avLst/>
+          </a:prstGeom>
+          <a:noFill/>
+        </p:spPr>
+        <p:txBody>
+          <a:bodyPr wrap="square">
+            <a:spAutoFit/>
+          </a:bodyPr>
+          <a:lstStyle/>
+          <a:p>
+            <a:r>
+              <a:rPr sz="1300" b="0">
+                <a:solidFill>
+                  <a:srgbClr val="333333"/>
+                </a:solidFill>
+                <a:latin typeface="Fira Sans"/>
+              </a:rPr>
+              <a:t>Predecir "tiene auto" cuando P supera 0,5 (desde 0,86 millones). Acierta el 70%, contra el 61% de decir siempre "no": la comparación con la base es obligatoria. Dónde se equivoca lo dice la matriz de confusión (un crosstab).</a:t>
             </a:r>
           </a:p>
         </p:txBody>
@@ -7493,7 +7487,7 @@
             <a:avLst/>
           </a:prstGeom>
           <a:solidFill>
-            <a:srgbClr val="FAFBFC"/>
+            <a:srgbClr val="1D3557"/>
           </a:solidFill>
           <a:ln>
             <a:noFill/>
@@ -7530,8 +7524,8 @@
         </p:nvSpPr>
         <p:spPr>
           <a:xfrm>
-            <a:off x="402336" y="301752"/>
-            <a:ext cx="8348472" cy="795528"/>
+            <a:off x="603504" y="1847088"/>
+            <a:ext cx="7946136" cy="1399032"/>
           </a:xfrm>
           <a:prstGeom prst="rect">
             <a:avLst/>
@@ -7545,120 +7539,24 @@
           <a:lstStyle/>
           <a:p>
             <a:r>
-              <a:rPr sz="2800" b="1">
-                <a:solidFill>
-                  <a:srgbClr val="0F0F0F"/>
-                </a:solidFill>
-                <a:latin typeface="Fira Sans"/>
-              </a:rPr>
-              <a:t>Próxima clase</a:t>
-            </a:r>
-          </a:p>
-        </p:txBody>
-      </p:sp>
-      <p:sp>
-        <p:nvSpPr>
-          <p:cNvPr id="4" name="TextBox 3"/>
-          <p:cNvSpPr txBox="1"/>
-          <p:nvPr/>
-        </p:nvSpPr>
-        <p:spPr>
-          <a:xfrm>
-            <a:off x="704088" y="1353312"/>
-            <a:ext cx="7744968" cy="3300984"/>
-          </a:xfrm>
-          <a:prstGeom prst="rect">
-            <a:avLst/>
-          </a:prstGeom>
-          <a:noFill/>
-        </p:spPr>
-        <p:txBody>
-          <a:bodyPr wrap="square">
-            <a:spAutoFit/>
-          </a:bodyPr>
-          <a:lstStyle/>
-          <a:p>
-            <a:pPr>
-              <a:lnSpc>
-                <a:spcPct val="112000"/>
-              </a:lnSpc>
-              <a:spcAft>
-                <a:spcPts val="900"/>
-              </a:spcAft>
-            </a:pPr>
-            <a:r>
-              <a:rPr sz="1800" b="1">
+              <a:rPr sz="3400" b="1">
+                <a:solidFill>
+                  <a:srgbClr val="FFFFFF"/>
+                </a:solidFill>
+                <a:latin typeface="Fira Sans"/>
+              </a:rPr>
+              <a:t>La trampa de las comparaciones múltiples</a:t>
+            </a:r>
+          </a:p>
+          <a:p>
+            <a:r>
+              <a:rPr sz="1800" b="0">
                 <a:solidFill>
                   <a:srgbClr val="E0A437"/>
                 </a:solidFill>
                 <a:latin typeface="Fira Sans"/>
               </a:rPr>
-              <a:t>▸ </a:t>
-            </a:r>
-            <a:r>
-              <a:rPr sz="1800" b="0">
-                <a:solidFill>
-                  <a:srgbClr val="000000"/>
-                </a:solidFill>
-                <a:latin typeface="Fira Sans"/>
-              </a:rPr>
-              <a:t>Jueves 10: regresión lineal en profundidad: supuestos, diagnósticos con los residuos y evaluación fuera de la muestra.</a:t>
-            </a:r>
-          </a:p>
-          <a:p>
-            <a:pPr>
-              <a:lnSpc>
-                <a:spcPct val="112000"/>
-              </a:lnSpc>
-              <a:spcAft>
-                <a:spcPts val="900"/>
-              </a:spcAft>
-            </a:pPr>
-            <a:r>
-              <a:rPr sz="1800" b="1">
-                <a:solidFill>
-                  <a:srgbClr val="E0A437"/>
-                </a:solidFill>
-                <a:latin typeface="Fira Sans"/>
-              </a:rPr>
-              <a:t>▸ </a:t>
-            </a:r>
-            <a:r>
-              <a:rPr sz="1800" b="0">
-                <a:solidFill>
-                  <a:srgbClr val="000000"/>
-                </a:solidFill>
-                <a:latin typeface="Fira Sans"/>
-              </a:rPr>
-              <a:t>Con lo de hoy ya se puede leer completo el summary de cualquier modelo.</a:t>
-            </a:r>
-          </a:p>
-          <a:p>
-            <a:pPr>
-              <a:lnSpc>
-                <a:spcPct val="112000"/>
-              </a:lnSpc>
-              <a:spcAft>
-                <a:spcPts val="900"/>
-              </a:spcAft>
-            </a:pPr>
-            <a:r>
-              <a:rPr sz="1800" b="1">
-                <a:solidFill>
-                  <a:srgbClr val="E0A437"/>
-                </a:solidFill>
-                <a:latin typeface="Fira Sans"/>
-              </a:rPr>
-              <a:t>▸ </a:t>
-            </a:r>
-            <a:r>
-              <a:rPr sz="1800" b="1">
-                <a:solidFill>
-                  <a:srgbClr val="1D3557"/>
-                </a:solidFill>
-                <a:latin typeface="Fira Sans"/>
-              </a:rPr>
-              <a:t>El primer análisis exploratorio se entrega el lunes 15.</a:t>
+              <a:t>Qué pasa con el valor p cuando se prueba de todo</a:t>
             </a:r>
           </a:p>
         </p:txBody>
@@ -7754,6 +7652,988 @@
                 </a:solidFill>
                 <a:latin typeface="Fira Sans"/>
               </a:rPr>
+              <a:t>20 variables de puro ruido</a:t>
+            </a:r>
+          </a:p>
+        </p:txBody>
+      </p:sp>
+      <p:pic>
+        <p:nvPicPr>
+          <p:cNvPr id="4" name="Picture 3" descr="c5_14_comparaciones_multiples.png"/>
+          <p:cNvPicPr>
+            <a:picLocks noChangeAspect="1"/>
+          </p:cNvPicPr>
+          <p:nvPr/>
+        </p:nvPicPr>
+        <p:blipFill>
+          <a:blip r:embed="rId2"/>
+          <a:stretch>
+            <a:fillRect/>
+          </a:stretch>
+        </p:blipFill>
+        <p:spPr>
+          <a:xfrm>
+            <a:off x="759392" y="1143000"/>
+            <a:ext cx="7625215" cy="3154680"/>
+          </a:xfrm>
+          <a:prstGeom prst="rect">
+            <a:avLst/>
+          </a:prstGeom>
+        </p:spPr>
+      </p:pic>
+      <p:sp>
+        <p:nvSpPr>
+          <p:cNvPr id="5" name="TextBox 4"/>
+          <p:cNvSpPr txBox="1"/>
+          <p:nvPr/>
+        </p:nvSpPr>
+        <p:spPr>
+          <a:xfrm>
+            <a:off x="704088" y="4434840"/>
+            <a:ext cx="7744968" cy="457200"/>
+          </a:xfrm>
+          <a:prstGeom prst="rect">
+            <a:avLst/>
+          </a:prstGeom>
+          <a:noFill/>
+        </p:spPr>
+        <p:txBody>
+          <a:bodyPr wrap="square">
+            <a:spAutoFit/>
+          </a:bodyPr>
+          <a:lstStyle/>
+          <a:p>
+            <a:r>
+              <a:rPr sz="1300" b="0">
+                <a:solidFill>
+                  <a:srgbClr val="333333"/>
+                </a:solidFill>
+                <a:latin typeface="Fira Sans"/>
+              </a:rPr>
+              <a:t>Números al azar, sin relación con nada, probados contra la duración por comuna: con 20 intentos y umbral 0,05 se espera una falsa alarma. Es lo que pasa al recorrer una matriz de correlación buscando la que dé.</a:t>
+            </a:r>
+          </a:p>
+        </p:txBody>
+      </p:sp>
+    </p:spTree>
+  </p:cSld>
+  <p:clrMapOvr>
+    <a:masterClrMapping/>
+  </p:clrMapOvr>
+</p:sld>
+</file>
+
+<file path=ppt/slides/slide34.xml><?xml version="1.0" encoding="utf-8"?>
+<p:sld xmlns:a="http://schemas.openxmlformats.org/drawingml/2006/main" xmlns:p="http://schemas.openxmlformats.org/presentationml/2006/main" xmlns:r="http://schemas.openxmlformats.org/officeDocument/2006/relationships">
+  <p:cSld>
+    <p:spTree>
+      <p:nvGrpSpPr>
+        <p:cNvPr id="1" name=""/>
+        <p:cNvGrpSpPr/>
+        <p:nvPr/>
+      </p:nvGrpSpPr>
+      <p:grpSpPr/>
+      <p:sp>
+        <p:nvSpPr>
+          <p:cNvPr id="2" name="Rectangle 1"/>
+          <p:cNvSpPr/>
+          <p:nvPr/>
+        </p:nvSpPr>
+        <p:spPr>
+          <a:xfrm>
+            <a:off x="0" y="0"/>
+            <a:ext cx="9144000" cy="5138928"/>
+          </a:xfrm>
+          <a:prstGeom prst="rect">
+            <a:avLst/>
+          </a:prstGeom>
+          <a:solidFill>
+            <a:srgbClr val="FAFBFC"/>
+          </a:solidFill>
+          <a:ln>
+            <a:noFill/>
+          </a:ln>
+          <a:effectLst/>
+        </p:spPr>
+        <p:style>
+          <a:lnRef idx="1">
+            <a:schemeClr val="accent1"/>
+          </a:lnRef>
+          <a:fillRef idx="3">
+            <a:schemeClr val="accent1"/>
+          </a:fillRef>
+          <a:effectRef idx="2">
+            <a:schemeClr val="accent1"/>
+          </a:effectRef>
+          <a:fontRef idx="minor">
+            <a:schemeClr val="lt1"/>
+          </a:fontRef>
+        </p:style>
+        <p:txBody>
+          <a:bodyPr rtlCol="0" anchor="ctr"/>
+          <a:lstStyle/>
+          <a:p>
+            <a:pPr algn="ctr"/>
+          </a:p>
+        </p:txBody>
+      </p:sp>
+      <p:sp>
+        <p:nvSpPr>
+          <p:cNvPr id="3" name="TextBox 2"/>
+          <p:cNvSpPr txBox="1"/>
+          <p:nvPr/>
+        </p:nvSpPr>
+        <p:spPr>
+          <a:xfrm>
+            <a:off x="402336" y="301752"/>
+            <a:ext cx="8348472" cy="795528"/>
+          </a:xfrm>
+          <a:prstGeom prst="rect">
+            <a:avLst/>
+          </a:prstGeom>
+          <a:noFill/>
+        </p:spPr>
+        <p:txBody>
+          <a:bodyPr wrap="square">
+            <a:spAutoFit/>
+          </a:bodyPr>
+          <a:lstStyle/>
+          <a:p>
+            <a:r>
+              <a:rPr sz="2800" b="1">
+                <a:solidFill>
+                  <a:srgbClr val="0F0F0F"/>
+                </a:solidFill>
+                <a:latin typeface="Fira Sans"/>
+              </a:rPr>
+              <a:t>Reglas para el EDA del proyecto</a:t>
+            </a:r>
+          </a:p>
+        </p:txBody>
+      </p:sp>
+      <p:sp>
+        <p:nvSpPr>
+          <p:cNvPr id="4" name="TextBox 3"/>
+          <p:cNvSpPr txBox="1"/>
+          <p:nvPr/>
+        </p:nvSpPr>
+        <p:spPr>
+          <a:xfrm>
+            <a:off x="704088" y="1353312"/>
+            <a:ext cx="7744968" cy="3300984"/>
+          </a:xfrm>
+          <a:prstGeom prst="rect">
+            <a:avLst/>
+          </a:prstGeom>
+          <a:noFill/>
+        </p:spPr>
+        <p:txBody>
+          <a:bodyPr wrap="square">
+            <a:spAutoFit/>
+          </a:bodyPr>
+          <a:lstStyle/>
+          <a:p>
+            <a:pPr>
+              <a:lnSpc>
+                <a:spcPct val="112000"/>
+              </a:lnSpc>
+              <a:spcAft>
+                <a:spcPts val="900"/>
+              </a:spcAft>
+            </a:pPr>
+            <a:r>
+              <a:rPr sz="1800" b="1">
+                <a:solidFill>
+                  <a:srgbClr val="E0A437"/>
+                </a:solidFill>
+                <a:latin typeface="Fira Sans"/>
+              </a:rPr>
+              <a:t>▸ </a:t>
+            </a:r>
+            <a:r>
+              <a:rPr sz="1800" b="1">
+                <a:solidFill>
+                  <a:srgbClr val="1D3557"/>
+                </a:solidFill>
+                <a:latin typeface="Fira Sans"/>
+              </a:rPr>
+              <a:t>Reportar cuántas pruebas se hicieron; un hallazgo aislado entre muchos intentos merece desconfianza.</a:t>
+            </a:r>
+          </a:p>
+          <a:p>
+            <a:pPr>
+              <a:lnSpc>
+                <a:spcPct val="112000"/>
+              </a:lnSpc>
+              <a:spcAft>
+                <a:spcPts val="900"/>
+              </a:spcAft>
+            </a:pPr>
+            <a:r>
+              <a:rPr sz="1800" b="1">
+                <a:solidFill>
+                  <a:srgbClr val="E0A437"/>
+                </a:solidFill>
+                <a:latin typeface="Fira Sans"/>
+              </a:rPr>
+              <a:t>▸ </a:t>
+            </a:r>
+            <a:r>
+              <a:rPr sz="1800" b="0">
+                <a:solidFill>
+                  <a:srgbClr val="000000"/>
+                </a:solidFill>
+                <a:latin typeface="Fira Sans"/>
+              </a:rPr>
+              <a:t>La corrección más simple, Bonferroni: dividir el umbral por el número de pruebas (0,05 / 20 = 0,0025).</a:t>
+            </a:r>
+          </a:p>
+          <a:p>
+            <a:pPr>
+              <a:lnSpc>
+                <a:spcPct val="112000"/>
+              </a:lnSpc>
+              <a:spcAft>
+                <a:spcPts val="900"/>
+              </a:spcAft>
+            </a:pPr>
+            <a:r>
+              <a:rPr sz="1800" b="1">
+                <a:solidFill>
+                  <a:srgbClr val="E0A437"/>
+                </a:solidFill>
+                <a:latin typeface="Fira Sans"/>
+              </a:rPr>
+              <a:t>▸ </a:t>
+            </a:r>
+            <a:r>
+              <a:rPr sz="1800" b="0">
+                <a:solidFill>
+                  <a:srgbClr val="000000"/>
+                </a:solidFill>
+                <a:latin typeface="Fira Sans"/>
+              </a:rPr>
+              <a:t>Preferir el intervalo de confianza al valor p: muestra el tamaño del efecto y su precisión.</a:t>
+            </a:r>
+          </a:p>
+          <a:p>
+            <a:pPr>
+              <a:lnSpc>
+                <a:spcPct val="112000"/>
+              </a:lnSpc>
+              <a:spcAft>
+                <a:spcPts val="900"/>
+              </a:spcAft>
+            </a:pPr>
+            <a:r>
+              <a:rPr sz="1800" b="1">
+                <a:solidFill>
+                  <a:srgbClr val="E0A437"/>
+                </a:solidFill>
+                <a:latin typeface="Fira Sans"/>
+              </a:rPr>
+              <a:t>▸ </a:t>
+            </a:r>
+            <a:r>
+              <a:rPr sz="1800" b="0">
+                <a:solidFill>
+                  <a:srgbClr val="000000"/>
+                </a:solidFill>
+                <a:latin typeface="Fira Sans"/>
+              </a:rPr>
+              <a:t>Significativo no es importante, y correlación no es causalidad.</a:t>
+            </a:r>
+          </a:p>
+        </p:txBody>
+      </p:sp>
+    </p:spTree>
+  </p:cSld>
+  <p:clrMapOvr>
+    <a:masterClrMapping/>
+  </p:clrMapOvr>
+</p:sld>
+</file>
+
+<file path=ppt/slides/slide35.xml><?xml version="1.0" encoding="utf-8"?>
+<p:sld xmlns:a="http://schemas.openxmlformats.org/drawingml/2006/main" xmlns:p="http://schemas.openxmlformats.org/presentationml/2006/main" xmlns:r="http://schemas.openxmlformats.org/officeDocument/2006/relationships">
+  <p:cSld>
+    <p:spTree>
+      <p:nvGrpSpPr>
+        <p:cNvPr id="1" name=""/>
+        <p:cNvGrpSpPr/>
+        <p:nvPr/>
+      </p:nvGrpSpPr>
+      <p:grpSpPr/>
+      <p:sp>
+        <p:nvSpPr>
+          <p:cNvPr id="2" name="Rectangle 1"/>
+          <p:cNvSpPr/>
+          <p:nvPr/>
+        </p:nvSpPr>
+        <p:spPr>
+          <a:xfrm>
+            <a:off x="0" y="0"/>
+            <a:ext cx="9144000" cy="5138928"/>
+          </a:xfrm>
+          <a:prstGeom prst="rect">
+            <a:avLst/>
+          </a:prstGeom>
+          <a:solidFill>
+            <a:srgbClr val="FAFBFC"/>
+          </a:solidFill>
+          <a:ln>
+            <a:noFill/>
+          </a:ln>
+          <a:effectLst/>
+        </p:spPr>
+        <p:style>
+          <a:lnRef idx="1">
+            <a:schemeClr val="accent1"/>
+          </a:lnRef>
+          <a:fillRef idx="3">
+            <a:schemeClr val="accent1"/>
+          </a:fillRef>
+          <a:effectRef idx="2">
+            <a:schemeClr val="accent1"/>
+          </a:effectRef>
+          <a:fontRef idx="minor">
+            <a:schemeClr val="lt1"/>
+          </a:fontRef>
+        </p:style>
+        <p:txBody>
+          <a:bodyPr rtlCol="0" anchor="ctr"/>
+          <a:lstStyle/>
+          <a:p>
+            <a:pPr algn="ctr"/>
+          </a:p>
+        </p:txBody>
+      </p:sp>
+      <p:sp>
+        <p:nvSpPr>
+          <p:cNvPr id="3" name="TextBox 2"/>
+          <p:cNvSpPr txBox="1"/>
+          <p:nvPr/>
+        </p:nvSpPr>
+        <p:spPr>
+          <a:xfrm>
+            <a:off x="402336" y="301752"/>
+            <a:ext cx="8348472" cy="795528"/>
+          </a:xfrm>
+          <a:prstGeom prst="rect">
+            <a:avLst/>
+          </a:prstGeom>
+          <a:noFill/>
+        </p:spPr>
+        <p:txBody>
+          <a:bodyPr wrap="square">
+            <a:spAutoFit/>
+          </a:bodyPr>
+          <a:lstStyle/>
+          <a:p>
+            <a:r>
+              <a:rPr sz="2800" b="1">
+                <a:solidFill>
+                  <a:srgbClr val="0F0F0F"/>
+                </a:solidFill>
+                <a:latin typeface="Fira Sans"/>
+              </a:rPr>
+              <a:t>Síntesis</a:t>
+            </a:r>
+          </a:p>
+        </p:txBody>
+      </p:sp>
+      <p:sp>
+        <p:nvSpPr>
+          <p:cNvPr id="4" name="TextBox 3"/>
+          <p:cNvSpPr txBox="1"/>
+          <p:nvPr/>
+        </p:nvSpPr>
+        <p:spPr>
+          <a:xfrm>
+            <a:off x="704088" y="1353312"/>
+            <a:ext cx="7744968" cy="3300984"/>
+          </a:xfrm>
+          <a:prstGeom prst="rect">
+            <a:avLst/>
+          </a:prstGeom>
+          <a:noFill/>
+        </p:spPr>
+        <p:txBody>
+          <a:bodyPr wrap="square">
+            <a:spAutoFit/>
+          </a:bodyPr>
+          <a:lstStyle/>
+          <a:p>
+            <a:pPr>
+              <a:lnSpc>
+                <a:spcPct val="112000"/>
+              </a:lnSpc>
+              <a:spcAft>
+                <a:spcPts val="900"/>
+              </a:spcAft>
+            </a:pPr>
+            <a:r>
+              <a:rPr sz="1800" b="1">
+                <a:solidFill>
+                  <a:srgbClr val="E0A437"/>
+                </a:solidFill>
+                <a:latin typeface="Fira Sans"/>
+              </a:rPr>
+              <a:t>▸ </a:t>
+            </a:r>
+            <a:r>
+              <a:rPr sz="1800" b="0">
+                <a:solidFill>
+                  <a:srgbClr val="000000"/>
+                </a:solidFill>
+                <a:latin typeface="Fira Sans"/>
+              </a:rPr>
+              <a:t>Una muestra es una de muchas: todo número calculado se movería con otra muestra, y el error estándar mide cuánto.</a:t>
+            </a:r>
+          </a:p>
+          <a:p>
+            <a:pPr>
+              <a:lnSpc>
+                <a:spcPct val="112000"/>
+              </a:lnSpc>
+              <a:spcAft>
+                <a:spcPts val="900"/>
+              </a:spcAft>
+            </a:pPr>
+            <a:r>
+              <a:rPr sz="1800" b="1">
+                <a:solidFill>
+                  <a:srgbClr val="E0A437"/>
+                </a:solidFill>
+                <a:latin typeface="Fira Sans"/>
+              </a:rPr>
+              <a:t>▸ </a:t>
+            </a:r>
+            <a:r>
+              <a:rPr sz="1800" b="0">
+                <a:solidFill>
+                  <a:srgbClr val="000000"/>
+                </a:solidFill>
+                <a:latin typeface="Fira Sans"/>
+              </a:rPr>
+              <a:t>El teorema central del límite: los promedios se distribuyen normal, aunque los datos no.</a:t>
+            </a:r>
+          </a:p>
+          <a:p>
+            <a:pPr>
+              <a:lnSpc>
+                <a:spcPct val="112000"/>
+              </a:lnSpc>
+              <a:spcAft>
+                <a:spcPts val="900"/>
+              </a:spcAft>
+            </a:pPr>
+            <a:r>
+              <a:rPr sz="1800" b="1">
+                <a:solidFill>
+                  <a:srgbClr val="E0A437"/>
+                </a:solidFill>
+                <a:latin typeface="Fira Sans"/>
+              </a:rPr>
+              <a:t>▸ </a:t>
+            </a:r>
+            <a:r>
+              <a:rPr sz="1800" b="0">
+                <a:solidFill>
+                  <a:srgbClr val="000000"/>
+                </a:solidFill>
+                <a:latin typeface="Fira Sans"/>
+              </a:rPr>
+              <a:t>El intervalo de confianza convierte el error estándar en un rango que atrapa el valor real el 95% de las veces.</a:t>
+            </a:r>
+          </a:p>
+          <a:p>
+            <a:pPr>
+              <a:lnSpc>
+                <a:spcPct val="112000"/>
+              </a:lnSpc>
+              <a:spcAft>
+                <a:spcPts val="900"/>
+              </a:spcAft>
+            </a:pPr>
+            <a:r>
+              <a:rPr sz="1800" b="1">
+                <a:solidFill>
+                  <a:srgbClr val="E0A437"/>
+                </a:solidFill>
+                <a:latin typeface="Fira Sans"/>
+              </a:rPr>
+              <a:t>▸ </a:t>
+            </a:r>
+            <a:r>
+              <a:rPr sz="1800" b="0">
+                <a:solidFill>
+                  <a:srgbClr val="000000"/>
+                </a:solidFill>
+                <a:latin typeface="Fira Sans"/>
+              </a:rPr>
+              <a:t>El valor p responde: si el efecto real fuera cero, ¿qué tan raro sería lo observado? Con p &lt; 0,05, la pendiente de −4,8 es real.</a:t>
+            </a:r>
+          </a:p>
+          <a:p>
+            <a:pPr>
+              <a:lnSpc>
+                <a:spcPct val="112000"/>
+              </a:lnSpc>
+              <a:spcAft>
+                <a:spcPts val="900"/>
+              </a:spcAft>
+            </a:pPr>
+            <a:r>
+              <a:rPr sz="1800" b="1">
+                <a:solidFill>
+                  <a:srgbClr val="E0A437"/>
+                </a:solidFill>
+                <a:latin typeface="Fira Sans"/>
+              </a:rPr>
+              <a:t>▸ </a:t>
+            </a:r>
+            <a:r>
+              <a:rPr sz="1800" b="0">
+                <a:solidFill>
+                  <a:srgbClr val="000000"/>
+                </a:solidFill>
+                <a:latin typeface="Fira Sans"/>
+              </a:rPr>
+              <a:t>Para un sí o no, la regresión logística: la recta dentro de una sigmoide; clasificar es cortar en 0,5 y comparar con la base.</a:t>
+            </a:r>
+          </a:p>
+          <a:p>
+            <a:pPr>
+              <a:lnSpc>
+                <a:spcPct val="112000"/>
+              </a:lnSpc>
+              <a:spcAft>
+                <a:spcPts val="900"/>
+              </a:spcAft>
+            </a:pPr>
+            <a:r>
+              <a:rPr sz="1800" b="1">
+                <a:solidFill>
+                  <a:srgbClr val="E0A437"/>
+                </a:solidFill>
+                <a:latin typeface="Fira Sans"/>
+              </a:rPr>
+              <a:t>▸ </a:t>
+            </a:r>
+            <a:r>
+              <a:rPr sz="1800" b="1">
+                <a:solidFill>
+                  <a:srgbClr val="1D3557"/>
+                </a:solidFill>
+                <a:latin typeface="Fira Sans"/>
+              </a:rPr>
+              <a:t>Para el EDA del lunes 15: intervalos, y cuidado con probar de todo.</a:t>
+            </a:r>
+          </a:p>
+        </p:txBody>
+      </p:sp>
+    </p:spTree>
+  </p:cSld>
+  <p:clrMapOvr>
+    <a:masterClrMapping/>
+  </p:clrMapOvr>
+</p:sld>
+</file>
+
+<file path=ppt/slides/slide36.xml><?xml version="1.0" encoding="utf-8"?>
+<p:sld xmlns:a="http://schemas.openxmlformats.org/drawingml/2006/main" xmlns:p="http://schemas.openxmlformats.org/presentationml/2006/main" xmlns:r="http://schemas.openxmlformats.org/officeDocument/2006/relationships">
+  <p:cSld>
+    <p:spTree>
+      <p:nvGrpSpPr>
+        <p:cNvPr id="1" name=""/>
+        <p:cNvGrpSpPr/>
+        <p:nvPr/>
+      </p:nvGrpSpPr>
+      <p:grpSpPr/>
+      <p:sp>
+        <p:nvSpPr>
+          <p:cNvPr id="2" name="Rectangle 1"/>
+          <p:cNvSpPr/>
+          <p:nvPr/>
+        </p:nvSpPr>
+        <p:spPr>
+          <a:xfrm>
+            <a:off x="0" y="0"/>
+            <a:ext cx="9144000" cy="5138928"/>
+          </a:xfrm>
+          <a:prstGeom prst="rect">
+            <a:avLst/>
+          </a:prstGeom>
+          <a:solidFill>
+            <a:srgbClr val="1D3557"/>
+          </a:solidFill>
+          <a:ln>
+            <a:noFill/>
+          </a:ln>
+          <a:effectLst/>
+        </p:spPr>
+        <p:style>
+          <a:lnRef idx="1">
+            <a:schemeClr val="accent1"/>
+          </a:lnRef>
+          <a:fillRef idx="3">
+            <a:schemeClr val="accent1"/>
+          </a:fillRef>
+          <a:effectRef idx="2">
+            <a:schemeClr val="accent1"/>
+          </a:effectRef>
+          <a:fontRef idx="minor">
+            <a:schemeClr val="lt1"/>
+          </a:fontRef>
+        </p:style>
+        <p:txBody>
+          <a:bodyPr rtlCol="0" anchor="ctr"/>
+          <a:lstStyle/>
+          <a:p>
+            <a:pPr algn="ctr"/>
+          </a:p>
+        </p:txBody>
+      </p:sp>
+      <p:sp>
+        <p:nvSpPr>
+          <p:cNvPr id="3" name="TextBox 2"/>
+          <p:cNvSpPr txBox="1"/>
+          <p:nvPr/>
+        </p:nvSpPr>
+        <p:spPr>
+          <a:xfrm>
+            <a:off x="603504" y="1847088"/>
+            <a:ext cx="7946136" cy="1399032"/>
+          </a:xfrm>
+          <a:prstGeom prst="rect">
+            <a:avLst/>
+          </a:prstGeom>
+          <a:noFill/>
+        </p:spPr>
+        <p:txBody>
+          <a:bodyPr wrap="square">
+            <a:spAutoFit/>
+          </a:bodyPr>
+          <a:lstStyle/>
+          <a:p>
+            <a:r>
+              <a:rPr sz="3400" b="1">
+                <a:solidFill>
+                  <a:srgbClr val="FFFFFF"/>
+                </a:solidFill>
+                <a:latin typeface="Fira Sans"/>
+              </a:rPr>
+              <a:t>Recreo</a:t>
+            </a:r>
+          </a:p>
+          <a:p>
+            <a:r>
+              <a:rPr sz="1800" b="0">
+                <a:solidFill>
+                  <a:srgbClr val="E0A437"/>
+                </a:solidFill>
+                <a:latin typeface="Fira Sans"/>
+              </a:rPr>
+              <a:t>10 minutos · al volver: manos al teclado, con el notebook</a:t>
+            </a:r>
+          </a:p>
+        </p:txBody>
+      </p:sp>
+    </p:spTree>
+  </p:cSld>
+  <p:clrMapOvr>
+    <a:masterClrMapping/>
+  </p:clrMapOvr>
+</p:sld>
+</file>
+
+<file path=ppt/slides/slide37.xml><?xml version="1.0" encoding="utf-8"?>
+<p:sld xmlns:a="http://schemas.openxmlformats.org/drawingml/2006/main" xmlns:p="http://schemas.openxmlformats.org/presentationml/2006/main" xmlns:r="http://schemas.openxmlformats.org/officeDocument/2006/relationships">
+  <p:cSld>
+    <p:spTree>
+      <p:nvGrpSpPr>
+        <p:cNvPr id="1" name=""/>
+        <p:cNvGrpSpPr/>
+        <p:nvPr/>
+      </p:nvGrpSpPr>
+      <p:grpSpPr/>
+      <p:sp>
+        <p:nvSpPr>
+          <p:cNvPr id="2" name="Rectangle 1"/>
+          <p:cNvSpPr/>
+          <p:nvPr/>
+        </p:nvSpPr>
+        <p:spPr>
+          <a:xfrm>
+            <a:off x="0" y="0"/>
+            <a:ext cx="9144000" cy="5138928"/>
+          </a:xfrm>
+          <a:prstGeom prst="rect">
+            <a:avLst/>
+          </a:prstGeom>
+          <a:solidFill>
+            <a:srgbClr val="FAFBFC"/>
+          </a:solidFill>
+          <a:ln>
+            <a:noFill/>
+          </a:ln>
+          <a:effectLst/>
+        </p:spPr>
+        <p:style>
+          <a:lnRef idx="1">
+            <a:schemeClr val="accent1"/>
+          </a:lnRef>
+          <a:fillRef idx="3">
+            <a:schemeClr val="accent1"/>
+          </a:fillRef>
+          <a:effectRef idx="2">
+            <a:schemeClr val="accent1"/>
+          </a:effectRef>
+          <a:fontRef idx="minor">
+            <a:schemeClr val="lt1"/>
+          </a:fontRef>
+        </p:style>
+        <p:txBody>
+          <a:bodyPr rtlCol="0" anchor="ctr"/>
+          <a:lstStyle/>
+          <a:p>
+            <a:pPr algn="ctr"/>
+          </a:p>
+        </p:txBody>
+      </p:sp>
+      <p:sp>
+        <p:nvSpPr>
+          <p:cNvPr id="3" name="TextBox 2"/>
+          <p:cNvSpPr txBox="1"/>
+          <p:nvPr/>
+        </p:nvSpPr>
+        <p:spPr>
+          <a:xfrm>
+            <a:off x="402336" y="301752"/>
+            <a:ext cx="8348472" cy="795528"/>
+          </a:xfrm>
+          <a:prstGeom prst="rect">
+            <a:avLst/>
+          </a:prstGeom>
+          <a:noFill/>
+        </p:spPr>
+        <p:txBody>
+          <a:bodyPr wrap="square">
+            <a:spAutoFit/>
+          </a:bodyPr>
+          <a:lstStyle/>
+          <a:p>
+            <a:r>
+              <a:rPr sz="2800" b="1">
+                <a:solidFill>
+                  <a:srgbClr val="0F0F0F"/>
+                </a:solidFill>
+                <a:latin typeface="Fira Sans"/>
+              </a:rPr>
+              <a:t>Próxima clase</a:t>
+            </a:r>
+          </a:p>
+        </p:txBody>
+      </p:sp>
+      <p:sp>
+        <p:nvSpPr>
+          <p:cNvPr id="4" name="TextBox 3"/>
+          <p:cNvSpPr txBox="1"/>
+          <p:nvPr/>
+        </p:nvSpPr>
+        <p:spPr>
+          <a:xfrm>
+            <a:off x="704088" y="1353312"/>
+            <a:ext cx="7744968" cy="3300984"/>
+          </a:xfrm>
+          <a:prstGeom prst="rect">
+            <a:avLst/>
+          </a:prstGeom>
+          <a:noFill/>
+        </p:spPr>
+        <p:txBody>
+          <a:bodyPr wrap="square">
+            <a:spAutoFit/>
+          </a:bodyPr>
+          <a:lstStyle/>
+          <a:p>
+            <a:pPr>
+              <a:lnSpc>
+                <a:spcPct val="112000"/>
+              </a:lnSpc>
+              <a:spcAft>
+                <a:spcPts val="900"/>
+              </a:spcAft>
+            </a:pPr>
+            <a:r>
+              <a:rPr sz="1800" b="1">
+                <a:solidFill>
+                  <a:srgbClr val="E0A437"/>
+                </a:solidFill>
+                <a:latin typeface="Fira Sans"/>
+              </a:rPr>
+              <a:t>▸ </a:t>
+            </a:r>
+            <a:r>
+              <a:rPr sz="1800" b="0">
+                <a:solidFill>
+                  <a:srgbClr val="000000"/>
+                </a:solidFill>
+                <a:latin typeface="Fira Sans"/>
+              </a:rPr>
+              <a:t>Jueves 10: regresión lineal en profundidad: supuestos, diagnósticos con los residuos y evaluación fuera de la muestra.</a:t>
+            </a:r>
+          </a:p>
+          <a:p>
+            <a:pPr>
+              <a:lnSpc>
+                <a:spcPct val="112000"/>
+              </a:lnSpc>
+              <a:spcAft>
+                <a:spcPts val="900"/>
+              </a:spcAft>
+            </a:pPr>
+            <a:r>
+              <a:rPr sz="1800" b="1">
+                <a:solidFill>
+                  <a:srgbClr val="E0A437"/>
+                </a:solidFill>
+                <a:latin typeface="Fira Sans"/>
+              </a:rPr>
+              <a:t>▸ </a:t>
+            </a:r>
+            <a:r>
+              <a:rPr sz="1800" b="0">
+                <a:solidFill>
+                  <a:srgbClr val="000000"/>
+                </a:solidFill>
+                <a:latin typeface="Fira Sans"/>
+              </a:rPr>
+              <a:t>Con lo de hoy ya se puede leer completo el summary de cualquier modelo.</a:t>
+            </a:r>
+          </a:p>
+          <a:p>
+            <a:pPr>
+              <a:lnSpc>
+                <a:spcPct val="112000"/>
+              </a:lnSpc>
+              <a:spcAft>
+                <a:spcPts val="900"/>
+              </a:spcAft>
+            </a:pPr>
+            <a:r>
+              <a:rPr sz="1800" b="1">
+                <a:solidFill>
+                  <a:srgbClr val="E0A437"/>
+                </a:solidFill>
+                <a:latin typeface="Fira Sans"/>
+              </a:rPr>
+              <a:t>▸ </a:t>
+            </a:r>
+            <a:r>
+              <a:rPr sz="1800" b="1">
+                <a:solidFill>
+                  <a:srgbClr val="1D3557"/>
+                </a:solidFill>
+                <a:latin typeface="Fira Sans"/>
+              </a:rPr>
+              <a:t>El primer análisis exploratorio se entrega el lunes 15.</a:t>
+            </a:r>
+          </a:p>
+        </p:txBody>
+      </p:sp>
+    </p:spTree>
+  </p:cSld>
+  <p:clrMapOvr>
+    <a:masterClrMapping/>
+  </p:clrMapOvr>
+</p:sld>
+</file>
+
+<file path=ppt/slides/slide38.xml><?xml version="1.0" encoding="utf-8"?>
+<p:sld xmlns:a="http://schemas.openxmlformats.org/drawingml/2006/main" xmlns:p="http://schemas.openxmlformats.org/presentationml/2006/main" xmlns:r="http://schemas.openxmlformats.org/officeDocument/2006/relationships">
+  <p:cSld>
+    <p:spTree>
+      <p:nvGrpSpPr>
+        <p:cNvPr id="1" name=""/>
+        <p:cNvGrpSpPr/>
+        <p:nvPr/>
+      </p:nvGrpSpPr>
+      <p:grpSpPr/>
+      <p:sp>
+        <p:nvSpPr>
+          <p:cNvPr id="2" name="Rectangle 1"/>
+          <p:cNvSpPr/>
+          <p:nvPr/>
+        </p:nvSpPr>
+        <p:spPr>
+          <a:xfrm>
+            <a:off x="0" y="0"/>
+            <a:ext cx="9144000" cy="5138928"/>
+          </a:xfrm>
+          <a:prstGeom prst="rect">
+            <a:avLst/>
+          </a:prstGeom>
+          <a:solidFill>
+            <a:srgbClr val="FAFBFC"/>
+          </a:solidFill>
+          <a:ln>
+            <a:noFill/>
+          </a:ln>
+          <a:effectLst/>
+        </p:spPr>
+        <p:style>
+          <a:lnRef idx="1">
+            <a:schemeClr val="accent1"/>
+          </a:lnRef>
+          <a:fillRef idx="3">
+            <a:schemeClr val="accent1"/>
+          </a:fillRef>
+          <a:effectRef idx="2">
+            <a:schemeClr val="accent1"/>
+          </a:effectRef>
+          <a:fontRef idx="minor">
+            <a:schemeClr val="lt1"/>
+          </a:fontRef>
+        </p:style>
+        <p:txBody>
+          <a:bodyPr rtlCol="0" anchor="ctr"/>
+          <a:lstStyle/>
+          <a:p>
+            <a:pPr algn="ctr"/>
+          </a:p>
+        </p:txBody>
+      </p:sp>
+      <p:sp>
+        <p:nvSpPr>
+          <p:cNvPr id="3" name="TextBox 2"/>
+          <p:cNvSpPr txBox="1"/>
+          <p:nvPr/>
+        </p:nvSpPr>
+        <p:spPr>
+          <a:xfrm>
+            <a:off x="402336" y="301752"/>
+            <a:ext cx="8348472" cy="795528"/>
+          </a:xfrm>
+          <a:prstGeom prst="rect">
+            <a:avLst/>
+          </a:prstGeom>
+          <a:noFill/>
+        </p:spPr>
+        <p:txBody>
+          <a:bodyPr wrap="square">
+            <a:spAutoFit/>
+          </a:bodyPr>
+          <a:lstStyle/>
+          <a:p>
+            <a:r>
+              <a:rPr sz="2800" b="1">
+                <a:solidFill>
+                  <a:srgbClr val="0F0F0F"/>
+                </a:solidFill>
+                <a:latin typeface="Fira Sans"/>
+              </a:rPr>
               <a:t>Referencias</a:t>
             </a:r>
           </a:p>
@@ -8056,7 +8936,7 @@
                 </a:solidFill>
                 <a:latin typeface="Fira Sans"/>
               </a:rPr>
-              <a:t>Probabilidad, lo justo</a:t>
+              <a:t>Probabilidad</a:t>
             </a:r>
           </a:p>
           <a:p>

</xml_diff>

<commit_message>
Clase 5: regla de la normal por paneles con 1,96, puente distribución muestral → intervalo, cajas del summary alineadas, supuestos de la regresión
Co-Authored-By: Claude Fable 5.1 <noreply@anthropic.com>
</commit_message>
<xml_diff>
--- a/presentaciones/clase05_probabilidad_inferencia.pptx
+++ b/presentaciones/clase05_probabilidad_inferencia.pptx
@@ -43,6 +43,8 @@
     <p:sldId id="291" r:id="rId42"/>
     <p:sldId id="292" r:id="rId43"/>
     <p:sldId id="293" r:id="rId44"/>
+    <p:sldId id="294" r:id="rId45"/>
+    <p:sldId id="295" r:id="rId46"/>
   </p:sldIdLst>
   <p:sldSz cx="9144000" cy="5138928" type="screen4x3"/>
   <p:notesSz cx="6858000" cy="9144000"/>
@@ -4087,7 +4089,7 @@
                 </a:solidFill>
                 <a:latin typeface="Fira Sans"/>
               </a:rPr>
-              <a:t>La media de una muestra se distribuye normal alrededor de la media real, con desviación σ/√n, aunque la variable no sea normal. Por eso la normal es la distribución de la inferencia: los promedios lo son.</a:t>
+              <a:t>La media de una muestra se distribuye normal alrededor de la media real, con desviación σ/√n, aunque la variable no sea normal. Por eso la normal es la distribución de la inferencia: los promedios lo son, y la regla del 1,96 σ se les puede aplicar.</a:t>
             </a:r>
           </a:p>
         </p:txBody>
@@ -4290,14 +4292,14 @@
                 </a:solidFill>
                 <a:latin typeface="Fira Sans"/>
               </a:rPr>
-              <a:t>El intervalo de confianza del 95%</a:t>
+              <a:t>De la distribución muestral al intervalo</a:t>
             </a:r>
           </a:p>
         </p:txBody>
       </p:sp>
       <p:pic>
         <p:nvPicPr>
-          <p:cNvPr id="4" name="Picture 3" descr="c5_09_formula_ic.png"/>
+          <p:cNvPr id="4" name="Picture 3" descr="c5_18_puente_ic.png"/>
           <p:cNvPicPr>
             <a:picLocks noChangeAspect="1"/>
           </p:cNvPicPr>
@@ -4311,8 +4313,8 @@
         </p:blipFill>
         <p:spPr>
           <a:xfrm>
-            <a:off x="699515" y="1402487"/>
-            <a:ext cx="7744968" cy="2635704"/>
+            <a:off x="699515" y="1493845"/>
+            <a:ext cx="7744968" cy="2452988"/>
           </a:xfrm>
           <a:prstGeom prst="rect">
             <a:avLst/>
@@ -4348,7 +4350,7 @@
                 </a:solidFill>
                 <a:latin typeface="Fira Sans"/>
               </a:rPr>
-              <a:t>Se lee sobre el procedimiento: si repitiéramos el muestreo, el 95% de los intervalos atraparía la media real. Este intervalo en particular la atrapa o no; nunca sabremos cuál de los dos.</a:t>
+              <a:t>Paso 1: por el TCL las medias muestrales son normales, así que el 95% cae a menos de 1,96 EE de μ. Paso 2, la misma frase al revés: μ está a menos de 1,96 EE de la media de mi muestra en el 95% de las muestras. Ese rango es el intervalo.</a:t>
             </a:r>
           </a:p>
         </p:txBody>
@@ -4444,14 +4446,14 @@
                 </a:solidFill>
                 <a:latin typeface="Fira Sans"/>
               </a:rPr>
-              <a:t>Comprobado con la población</a:t>
+              <a:t>El intervalo de confianza del 95%</a:t>
             </a:r>
           </a:p>
         </p:txBody>
       </p:sp>
       <p:pic>
         <p:nvPicPr>
-          <p:cNvPr id="4" name="Picture 3" descr="c5_10_cobertura.png"/>
+          <p:cNvPr id="4" name="Picture 3" descr="c5_09_formula_ic.png"/>
           <p:cNvPicPr>
             <a:picLocks noChangeAspect="1"/>
           </p:cNvPicPr>
@@ -4465,8 +4467,8 @@
         </p:blipFill>
         <p:spPr>
           <a:xfrm>
-            <a:off x="1060186" y="1143000"/>
-            <a:ext cx="7023627" cy="3154680"/>
+            <a:off x="699515" y="1402487"/>
+            <a:ext cx="7744968" cy="2635704"/>
           </a:xfrm>
           <a:prstGeom prst="rect">
             <a:avLst/>
@@ -4502,7 +4504,7 @@
                 </a:solidFill>
                 <a:latin typeface="Fira Sans"/>
               </a:rPr>
-              <a:t>100 muestras de 100 viajes, 100 intervalos: los rojos no atrapan la media. Cerca del 95% lo hace; con cola larga y n = 100, un poco menos.</a:t>
+              <a:t>Se lee sobre el procedimiento: si repitiéramos el muestreo, el 95% de los intervalos atraparía la media real. Este intervalo en particular la atrapa o no; nunca sabremos cuál de los dos.</a:t>
             </a:r>
           </a:p>
         </p:txBody>
@@ -4540,7 +4542,7 @@
             <a:avLst/>
           </a:prstGeom>
           <a:solidFill>
-            <a:srgbClr val="1D3557"/>
+            <a:srgbClr val="FAFBFC"/>
           </a:solidFill>
           <a:ln>
             <a:noFill/>
@@ -4577,8 +4579,8 @@
         </p:nvSpPr>
         <p:spPr>
           <a:xfrm>
-            <a:off x="603504" y="1847088"/>
-            <a:ext cx="7946136" cy="1399032"/>
+            <a:off x="402336" y="301752"/>
+            <a:ext cx="8348472" cy="795528"/>
           </a:xfrm>
           <a:prstGeom prst="rect">
             <a:avLst/>
@@ -4592,24 +4594,71 @@
           <a:lstStyle/>
           <a:p>
             <a:r>
-              <a:rPr sz="3400" b="1">
-                <a:solidFill>
-                  <a:srgbClr val="FFFFFF"/>
-                </a:solidFill>
-                <a:latin typeface="Fira Sans"/>
-              </a:rPr>
-              <a:t>Prueba de hipótesis y valor p</a:t>
-            </a:r>
-          </a:p>
-          <a:p>
-            <a:r>
-              <a:rPr sz="1800" b="0">
-                <a:solidFill>
-                  <a:srgbClr val="E0A437"/>
-                </a:solidFill>
-                <a:latin typeface="Fira Sans"/>
-              </a:rPr>
-              <a:t>La pregunta pendiente: ¿la pendiente es real o azar?</a:t>
+              <a:rPr sz="2800" b="1">
+                <a:solidFill>
+                  <a:srgbClr val="0F0F0F"/>
+                </a:solidFill>
+                <a:latin typeface="Fira Sans"/>
+              </a:rPr>
+              <a:t>Comprobado con la población</a:t>
+            </a:r>
+          </a:p>
+        </p:txBody>
+      </p:sp>
+      <p:pic>
+        <p:nvPicPr>
+          <p:cNvPr id="4" name="Picture 3" descr="c5_10_cobertura.png"/>
+          <p:cNvPicPr>
+            <a:picLocks noChangeAspect="1"/>
+          </p:cNvPicPr>
+          <p:nvPr/>
+        </p:nvPicPr>
+        <p:blipFill>
+          <a:blip r:embed="rId2"/>
+          <a:stretch>
+            <a:fillRect/>
+          </a:stretch>
+        </p:blipFill>
+        <p:spPr>
+          <a:xfrm>
+            <a:off x="1060186" y="1143000"/>
+            <a:ext cx="7023627" cy="3154680"/>
+          </a:xfrm>
+          <a:prstGeom prst="rect">
+            <a:avLst/>
+          </a:prstGeom>
+        </p:spPr>
+      </p:pic>
+      <p:sp>
+        <p:nvSpPr>
+          <p:cNvPr id="5" name="TextBox 4"/>
+          <p:cNvSpPr txBox="1"/>
+          <p:nvPr/>
+        </p:nvSpPr>
+        <p:spPr>
+          <a:xfrm>
+            <a:off x="704088" y="4434840"/>
+            <a:ext cx="7744968" cy="457200"/>
+          </a:xfrm>
+          <a:prstGeom prst="rect">
+            <a:avLst/>
+          </a:prstGeom>
+          <a:noFill/>
+        </p:spPr>
+        <p:txBody>
+          <a:bodyPr wrap="square">
+            <a:spAutoFit/>
+          </a:bodyPr>
+          <a:lstStyle/>
+          <a:p>
+            <a:r>
+              <a:rPr sz="1300" b="0">
+                <a:solidFill>
+                  <a:srgbClr val="333333"/>
+                </a:solidFill>
+                <a:latin typeface="Fira Sans"/>
+              </a:rPr>
+              <a:t>100 muestras de 100 viajes, 100 intervalos: los rojos no atrapan la media. Cerca del 95% lo hace; con cola larga y n = 100, un poco menos.</a:t>
             </a:r>
           </a:p>
         </p:txBody>
@@ -4647,7 +4696,7 @@
             <a:avLst/>
           </a:prstGeom>
           <a:solidFill>
-            <a:srgbClr val="FAFBFC"/>
+            <a:srgbClr val="1D3557"/>
           </a:solidFill>
           <a:ln>
             <a:noFill/>
@@ -4684,8 +4733,8 @@
         </p:nvSpPr>
         <p:spPr>
           <a:xfrm>
-            <a:off x="402336" y="301752"/>
-            <a:ext cx="8348472" cy="795528"/>
+            <a:off x="603504" y="1847088"/>
+            <a:ext cx="7946136" cy="1399032"/>
           </a:xfrm>
           <a:prstGeom prst="rect">
             <a:avLst/>
@@ -4699,148 +4748,24 @@
           <a:lstStyle/>
           <a:p>
             <a:r>
-              <a:rPr sz="2800" b="1">
-                <a:solidFill>
-                  <a:srgbClr val="0F0F0F"/>
-                </a:solidFill>
-                <a:latin typeface="Fira Sans"/>
-              </a:rPr>
-              <a:t>La lógica de la prueba</a:t>
-            </a:r>
-          </a:p>
-        </p:txBody>
-      </p:sp>
-      <p:sp>
-        <p:nvSpPr>
-          <p:cNvPr id="4" name="TextBox 3"/>
-          <p:cNvSpPr txBox="1"/>
-          <p:nvPr/>
-        </p:nvSpPr>
-        <p:spPr>
-          <a:xfrm>
-            <a:off x="704088" y="1353312"/>
-            <a:ext cx="7744968" cy="3300984"/>
-          </a:xfrm>
-          <a:prstGeom prst="rect">
-            <a:avLst/>
-          </a:prstGeom>
-          <a:noFill/>
-        </p:spPr>
-        <p:txBody>
-          <a:bodyPr wrap="square">
-            <a:spAutoFit/>
-          </a:bodyPr>
-          <a:lstStyle/>
-          <a:p>
-            <a:pPr>
-              <a:lnSpc>
-                <a:spcPct val="112000"/>
-              </a:lnSpc>
-              <a:spcAft>
-                <a:spcPts val="900"/>
-              </a:spcAft>
-            </a:pPr>
-            <a:r>
-              <a:rPr sz="1800" b="1">
+              <a:rPr sz="3400" b="1">
+                <a:solidFill>
+                  <a:srgbClr val="FFFFFF"/>
+                </a:solidFill>
+                <a:latin typeface="Fira Sans"/>
+              </a:rPr>
+              <a:t>Prueba de hipótesis y valor p</a:t>
+            </a:r>
+          </a:p>
+          <a:p>
+            <a:r>
+              <a:rPr sz="1800" b="0">
                 <a:solidFill>
                   <a:srgbClr val="E0A437"/>
                 </a:solidFill>
                 <a:latin typeface="Fira Sans"/>
               </a:rPr>
-              <a:t>▸ </a:t>
-            </a:r>
-            <a:r>
-              <a:rPr sz="1800" b="1">
-                <a:solidFill>
-                  <a:srgbClr val="1D3557"/>
-                </a:solidFill>
-                <a:latin typeface="Fira Sans"/>
-              </a:rPr>
-              <a:t>Hipótesis nula H0: la pendiente real es 0, el ingreso no tiene efecto sobre la duración. Alternativa H1: no es 0.</a:t>
-            </a:r>
-          </a:p>
-          <a:p>
-            <a:pPr>
-              <a:lnSpc>
-                <a:spcPct val="112000"/>
-              </a:lnSpc>
-              <a:spcAft>
-                <a:spcPts val="900"/>
-              </a:spcAft>
-            </a:pPr>
-            <a:r>
-              <a:rPr sz="1800" b="1">
-                <a:solidFill>
-                  <a:srgbClr val="E0A437"/>
-                </a:solidFill>
-                <a:latin typeface="Fira Sans"/>
-              </a:rPr>
-              <a:t>▸ </a:t>
-            </a:r>
-            <a:r>
-              <a:rPr sz="1800" b="0">
-                <a:solidFill>
-                  <a:srgbClr val="000000"/>
-                </a:solidFill>
-                <a:latin typeface="Fira Sans"/>
-              </a:rPr>
-              <a:t>Si H0 fuera cierta, ¿qué tan raro sería obtener una pendiente como la nuestra solo por azar de qué comunas cayeron en la muestra?</a:t>
-            </a:r>
-          </a:p>
-          <a:p>
-            <a:pPr>
-              <a:lnSpc>
-                <a:spcPct val="112000"/>
-              </a:lnSpc>
-              <a:spcAft>
-                <a:spcPts val="900"/>
-              </a:spcAft>
-            </a:pPr>
-            <a:r>
-              <a:rPr sz="1800" b="1">
-                <a:solidFill>
-                  <a:srgbClr val="E0A437"/>
-                </a:solidFill>
-                <a:latin typeface="Fira Sans"/>
-              </a:rPr>
-              <a:t>▸ </a:t>
-            </a:r>
-            <a:r>
-              <a:rPr sz="1800" b="0">
-                <a:solidFill>
-                  <a:srgbClr val="000000"/>
-                </a:solidFill>
-                <a:latin typeface="Fira Sans"/>
-              </a:rPr>
-              <a:t>Esa probabilidad es el valor p. Convención: si p &lt; 0,05, se rechaza H0 y el efecto se declara significativo.</a:t>
-            </a:r>
-          </a:p>
-          <a:p>
-            <a:pPr>
-              <a:lnSpc>
-                <a:spcPct val="112000"/>
-              </a:lnSpc>
-              <a:spcAft>
-                <a:spcPts val="900"/>
-              </a:spcAft>
-            </a:pPr>
-            <a:r>
-              <a:rPr sz="1800" b="1">
-                <a:solidFill>
-                  <a:srgbClr val="E0A437"/>
-                </a:solidFill>
-                <a:latin typeface="Fira Sans"/>
-              </a:rPr>
-              <a:t>▸ </a:t>
-            </a:r>
-            <a:r>
-              <a:rPr sz="1800" b="0">
-                <a:solidFill>
-                  <a:srgbClr val="000000"/>
-                </a:solidFill>
-                <a:latin typeface="Fira Sans"/>
-              </a:rPr>
-              <a:t>El estadístico que lo mide: t = coeficiente / error estándar, a cuántos errores estándar del cero está la pendiente.</a:t>
+              <a:t>La pregunta pendiente: ¿la pendiente es real o azar?</a:t>
             </a:r>
           </a:p>
         </p:txBody>
@@ -5139,45 +5064,21 @@
                 </a:solidFill>
                 <a:latin typeface="Fira Sans"/>
               </a:rPr>
-              <a:t>El summary completo, por fin</a:t>
-            </a:r>
-          </a:p>
-        </p:txBody>
-      </p:sp>
-      <p:pic>
-        <p:nvPicPr>
-          <p:cNvPr id="4" name="Picture 3" descr="c5_11_summary_completo.png"/>
-          <p:cNvPicPr>
-            <a:picLocks noChangeAspect="1"/>
-          </p:cNvPicPr>
-          <p:nvPr/>
-        </p:nvPicPr>
-        <p:blipFill>
-          <a:blip r:embed="rId2"/>
-          <a:stretch>
-            <a:fillRect/>
-          </a:stretch>
-        </p:blipFill>
-        <p:spPr>
-          <a:xfrm>
-            <a:off x="699515" y="1447565"/>
-            <a:ext cx="7744968" cy="2545549"/>
-          </a:xfrm>
-          <a:prstGeom prst="rect">
-            <a:avLst/>
-          </a:prstGeom>
-        </p:spPr>
-      </p:pic>
-      <p:sp>
-        <p:nvSpPr>
-          <p:cNvPr id="5" name="TextBox 4"/>
+              <a:t>La lógica de la prueba</a:t>
+            </a:r>
+          </a:p>
+        </p:txBody>
+      </p:sp>
+      <p:sp>
+        <p:nvSpPr>
+          <p:cNvPr id="4" name="TextBox 3"/>
           <p:cNvSpPr txBox="1"/>
           <p:nvPr/>
         </p:nvSpPr>
         <p:spPr>
           <a:xfrm>
-            <a:off x="704088" y="4434840"/>
-            <a:ext cx="7744968" cy="457200"/>
+            <a:off x="704088" y="1353312"/>
+            <a:ext cx="7744968" cy="3300984"/>
           </a:xfrm>
           <a:prstGeom prst="rect">
             <a:avLst/>
@@ -5190,14 +5091,115 @@
           </a:bodyPr>
           <a:lstStyle/>
           <a:p>
-            <a:r>
-              <a:rPr sz="1300" b="0">
-                <a:solidFill>
-                  <a:srgbClr val="333333"/>
-                </a:solidFill>
-                <a:latin typeface="Fira Sans"/>
-              </a:rPr>
-              <a:t>La pendiente −4,81 con error estándar 2,02: t = −2,39. Si la real fuera 0, un t así de lejos ocurre el 2,1% de las veces: p = 0,021. El intervalo [−8,9; −0,75] no incluye el 0.</a:t>
+            <a:pPr>
+              <a:lnSpc>
+                <a:spcPct val="112000"/>
+              </a:lnSpc>
+              <a:spcAft>
+                <a:spcPts val="900"/>
+              </a:spcAft>
+            </a:pPr>
+            <a:r>
+              <a:rPr sz="1800" b="1">
+                <a:solidFill>
+                  <a:srgbClr val="E0A437"/>
+                </a:solidFill>
+                <a:latin typeface="Fira Sans"/>
+              </a:rPr>
+              <a:t>▸ </a:t>
+            </a:r>
+            <a:r>
+              <a:rPr sz="1800" b="1">
+                <a:solidFill>
+                  <a:srgbClr val="1D3557"/>
+                </a:solidFill>
+                <a:latin typeface="Fira Sans"/>
+              </a:rPr>
+              <a:t>Hipótesis nula H0: la pendiente real es 0, el ingreso no tiene efecto sobre la duración. Alternativa H1: no es 0.</a:t>
+            </a:r>
+          </a:p>
+          <a:p>
+            <a:pPr>
+              <a:lnSpc>
+                <a:spcPct val="112000"/>
+              </a:lnSpc>
+              <a:spcAft>
+                <a:spcPts val="900"/>
+              </a:spcAft>
+            </a:pPr>
+            <a:r>
+              <a:rPr sz="1800" b="1">
+                <a:solidFill>
+                  <a:srgbClr val="E0A437"/>
+                </a:solidFill>
+                <a:latin typeface="Fira Sans"/>
+              </a:rPr>
+              <a:t>▸ </a:t>
+            </a:r>
+            <a:r>
+              <a:rPr sz="1800" b="0">
+                <a:solidFill>
+                  <a:srgbClr val="000000"/>
+                </a:solidFill>
+                <a:latin typeface="Fira Sans"/>
+              </a:rPr>
+              <a:t>Si H0 fuera cierta, ¿qué tan raro sería obtener una pendiente como la nuestra solo por azar de qué comunas cayeron en la muestra?</a:t>
+            </a:r>
+          </a:p>
+          <a:p>
+            <a:pPr>
+              <a:lnSpc>
+                <a:spcPct val="112000"/>
+              </a:lnSpc>
+              <a:spcAft>
+                <a:spcPts val="900"/>
+              </a:spcAft>
+            </a:pPr>
+            <a:r>
+              <a:rPr sz="1800" b="1">
+                <a:solidFill>
+                  <a:srgbClr val="E0A437"/>
+                </a:solidFill>
+                <a:latin typeface="Fira Sans"/>
+              </a:rPr>
+              <a:t>▸ </a:t>
+            </a:r>
+            <a:r>
+              <a:rPr sz="1800" b="0">
+                <a:solidFill>
+                  <a:srgbClr val="000000"/>
+                </a:solidFill>
+                <a:latin typeface="Fira Sans"/>
+              </a:rPr>
+              <a:t>Esa probabilidad es el valor p. Convención: si p &lt; 0,05, se rechaza H0 y el efecto se declara significativo.</a:t>
+            </a:r>
+          </a:p>
+          <a:p>
+            <a:pPr>
+              <a:lnSpc>
+                <a:spcPct val="112000"/>
+              </a:lnSpc>
+              <a:spcAft>
+                <a:spcPts val="900"/>
+              </a:spcAft>
+            </a:pPr>
+            <a:r>
+              <a:rPr sz="1800" b="1">
+                <a:solidFill>
+                  <a:srgbClr val="E0A437"/>
+                </a:solidFill>
+                <a:latin typeface="Fira Sans"/>
+              </a:rPr>
+              <a:t>▸ </a:t>
+            </a:r>
+            <a:r>
+              <a:rPr sz="1800" b="0">
+                <a:solidFill>
+                  <a:srgbClr val="000000"/>
+                </a:solidFill>
+                <a:latin typeface="Fira Sans"/>
+              </a:rPr>
+              <a:t>El estadístico que lo mide: t = coeficiente / error estándar, a cuántos errores estándar del cero está la pendiente.</a:t>
             </a:r>
           </a:p>
         </p:txBody>
@@ -5293,14 +5295,14 @@
                 </a:solidFill>
                 <a:latin typeface="Fira Sans"/>
               </a:rPr>
-              <a:t>El valor p, dibujado</a:t>
+              <a:t>El summary completo, por fin</a:t>
             </a:r>
           </a:p>
         </p:txBody>
       </p:sp>
       <p:pic>
         <p:nvPicPr>
-          <p:cNvPr id="4" name="Picture 3" descr="c5_12_valor_p.png"/>
+          <p:cNvPr id="4" name="Picture 3" descr="c5_11_summary_completo.png"/>
           <p:cNvPicPr>
             <a:picLocks noChangeAspect="1"/>
           </p:cNvPicPr>
@@ -5314,8 +5316,8 @@
         </p:blipFill>
         <p:spPr>
           <a:xfrm>
-            <a:off x="858678" y="1143000"/>
-            <a:ext cx="7426642" cy="3154680"/>
+            <a:off x="699515" y="1447565"/>
+            <a:ext cx="7744968" cy="2545549"/>
           </a:xfrm>
           <a:prstGeom prst="rect">
             <a:avLst/>
@@ -5351,7 +5353,7 @@
                 </a:solidFill>
                 <a:latin typeface="Fira Sans"/>
               </a:rPr>
-              <a:t>Con 45 puntos se usa la distribución t (una normal algo más ancha, por estimar σ con s). El área dorada de las dos colas más allá del t observado es el valor p.</a:t>
+              <a:t>La pendiente −4,81 con error estándar 2,02: t = −2,39. Si la real fuera 0, un t así de lejos ocurre el 2,1% de las veces: p = 0,021. El intervalo [−8,9; −0,75] no incluye el 0.</a:t>
             </a:r>
           </a:p>
         </p:txBody>
@@ -5447,114 +5449,35 @@
                 </a:solidFill>
                 <a:latin typeface="Fira Sans"/>
               </a:rPr>
-              <a:t>t y p, a mano</a:t>
-            </a:r>
-          </a:p>
-        </p:txBody>
-      </p:sp>
-      <p:sp>
-        <p:nvSpPr>
-          <p:cNvPr id="4" name="Rectangle 3"/>
-          <p:cNvSpPr/>
-          <p:nvPr/>
-        </p:nvSpPr>
-        <p:spPr>
-          <a:xfrm>
-            <a:off x="704088" y="1280160"/>
-            <a:ext cx="7744968" cy="2880360"/>
-          </a:xfrm>
-          <a:prstGeom prst="rect">
-            <a:avLst/>
-          </a:prstGeom>
-          <a:solidFill>
-            <a:srgbClr val="F0F2F5"/>
-          </a:solidFill>
-          <a:ln>
-            <a:solidFill>
-              <a:srgbClr val="D8DDE3"/>
-            </a:solidFill>
-          </a:ln>
-          <a:effectLst/>
-        </p:spPr>
-        <p:style>
-          <a:lnRef idx="1">
-            <a:schemeClr val="accent1"/>
-          </a:lnRef>
-          <a:fillRef idx="3">
-            <a:schemeClr val="accent1"/>
-          </a:fillRef>
-          <a:effectRef idx="2">
-            <a:schemeClr val="accent1"/>
-          </a:effectRef>
-          <a:fontRef idx="minor">
-            <a:schemeClr val="lt1"/>
-          </a:fontRef>
-        </p:style>
-        <p:txBody>
-          <a:bodyPr rtlCol="0" anchor="ctr" wrap="square" lIns="228600" tIns="137160"/>
-          <a:lstStyle/>
-          <a:p>
-            <a:pPr/>
-            <a:r>
-              <a:rPr sz="1500" b="0">
-                <a:solidFill>
-                  <a:srgbClr val="1D3557"/>
-                </a:solidFill>
-                <a:latin typeface="Menlo"/>
-              </a:rPr>
-              <a:t>b, ee = modelo.params["ingreso"], modelo.bse["ingreso"]</a:t>
-            </a:r>
-          </a:p>
-          <a:p>
-            <a:pPr/>
-            <a:r>
-              <a:rPr sz="1500" b="0">
-                <a:solidFill>
-                  <a:srgbClr val="1D3557"/>
-                </a:solidFill>
-                <a:latin typeface="Menlo"/>
-              </a:rPr>
-              <a:t>t = b / ee                                 # -2.39</a:t>
-            </a:r>
-          </a:p>
-          <a:p>
-            <a:pPr/>
-            <a:r>
-              <a:rPr sz="1500" b="0">
-                <a:solidFill>
-                  <a:srgbClr val="1D3557"/>
-                </a:solidFill>
-                <a:latin typeface="Menlo"/>
-              </a:rPr>
-              <a:t/>
-            </a:r>
-          </a:p>
-          <a:p>
-            <a:pPr/>
-            <a:r>
-              <a:rPr sz="1500" b="0">
-                <a:solidFill>
-                  <a:srgbClr val="1D3557"/>
-                </a:solidFill>
-                <a:latin typeface="Menlo"/>
-              </a:rPr>
-              <a:t># Dos colas de la t con n - 2 grados de libertad</a:t>
-            </a:r>
-          </a:p>
-          <a:p>
-            <a:pPr/>
-            <a:r>
-              <a:rPr sz="1500" b="0">
-                <a:solidFill>
-                  <a:srgbClr val="1D3557"/>
-                </a:solidFill>
-                <a:latin typeface="Menlo"/>
-              </a:rPr>
-              <a:t>p = 2 * (1 - stats.t.cdf(abs(t), df=43))   # 0.021</a:t>
-            </a:r>
-          </a:p>
-        </p:txBody>
-      </p:sp>
+              <a:t>El valor p, dibujado</a:t>
+            </a:r>
+          </a:p>
+        </p:txBody>
+      </p:sp>
+      <p:pic>
+        <p:nvPicPr>
+          <p:cNvPr id="4" name="Picture 3" descr="c5_12_valor_p.png"/>
+          <p:cNvPicPr>
+            <a:picLocks noChangeAspect="1"/>
+          </p:cNvPicPr>
+          <p:nvPr/>
+        </p:nvPicPr>
+        <p:blipFill>
+          <a:blip r:embed="rId2"/>
+          <a:stretch>
+            <a:fillRect/>
+          </a:stretch>
+        </p:blipFill>
+        <p:spPr>
+          <a:xfrm>
+            <a:off x="858678" y="1143000"/>
+            <a:ext cx="7426642" cy="3154680"/>
+          </a:xfrm>
+          <a:prstGeom prst="rect">
+            <a:avLst/>
+          </a:prstGeom>
+        </p:spPr>
+      </p:pic>
       <p:sp>
         <p:nvSpPr>
           <p:cNvPr id="5" name="TextBox 4"/>
@@ -5563,8 +5486,8 @@
         </p:nvSpPr>
         <p:spPr>
           <a:xfrm>
-            <a:off x="704088" y="4389120"/>
-            <a:ext cx="7744968" cy="1097280"/>
+            <a:off x="704088" y="4434840"/>
+            <a:ext cx="7744968" cy="457200"/>
           </a:xfrm>
           <a:prstGeom prst="rect">
             <a:avLst/>
@@ -5577,31 +5500,14 @@
           </a:bodyPr>
           <a:lstStyle/>
           <a:p>
-            <a:pPr>
-              <a:lnSpc>
-                <a:spcPct val="112000"/>
-              </a:lnSpc>
-              <a:spcAft>
-                <a:spcPts val="900"/>
-              </a:spcAft>
-            </a:pPr>
-            <a:r>
-              <a:rPr sz="1600" b="1">
-                <a:solidFill>
-                  <a:srgbClr val="E0A437"/>
-                </a:solidFill>
-                <a:latin typeface="Fira Sans"/>
-              </a:rPr>
-              <a:t>▸ </a:t>
-            </a:r>
-            <a:r>
-              <a:rPr sz="1600" b="0">
-                <a:solidFill>
-                  <a:srgbClr val="000000"/>
-                </a:solidFill>
-                <a:latin typeface="Fira Sans"/>
-              </a:rPr>
-              <a:t>Lo que statsmodels imprime sale de esta cuenta: el coeficiente en unidades de su error estándar, y el área que deja en las colas.</a:t>
+            <a:r>
+              <a:rPr sz="1300" b="0">
+                <a:solidFill>
+                  <a:srgbClr val="333333"/>
+                </a:solidFill>
+                <a:latin typeface="Fira Sans"/>
+              </a:rPr>
+              <a:t>Con 45 puntos se usa la distribución t (una normal algo más ancha, por estimar σ con s). El área dorada de las dos colas más allá del t observado es el valor p.</a:t>
             </a:r>
           </a:p>
         </p:txBody>
@@ -5697,21 +5603,124 @@
                 </a:solidFill>
                 <a:latin typeface="Fira Sans"/>
               </a:rPr>
-              <a:t>La respuesta, y su letra chica</a:t>
-            </a:r>
-          </a:p>
-        </p:txBody>
-      </p:sp>
-      <p:sp>
-        <p:nvSpPr>
-          <p:cNvPr id="4" name="TextBox 3"/>
+              <a:t>t y p, a mano</a:t>
+            </a:r>
+          </a:p>
+        </p:txBody>
+      </p:sp>
+      <p:sp>
+        <p:nvSpPr>
+          <p:cNvPr id="4" name="Rectangle 3"/>
+          <p:cNvSpPr/>
+          <p:nvPr/>
+        </p:nvSpPr>
+        <p:spPr>
+          <a:xfrm>
+            <a:off x="704088" y="1280160"/>
+            <a:ext cx="7744968" cy="2880360"/>
+          </a:xfrm>
+          <a:prstGeom prst="rect">
+            <a:avLst/>
+          </a:prstGeom>
+          <a:solidFill>
+            <a:srgbClr val="F0F2F5"/>
+          </a:solidFill>
+          <a:ln>
+            <a:solidFill>
+              <a:srgbClr val="D8DDE3"/>
+            </a:solidFill>
+          </a:ln>
+          <a:effectLst/>
+        </p:spPr>
+        <p:style>
+          <a:lnRef idx="1">
+            <a:schemeClr val="accent1"/>
+          </a:lnRef>
+          <a:fillRef idx="3">
+            <a:schemeClr val="accent1"/>
+          </a:fillRef>
+          <a:effectRef idx="2">
+            <a:schemeClr val="accent1"/>
+          </a:effectRef>
+          <a:fontRef idx="minor">
+            <a:schemeClr val="lt1"/>
+          </a:fontRef>
+        </p:style>
+        <p:txBody>
+          <a:bodyPr rtlCol="0" anchor="ctr" wrap="square" lIns="228600" tIns="137160"/>
+          <a:lstStyle/>
+          <a:p>
+            <a:pPr/>
+            <a:r>
+              <a:rPr sz="1500" b="0">
+                <a:solidFill>
+                  <a:srgbClr val="1D3557"/>
+                </a:solidFill>
+                <a:latin typeface="Menlo"/>
+              </a:rPr>
+              <a:t>b, ee = modelo.params["ingreso"], modelo.bse["ingreso"]</a:t>
+            </a:r>
+          </a:p>
+          <a:p>
+            <a:pPr/>
+            <a:r>
+              <a:rPr sz="1500" b="0">
+                <a:solidFill>
+                  <a:srgbClr val="1D3557"/>
+                </a:solidFill>
+                <a:latin typeface="Menlo"/>
+              </a:rPr>
+              <a:t>t = b / ee                                 # -2.39</a:t>
+            </a:r>
+          </a:p>
+          <a:p>
+            <a:pPr/>
+            <a:r>
+              <a:rPr sz="1500" b="0">
+                <a:solidFill>
+                  <a:srgbClr val="1D3557"/>
+                </a:solidFill>
+                <a:latin typeface="Menlo"/>
+              </a:rPr>
+              <a:t/>
+            </a:r>
+          </a:p>
+          <a:p>
+            <a:pPr/>
+            <a:r>
+              <a:rPr sz="1500" b="0">
+                <a:solidFill>
+                  <a:srgbClr val="1D3557"/>
+                </a:solidFill>
+                <a:latin typeface="Menlo"/>
+              </a:rPr>
+              <a:t># Dos colas de la t con n - 2 grados de libertad</a:t>
+            </a:r>
+          </a:p>
+          <a:p>
+            <a:pPr/>
+            <a:r>
+              <a:rPr sz="1500" b="0">
+                <a:solidFill>
+                  <a:srgbClr val="1D3557"/>
+                </a:solidFill>
+                <a:latin typeface="Menlo"/>
+              </a:rPr>
+              <a:t>p = 2 * (1 - stats.t.cdf(abs(t), df=43))   # 0.021</a:t>
+            </a:r>
+          </a:p>
+        </p:txBody>
+      </p:sp>
+      <p:sp>
+        <p:nvSpPr>
+          <p:cNvPr id="5" name="TextBox 4"/>
           <p:cNvSpPr txBox="1"/>
           <p:nvPr/>
         </p:nvSpPr>
         <p:spPr>
           <a:xfrm>
-            <a:off x="704088" y="1353312"/>
-            <a:ext cx="7744968" cy="3300984"/>
+            <a:off x="704088" y="4389120"/>
+            <a:ext cx="7744968" cy="1097280"/>
           </a:xfrm>
           <a:prstGeom prst="rect">
             <a:avLst/>
@@ -5733,7 +5742,7 @@
               </a:spcAft>
             </a:pPr>
             <a:r>
-              <a:rPr sz="1800" b="1">
+              <a:rPr sz="1600" b="1">
                 <a:solidFill>
                   <a:srgbClr val="E0A437"/>
                 </a:solidFill>
@@ -5742,97 +5751,13 @@
               <a:t>▸ </a:t>
             </a:r>
             <a:r>
-              <a:rPr sz="1800" b="1">
-                <a:solidFill>
-                  <a:srgbClr val="1D3557"/>
-                </a:solidFill>
-                <a:latin typeface="Fira Sans"/>
-              </a:rPr>
-              <a:t>La pendiente de −4,8 no parece azar: p = 0,021 y el intervalo [−8,9; −0,75] no incluye el 0. Rechazamos H0.</a:t>
-            </a:r>
-          </a:p>
-          <a:p>
-            <a:pPr>
-              <a:lnSpc>
-                <a:spcPct val="112000"/>
-              </a:lnSpc>
-              <a:spcAft>
-                <a:spcPts val="900"/>
-              </a:spcAft>
-            </a:pPr>
-            <a:r>
-              <a:rPr sz="1800" b="1">
-                <a:solidFill>
-                  <a:srgbClr val="E0A437"/>
-                </a:solidFill>
-                <a:latin typeface="Fira Sans"/>
-              </a:rPr>
-              <a:t>▸ </a:t>
-            </a:r>
-            <a:r>
-              <a:rPr sz="1800" b="0">
+              <a:rPr sz="1600" b="0">
                 <a:solidFill>
                   <a:srgbClr val="000000"/>
                 </a:solidFill>
                 <a:latin typeface="Fira Sans"/>
               </a:rPr>
-              <a:t>Pero el valor p depende del efecto y del tamaño de la muestra: la motorización (18 mil hogares) tiene t = 80 y p prácticamente 0; las comunas, con 45 puntos, apenas cruzan el umbral.</a:t>
-            </a:r>
-          </a:p>
-          <a:p>
-            <a:pPr>
-              <a:lnSpc>
-                <a:spcPct val="112000"/>
-              </a:lnSpc>
-              <a:spcAft>
-                <a:spcPts val="900"/>
-              </a:spcAft>
-            </a:pPr>
-            <a:r>
-              <a:rPr sz="1800" b="1">
-                <a:solidFill>
-                  <a:srgbClr val="E0A437"/>
-                </a:solidFill>
-                <a:latin typeface="Fira Sans"/>
-              </a:rPr>
-              <a:t>▸ </a:t>
-            </a:r>
-            <a:r>
-              <a:rPr sz="1800" b="0">
-                <a:solidFill>
-                  <a:srgbClr val="000000"/>
-                </a:solidFill>
-                <a:latin typeface="Fira Sans"/>
-              </a:rPr>
-              <a:t>Significativo no es importante: el tamaño del efecto lo dice el coeficiente; su precisión, el intervalo.</a:t>
-            </a:r>
-          </a:p>
-          <a:p>
-            <a:pPr>
-              <a:lnSpc>
-                <a:spcPct val="112000"/>
-              </a:lnSpc>
-              <a:spcAft>
-                <a:spcPts val="900"/>
-              </a:spcAft>
-            </a:pPr>
-            <a:r>
-              <a:rPr sz="1800" b="1">
-                <a:solidFill>
-                  <a:srgbClr val="E0A437"/>
-                </a:solidFill>
-                <a:latin typeface="Fira Sans"/>
-              </a:rPr>
-              <a:t>▸ </a:t>
-            </a:r>
-            <a:r>
-              <a:rPr sz="1800" b="0">
-                <a:solidFill>
-                  <a:srgbClr val="000000"/>
-                </a:solidFill>
-                <a:latin typeface="Fira Sans"/>
-              </a:rPr>
-              <a:t>Correlación no es causalidad, tampoco con p pequeño: seguimos reportando asociación.</a:t>
+              <a:t>Lo que statsmodels imprime sale de esta cuenta: el coeficiente en unidades de su error estándar, y el área que deja en las colas.</a:t>
             </a:r>
           </a:p>
         </p:txBody>
@@ -5870,7 +5795,7 @@
             <a:avLst/>
           </a:prstGeom>
           <a:solidFill>
-            <a:srgbClr val="1D3557"/>
+            <a:srgbClr val="FAFBFC"/>
           </a:solidFill>
           <a:ln>
             <a:noFill/>
@@ -5907,8 +5832,8 @@
         </p:nvSpPr>
         <p:spPr>
           <a:xfrm>
-            <a:off x="603504" y="1847088"/>
-            <a:ext cx="7946136" cy="1399032"/>
+            <a:off x="402336" y="301752"/>
+            <a:ext cx="8348472" cy="795528"/>
           </a:xfrm>
           <a:prstGeom prst="rect">
             <a:avLst/>
@@ -5922,24 +5847,148 @@
           <a:lstStyle/>
           <a:p>
             <a:r>
-              <a:rPr sz="3400" b="1">
-                <a:solidFill>
-                  <a:srgbClr val="FFFFFF"/>
-                </a:solidFill>
-                <a:latin typeface="Fira Sans"/>
-              </a:rPr>
-              <a:t>Bootstrap</a:t>
-            </a:r>
-          </a:p>
-          <a:p>
+              <a:rPr sz="2800" b="1">
+                <a:solidFill>
+                  <a:srgbClr val="0F0F0F"/>
+                </a:solidFill>
+                <a:latin typeface="Fira Sans"/>
+              </a:rPr>
+              <a:t>La respuesta, y su letra chica</a:t>
+            </a:r>
+          </a:p>
+        </p:txBody>
+      </p:sp>
+      <p:sp>
+        <p:nvSpPr>
+          <p:cNvPr id="4" name="TextBox 3"/>
+          <p:cNvSpPr txBox="1"/>
+          <p:nvPr/>
+        </p:nvSpPr>
+        <p:spPr>
+          <a:xfrm>
+            <a:off x="704088" y="1353312"/>
+            <a:ext cx="7744968" cy="3300984"/>
+          </a:xfrm>
+          <a:prstGeom prst="rect">
+            <a:avLst/>
+          </a:prstGeom>
+          <a:noFill/>
+        </p:spPr>
+        <p:txBody>
+          <a:bodyPr wrap="square">
+            <a:spAutoFit/>
+          </a:bodyPr>
+          <a:lstStyle/>
+          <a:p>
+            <a:pPr>
+              <a:lnSpc>
+                <a:spcPct val="112000"/>
+              </a:lnSpc>
+              <a:spcAft>
+                <a:spcPts val="900"/>
+              </a:spcAft>
+            </a:pPr>
+            <a:r>
+              <a:rPr sz="1800" b="1">
+                <a:solidFill>
+                  <a:srgbClr val="E0A437"/>
+                </a:solidFill>
+                <a:latin typeface="Fira Sans"/>
+              </a:rPr>
+              <a:t>▸ </a:t>
+            </a:r>
+            <a:r>
+              <a:rPr sz="1800" b="1">
+                <a:solidFill>
+                  <a:srgbClr val="1D3557"/>
+                </a:solidFill>
+                <a:latin typeface="Fira Sans"/>
+              </a:rPr>
+              <a:t>La pendiente de −4,8 no parece azar: p = 0,021 y el intervalo [−8,9; −0,75] no incluye el 0. Rechazamos H0.</a:t>
+            </a:r>
+          </a:p>
+          <a:p>
+            <a:pPr>
+              <a:lnSpc>
+                <a:spcPct val="112000"/>
+              </a:lnSpc>
+              <a:spcAft>
+                <a:spcPts val="900"/>
+              </a:spcAft>
+            </a:pPr>
+            <a:r>
+              <a:rPr sz="1800" b="1">
+                <a:solidFill>
+                  <a:srgbClr val="E0A437"/>
+                </a:solidFill>
+                <a:latin typeface="Fira Sans"/>
+              </a:rPr>
+              <a:t>▸ </a:t>
+            </a:r>
             <a:r>
               <a:rPr sz="1800" b="0">
                 <a:solidFill>
+                  <a:srgbClr val="000000"/>
+                </a:solidFill>
+                <a:latin typeface="Fira Sans"/>
+              </a:rPr>
+              <a:t>Pero el valor p depende del efecto y del tamaño de la muestra: la motorización (18 mil hogares) tiene t = 80 y p prácticamente 0; las comunas, con 45 puntos, apenas cruzan el umbral.</a:t>
+            </a:r>
+          </a:p>
+          <a:p>
+            <a:pPr>
+              <a:lnSpc>
+                <a:spcPct val="112000"/>
+              </a:lnSpc>
+              <a:spcAft>
+                <a:spcPts val="900"/>
+              </a:spcAft>
+            </a:pPr>
+            <a:r>
+              <a:rPr sz="1800" b="1">
+                <a:solidFill>
                   <a:srgbClr val="E0A437"/>
                 </a:solidFill>
                 <a:latin typeface="Fira Sans"/>
               </a:rPr>
-              <a:t>La misma respuesta, sin fórmulas</a:t>
+              <a:t>▸ </a:t>
+            </a:r>
+            <a:r>
+              <a:rPr sz="1800" b="0">
+                <a:solidFill>
+                  <a:srgbClr val="000000"/>
+                </a:solidFill>
+                <a:latin typeface="Fira Sans"/>
+              </a:rPr>
+              <a:t>Significativo no es importante: el tamaño del efecto lo dice el coeficiente; su precisión, el intervalo.</a:t>
+            </a:r>
+          </a:p>
+          <a:p>
+            <a:pPr>
+              <a:lnSpc>
+                <a:spcPct val="112000"/>
+              </a:lnSpc>
+              <a:spcAft>
+                <a:spcPts val="900"/>
+              </a:spcAft>
+            </a:pPr>
+            <a:r>
+              <a:rPr sz="1800" b="1">
+                <a:solidFill>
+                  <a:srgbClr val="E0A437"/>
+                </a:solidFill>
+                <a:latin typeface="Fira Sans"/>
+              </a:rPr>
+              <a:t>▸ </a:t>
+            </a:r>
+            <a:r>
+              <a:rPr sz="1800" b="0">
+                <a:solidFill>
+                  <a:srgbClr val="000000"/>
+                </a:solidFill>
+                <a:latin typeface="Fira Sans"/>
+              </a:rPr>
+              <a:t>Correlación no es causalidad, tampoco con p pequeño: seguimos reportando asociación.</a:t>
             </a:r>
           </a:p>
         </p:txBody>
@@ -6035,124 +6084,21 @@
                 </a:solidFill>
                 <a:latin typeface="Fira Sans"/>
               </a:rPr>
-              <a:t>Remuestrear los datos</a:t>
-            </a:r>
-          </a:p>
-        </p:txBody>
-      </p:sp>
-      <p:sp>
-        <p:nvSpPr>
-          <p:cNvPr id="4" name="Rectangle 3"/>
-          <p:cNvSpPr/>
-          <p:nvPr/>
-        </p:nvSpPr>
-        <p:spPr>
-          <a:xfrm>
-            <a:off x="704088" y="1280160"/>
-            <a:ext cx="7744968" cy="2880360"/>
-          </a:xfrm>
-          <a:prstGeom prst="rect">
-            <a:avLst/>
-          </a:prstGeom>
-          <a:solidFill>
-            <a:srgbClr val="F0F2F5"/>
-          </a:solidFill>
-          <a:ln>
-            <a:solidFill>
-              <a:srgbClr val="D8DDE3"/>
-            </a:solidFill>
-          </a:ln>
-          <a:effectLst/>
-        </p:spPr>
-        <p:style>
-          <a:lnRef idx="1">
-            <a:schemeClr val="accent1"/>
-          </a:lnRef>
-          <a:fillRef idx="3">
-            <a:schemeClr val="accent1"/>
-          </a:fillRef>
-          <a:effectRef idx="2">
-            <a:schemeClr val="accent1"/>
-          </a:effectRef>
-          <a:fontRef idx="minor">
-            <a:schemeClr val="lt1"/>
-          </a:fontRef>
-        </p:style>
-        <p:txBody>
-          <a:bodyPr rtlCol="0" anchor="ctr" wrap="square" lIns="228600" tIns="137160"/>
-          <a:lstStyle/>
-          <a:p>
-            <a:pPr/>
-            <a:r>
-              <a:rPr sz="1500" b="0">
-                <a:solidFill>
-                  <a:srgbClr val="1D3557"/>
-                </a:solidFill>
-                <a:latin typeface="Menlo"/>
-              </a:rPr>
-              <a:t>pendientes = []</a:t>
-            </a:r>
-          </a:p>
-          <a:p>
-            <a:pPr/>
-            <a:r>
-              <a:rPr sz="1500" b="0">
-                <a:solidFill>
-                  <a:srgbClr val="1D3557"/>
-                </a:solidFill>
-                <a:latin typeface="Menlo"/>
-              </a:rPr>
-              <a:t>for _ in range(2000):</a:t>
-            </a:r>
-          </a:p>
-          <a:p>
-            <a:pPr/>
-            <a:r>
-              <a:rPr sz="1500" b="0">
-                <a:solidFill>
-                  <a:srgbClr val="1D3557"/>
-                </a:solidFill>
-                <a:latin typeface="Menlo"/>
-              </a:rPr>
-              <a:t>    idx = rng.integers(0, 45, 45)     # 45 comunas, con reemplazo</a:t>
-            </a:r>
-          </a:p>
-          <a:p>
-            <a:pPr/>
-            <a:r>
-              <a:rPr sz="1500" b="0">
-                <a:solidFill>
-                  <a:srgbClr val="1D3557"/>
-                </a:solidFill>
-                <a:latin typeface="Menlo"/>
-              </a:rPr>
-              <a:t>    pendientes.append(np.polyfit(x[idx], y[idx], 1)[0])</a:t>
-            </a:r>
-          </a:p>
-          <a:p>
-            <a:pPr/>
-            <a:r>
-              <a:rPr sz="1500" b="0">
-                <a:solidFill>
-                  <a:srgbClr val="1D3557"/>
-                </a:solidFill>
-                <a:latin typeface="Menlo"/>
-              </a:rPr>
-              <a:t>np.percentile(pendientes, [2.5, 97.5])</a:t>
-            </a:r>
-          </a:p>
-        </p:txBody>
-      </p:sp>
-      <p:sp>
-        <p:nvSpPr>
-          <p:cNvPr id="5" name="TextBox 4"/>
+              <a:t>Qué supone la regresión para inferir</a:t>
+            </a:r>
+          </a:p>
+        </p:txBody>
+      </p:sp>
+      <p:sp>
+        <p:nvSpPr>
+          <p:cNvPr id="4" name="TextBox 3"/>
           <p:cNvSpPr txBox="1"/>
           <p:nvPr/>
         </p:nvSpPr>
         <p:spPr>
           <a:xfrm>
-            <a:off x="704088" y="4389120"/>
-            <a:ext cx="7744968" cy="1097280"/>
+            <a:off x="704088" y="1353312"/>
+            <a:ext cx="7744968" cy="3300984"/>
           </a:xfrm>
           <a:prstGeom prst="rect">
             <a:avLst/>
@@ -6174,7 +6120,7 @@
               </a:spcAft>
             </a:pPr>
             <a:r>
-              <a:rPr sz="1600" b="1">
+              <a:rPr sz="1800" b="1">
                 <a:solidFill>
                   <a:srgbClr val="E0A437"/>
                 </a:solidFill>
@@ -6183,13 +6129,97 @@
               <a:t>▸ </a:t>
             </a:r>
             <a:r>
-              <a:rPr sz="1600" b="0">
+              <a:rPr sz="1800" b="1">
+                <a:solidFill>
+                  <a:srgbClr val="1D3557"/>
+                </a:solidFill>
+                <a:latin typeface="Fira Sans"/>
+              </a:rPr>
+              <a:t>No que las variables sean normales. Los t y p del summary suponen residuos independientes, con la misma varianza y, con n chico, normales.</a:t>
+            </a:r>
+          </a:p>
+          <a:p>
+            <a:pPr>
+              <a:lnSpc>
+                <a:spcPct val="112000"/>
+              </a:lnSpc>
+              <a:spcAft>
+                <a:spcPts val="900"/>
+              </a:spcAft>
+            </a:pPr>
+            <a:r>
+              <a:rPr sz="1800" b="1">
+                <a:solidFill>
+                  <a:srgbClr val="E0A437"/>
+                </a:solidFill>
+                <a:latin typeface="Fira Sans"/>
+              </a:rPr>
+              <a:t>▸ </a:t>
+            </a:r>
+            <a:r>
+              <a:rPr sz="1800" b="0">
                 <a:solidFill>
                   <a:srgbClr val="000000"/>
                 </a:solidFill>
                 <a:latin typeface="Fira Sans"/>
               </a:rPr>
-              <a:t>Sacar 45 comunas con reemplazo imita el azar del muestreo: algunas se repiten, otras quedan fuera. La distribución de las 2.000 pendientes dice cuánto se mueve la nuestra.</a:t>
+              <a:t>Con n grande el TCL hace el trabajo: un coeficiente es un promedio ponderado de los y, y los promedios se vuelven normales.</a:t>
+            </a:r>
+          </a:p>
+          <a:p>
+            <a:pPr>
+              <a:lnSpc>
+                <a:spcPct val="112000"/>
+              </a:lnSpc>
+              <a:spcAft>
+                <a:spcPts val="900"/>
+              </a:spcAft>
+            </a:pPr>
+            <a:r>
+              <a:rPr sz="1800" b="1">
+                <a:solidFill>
+                  <a:srgbClr val="E0A437"/>
+                </a:solidFill>
+                <a:latin typeface="Fira Sans"/>
+              </a:rPr>
+              <a:t>▸ </a:t>
+            </a:r>
+            <a:r>
+              <a:rPr sz="1800" b="0">
+                <a:solidFill>
+                  <a:srgbClr val="000000"/>
+                </a:solidFill>
+                <a:latin typeface="Fira Sans"/>
+              </a:rPr>
+              <a:t>Lo que sí daña la inferencia: colas largas y atípicos, que inflan el error estándar. El log de la clase 4 también ayuda aquí.</a:t>
+            </a:r>
+          </a:p>
+          <a:p>
+            <a:pPr>
+              <a:lnSpc>
+                <a:spcPct val="112000"/>
+              </a:lnSpc>
+              <a:spcAft>
+                <a:spcPts val="900"/>
+              </a:spcAft>
+            </a:pPr>
+            <a:r>
+              <a:rPr sz="1800" b="1">
+                <a:solidFill>
+                  <a:srgbClr val="E0A437"/>
+                </a:solidFill>
+                <a:latin typeface="Fira Sans"/>
+              </a:rPr>
+              <a:t>▸ </a:t>
+            </a:r>
+            <a:r>
+              <a:rPr sz="1800" b="0">
+                <a:solidFill>
+                  <a:srgbClr val="000000"/>
+                </a:solidFill>
+                <a:latin typeface="Fira Sans"/>
+              </a:rPr>
+              <a:t>Con 45 comunas los supuestos pesan; con 113 mil viajes, casi nada.</a:t>
             </a:r>
           </a:p>
         </p:txBody>
@@ -6227,7 +6257,7 @@
             <a:avLst/>
           </a:prstGeom>
           <a:solidFill>
-            <a:srgbClr val="FAFBFC"/>
+            <a:srgbClr val="1D3557"/>
           </a:solidFill>
           <a:ln>
             <a:noFill/>
@@ -6264,8 +6294,8 @@
         </p:nvSpPr>
         <p:spPr>
           <a:xfrm>
-            <a:off x="402336" y="301752"/>
-            <a:ext cx="8348472" cy="795528"/>
+            <a:off x="603504" y="1847088"/>
+            <a:ext cx="7946136" cy="1399032"/>
           </a:xfrm>
           <a:prstGeom prst="rect">
             <a:avLst/>
@@ -6279,71 +6309,24 @@
           <a:lstStyle/>
           <a:p>
             <a:r>
-              <a:rPr sz="2800" b="1">
-                <a:solidFill>
-                  <a:srgbClr val="0F0F0F"/>
-                </a:solidFill>
-                <a:latin typeface="Fira Sans"/>
-              </a:rPr>
-              <a:t>La pendiente, remuestreada</a:t>
-            </a:r>
-          </a:p>
-        </p:txBody>
-      </p:sp>
-      <p:pic>
-        <p:nvPicPr>
-          <p:cNvPr id="4" name="Picture 3" descr="c5_13_bootstrap.png"/>
-          <p:cNvPicPr>
-            <a:picLocks noChangeAspect="1"/>
-          </p:cNvPicPr>
-          <p:nvPr/>
-        </p:nvPicPr>
-        <p:blipFill>
-          <a:blip r:embed="rId2"/>
-          <a:stretch>
-            <a:fillRect/>
-          </a:stretch>
-        </p:blipFill>
-        <p:spPr>
-          <a:xfrm>
-            <a:off x="1022984" y="1143000"/>
-            <a:ext cx="7098030" cy="3154680"/>
-          </a:xfrm>
-          <a:prstGeom prst="rect">
-            <a:avLst/>
-          </a:prstGeom>
-        </p:spPr>
-      </p:pic>
-      <p:sp>
-        <p:nvSpPr>
-          <p:cNvPr id="5" name="TextBox 4"/>
-          <p:cNvSpPr txBox="1"/>
-          <p:nvPr/>
-        </p:nvSpPr>
-        <p:spPr>
-          <a:xfrm>
-            <a:off x="704088" y="4434840"/>
-            <a:ext cx="7744968" cy="457200"/>
-          </a:xfrm>
-          <a:prstGeom prst="rect">
-            <a:avLst/>
-          </a:prstGeom>
-          <a:noFill/>
-        </p:spPr>
-        <p:txBody>
-          <a:bodyPr wrap="square">
-            <a:spAutoFit/>
-          </a:bodyPr>
-          <a:lstStyle/>
-          <a:p>
-            <a:r>
-              <a:rPr sz="1300" b="0">
-                <a:solidFill>
-                  <a:srgbClr val="333333"/>
-                </a:solidFill>
-                <a:latin typeface="Fira Sans"/>
-              </a:rPr>
-              <a:t>El intervalo bootstrap se parece al de statsmodels y casi ninguna remuestra llega al 0: la misma conclusión por un camino que solo usa el computador. Sirve para cualquier estadístico.</a:t>
+              <a:rPr sz="3400" b="1">
+                <a:solidFill>
+                  <a:srgbClr val="FFFFFF"/>
+                </a:solidFill>
+                <a:latin typeface="Fira Sans"/>
+              </a:rPr>
+              <a:t>Bootstrap</a:t>
+            </a:r>
+          </a:p>
+          <a:p>
+            <a:r>
+              <a:rPr sz="1800" b="0">
+                <a:solidFill>
+                  <a:srgbClr val="E0A437"/>
+                </a:solidFill>
+                <a:latin typeface="Fira Sans"/>
+              </a:rPr>
+              <a:t>La misma respuesta, sin fórmulas</a:t>
             </a:r>
           </a:p>
         </p:txBody>
@@ -6381,7 +6364,7 @@
             <a:avLst/>
           </a:prstGeom>
           <a:solidFill>
-            <a:srgbClr val="1D3557"/>
+            <a:srgbClr val="FAFBFC"/>
           </a:solidFill>
           <a:ln>
             <a:noFill/>
@@ -6418,8 +6401,8 @@
         </p:nvSpPr>
         <p:spPr>
           <a:xfrm>
-            <a:off x="603504" y="1847088"/>
-            <a:ext cx="7946136" cy="1399032"/>
+            <a:off x="402336" y="301752"/>
+            <a:ext cx="8348472" cy="795528"/>
           </a:xfrm>
           <a:prstGeom prst="rect">
             <a:avLst/>
@@ -6433,24 +6416,167 @@
           <a:lstStyle/>
           <a:p>
             <a:r>
-              <a:rPr sz="3400" b="1">
-                <a:solidFill>
-                  <a:srgbClr val="FFFFFF"/>
-                </a:solidFill>
-                <a:latin typeface="Fira Sans"/>
-              </a:rPr>
-              <a:t>¿Qué hogares tienen auto?</a:t>
-            </a:r>
-          </a:p>
-          <a:p>
-            <a:r>
-              <a:rPr sz="1800" b="0">
+              <a:rPr sz="2800" b="1">
+                <a:solidFill>
+                  <a:srgbClr val="0F0F0F"/>
+                </a:solidFill>
+                <a:latin typeface="Fira Sans"/>
+              </a:rPr>
+              <a:t>Remuestrear los datos</a:t>
+            </a:r>
+          </a:p>
+        </p:txBody>
+      </p:sp>
+      <p:sp>
+        <p:nvSpPr>
+          <p:cNvPr id="4" name="Rectangle 3"/>
+          <p:cNvSpPr/>
+          <p:nvPr/>
+        </p:nvSpPr>
+        <p:spPr>
+          <a:xfrm>
+            <a:off x="704088" y="1280160"/>
+            <a:ext cx="7744968" cy="2880360"/>
+          </a:xfrm>
+          <a:prstGeom prst="rect">
+            <a:avLst/>
+          </a:prstGeom>
+          <a:solidFill>
+            <a:srgbClr val="F0F2F5"/>
+          </a:solidFill>
+          <a:ln>
+            <a:solidFill>
+              <a:srgbClr val="D8DDE3"/>
+            </a:solidFill>
+          </a:ln>
+          <a:effectLst/>
+        </p:spPr>
+        <p:style>
+          <a:lnRef idx="1">
+            <a:schemeClr val="accent1"/>
+          </a:lnRef>
+          <a:fillRef idx="3">
+            <a:schemeClr val="accent1"/>
+          </a:fillRef>
+          <a:effectRef idx="2">
+            <a:schemeClr val="accent1"/>
+          </a:effectRef>
+          <a:fontRef idx="minor">
+            <a:schemeClr val="lt1"/>
+          </a:fontRef>
+        </p:style>
+        <p:txBody>
+          <a:bodyPr rtlCol="0" anchor="ctr" wrap="square" lIns="228600" tIns="137160"/>
+          <a:lstStyle/>
+          <a:p>
+            <a:pPr/>
+            <a:r>
+              <a:rPr sz="1500" b="0">
+                <a:solidFill>
+                  <a:srgbClr val="1D3557"/>
+                </a:solidFill>
+                <a:latin typeface="Menlo"/>
+              </a:rPr>
+              <a:t>pendientes = []</a:t>
+            </a:r>
+          </a:p>
+          <a:p>
+            <a:pPr/>
+            <a:r>
+              <a:rPr sz="1500" b="0">
+                <a:solidFill>
+                  <a:srgbClr val="1D3557"/>
+                </a:solidFill>
+                <a:latin typeface="Menlo"/>
+              </a:rPr>
+              <a:t>for _ in range(2000):</a:t>
+            </a:r>
+          </a:p>
+          <a:p>
+            <a:pPr/>
+            <a:r>
+              <a:rPr sz="1500" b="0">
+                <a:solidFill>
+                  <a:srgbClr val="1D3557"/>
+                </a:solidFill>
+                <a:latin typeface="Menlo"/>
+              </a:rPr>
+              <a:t>    idx = rng.integers(0, 45, 45)     # 45 comunas, con reemplazo</a:t>
+            </a:r>
+          </a:p>
+          <a:p>
+            <a:pPr/>
+            <a:r>
+              <a:rPr sz="1500" b="0">
+                <a:solidFill>
+                  <a:srgbClr val="1D3557"/>
+                </a:solidFill>
+                <a:latin typeface="Menlo"/>
+              </a:rPr>
+              <a:t>    pendientes.append(np.polyfit(x[idx], y[idx], 1)[0])</a:t>
+            </a:r>
+          </a:p>
+          <a:p>
+            <a:pPr/>
+            <a:r>
+              <a:rPr sz="1500" b="0">
+                <a:solidFill>
+                  <a:srgbClr val="1D3557"/>
+                </a:solidFill>
+                <a:latin typeface="Menlo"/>
+              </a:rPr>
+              <a:t>np.percentile(pendientes, [2.5, 97.5])</a:t>
+            </a:r>
+          </a:p>
+        </p:txBody>
+      </p:sp>
+      <p:sp>
+        <p:nvSpPr>
+          <p:cNvPr id="5" name="TextBox 4"/>
+          <p:cNvSpPr txBox="1"/>
+          <p:nvPr/>
+        </p:nvSpPr>
+        <p:spPr>
+          <a:xfrm>
+            <a:off x="704088" y="4389120"/>
+            <a:ext cx="7744968" cy="1097280"/>
+          </a:xfrm>
+          <a:prstGeom prst="rect">
+            <a:avLst/>
+          </a:prstGeom>
+          <a:noFill/>
+        </p:spPr>
+        <p:txBody>
+          <a:bodyPr wrap="square">
+            <a:spAutoFit/>
+          </a:bodyPr>
+          <a:lstStyle/>
+          <a:p>
+            <a:pPr>
+              <a:lnSpc>
+                <a:spcPct val="112000"/>
+              </a:lnSpc>
+              <a:spcAft>
+                <a:spcPts val="900"/>
+              </a:spcAft>
+            </a:pPr>
+            <a:r>
+              <a:rPr sz="1600" b="1">
                 <a:solidFill>
                   <a:srgbClr val="E0A437"/>
                 </a:solidFill>
                 <a:latin typeface="Fira Sans"/>
               </a:rPr>
-              <a:t>Explicar un sí o no (tiene auto) con el ingreso del hogar: la regresión logística, y con ella, clasificar</a:t>
+              <a:t>▸ </a:t>
+            </a:r>
+            <a:r>
+              <a:rPr sz="1600" b="0">
+                <a:solidFill>
+                  <a:srgbClr val="000000"/>
+                </a:solidFill>
+                <a:latin typeface="Fira Sans"/>
+              </a:rPr>
+              <a:t>Sacar 45 comunas con reemplazo imita el azar del muestreo: algunas se repiten, otras quedan fuera. La distribución de las 2.000 pendientes dice cuánto se mueve la nuestra.</a:t>
             </a:r>
           </a:p>
         </p:txBody>
@@ -6546,14 +6672,14 @@
                 </a:solidFill>
                 <a:latin typeface="Fira Sans"/>
               </a:rPr>
-              <a:t>La recta no sirve para un sí o no</a:t>
+              <a:t>La pendiente, remuestreada</a:t>
             </a:r>
           </a:p>
         </p:txBody>
       </p:sp>
       <p:pic>
         <p:nvPicPr>
-          <p:cNvPr id="4" name="Picture 3" descr="c5_15_recta_vs_logistica.png"/>
+          <p:cNvPr id="4" name="Picture 3" descr="c5_13_bootstrap.png"/>
           <p:cNvPicPr>
             <a:picLocks noChangeAspect="1"/>
           </p:cNvPicPr>
@@ -6567,8 +6693,8 @@
         </p:blipFill>
         <p:spPr>
           <a:xfrm>
-            <a:off x="1208992" y="1143000"/>
-            <a:ext cx="6726015" cy="3154680"/>
+            <a:off x="1022984" y="1143000"/>
+            <a:ext cx="7098030" cy="3154680"/>
           </a:xfrm>
           <a:prstGeom prst="rect">
             <a:avLst/>
@@ -6604,7 +6730,7 @@
                 </a:solidFill>
                 <a:latin typeface="Fira Sans"/>
               </a:rPr>
-              <a:t>Sobre un 0/1, la recta predice 1,39 a los 5 millones y valores negativos abajo: no respeta que la respuesta vive entre 0 y 1. La logística pasa la recta por una S y queda siempre en el rango.</a:t>
+              <a:t>El intervalo bootstrap se parece al de statsmodels y casi ninguna remuestra llega al 0: la misma conclusión por un camino que solo usa el computador. Sirve para cualquier estadístico.</a:t>
             </a:r>
           </a:p>
         </p:txBody>
@@ -6642,7 +6768,7 @@
             <a:avLst/>
           </a:prstGeom>
           <a:solidFill>
-            <a:srgbClr val="FAFBFC"/>
+            <a:srgbClr val="1D3557"/>
           </a:solidFill>
           <a:ln>
             <a:noFill/>
@@ -6679,8 +6805,8 @@
         </p:nvSpPr>
         <p:spPr>
           <a:xfrm>
-            <a:off x="402336" y="301752"/>
-            <a:ext cx="8348472" cy="795528"/>
+            <a:off x="603504" y="1847088"/>
+            <a:ext cx="7946136" cy="1399032"/>
           </a:xfrm>
           <a:prstGeom prst="rect">
             <a:avLst/>
@@ -6694,71 +6820,24 @@
           <a:lstStyle/>
           <a:p>
             <a:r>
-              <a:rPr sz="2800" b="1">
-                <a:solidFill>
-                  <a:srgbClr val="0F0F0F"/>
-                </a:solidFill>
-                <a:latin typeface="Fira Sans"/>
-              </a:rPr>
-              <a:t>La regresión logística</a:t>
-            </a:r>
-          </a:p>
-        </p:txBody>
-      </p:sp>
-      <p:pic>
-        <p:nvPicPr>
-          <p:cNvPr id="4" name="Picture 3" descr="c5_16_formula_logistica.png"/>
-          <p:cNvPicPr>
-            <a:picLocks noChangeAspect="1"/>
-          </p:cNvPicPr>
-          <p:nvPr/>
-        </p:nvPicPr>
-        <p:blipFill>
-          <a:blip r:embed="rId2"/>
-          <a:stretch>
-            <a:fillRect/>
-          </a:stretch>
-        </p:blipFill>
-        <p:spPr>
-          <a:xfrm>
-            <a:off x="699515" y="1262245"/>
-            <a:ext cx="7744968" cy="2916190"/>
-          </a:xfrm>
-          <a:prstGeom prst="rect">
-            <a:avLst/>
-          </a:prstGeom>
-        </p:spPr>
-      </p:pic>
-      <p:sp>
-        <p:nvSpPr>
-          <p:cNvPr id="5" name="TextBox 4"/>
-          <p:cNvSpPr txBox="1"/>
-          <p:nvPr/>
-        </p:nvSpPr>
-        <p:spPr>
-          <a:xfrm>
-            <a:off x="704088" y="4434840"/>
-            <a:ext cx="7744968" cy="457200"/>
-          </a:xfrm>
-          <a:prstGeom prst="rect">
-            <a:avLst/>
-          </a:prstGeom>
-          <a:noFill/>
-        </p:spPr>
-        <p:txBody>
-          <a:bodyPr wrap="square">
-            <a:spAutoFit/>
-          </a:bodyPr>
-          <a:lstStyle/>
-          <a:p>
-            <a:r>
-              <a:rPr sz="1300" b="0">
-                <a:solidFill>
-                  <a:srgbClr val="333333"/>
-                </a:solidFill>
-                <a:latin typeface="Fira Sans"/>
-              </a:rPr>
-              <a:t>La misma recta a + b·x, pero dentro de la sigmoide. La respuesta es una Bernoulli (la binomial con n = 1) cuya probabilidad depende de x.</a:t>
+              <a:rPr sz="3400" b="1">
+                <a:solidFill>
+                  <a:srgbClr val="FFFFFF"/>
+                </a:solidFill>
+                <a:latin typeface="Fira Sans"/>
+              </a:rPr>
+              <a:t>¿Qué hogares tienen auto?</a:t>
+            </a:r>
+          </a:p>
+          <a:p>
+            <a:r>
+              <a:rPr sz="1800" b="0">
+                <a:solidFill>
+                  <a:srgbClr val="E0A437"/>
+                </a:solidFill>
+                <a:latin typeface="Fira Sans"/>
+              </a:rPr>
+              <a:t>Explicar un sí o no (tiene auto) con el ingreso del hogar: la regresión logística, y con ella, clasificar</a:t>
             </a:r>
           </a:p>
         </p:txBody>
@@ -7141,114 +7220,35 @@
                 </a:solidFill>
                 <a:latin typeface="Fira Sans"/>
               </a:rPr>
-              <a:t>La logística en statsmodels</a:t>
-            </a:r>
-          </a:p>
-        </p:txBody>
-      </p:sp>
-      <p:sp>
-        <p:nvSpPr>
-          <p:cNvPr id="4" name="Rectangle 3"/>
-          <p:cNvSpPr/>
-          <p:nvPr/>
-        </p:nvSpPr>
-        <p:spPr>
-          <a:xfrm>
-            <a:off x="704088" y="1280160"/>
-            <a:ext cx="7744968" cy="2880360"/>
-          </a:xfrm>
-          <a:prstGeom prst="rect">
-            <a:avLst/>
-          </a:prstGeom>
-          <a:solidFill>
-            <a:srgbClr val="F0F2F5"/>
-          </a:solidFill>
-          <a:ln>
-            <a:solidFill>
-              <a:srgbClr val="D8DDE3"/>
-            </a:solidFill>
-          </a:ln>
-          <a:effectLst/>
-        </p:spPr>
-        <p:style>
-          <a:lnRef idx="1">
-            <a:schemeClr val="accent1"/>
-          </a:lnRef>
-          <a:fillRef idx="3">
-            <a:schemeClr val="accent1"/>
-          </a:fillRef>
-          <a:effectRef idx="2">
-            <a:schemeClr val="accent1"/>
-          </a:effectRef>
-          <a:fontRef idx="minor">
-            <a:schemeClr val="lt1"/>
-          </a:fontRef>
-        </p:style>
-        <p:txBody>
-          <a:bodyPr rtlCol="0" anchor="ctr" wrap="square" lIns="228600" tIns="137160"/>
-          <a:lstStyle/>
-          <a:p>
-            <a:pPr/>
-            <a:r>
-              <a:rPr sz="1500" b="0">
-                <a:solidFill>
-                  <a:srgbClr val="1D3557"/>
-                </a:solidFill>
-                <a:latin typeface="Menlo"/>
-              </a:rPr>
-              <a:t>logistica = sm.GLM(h["tiene_auto"], sm.add_constant(ingreso),</a:t>
-            </a:r>
-          </a:p>
-          <a:p>
-            <a:pPr/>
-            <a:r>
-              <a:rPr sz="1500" b="0">
-                <a:solidFill>
-                  <a:srgbClr val="1D3557"/>
-                </a:solidFill>
-                <a:latin typeface="Menlo"/>
-              </a:rPr>
-              <a:t>                   family=sm.families.Binomial(),</a:t>
-            </a:r>
-          </a:p>
-          <a:p>
-            <a:pPr/>
-            <a:r>
-              <a:rPr sz="1500" b="0">
-                <a:solidFill>
-                  <a:srgbClr val="1D3557"/>
-                </a:solidFill>
-                <a:latin typeface="Menlo"/>
-              </a:rPr>
-              <a:t>                   freq_weights=h["Factor"]).fit()</a:t>
-            </a:r>
-          </a:p>
-          <a:p>
-            <a:pPr/>
-            <a:r>
-              <a:rPr sz="1500" b="0">
-                <a:solidFill>
-                  <a:srgbClr val="1D3557"/>
-                </a:solidFill>
-                <a:latin typeface="Menlo"/>
-              </a:rPr>
-              <a:t/>
-            </a:r>
-          </a:p>
-          <a:p>
-            <a:pPr/>
-            <a:r>
-              <a:rPr sz="1500" b="0">
-                <a:solidFill>
-                  <a:srgbClr val="1D3557"/>
-                </a:solidFill>
-                <a:latin typeface="Menlo"/>
-              </a:rPr>
-              <a:t>np.exp(logistica.params["IngresoHogar"])   # 8.9</a:t>
-            </a:r>
-          </a:p>
-        </p:txBody>
-      </p:sp>
+              <a:t>La recta no sirve para un sí o no</a:t>
+            </a:r>
+          </a:p>
+        </p:txBody>
+      </p:sp>
+      <p:pic>
+        <p:nvPicPr>
+          <p:cNvPr id="4" name="Picture 3" descr="c5_15_recta_vs_logistica.png"/>
+          <p:cNvPicPr>
+            <a:picLocks noChangeAspect="1"/>
+          </p:cNvPicPr>
+          <p:nvPr/>
+        </p:nvPicPr>
+        <p:blipFill>
+          <a:blip r:embed="rId2"/>
+          <a:stretch>
+            <a:fillRect/>
+          </a:stretch>
+        </p:blipFill>
+        <p:spPr>
+          <a:xfrm>
+            <a:off x="1208992" y="1143000"/>
+            <a:ext cx="6726015" cy="3154680"/>
+          </a:xfrm>
+          <a:prstGeom prst="rect">
+            <a:avLst/>
+          </a:prstGeom>
+        </p:spPr>
+      </p:pic>
       <p:sp>
         <p:nvSpPr>
           <p:cNvPr id="5" name="TextBox 4"/>
@@ -7257,8 +7257,8 @@
         </p:nvSpPr>
         <p:spPr>
           <a:xfrm>
-            <a:off x="704088" y="4389120"/>
-            <a:ext cx="7744968" cy="1097280"/>
+            <a:off x="704088" y="4434840"/>
+            <a:ext cx="7744968" cy="457200"/>
           </a:xfrm>
           <a:prstGeom prst="rect">
             <a:avLst/>
@@ -7271,31 +7271,14 @@
           </a:bodyPr>
           <a:lstStyle/>
           <a:p>
-            <a:pPr>
-              <a:lnSpc>
-                <a:spcPct val="112000"/>
-              </a:lnSpc>
-              <a:spcAft>
-                <a:spcPts val="900"/>
-              </a:spcAft>
-            </a:pPr>
-            <a:r>
-              <a:rPr sz="1600" b="1">
-                <a:solidFill>
-                  <a:srgbClr val="E0A437"/>
-                </a:solidFill>
-                <a:latin typeface="Fira Sans"/>
-              </a:rPr>
-              <a:t>▸ </a:t>
-            </a:r>
-            <a:r>
-              <a:rPr sz="1600" b="0">
-                <a:solidFill>
-                  <a:srgbClr val="000000"/>
-                </a:solidFill>
-                <a:latin typeface="Fira Sans"/>
-              </a:rPr>
-              <a:t>GLM con familia binomial, ponderado con el factor. Lectura multiplicativa, como el log de la clase 4: cada millón multiplica las chances de tener auto por 8,9.</a:t>
+            <a:r>
+              <a:rPr sz="1300" b="0">
+                <a:solidFill>
+                  <a:srgbClr val="333333"/>
+                </a:solidFill>
+                <a:latin typeface="Fira Sans"/>
+              </a:rPr>
+              <a:t>Sobre un 0/1, la recta predice 1,39 a los 5 millones y valores negativos abajo: no respeta que la respuesta vive entre 0 y 1. La logística pasa la recta por una S y queda siempre en el rango.</a:t>
             </a:r>
           </a:p>
         </p:txBody>
@@ -7391,14 +7374,14 @@
                 </a:solidFill>
                 <a:latin typeface="Fira Sans"/>
               </a:rPr>
-              <a:t>Clasificar: de la probabilidad a la decisión</a:t>
+              <a:t>La regresión logística</a:t>
             </a:r>
           </a:p>
         </p:txBody>
       </p:sp>
       <p:pic>
         <p:nvPicPr>
-          <p:cNvPr id="4" name="Picture 3" descr="c5_17_clasificacion.png"/>
+          <p:cNvPr id="4" name="Picture 3" descr="c5_16_formula_logistica.png"/>
           <p:cNvPicPr>
             <a:picLocks noChangeAspect="1"/>
           </p:cNvPicPr>
@@ -7412,8 +7395,8 @@
         </p:blipFill>
         <p:spPr>
           <a:xfrm>
-            <a:off x="1042506" y="1143000"/>
-            <a:ext cx="7058986" cy="3154680"/>
+            <a:off x="699515" y="1262245"/>
+            <a:ext cx="7744968" cy="2916190"/>
           </a:xfrm>
           <a:prstGeom prst="rect">
             <a:avLst/>
@@ -7449,7 +7432,7 @@
                 </a:solidFill>
                 <a:latin typeface="Fira Sans"/>
               </a:rPr>
-              <a:t>Predecir "tiene auto" cuando P supera 0,5 (desde 0,86 millones). Acierta el 70%, contra el 61% de decir siempre "no": la comparación con la base es obligatoria. Dónde se equivoca lo dice la matriz de confusión (un crosstab).</a:t>
+              <a:t>La misma recta a + b·x, pero dentro de la sigmoide. La respuesta es una Bernoulli (la binomial con n = 1) cuya probabilidad depende de x.</a:t>
             </a:r>
           </a:p>
         </p:txBody>
@@ -7487,7 +7470,7 @@
             <a:avLst/>
           </a:prstGeom>
           <a:solidFill>
-            <a:srgbClr val="1D3557"/>
+            <a:srgbClr val="FAFBFC"/>
           </a:solidFill>
           <a:ln>
             <a:noFill/>
@@ -7524,8 +7507,8 @@
         </p:nvSpPr>
         <p:spPr>
           <a:xfrm>
-            <a:off x="603504" y="1847088"/>
-            <a:ext cx="7946136" cy="1399032"/>
+            <a:off x="402336" y="301752"/>
+            <a:ext cx="8348472" cy="795528"/>
           </a:xfrm>
           <a:prstGeom prst="rect">
             <a:avLst/>
@@ -7539,24 +7522,167 @@
           <a:lstStyle/>
           <a:p>
             <a:r>
-              <a:rPr sz="3400" b="1">
-                <a:solidFill>
-                  <a:srgbClr val="FFFFFF"/>
-                </a:solidFill>
-                <a:latin typeface="Fira Sans"/>
-              </a:rPr>
-              <a:t>La trampa de las comparaciones múltiples</a:t>
-            </a:r>
-          </a:p>
-          <a:p>
-            <a:r>
-              <a:rPr sz="1800" b="0">
+              <a:rPr sz="2800" b="1">
+                <a:solidFill>
+                  <a:srgbClr val="0F0F0F"/>
+                </a:solidFill>
+                <a:latin typeface="Fira Sans"/>
+              </a:rPr>
+              <a:t>La logística en statsmodels</a:t>
+            </a:r>
+          </a:p>
+        </p:txBody>
+      </p:sp>
+      <p:sp>
+        <p:nvSpPr>
+          <p:cNvPr id="4" name="Rectangle 3"/>
+          <p:cNvSpPr/>
+          <p:nvPr/>
+        </p:nvSpPr>
+        <p:spPr>
+          <a:xfrm>
+            <a:off x="704088" y="1280160"/>
+            <a:ext cx="7744968" cy="2880360"/>
+          </a:xfrm>
+          <a:prstGeom prst="rect">
+            <a:avLst/>
+          </a:prstGeom>
+          <a:solidFill>
+            <a:srgbClr val="F0F2F5"/>
+          </a:solidFill>
+          <a:ln>
+            <a:solidFill>
+              <a:srgbClr val="D8DDE3"/>
+            </a:solidFill>
+          </a:ln>
+          <a:effectLst/>
+        </p:spPr>
+        <p:style>
+          <a:lnRef idx="1">
+            <a:schemeClr val="accent1"/>
+          </a:lnRef>
+          <a:fillRef idx="3">
+            <a:schemeClr val="accent1"/>
+          </a:fillRef>
+          <a:effectRef idx="2">
+            <a:schemeClr val="accent1"/>
+          </a:effectRef>
+          <a:fontRef idx="minor">
+            <a:schemeClr val="lt1"/>
+          </a:fontRef>
+        </p:style>
+        <p:txBody>
+          <a:bodyPr rtlCol="0" anchor="ctr" wrap="square" lIns="228600" tIns="137160"/>
+          <a:lstStyle/>
+          <a:p>
+            <a:pPr/>
+            <a:r>
+              <a:rPr sz="1500" b="0">
+                <a:solidFill>
+                  <a:srgbClr val="1D3557"/>
+                </a:solidFill>
+                <a:latin typeface="Menlo"/>
+              </a:rPr>
+              <a:t>logistica = sm.GLM(h["tiene_auto"], sm.add_constant(ingreso),</a:t>
+            </a:r>
+          </a:p>
+          <a:p>
+            <a:pPr/>
+            <a:r>
+              <a:rPr sz="1500" b="0">
+                <a:solidFill>
+                  <a:srgbClr val="1D3557"/>
+                </a:solidFill>
+                <a:latin typeface="Menlo"/>
+              </a:rPr>
+              <a:t>                   family=sm.families.Binomial(),</a:t>
+            </a:r>
+          </a:p>
+          <a:p>
+            <a:pPr/>
+            <a:r>
+              <a:rPr sz="1500" b="0">
+                <a:solidFill>
+                  <a:srgbClr val="1D3557"/>
+                </a:solidFill>
+                <a:latin typeface="Menlo"/>
+              </a:rPr>
+              <a:t>                   freq_weights=h["Factor"]).fit()</a:t>
+            </a:r>
+          </a:p>
+          <a:p>
+            <a:pPr/>
+            <a:r>
+              <a:rPr sz="1500" b="0">
+                <a:solidFill>
+                  <a:srgbClr val="1D3557"/>
+                </a:solidFill>
+                <a:latin typeface="Menlo"/>
+              </a:rPr>
+              <a:t/>
+            </a:r>
+          </a:p>
+          <a:p>
+            <a:pPr/>
+            <a:r>
+              <a:rPr sz="1500" b="0">
+                <a:solidFill>
+                  <a:srgbClr val="1D3557"/>
+                </a:solidFill>
+                <a:latin typeface="Menlo"/>
+              </a:rPr>
+              <a:t>np.exp(logistica.params["IngresoHogar"])   # 8.9</a:t>
+            </a:r>
+          </a:p>
+        </p:txBody>
+      </p:sp>
+      <p:sp>
+        <p:nvSpPr>
+          <p:cNvPr id="5" name="TextBox 4"/>
+          <p:cNvSpPr txBox="1"/>
+          <p:nvPr/>
+        </p:nvSpPr>
+        <p:spPr>
+          <a:xfrm>
+            <a:off x="704088" y="4389120"/>
+            <a:ext cx="7744968" cy="1097280"/>
+          </a:xfrm>
+          <a:prstGeom prst="rect">
+            <a:avLst/>
+          </a:prstGeom>
+          <a:noFill/>
+        </p:spPr>
+        <p:txBody>
+          <a:bodyPr wrap="square">
+            <a:spAutoFit/>
+          </a:bodyPr>
+          <a:lstStyle/>
+          <a:p>
+            <a:pPr>
+              <a:lnSpc>
+                <a:spcPct val="112000"/>
+              </a:lnSpc>
+              <a:spcAft>
+                <a:spcPts val="900"/>
+              </a:spcAft>
+            </a:pPr>
+            <a:r>
+              <a:rPr sz="1600" b="1">
                 <a:solidFill>
                   <a:srgbClr val="E0A437"/>
                 </a:solidFill>
                 <a:latin typeface="Fira Sans"/>
               </a:rPr>
-              <a:t>Qué pasa con el valor p cuando se prueba de todo</a:t>
+              <a:t>▸ </a:t>
+            </a:r>
+            <a:r>
+              <a:rPr sz="1600" b="0">
+                <a:solidFill>
+                  <a:srgbClr val="000000"/>
+                </a:solidFill>
+                <a:latin typeface="Fira Sans"/>
+              </a:rPr>
+              <a:t>GLM con familia binomial, ponderado con el factor. Lectura multiplicativa, como el log de la clase 4: cada millón multiplica las chances de tener auto por 8,9.</a:t>
             </a:r>
           </a:p>
         </p:txBody>
@@ -7652,14 +7778,14 @@
                 </a:solidFill>
                 <a:latin typeface="Fira Sans"/>
               </a:rPr>
-              <a:t>20 variables de puro ruido</a:t>
+              <a:t>Clasificar: de la probabilidad a la decisión</a:t>
             </a:r>
           </a:p>
         </p:txBody>
       </p:sp>
       <p:pic>
         <p:nvPicPr>
-          <p:cNvPr id="4" name="Picture 3" descr="c5_14_comparaciones_multiples.png"/>
+          <p:cNvPr id="4" name="Picture 3" descr="c5_17_clasificacion.png"/>
           <p:cNvPicPr>
             <a:picLocks noChangeAspect="1"/>
           </p:cNvPicPr>
@@ -7673,8 +7799,8 @@
         </p:blipFill>
         <p:spPr>
           <a:xfrm>
-            <a:off x="759392" y="1143000"/>
-            <a:ext cx="7625215" cy="3154680"/>
+            <a:off x="1042506" y="1143000"/>
+            <a:ext cx="7058986" cy="3154680"/>
           </a:xfrm>
           <a:prstGeom prst="rect">
             <a:avLst/>
@@ -7710,7 +7836,7 @@
                 </a:solidFill>
                 <a:latin typeface="Fira Sans"/>
               </a:rPr>
-              <a:t>Números al azar, sin relación con nada, probados contra la duración por comuna: con 20 intentos y umbral 0,05 se espera una falsa alarma. Es lo que pasa al recorrer una matriz de correlación buscando la que dé.</a:t>
+              <a:t>Predecir "tiene auto" cuando P supera 0,5 (desde 0,86 millones). Acierta el 70%, contra el 61% de decir siempre "no": la comparación con la base es obligatoria. Dónde se equivoca lo dice la matriz de confusión (un crosstab).</a:t>
             </a:r>
           </a:p>
         </p:txBody>
@@ -7748,7 +7874,7 @@
             <a:avLst/>
           </a:prstGeom>
           <a:solidFill>
-            <a:srgbClr val="FAFBFC"/>
+            <a:srgbClr val="1D3557"/>
           </a:solidFill>
           <a:ln>
             <a:noFill/>
@@ -7785,8 +7911,8 @@
         </p:nvSpPr>
         <p:spPr>
           <a:xfrm>
-            <a:off x="402336" y="301752"/>
-            <a:ext cx="8348472" cy="795528"/>
+            <a:off x="603504" y="1847088"/>
+            <a:ext cx="7946136" cy="1399032"/>
           </a:xfrm>
           <a:prstGeom prst="rect">
             <a:avLst/>
@@ -7800,148 +7926,24 @@
           <a:lstStyle/>
           <a:p>
             <a:r>
-              <a:rPr sz="2800" b="1">
-                <a:solidFill>
-                  <a:srgbClr val="0F0F0F"/>
-                </a:solidFill>
-                <a:latin typeface="Fira Sans"/>
-              </a:rPr>
-              <a:t>Reglas para el EDA del proyecto</a:t>
-            </a:r>
-          </a:p>
-        </p:txBody>
-      </p:sp>
-      <p:sp>
-        <p:nvSpPr>
-          <p:cNvPr id="4" name="TextBox 3"/>
-          <p:cNvSpPr txBox="1"/>
-          <p:nvPr/>
-        </p:nvSpPr>
-        <p:spPr>
-          <a:xfrm>
-            <a:off x="704088" y="1353312"/>
-            <a:ext cx="7744968" cy="3300984"/>
-          </a:xfrm>
-          <a:prstGeom prst="rect">
-            <a:avLst/>
-          </a:prstGeom>
-          <a:noFill/>
-        </p:spPr>
-        <p:txBody>
-          <a:bodyPr wrap="square">
-            <a:spAutoFit/>
-          </a:bodyPr>
-          <a:lstStyle/>
-          <a:p>
-            <a:pPr>
-              <a:lnSpc>
-                <a:spcPct val="112000"/>
-              </a:lnSpc>
-              <a:spcAft>
-                <a:spcPts val="900"/>
-              </a:spcAft>
-            </a:pPr>
-            <a:r>
-              <a:rPr sz="1800" b="1">
+              <a:rPr sz="3400" b="1">
+                <a:solidFill>
+                  <a:srgbClr val="FFFFFF"/>
+                </a:solidFill>
+                <a:latin typeface="Fira Sans"/>
+              </a:rPr>
+              <a:t>La trampa de las comparaciones múltiples</a:t>
+            </a:r>
+          </a:p>
+          <a:p>
+            <a:r>
+              <a:rPr sz="1800" b="0">
                 <a:solidFill>
                   <a:srgbClr val="E0A437"/>
                 </a:solidFill>
                 <a:latin typeface="Fira Sans"/>
               </a:rPr>
-              <a:t>▸ </a:t>
-            </a:r>
-            <a:r>
-              <a:rPr sz="1800" b="1">
-                <a:solidFill>
-                  <a:srgbClr val="1D3557"/>
-                </a:solidFill>
-                <a:latin typeface="Fira Sans"/>
-              </a:rPr>
-              <a:t>Reportar cuántas pruebas se hicieron; un hallazgo aislado entre muchos intentos merece desconfianza.</a:t>
-            </a:r>
-          </a:p>
-          <a:p>
-            <a:pPr>
-              <a:lnSpc>
-                <a:spcPct val="112000"/>
-              </a:lnSpc>
-              <a:spcAft>
-                <a:spcPts val="900"/>
-              </a:spcAft>
-            </a:pPr>
-            <a:r>
-              <a:rPr sz="1800" b="1">
-                <a:solidFill>
-                  <a:srgbClr val="E0A437"/>
-                </a:solidFill>
-                <a:latin typeface="Fira Sans"/>
-              </a:rPr>
-              <a:t>▸ </a:t>
-            </a:r>
-            <a:r>
-              <a:rPr sz="1800" b="0">
-                <a:solidFill>
-                  <a:srgbClr val="000000"/>
-                </a:solidFill>
-                <a:latin typeface="Fira Sans"/>
-              </a:rPr>
-              <a:t>La corrección más simple, Bonferroni: dividir el umbral por el número de pruebas (0,05 / 20 = 0,0025).</a:t>
-            </a:r>
-          </a:p>
-          <a:p>
-            <a:pPr>
-              <a:lnSpc>
-                <a:spcPct val="112000"/>
-              </a:lnSpc>
-              <a:spcAft>
-                <a:spcPts val="900"/>
-              </a:spcAft>
-            </a:pPr>
-            <a:r>
-              <a:rPr sz="1800" b="1">
-                <a:solidFill>
-                  <a:srgbClr val="E0A437"/>
-                </a:solidFill>
-                <a:latin typeface="Fira Sans"/>
-              </a:rPr>
-              <a:t>▸ </a:t>
-            </a:r>
-            <a:r>
-              <a:rPr sz="1800" b="0">
-                <a:solidFill>
-                  <a:srgbClr val="000000"/>
-                </a:solidFill>
-                <a:latin typeface="Fira Sans"/>
-              </a:rPr>
-              <a:t>Preferir el intervalo de confianza al valor p: muestra el tamaño del efecto y su precisión.</a:t>
-            </a:r>
-          </a:p>
-          <a:p>
-            <a:pPr>
-              <a:lnSpc>
-                <a:spcPct val="112000"/>
-              </a:lnSpc>
-              <a:spcAft>
-                <a:spcPts val="900"/>
-              </a:spcAft>
-            </a:pPr>
-            <a:r>
-              <a:rPr sz="1800" b="1">
-                <a:solidFill>
-                  <a:srgbClr val="E0A437"/>
-                </a:solidFill>
-                <a:latin typeface="Fira Sans"/>
-              </a:rPr>
-              <a:t>▸ </a:t>
-            </a:r>
-            <a:r>
-              <a:rPr sz="1800" b="0">
-                <a:solidFill>
-                  <a:srgbClr val="000000"/>
-                </a:solidFill>
-                <a:latin typeface="Fira Sans"/>
-              </a:rPr>
-              <a:t>Significativo no es importante, y correlación no es causalidad.</a:t>
+              <a:t>Qué pasa con el valor p cuando se prueba de todo</a:t>
             </a:r>
           </a:p>
         </p:txBody>
@@ -8037,21 +8039,45 @@
                 </a:solidFill>
                 <a:latin typeface="Fira Sans"/>
               </a:rPr>
-              <a:t>Síntesis</a:t>
-            </a:r>
-          </a:p>
-        </p:txBody>
-      </p:sp>
-      <p:sp>
-        <p:nvSpPr>
-          <p:cNvPr id="4" name="TextBox 3"/>
+              <a:t>20 variables de puro ruido</a:t>
+            </a:r>
+          </a:p>
+        </p:txBody>
+      </p:sp>
+      <p:pic>
+        <p:nvPicPr>
+          <p:cNvPr id="4" name="Picture 3" descr="c5_14_comparaciones_multiples.png"/>
+          <p:cNvPicPr>
+            <a:picLocks noChangeAspect="1"/>
+          </p:cNvPicPr>
+          <p:nvPr/>
+        </p:nvPicPr>
+        <p:blipFill>
+          <a:blip r:embed="rId2"/>
+          <a:stretch>
+            <a:fillRect/>
+          </a:stretch>
+        </p:blipFill>
+        <p:spPr>
+          <a:xfrm>
+            <a:off x="759392" y="1143000"/>
+            <a:ext cx="7625215" cy="3154680"/>
+          </a:xfrm>
+          <a:prstGeom prst="rect">
+            <a:avLst/>
+          </a:prstGeom>
+        </p:spPr>
+      </p:pic>
+      <p:sp>
+        <p:nvSpPr>
+          <p:cNvPr id="5" name="TextBox 4"/>
           <p:cNvSpPr txBox="1"/>
           <p:nvPr/>
         </p:nvSpPr>
         <p:spPr>
           <a:xfrm>
-            <a:off x="704088" y="1353312"/>
-            <a:ext cx="7744968" cy="3300984"/>
+            <a:off x="704088" y="4434840"/>
+            <a:ext cx="7744968" cy="457200"/>
           </a:xfrm>
           <a:prstGeom prst="rect">
             <a:avLst/>
@@ -8064,171 +8090,14 @@
           </a:bodyPr>
           <a:lstStyle/>
           <a:p>
-            <a:pPr>
-              <a:lnSpc>
-                <a:spcPct val="112000"/>
-              </a:lnSpc>
-              <a:spcAft>
-                <a:spcPts val="900"/>
-              </a:spcAft>
-            </a:pPr>
-            <a:r>
-              <a:rPr sz="1800" b="1">
-                <a:solidFill>
-                  <a:srgbClr val="E0A437"/>
-                </a:solidFill>
-                <a:latin typeface="Fira Sans"/>
-              </a:rPr>
-              <a:t>▸ </a:t>
-            </a:r>
-            <a:r>
-              <a:rPr sz="1800" b="0">
-                <a:solidFill>
-                  <a:srgbClr val="000000"/>
-                </a:solidFill>
-                <a:latin typeface="Fira Sans"/>
-              </a:rPr>
-              <a:t>Una muestra es una de muchas: todo número calculado se movería con otra muestra, y el error estándar mide cuánto.</a:t>
-            </a:r>
-          </a:p>
-          <a:p>
-            <a:pPr>
-              <a:lnSpc>
-                <a:spcPct val="112000"/>
-              </a:lnSpc>
-              <a:spcAft>
-                <a:spcPts val="900"/>
-              </a:spcAft>
-            </a:pPr>
-            <a:r>
-              <a:rPr sz="1800" b="1">
-                <a:solidFill>
-                  <a:srgbClr val="E0A437"/>
-                </a:solidFill>
-                <a:latin typeface="Fira Sans"/>
-              </a:rPr>
-              <a:t>▸ </a:t>
-            </a:r>
-            <a:r>
-              <a:rPr sz="1800" b="0">
-                <a:solidFill>
-                  <a:srgbClr val="000000"/>
-                </a:solidFill>
-                <a:latin typeface="Fira Sans"/>
-              </a:rPr>
-              <a:t>El teorema central del límite: los promedios se distribuyen normal, aunque los datos no.</a:t>
-            </a:r>
-          </a:p>
-          <a:p>
-            <a:pPr>
-              <a:lnSpc>
-                <a:spcPct val="112000"/>
-              </a:lnSpc>
-              <a:spcAft>
-                <a:spcPts val="900"/>
-              </a:spcAft>
-            </a:pPr>
-            <a:r>
-              <a:rPr sz="1800" b="1">
-                <a:solidFill>
-                  <a:srgbClr val="E0A437"/>
-                </a:solidFill>
-                <a:latin typeface="Fira Sans"/>
-              </a:rPr>
-              <a:t>▸ </a:t>
-            </a:r>
-            <a:r>
-              <a:rPr sz="1800" b="0">
-                <a:solidFill>
-                  <a:srgbClr val="000000"/>
-                </a:solidFill>
-                <a:latin typeface="Fira Sans"/>
-              </a:rPr>
-              <a:t>El intervalo de confianza convierte el error estándar en un rango que atrapa el valor real el 95% de las veces.</a:t>
-            </a:r>
-          </a:p>
-          <a:p>
-            <a:pPr>
-              <a:lnSpc>
-                <a:spcPct val="112000"/>
-              </a:lnSpc>
-              <a:spcAft>
-                <a:spcPts val="900"/>
-              </a:spcAft>
-            </a:pPr>
-            <a:r>
-              <a:rPr sz="1800" b="1">
-                <a:solidFill>
-                  <a:srgbClr val="E0A437"/>
-                </a:solidFill>
-                <a:latin typeface="Fira Sans"/>
-              </a:rPr>
-              <a:t>▸ </a:t>
-            </a:r>
-            <a:r>
-              <a:rPr sz="1800" b="0">
-                <a:solidFill>
-                  <a:srgbClr val="000000"/>
-                </a:solidFill>
-                <a:latin typeface="Fira Sans"/>
-              </a:rPr>
-              <a:t>El valor p responde: si el efecto real fuera cero, ¿qué tan raro sería lo observado? Con p &lt; 0,05, la pendiente de −4,8 es real.</a:t>
-            </a:r>
-          </a:p>
-          <a:p>
-            <a:pPr>
-              <a:lnSpc>
-                <a:spcPct val="112000"/>
-              </a:lnSpc>
-              <a:spcAft>
-                <a:spcPts val="900"/>
-              </a:spcAft>
-            </a:pPr>
-            <a:r>
-              <a:rPr sz="1800" b="1">
-                <a:solidFill>
-                  <a:srgbClr val="E0A437"/>
-                </a:solidFill>
-                <a:latin typeface="Fira Sans"/>
-              </a:rPr>
-              <a:t>▸ </a:t>
-            </a:r>
-            <a:r>
-              <a:rPr sz="1800" b="0">
-                <a:solidFill>
-                  <a:srgbClr val="000000"/>
-                </a:solidFill>
-                <a:latin typeface="Fira Sans"/>
-              </a:rPr>
-              <a:t>Para un sí o no, la regresión logística: la recta dentro de una sigmoide; clasificar es cortar en 0,5 y comparar con la base.</a:t>
-            </a:r>
-          </a:p>
-          <a:p>
-            <a:pPr>
-              <a:lnSpc>
-                <a:spcPct val="112000"/>
-              </a:lnSpc>
-              <a:spcAft>
-                <a:spcPts val="900"/>
-              </a:spcAft>
-            </a:pPr>
-            <a:r>
-              <a:rPr sz="1800" b="1">
-                <a:solidFill>
-                  <a:srgbClr val="E0A437"/>
-                </a:solidFill>
-                <a:latin typeface="Fira Sans"/>
-              </a:rPr>
-              <a:t>▸ </a:t>
-            </a:r>
-            <a:r>
-              <a:rPr sz="1800" b="1">
-                <a:solidFill>
-                  <a:srgbClr val="1D3557"/>
-                </a:solidFill>
-                <a:latin typeface="Fira Sans"/>
-              </a:rPr>
-              <a:t>Para el EDA del lunes 15: intervalos, y cuidado con probar de todo.</a:t>
+            <a:r>
+              <a:rPr sz="1300" b="0">
+                <a:solidFill>
+                  <a:srgbClr val="333333"/>
+                </a:solidFill>
+                <a:latin typeface="Fira Sans"/>
+              </a:rPr>
+              <a:t>Números al azar, sin relación con nada, probados contra la duración por comuna: con 20 intentos y umbral 0,05 se espera una falsa alarma. Es lo que pasa al recorrer una matriz de correlación buscando la que dé.</a:t>
             </a:r>
           </a:p>
         </p:txBody>
@@ -8266,7 +8135,7 @@
             <a:avLst/>
           </a:prstGeom>
           <a:solidFill>
-            <a:srgbClr val="1D3557"/>
+            <a:srgbClr val="FAFBFC"/>
           </a:solidFill>
           <a:ln>
             <a:noFill/>
@@ -8303,8 +8172,8 @@
         </p:nvSpPr>
         <p:spPr>
           <a:xfrm>
-            <a:off x="603504" y="1847088"/>
-            <a:ext cx="7946136" cy="1399032"/>
+            <a:off x="402336" y="301752"/>
+            <a:ext cx="8348472" cy="795528"/>
           </a:xfrm>
           <a:prstGeom prst="rect">
             <a:avLst/>
@@ -8318,24 +8187,148 @@
           <a:lstStyle/>
           <a:p>
             <a:r>
-              <a:rPr sz="3400" b="1">
-                <a:solidFill>
-                  <a:srgbClr val="FFFFFF"/>
-                </a:solidFill>
-                <a:latin typeface="Fira Sans"/>
-              </a:rPr>
-              <a:t>Recreo</a:t>
-            </a:r>
-          </a:p>
-          <a:p>
+              <a:rPr sz="2800" b="1">
+                <a:solidFill>
+                  <a:srgbClr val="0F0F0F"/>
+                </a:solidFill>
+                <a:latin typeface="Fira Sans"/>
+              </a:rPr>
+              <a:t>Reglas para el EDA del proyecto</a:t>
+            </a:r>
+          </a:p>
+        </p:txBody>
+      </p:sp>
+      <p:sp>
+        <p:nvSpPr>
+          <p:cNvPr id="4" name="TextBox 3"/>
+          <p:cNvSpPr txBox="1"/>
+          <p:nvPr/>
+        </p:nvSpPr>
+        <p:spPr>
+          <a:xfrm>
+            <a:off x="704088" y="1353312"/>
+            <a:ext cx="7744968" cy="3300984"/>
+          </a:xfrm>
+          <a:prstGeom prst="rect">
+            <a:avLst/>
+          </a:prstGeom>
+          <a:noFill/>
+        </p:spPr>
+        <p:txBody>
+          <a:bodyPr wrap="square">
+            <a:spAutoFit/>
+          </a:bodyPr>
+          <a:lstStyle/>
+          <a:p>
+            <a:pPr>
+              <a:lnSpc>
+                <a:spcPct val="112000"/>
+              </a:lnSpc>
+              <a:spcAft>
+                <a:spcPts val="900"/>
+              </a:spcAft>
+            </a:pPr>
+            <a:r>
+              <a:rPr sz="1800" b="1">
+                <a:solidFill>
+                  <a:srgbClr val="E0A437"/>
+                </a:solidFill>
+                <a:latin typeface="Fira Sans"/>
+              </a:rPr>
+              <a:t>▸ </a:t>
+            </a:r>
+            <a:r>
+              <a:rPr sz="1800" b="1">
+                <a:solidFill>
+                  <a:srgbClr val="1D3557"/>
+                </a:solidFill>
+                <a:latin typeface="Fira Sans"/>
+              </a:rPr>
+              <a:t>Reportar cuántas pruebas se hicieron; un hallazgo aislado entre muchos intentos merece desconfianza.</a:t>
+            </a:r>
+          </a:p>
+          <a:p>
+            <a:pPr>
+              <a:lnSpc>
+                <a:spcPct val="112000"/>
+              </a:lnSpc>
+              <a:spcAft>
+                <a:spcPts val="900"/>
+              </a:spcAft>
+            </a:pPr>
+            <a:r>
+              <a:rPr sz="1800" b="1">
+                <a:solidFill>
+                  <a:srgbClr val="E0A437"/>
+                </a:solidFill>
+                <a:latin typeface="Fira Sans"/>
+              </a:rPr>
+              <a:t>▸ </a:t>
+            </a:r>
             <a:r>
               <a:rPr sz="1800" b="0">
                 <a:solidFill>
+                  <a:srgbClr val="000000"/>
+                </a:solidFill>
+                <a:latin typeface="Fira Sans"/>
+              </a:rPr>
+              <a:t>La corrección más simple, Bonferroni: dividir el umbral por el número de pruebas (0,05 / 20 = 0,0025).</a:t>
+            </a:r>
+          </a:p>
+          <a:p>
+            <a:pPr>
+              <a:lnSpc>
+                <a:spcPct val="112000"/>
+              </a:lnSpc>
+              <a:spcAft>
+                <a:spcPts val="900"/>
+              </a:spcAft>
+            </a:pPr>
+            <a:r>
+              <a:rPr sz="1800" b="1">
+                <a:solidFill>
                   <a:srgbClr val="E0A437"/>
                 </a:solidFill>
                 <a:latin typeface="Fira Sans"/>
               </a:rPr>
-              <a:t>10 minutos · al volver: manos al teclado, con el notebook</a:t>
+              <a:t>▸ </a:t>
+            </a:r>
+            <a:r>
+              <a:rPr sz="1800" b="0">
+                <a:solidFill>
+                  <a:srgbClr val="000000"/>
+                </a:solidFill>
+                <a:latin typeface="Fira Sans"/>
+              </a:rPr>
+              <a:t>Preferir el intervalo de confianza al valor p: muestra el tamaño del efecto y su precisión.</a:t>
+            </a:r>
+          </a:p>
+          <a:p>
+            <a:pPr>
+              <a:lnSpc>
+                <a:spcPct val="112000"/>
+              </a:lnSpc>
+              <a:spcAft>
+                <a:spcPts val="900"/>
+              </a:spcAft>
+            </a:pPr>
+            <a:r>
+              <a:rPr sz="1800" b="1">
+                <a:solidFill>
+                  <a:srgbClr val="E0A437"/>
+                </a:solidFill>
+                <a:latin typeface="Fira Sans"/>
+              </a:rPr>
+              <a:t>▸ </a:t>
+            </a:r>
+            <a:r>
+              <a:rPr sz="1800" b="0">
+                <a:solidFill>
+                  <a:srgbClr val="000000"/>
+                </a:solidFill>
+                <a:latin typeface="Fira Sans"/>
+              </a:rPr>
+              <a:t>Significativo no es importante, y correlación no es causalidad.</a:t>
             </a:r>
           </a:p>
         </p:txBody>
@@ -8431,7 +8424,7 @@
                 </a:solidFill>
                 <a:latin typeface="Fira Sans"/>
               </a:rPr>
-              <a:t>Próxima clase</a:t>
+              <a:t>Síntesis</a:t>
             </a:r>
           </a:p>
         </p:txBody>
@@ -8482,7 +8475,7 @@
                 </a:solidFill>
                 <a:latin typeface="Fira Sans"/>
               </a:rPr>
-              <a:t>Jueves 10: regresión lineal en profundidad: supuestos, diagnósticos con los residuos y evaluación fuera de la muestra.</a:t>
+              <a:t>Una muestra es una de muchas: todo número calculado se movería con otra muestra, y el error estándar mide cuánto.</a:t>
             </a:r>
           </a:p>
           <a:p>
@@ -8510,7 +8503,7 @@
                 </a:solidFill>
                 <a:latin typeface="Fira Sans"/>
               </a:rPr>
-              <a:t>Con lo de hoy ya se puede leer completo el summary de cualquier modelo.</a:t>
+              <a:t>El teorema central del límite: los promedios se distribuyen normal, aunque los datos no.</a:t>
             </a:r>
           </a:p>
           <a:p>
@@ -8532,13 +8525,97 @@
               <a:t>▸ </a:t>
             </a:r>
             <a:r>
+              <a:rPr sz="1800" b="0">
+                <a:solidFill>
+                  <a:srgbClr val="000000"/>
+                </a:solidFill>
+                <a:latin typeface="Fira Sans"/>
+              </a:rPr>
+              <a:t>El intervalo de confianza convierte el error estándar en un rango que atrapa el valor real el 95% de las veces.</a:t>
+            </a:r>
+          </a:p>
+          <a:p>
+            <a:pPr>
+              <a:lnSpc>
+                <a:spcPct val="112000"/>
+              </a:lnSpc>
+              <a:spcAft>
+                <a:spcPts val="900"/>
+              </a:spcAft>
+            </a:pPr>
+            <a:r>
               <a:rPr sz="1800" b="1">
                 <a:solidFill>
+                  <a:srgbClr val="E0A437"/>
+                </a:solidFill>
+                <a:latin typeface="Fira Sans"/>
+              </a:rPr>
+              <a:t>▸ </a:t>
+            </a:r>
+            <a:r>
+              <a:rPr sz="1800" b="0">
+                <a:solidFill>
+                  <a:srgbClr val="000000"/>
+                </a:solidFill>
+                <a:latin typeface="Fira Sans"/>
+              </a:rPr>
+              <a:t>El valor p responde: si el efecto real fuera cero, ¿qué tan raro sería lo observado? Con p &lt; 0,05, la pendiente de −4,8 es real.</a:t>
+            </a:r>
+          </a:p>
+          <a:p>
+            <a:pPr>
+              <a:lnSpc>
+                <a:spcPct val="112000"/>
+              </a:lnSpc>
+              <a:spcAft>
+                <a:spcPts val="900"/>
+              </a:spcAft>
+            </a:pPr>
+            <a:r>
+              <a:rPr sz="1800" b="1">
+                <a:solidFill>
+                  <a:srgbClr val="E0A437"/>
+                </a:solidFill>
+                <a:latin typeface="Fira Sans"/>
+              </a:rPr>
+              <a:t>▸ </a:t>
+            </a:r>
+            <a:r>
+              <a:rPr sz="1800" b="0">
+                <a:solidFill>
+                  <a:srgbClr val="000000"/>
+                </a:solidFill>
+                <a:latin typeface="Fira Sans"/>
+              </a:rPr>
+              <a:t>Para un sí o no, la regresión logística: la recta dentro de una sigmoide; clasificar es cortar en 0,5 y comparar con la base.</a:t>
+            </a:r>
+          </a:p>
+          <a:p>
+            <a:pPr>
+              <a:lnSpc>
+                <a:spcPct val="112000"/>
+              </a:lnSpc>
+              <a:spcAft>
+                <a:spcPts val="900"/>
+              </a:spcAft>
+            </a:pPr>
+            <a:r>
+              <a:rPr sz="1800" b="1">
+                <a:solidFill>
+                  <a:srgbClr val="E0A437"/>
+                </a:solidFill>
+                <a:latin typeface="Fira Sans"/>
+              </a:rPr>
+              <a:t>▸ </a:t>
+            </a:r>
+            <a:r>
+              <a:rPr sz="1800" b="1">
+                <a:solidFill>
                   <a:srgbClr val="1D3557"/>
                 </a:solidFill>
                 <a:latin typeface="Fira Sans"/>
               </a:rPr>
-              <a:t>El primer análisis exploratorio se entrega el lunes 15.</a:t>
+              <a:t>Para el EDA del lunes 15: intervalos, y cuidado con probar de todo.</a:t>
             </a:r>
           </a:p>
         </p:txBody>
@@ -8576,6 +8653,113 @@
             <a:avLst/>
           </a:prstGeom>
           <a:solidFill>
+            <a:srgbClr val="1D3557"/>
+          </a:solidFill>
+          <a:ln>
+            <a:noFill/>
+          </a:ln>
+          <a:effectLst/>
+        </p:spPr>
+        <p:style>
+          <a:lnRef idx="1">
+            <a:schemeClr val="accent1"/>
+          </a:lnRef>
+          <a:fillRef idx="3">
+            <a:schemeClr val="accent1"/>
+          </a:fillRef>
+          <a:effectRef idx="2">
+            <a:schemeClr val="accent1"/>
+          </a:effectRef>
+          <a:fontRef idx="minor">
+            <a:schemeClr val="lt1"/>
+          </a:fontRef>
+        </p:style>
+        <p:txBody>
+          <a:bodyPr rtlCol="0" anchor="ctr"/>
+          <a:lstStyle/>
+          <a:p>
+            <a:pPr algn="ctr"/>
+          </a:p>
+        </p:txBody>
+      </p:sp>
+      <p:sp>
+        <p:nvSpPr>
+          <p:cNvPr id="3" name="TextBox 2"/>
+          <p:cNvSpPr txBox="1"/>
+          <p:nvPr/>
+        </p:nvSpPr>
+        <p:spPr>
+          <a:xfrm>
+            <a:off x="603504" y="1847088"/>
+            <a:ext cx="7946136" cy="1399032"/>
+          </a:xfrm>
+          <a:prstGeom prst="rect">
+            <a:avLst/>
+          </a:prstGeom>
+          <a:noFill/>
+        </p:spPr>
+        <p:txBody>
+          <a:bodyPr wrap="square">
+            <a:spAutoFit/>
+          </a:bodyPr>
+          <a:lstStyle/>
+          <a:p>
+            <a:r>
+              <a:rPr sz="3400" b="1">
+                <a:solidFill>
+                  <a:srgbClr val="FFFFFF"/>
+                </a:solidFill>
+                <a:latin typeface="Fira Sans"/>
+              </a:rPr>
+              <a:t>Recreo</a:t>
+            </a:r>
+          </a:p>
+          <a:p>
+            <a:r>
+              <a:rPr sz="1800" b="0">
+                <a:solidFill>
+                  <a:srgbClr val="E0A437"/>
+                </a:solidFill>
+                <a:latin typeface="Fira Sans"/>
+              </a:rPr>
+              <a:t>10 minutos · al volver: manos al teclado, con el notebook</a:t>
+            </a:r>
+          </a:p>
+        </p:txBody>
+      </p:sp>
+    </p:spTree>
+  </p:cSld>
+  <p:clrMapOvr>
+    <a:masterClrMapping/>
+  </p:clrMapOvr>
+</p:sld>
+</file>
+
+<file path=ppt/slides/slide39.xml><?xml version="1.0" encoding="utf-8"?>
+<p:sld xmlns:a="http://schemas.openxmlformats.org/drawingml/2006/main" xmlns:p="http://schemas.openxmlformats.org/presentationml/2006/main" xmlns:r="http://schemas.openxmlformats.org/officeDocument/2006/relationships">
+  <p:cSld>
+    <p:spTree>
+      <p:nvGrpSpPr>
+        <p:cNvPr id="1" name=""/>
+        <p:cNvGrpSpPr/>
+        <p:nvPr/>
+      </p:nvGrpSpPr>
+      <p:grpSpPr/>
+      <p:sp>
+        <p:nvSpPr>
+          <p:cNvPr id="2" name="Rectangle 1"/>
+          <p:cNvSpPr/>
+          <p:nvPr/>
+        </p:nvSpPr>
+        <p:spPr>
+          <a:xfrm>
+            <a:off x="0" y="0"/>
+            <a:ext cx="9144000" cy="5138928"/>
+          </a:xfrm>
+          <a:prstGeom prst="rect">
+            <a:avLst/>
+          </a:prstGeom>
+          <a:solidFill>
             <a:srgbClr val="FAFBFC"/>
           </a:solidFill>
           <a:ln>
@@ -8634,7 +8818,7 @@
                 </a:solidFill>
                 <a:latin typeface="Fira Sans"/>
               </a:rPr>
-              <a:t>Referencias</a:t>
+              <a:t>Próxima clase</a:t>
             </a:r>
           </a:p>
         </p:txBody>
@@ -8647,8 +8831,8 @@
         </p:nvSpPr>
         <p:spPr>
           <a:xfrm>
-            <a:off x="704088" y="1234440"/>
-            <a:ext cx="7744968" cy="3566160"/>
+            <a:off x="704088" y="1353312"/>
+            <a:ext cx="7744968" cy="3300984"/>
           </a:xfrm>
           <a:prstGeom prst="rect">
             <a:avLst/>
@@ -8663,77 +8847,85 @@
           <a:p>
             <a:pPr>
               <a:lnSpc>
-                <a:spcPct val="115000"/>
+                <a:spcPct val="112000"/>
               </a:lnSpc>
               <a:spcAft>
-                <a:spcPts val="700"/>
+                <a:spcPts val="900"/>
               </a:spcAft>
             </a:pPr>
             <a:r>
-              <a:rPr sz="1300" b="0">
-                <a:solidFill>
-                  <a:srgbClr val="333333"/>
-                </a:solidFill>
-                <a:latin typeface="Fira Sans"/>
-              </a:rPr>
-              <a:t>Efron, B. y Tibshirani, R. J. (1993). An Introduction to the Bootstrap. Chapman &amp; Hall.</a:t>
+              <a:rPr sz="1800" b="1">
+                <a:solidFill>
+                  <a:srgbClr val="E0A437"/>
+                </a:solidFill>
+                <a:latin typeface="Fira Sans"/>
+              </a:rPr>
+              <a:t>▸ </a:t>
+            </a:r>
+            <a:r>
+              <a:rPr sz="1800" b="0">
+                <a:solidFill>
+                  <a:srgbClr val="000000"/>
+                </a:solidFill>
+                <a:latin typeface="Fira Sans"/>
+              </a:rPr>
+              <a:t>Jueves 10: regresión lineal en profundidad: supuestos, diagnósticos con los residuos y evaluación fuera de la muestra.</a:t>
             </a:r>
           </a:p>
           <a:p>
             <a:pPr>
               <a:lnSpc>
-                <a:spcPct val="115000"/>
+                <a:spcPct val="112000"/>
               </a:lnSpc>
               <a:spcAft>
-                <a:spcPts val="700"/>
+                <a:spcPts val="900"/>
               </a:spcAft>
             </a:pPr>
             <a:r>
-              <a:rPr sz="1300" b="0">
-                <a:solidFill>
-                  <a:srgbClr val="333333"/>
-                </a:solidFill>
-                <a:latin typeface="Fira Sans"/>
-              </a:rPr>
-              <a:t>Wasserstein, R. L. y Lazar, N. A. (2016). The ASA Statement on p-Values: Context, Process, and Purpose. The American Statistician, 70(2), 129-133.</a:t>
+              <a:rPr sz="1800" b="1">
+                <a:solidFill>
+                  <a:srgbClr val="E0A437"/>
+                </a:solidFill>
+                <a:latin typeface="Fira Sans"/>
+              </a:rPr>
+              <a:t>▸ </a:t>
+            </a:r>
+            <a:r>
+              <a:rPr sz="1800" b="0">
+                <a:solidFill>
+                  <a:srgbClr val="000000"/>
+                </a:solidFill>
+                <a:latin typeface="Fira Sans"/>
+              </a:rPr>
+              <a:t>Con lo de hoy ya se puede leer completo el summary de cualquier modelo.</a:t>
             </a:r>
           </a:p>
           <a:p>
             <a:pPr>
               <a:lnSpc>
-                <a:spcPct val="115000"/>
+                <a:spcPct val="112000"/>
               </a:lnSpc>
               <a:spcAft>
-                <a:spcPts val="700"/>
+                <a:spcPts val="900"/>
               </a:spcAft>
             </a:pPr>
             <a:r>
-              <a:rPr sz="1300" b="0">
-                <a:solidFill>
-                  <a:srgbClr val="333333"/>
-                </a:solidFill>
-                <a:latin typeface="Fira Sans"/>
-              </a:rPr>
-              <a:t>VanderPlas, J. (2016). Python Data Science Handbook. O'Reilly.</a:t>
-            </a:r>
-          </a:p>
-          <a:p>
-            <a:pPr>
-              <a:lnSpc>
-                <a:spcPct val="115000"/>
-              </a:lnSpc>
-              <a:spcAft>
-                <a:spcPts val="700"/>
-              </a:spcAft>
-            </a:pPr>
-            <a:r>
-              <a:rPr sz="1300" b="0">
-                <a:solidFill>
-                  <a:srgbClr val="333333"/>
-                </a:solidFill>
-                <a:latin typeface="Fira Sans"/>
-              </a:rPr>
-              <a:t>Datos: Encuesta Origen Destino Santiago 2012 (Sectra).</a:t>
+              <a:rPr sz="1800" b="1">
+                <a:solidFill>
+                  <a:srgbClr val="E0A437"/>
+                </a:solidFill>
+                <a:latin typeface="Fira Sans"/>
+              </a:rPr>
+              <a:t>▸ </a:t>
+            </a:r>
+            <a:r>
+              <a:rPr sz="1800" b="1">
+                <a:solidFill>
+                  <a:srgbClr val="1D3557"/>
+                </a:solidFill>
+                <a:latin typeface="Fira Sans"/>
+              </a:rPr>
+              <a:t>El primer análisis exploratorio se entrega el lunes 15.</a:t>
             </a:r>
           </a:p>
         </p:txBody>
@@ -8853,6 +9045,201 @@
 </p:sld>
 </file>
 
+<file path=ppt/slides/slide40.xml><?xml version="1.0" encoding="utf-8"?>
+<p:sld xmlns:a="http://schemas.openxmlformats.org/drawingml/2006/main" xmlns:p="http://schemas.openxmlformats.org/presentationml/2006/main" xmlns:r="http://schemas.openxmlformats.org/officeDocument/2006/relationships">
+  <p:cSld>
+    <p:spTree>
+      <p:nvGrpSpPr>
+        <p:cNvPr id="1" name=""/>
+        <p:cNvGrpSpPr/>
+        <p:nvPr/>
+      </p:nvGrpSpPr>
+      <p:grpSpPr/>
+      <p:sp>
+        <p:nvSpPr>
+          <p:cNvPr id="2" name="Rectangle 1"/>
+          <p:cNvSpPr/>
+          <p:nvPr/>
+        </p:nvSpPr>
+        <p:spPr>
+          <a:xfrm>
+            <a:off x="0" y="0"/>
+            <a:ext cx="9144000" cy="5138928"/>
+          </a:xfrm>
+          <a:prstGeom prst="rect">
+            <a:avLst/>
+          </a:prstGeom>
+          <a:solidFill>
+            <a:srgbClr val="FAFBFC"/>
+          </a:solidFill>
+          <a:ln>
+            <a:noFill/>
+          </a:ln>
+          <a:effectLst/>
+        </p:spPr>
+        <p:style>
+          <a:lnRef idx="1">
+            <a:schemeClr val="accent1"/>
+          </a:lnRef>
+          <a:fillRef idx="3">
+            <a:schemeClr val="accent1"/>
+          </a:fillRef>
+          <a:effectRef idx="2">
+            <a:schemeClr val="accent1"/>
+          </a:effectRef>
+          <a:fontRef idx="minor">
+            <a:schemeClr val="lt1"/>
+          </a:fontRef>
+        </p:style>
+        <p:txBody>
+          <a:bodyPr rtlCol="0" anchor="ctr"/>
+          <a:lstStyle/>
+          <a:p>
+            <a:pPr algn="ctr"/>
+          </a:p>
+        </p:txBody>
+      </p:sp>
+      <p:sp>
+        <p:nvSpPr>
+          <p:cNvPr id="3" name="TextBox 2"/>
+          <p:cNvSpPr txBox="1"/>
+          <p:nvPr/>
+        </p:nvSpPr>
+        <p:spPr>
+          <a:xfrm>
+            <a:off x="402336" y="301752"/>
+            <a:ext cx="8348472" cy="795528"/>
+          </a:xfrm>
+          <a:prstGeom prst="rect">
+            <a:avLst/>
+          </a:prstGeom>
+          <a:noFill/>
+        </p:spPr>
+        <p:txBody>
+          <a:bodyPr wrap="square">
+            <a:spAutoFit/>
+          </a:bodyPr>
+          <a:lstStyle/>
+          <a:p>
+            <a:r>
+              <a:rPr sz="2800" b="1">
+                <a:solidFill>
+                  <a:srgbClr val="0F0F0F"/>
+                </a:solidFill>
+                <a:latin typeface="Fira Sans"/>
+              </a:rPr>
+              <a:t>Referencias</a:t>
+            </a:r>
+          </a:p>
+        </p:txBody>
+      </p:sp>
+      <p:sp>
+        <p:nvSpPr>
+          <p:cNvPr id="4" name="TextBox 3"/>
+          <p:cNvSpPr txBox="1"/>
+          <p:nvPr/>
+        </p:nvSpPr>
+        <p:spPr>
+          <a:xfrm>
+            <a:off x="704088" y="1234440"/>
+            <a:ext cx="7744968" cy="3566160"/>
+          </a:xfrm>
+          <a:prstGeom prst="rect">
+            <a:avLst/>
+          </a:prstGeom>
+          <a:noFill/>
+        </p:spPr>
+        <p:txBody>
+          <a:bodyPr wrap="square">
+            <a:spAutoFit/>
+          </a:bodyPr>
+          <a:lstStyle/>
+          <a:p>
+            <a:pPr>
+              <a:lnSpc>
+                <a:spcPct val="115000"/>
+              </a:lnSpc>
+              <a:spcAft>
+                <a:spcPts val="700"/>
+              </a:spcAft>
+            </a:pPr>
+            <a:r>
+              <a:rPr sz="1300" b="0">
+                <a:solidFill>
+                  <a:srgbClr val="333333"/>
+                </a:solidFill>
+                <a:latin typeface="Fira Sans"/>
+              </a:rPr>
+              <a:t>Efron, B. y Tibshirani, R. J. (1993). An Introduction to the Bootstrap. Chapman &amp; Hall.</a:t>
+            </a:r>
+          </a:p>
+          <a:p>
+            <a:pPr>
+              <a:lnSpc>
+                <a:spcPct val="115000"/>
+              </a:lnSpc>
+              <a:spcAft>
+                <a:spcPts val="700"/>
+              </a:spcAft>
+            </a:pPr>
+            <a:r>
+              <a:rPr sz="1300" b="0">
+                <a:solidFill>
+                  <a:srgbClr val="333333"/>
+                </a:solidFill>
+                <a:latin typeface="Fira Sans"/>
+              </a:rPr>
+              <a:t>Wasserstein, R. L. y Lazar, N. A. (2016). The ASA Statement on p-Values: Context, Process, and Purpose. The American Statistician, 70(2), 129-133.</a:t>
+            </a:r>
+          </a:p>
+          <a:p>
+            <a:pPr>
+              <a:lnSpc>
+                <a:spcPct val="115000"/>
+              </a:lnSpc>
+              <a:spcAft>
+                <a:spcPts val="700"/>
+              </a:spcAft>
+            </a:pPr>
+            <a:r>
+              <a:rPr sz="1300" b="0">
+                <a:solidFill>
+                  <a:srgbClr val="333333"/>
+                </a:solidFill>
+                <a:latin typeface="Fira Sans"/>
+              </a:rPr>
+              <a:t>VanderPlas, J. (2016). Python Data Science Handbook. O'Reilly.</a:t>
+            </a:r>
+          </a:p>
+          <a:p>
+            <a:pPr>
+              <a:lnSpc>
+                <a:spcPct val="115000"/>
+              </a:lnSpc>
+              <a:spcAft>
+                <a:spcPts val="700"/>
+              </a:spcAft>
+            </a:pPr>
+            <a:r>
+              <a:rPr sz="1300" b="0">
+                <a:solidFill>
+                  <a:srgbClr val="333333"/>
+                </a:solidFill>
+                <a:latin typeface="Fira Sans"/>
+              </a:rPr>
+              <a:t>Datos: Encuesta Origen Destino Santiago 2012 (Sectra).</a:t>
+            </a:r>
+          </a:p>
+        </p:txBody>
+      </p:sp>
+    </p:spTree>
+  </p:cSld>
+  <p:clrMapOvr>
+    <a:masterClrMapping/>
+  </p:clrMapOvr>
+</p:sld>
+</file>
+
 <file path=ppt/slides/slide5.xml><?xml version="1.0" encoding="utf-8"?>
 <p:sld xmlns:a="http://schemas.openxmlformats.org/drawingml/2006/main" xmlns:p="http://schemas.openxmlformats.org/presentationml/2006/main" xmlns:r="http://schemas.openxmlformats.org/officeDocument/2006/relationships">
   <p:cSld>
@@ -9218,8 +9605,8 @@
         </p:blipFill>
         <p:spPr>
           <a:xfrm>
-            <a:off x="776525" y="1143000"/>
-            <a:ext cx="7590948" cy="3154680"/>
+            <a:off x="699515" y="1438850"/>
+            <a:ext cx="7744968" cy="2562978"/>
           </a:xfrm>
           <a:prstGeom prst="rect">
             <a:avLst/>
@@ -9255,7 +9642,7 @@
                 </a:solidFill>
                 <a:latin typeface="Fira Sans"/>
               </a:rPr>
-              <a:t>La campana: dos parámetros, μ (centro) y σ (dispersión). El 95% de los valores cae a menos de 1,96 σ de la media; ese 1,96 vuelve en los intervalos de confianza.</a:t>
+              <a:t>La campana tiene dos parámetros: μ, la media, y σ, la desviación estándar. El 95% de los valores cae a menos de 1,96 σ de la media; ese 1,96 vuelve en los intervalos de confianza.</a:t>
             </a:r>
           </a:p>
         </p:txBody>

</xml_diff>

<commit_message>
Clase 5: definición de inferencia, por qué aparece la normal (diagrama del camino), ajustes de texto
Co-Authored-By: Claude Fable 5.1 <noreply@anthropic.com>
</commit_message>
<xml_diff>
--- a/presentaciones/clase05_probabilidad_inferencia.pptx
+++ b/presentaciones/clase05_probabilidad_inferencia.pptx
@@ -45,6 +45,8 @@
     <p:sldId id="293" r:id="rId44"/>
     <p:sldId id="294" r:id="rId45"/>
     <p:sldId id="295" r:id="rId46"/>
+    <p:sldId id="296" r:id="rId47"/>
+    <p:sldId id="297" r:id="rId48"/>
   </p:sldIdLst>
   <p:sldSz cx="9144000" cy="5138928" type="screen4x3"/>
   <p:notesSz cx="6858000" cy="9144000"/>
@@ -3404,7 +3406,7 @@
             <a:avLst/>
           </a:prstGeom>
           <a:solidFill>
-            <a:srgbClr val="1D3557"/>
+            <a:srgbClr val="FAFBFC"/>
           </a:solidFill>
           <a:ln>
             <a:noFill/>
@@ -3441,8 +3443,8 @@
         </p:nvSpPr>
         <p:spPr>
           <a:xfrm>
-            <a:off x="603504" y="1847088"/>
-            <a:ext cx="7946136" cy="1399032"/>
+            <a:off x="402336" y="301752"/>
+            <a:ext cx="8348472" cy="795528"/>
           </a:xfrm>
           <a:prstGeom prst="rect">
             <a:avLst/>
@@ -3456,24 +3458,71 @@
           <a:lstStyle/>
           <a:p>
             <a:r>
-              <a:rPr sz="3400" b="1">
-                <a:solidFill>
-                  <a:srgbClr val="FFFFFF"/>
-                </a:solidFill>
-                <a:latin typeface="Fira Sans"/>
-              </a:rPr>
-              <a:t>Muestra y población</a:t>
-            </a:r>
-          </a:p>
-          <a:p>
-            <a:r>
-              <a:rPr sz="1800" b="0">
-                <a:solidFill>
-                  <a:srgbClr val="E0A437"/>
-                </a:solidFill>
-                <a:latin typeface="Fira Sans"/>
-              </a:rPr>
-              <a:t>Una muestra es una de muchas posibles</a:t>
+              <a:rPr sz="2800" b="1">
+                <a:solidFill>
+                  <a:srgbClr val="0F0F0F"/>
+                </a:solidFill>
+                <a:latin typeface="Fira Sans"/>
+              </a:rPr>
+              <a:t>¿Es normal la duración? En minutos no; en log, casi</a:t>
+            </a:r>
+          </a:p>
+        </p:txBody>
+      </p:sp>
+      <p:pic>
+        <p:nvPicPr>
+          <p:cNvPr id="4" name="Picture 3" descr="c5_02_normal_log.png"/>
+          <p:cNvPicPr>
+            <a:picLocks noChangeAspect="1"/>
+          </p:cNvPicPr>
+          <p:nvPr/>
+        </p:nvPicPr>
+        <p:blipFill>
+          <a:blip r:embed="rId2"/>
+          <a:stretch>
+            <a:fillRect/>
+          </a:stretch>
+        </p:blipFill>
+        <p:spPr>
+          <a:xfrm>
+            <a:off x="699515" y="1443171"/>
+            <a:ext cx="7744968" cy="2554337"/>
+          </a:xfrm>
+          <a:prstGeom prst="rect">
+            <a:avLst/>
+          </a:prstGeom>
+        </p:spPr>
+      </p:pic>
+      <p:sp>
+        <p:nvSpPr>
+          <p:cNvPr id="5" name="TextBox 4"/>
+          <p:cNvSpPr txBox="1"/>
+          <p:nvPr/>
+        </p:nvSpPr>
+        <p:spPr>
+          <a:xfrm>
+            <a:off x="704088" y="4434840"/>
+            <a:ext cx="7744968" cy="457200"/>
+          </a:xfrm>
+          <a:prstGeom prst="rect">
+            <a:avLst/>
+          </a:prstGeom>
+          <a:noFill/>
+        </p:spPr>
+        <p:txBody>
+          <a:bodyPr wrap="square">
+            <a:spAutoFit/>
+          </a:bodyPr>
+          <a:lstStyle/>
+          <a:p>
+            <a:r>
+              <a:rPr sz="1300" b="0">
+                <a:solidFill>
+                  <a:srgbClr val="333333"/>
+                </a:solidFill>
+                <a:latin typeface="Fira Sans"/>
+              </a:rPr>
+              <a:t>La cola larga (asimetría 5,3) se aleja de la normal; en log la variable se acomoda a la campana. Es la razón de fondo del log de la clase 4.</a:t>
             </a:r>
           </a:p>
         </p:txBody>
@@ -3569,14 +3618,14 @@
                 </a:solidFill>
                 <a:latin typeface="Fira Sans"/>
               </a:rPr>
-              <a:t>Dos muestras, dos medias</a:t>
+              <a:t>Una distribución para contar: la binomial</a:t>
             </a:r>
           </a:p>
         </p:txBody>
       </p:sp>
       <p:pic>
         <p:nvPicPr>
-          <p:cNvPr id="4" name="Picture 3" descr="c5_05_dos_muestras.png"/>
+          <p:cNvPr id="4" name="Picture 3" descr="c5_04_binomial.png"/>
           <p:cNvPicPr>
             <a:picLocks noChangeAspect="1"/>
           </p:cNvPicPr>
@@ -3590,8 +3639,8 @@
         </p:blipFill>
         <p:spPr>
           <a:xfrm>
-            <a:off x="699515" y="1441281"/>
-            <a:ext cx="7744968" cy="2558117"/>
+            <a:off x="964643" y="1143000"/>
+            <a:ext cx="7214713" cy="3154680"/>
           </a:xfrm>
           <a:prstGeom prst="rect">
             <a:avLst/>
@@ -3627,7 +3676,7 @@
                 </a:solidFill>
                 <a:latin typeface="Fira Sans"/>
               </a:rPr>
-              <a:t>Hoy tratamos los 113 mil viajes de la EOD como si fueran la población, para poder muestrear muchas veces. Cada muestra de 100 viajes da otra media; ninguna es la poblacional.</a:t>
+              <a:t>El número de éxitos en n intentos independientes con probabilidad p: cuántos viajes en auto entre 20 tomados al azar. Otra distribución con nombre y fórmula.</a:t>
             </a:r>
           </a:p>
         </p:txBody>
@@ -3665,7 +3714,7 @@
             <a:avLst/>
           </a:prstGeom>
           <a:solidFill>
-            <a:srgbClr val="FAFBFC"/>
+            <a:srgbClr val="1D3557"/>
           </a:solidFill>
           <a:ln>
             <a:noFill/>
@@ -3702,8 +3751,8 @@
         </p:nvSpPr>
         <p:spPr>
           <a:xfrm>
-            <a:off x="402336" y="301752"/>
-            <a:ext cx="8348472" cy="795528"/>
+            <a:off x="603504" y="1847088"/>
+            <a:ext cx="7946136" cy="1399032"/>
           </a:xfrm>
           <a:prstGeom prst="rect">
             <a:avLst/>
@@ -3717,71 +3766,24 @@
           <a:lstStyle/>
           <a:p>
             <a:r>
-              <a:rPr sz="2800" b="1">
-                <a:solidFill>
-                  <a:srgbClr val="0F0F0F"/>
-                </a:solidFill>
-                <a:latin typeface="Fira Sans"/>
-              </a:rPr>
-              <a:t>La distribución muestral de la media</a:t>
-            </a:r>
-          </a:p>
-        </p:txBody>
-      </p:sp>
-      <p:pic>
-        <p:nvPicPr>
-          <p:cNvPr id="4" name="Picture 3" descr="c5_06_distribucion_muestral.png"/>
-          <p:cNvPicPr>
-            <a:picLocks noChangeAspect="1"/>
-          </p:cNvPicPr>
-          <p:nvPr/>
-        </p:nvPicPr>
-        <p:blipFill>
-          <a:blip r:embed="rId2"/>
-          <a:stretch>
-            <a:fillRect/>
-          </a:stretch>
-        </p:blipFill>
-        <p:spPr>
-          <a:xfrm>
-            <a:off x="1022984" y="1143000"/>
-            <a:ext cx="7098030" cy="3154680"/>
-          </a:xfrm>
-          <a:prstGeom prst="rect">
-            <a:avLst/>
-          </a:prstGeom>
-        </p:spPr>
-      </p:pic>
-      <p:sp>
-        <p:nvSpPr>
-          <p:cNvPr id="5" name="TextBox 4"/>
-          <p:cNvSpPr txBox="1"/>
-          <p:nvPr/>
-        </p:nvSpPr>
-        <p:spPr>
-          <a:xfrm>
-            <a:off x="704088" y="4434840"/>
-            <a:ext cx="7744968" cy="457200"/>
-          </a:xfrm>
-          <a:prstGeom prst="rect">
-            <a:avLst/>
-          </a:prstGeom>
-          <a:noFill/>
-        </p:spPr>
-        <p:txBody>
-          <a:bodyPr wrap="square">
-            <a:spAutoFit/>
-          </a:bodyPr>
-          <a:lstStyle/>
-          <a:p>
-            <a:r>
-              <a:rPr sz="1300" b="0">
-                <a:solidFill>
-                  <a:srgbClr val="333333"/>
-                </a:solidFill>
-                <a:latin typeface="Fira Sans"/>
-              </a:rPr>
-              <a:t>2.000 muestras, 2.000 medias: su histograma es la distribución muestral, centrada en la media real. Su desviación estándar es el error estándar: cuánto se mueve la media de una muestra a otra.</a:t>
+              <a:rPr sz="3400" b="1">
+                <a:solidFill>
+                  <a:srgbClr val="FFFFFF"/>
+                </a:solidFill>
+                <a:latin typeface="Fira Sans"/>
+              </a:rPr>
+              <a:t>Muestra y población</a:t>
+            </a:r>
+          </a:p>
+          <a:p>
+            <a:r>
+              <a:rPr sz="1800" b="0">
+                <a:solidFill>
+                  <a:srgbClr val="E0A437"/>
+                </a:solidFill>
+                <a:latin typeface="Fira Sans"/>
+              </a:rPr>
+              <a:t>Una muestra es una de muchas posibles</a:t>
             </a:r>
           </a:p>
         </p:txBody>
@@ -3877,14 +3879,14 @@
                 </a:solidFill>
                 <a:latin typeface="Fira Sans"/>
               </a:rPr>
-              <a:t>El error estándar de la media</a:t>
+              <a:t>Dos muestras, dos medias</a:t>
             </a:r>
           </a:p>
         </p:txBody>
       </p:sp>
       <p:pic>
         <p:nvPicPr>
-          <p:cNvPr id="4" name="Picture 3" descr="c5_08_formula_ee.png"/>
+          <p:cNvPr id="4" name="Picture 3" descr="c5_05_dos_muestras.png"/>
           <p:cNvPicPr>
             <a:picLocks noChangeAspect="1"/>
           </p:cNvPicPr>
@@ -3898,8 +3900,8 @@
         </p:blipFill>
         <p:spPr>
           <a:xfrm>
-            <a:off x="699515" y="1619678"/>
-            <a:ext cx="7744968" cy="2201323"/>
+            <a:off x="699515" y="1441281"/>
+            <a:ext cx="7744968" cy="2558117"/>
           </a:xfrm>
           <a:prstGeom prst="rect">
             <a:avLst/>
@@ -3935,7 +3937,7 @@
                 </a:solidFill>
                 <a:latin typeface="Fira Sans"/>
               </a:rPr>
-              <a:t>Se calcula desde una sola muestra, sin ver la población. Para reducirlo a la mitad hay que cuadruplicar la muestra.</a:t>
+              <a:t>Hoy tratamos los 113 mil viajes de la EOD como si fueran la población, para poder muestrear muchas veces. Cada muestra de 100 viajes da otra media; ninguna es la poblacional.</a:t>
             </a:r>
           </a:p>
         </p:txBody>
@@ -4031,14 +4033,14 @@
                 </a:solidFill>
                 <a:latin typeface="Fira Sans"/>
               </a:rPr>
-              <a:t>El teorema central del límite</a:t>
+              <a:t>La distribución muestral de la media</a:t>
             </a:r>
           </a:p>
         </p:txBody>
       </p:sp>
       <p:pic>
         <p:nvPicPr>
-          <p:cNvPr id="4" name="Picture 3" descr="c5_07_tcl.png"/>
+          <p:cNvPr id="4" name="Picture 3" descr="c5_06_distribucion_muestral.png"/>
           <p:cNvPicPr>
             <a:picLocks noChangeAspect="1"/>
           </p:cNvPicPr>
@@ -4052,8 +4054,8 @@
         </p:blipFill>
         <p:spPr>
           <a:xfrm>
-            <a:off x="699515" y="1614213"/>
-            <a:ext cx="7744968" cy="2212254"/>
+            <a:off x="1022984" y="1143000"/>
+            <a:ext cx="7098030" cy="3154680"/>
           </a:xfrm>
           <a:prstGeom prst="rect">
             <a:avLst/>
@@ -4089,7 +4091,7 @@
                 </a:solidFill>
                 <a:latin typeface="Fira Sans"/>
               </a:rPr>
-              <a:t>La media de una muestra se distribuye normal alrededor de la media real, con desviación σ/√n, aunque la variable no sea normal. Por eso la normal es la distribución de la inferencia: los promedios lo son, y la regla del 1,96 σ se les puede aplicar.</a:t>
+              <a:t>2.000 muestras, 2.000 medias: su histograma es la distribución muestral, centrada en la media real. Su desviación estándar es el error estándar: cuánto se mueve la media de una muestra a otra.</a:t>
             </a:r>
           </a:p>
         </p:txBody>
@@ -4127,7 +4129,7 @@
             <a:avLst/>
           </a:prstGeom>
           <a:solidFill>
-            <a:srgbClr val="1D3557"/>
+            <a:srgbClr val="FAFBFC"/>
           </a:solidFill>
           <a:ln>
             <a:noFill/>
@@ -4164,8 +4166,8 @@
         </p:nvSpPr>
         <p:spPr>
           <a:xfrm>
-            <a:off x="603504" y="1847088"/>
-            <a:ext cx="7946136" cy="1399032"/>
+            <a:off x="402336" y="301752"/>
+            <a:ext cx="8348472" cy="795528"/>
           </a:xfrm>
           <a:prstGeom prst="rect">
             <a:avLst/>
@@ -4179,24 +4181,71 @@
           <a:lstStyle/>
           <a:p>
             <a:r>
-              <a:rPr sz="3400" b="1">
-                <a:solidFill>
-                  <a:srgbClr val="FFFFFF"/>
-                </a:solidFill>
-                <a:latin typeface="Fira Sans"/>
-              </a:rPr>
-              <a:t>Intervalos de confianza</a:t>
-            </a:r>
-          </a:p>
-          <a:p>
-            <a:r>
-              <a:rPr sz="1800" b="0">
-                <a:solidFill>
-                  <a:srgbClr val="E0A437"/>
-                </a:solidFill>
-                <a:latin typeface="Fira Sans"/>
-              </a:rPr>
-              <a:t>Del error estándar a un rango honesto</a:t>
+              <a:rPr sz="2800" b="1">
+                <a:solidFill>
+                  <a:srgbClr val="0F0F0F"/>
+                </a:solidFill>
+                <a:latin typeface="Fira Sans"/>
+              </a:rPr>
+              <a:t>El error estándar de la media</a:t>
+            </a:r>
+          </a:p>
+        </p:txBody>
+      </p:sp>
+      <p:pic>
+        <p:nvPicPr>
+          <p:cNvPr id="4" name="Picture 3" descr="c5_08_formula_ee.png"/>
+          <p:cNvPicPr>
+            <a:picLocks noChangeAspect="1"/>
+          </p:cNvPicPr>
+          <p:nvPr/>
+        </p:nvPicPr>
+        <p:blipFill>
+          <a:blip r:embed="rId2"/>
+          <a:stretch>
+            <a:fillRect/>
+          </a:stretch>
+        </p:blipFill>
+        <p:spPr>
+          <a:xfrm>
+            <a:off x="699515" y="1619678"/>
+            <a:ext cx="7744968" cy="2201323"/>
+          </a:xfrm>
+          <a:prstGeom prst="rect">
+            <a:avLst/>
+          </a:prstGeom>
+        </p:spPr>
+      </p:pic>
+      <p:sp>
+        <p:nvSpPr>
+          <p:cNvPr id="5" name="TextBox 4"/>
+          <p:cNvSpPr txBox="1"/>
+          <p:nvPr/>
+        </p:nvSpPr>
+        <p:spPr>
+          <a:xfrm>
+            <a:off x="704088" y="4434840"/>
+            <a:ext cx="7744968" cy="457200"/>
+          </a:xfrm>
+          <a:prstGeom prst="rect">
+            <a:avLst/>
+          </a:prstGeom>
+          <a:noFill/>
+        </p:spPr>
+        <p:txBody>
+          <a:bodyPr wrap="square">
+            <a:spAutoFit/>
+          </a:bodyPr>
+          <a:lstStyle/>
+          <a:p>
+            <a:r>
+              <a:rPr sz="1300" b="0">
+                <a:solidFill>
+                  <a:srgbClr val="333333"/>
+                </a:solidFill>
+                <a:latin typeface="Fira Sans"/>
+              </a:rPr>
+              <a:t>Se calcula desde una sola muestra, sin ver la población. Para reducirlo a la mitad hay que cuadruplicar la muestra.</a:t>
             </a:r>
           </a:p>
         </p:txBody>
@@ -4292,14 +4341,14 @@
                 </a:solidFill>
                 <a:latin typeface="Fira Sans"/>
               </a:rPr>
-              <a:t>De la distribución muestral al intervalo</a:t>
+              <a:t>El teorema central del límite</a:t>
             </a:r>
           </a:p>
         </p:txBody>
       </p:sp>
       <p:pic>
         <p:nvPicPr>
-          <p:cNvPr id="4" name="Picture 3" descr="c5_18_puente_ic.png"/>
+          <p:cNvPr id="4" name="Picture 3" descr="c5_07_tcl.png"/>
           <p:cNvPicPr>
             <a:picLocks noChangeAspect="1"/>
           </p:cNvPicPr>
@@ -4313,8 +4362,8 @@
         </p:blipFill>
         <p:spPr>
           <a:xfrm>
-            <a:off x="699515" y="1493845"/>
-            <a:ext cx="7744968" cy="2452988"/>
+            <a:off x="699515" y="1614213"/>
+            <a:ext cx="7744968" cy="2212254"/>
           </a:xfrm>
           <a:prstGeom prst="rect">
             <a:avLst/>
@@ -4350,7 +4399,7 @@
                 </a:solidFill>
                 <a:latin typeface="Fira Sans"/>
               </a:rPr>
-              <a:t>Paso 1: por el TCL las medias muestrales son normales, así que el 95% cae a menos de 1,96 EE de μ. Paso 2, la misma frase al revés: μ está a menos de 1,96 EE de la media de mi muestra en el 95% de las muestras. Ese rango es el intervalo.</a:t>
+              <a:t>La media de una muestra se distribuye normal alrededor de la media real, con desviación σ/√n, aunque la variable no sea normal. Por eso la normal es la distribución de la inferencia: los promedios lo son, y la regla del 1,96 σ se les puede aplicar.</a:t>
             </a:r>
           </a:p>
         </p:txBody>
@@ -4388,7 +4437,7 @@
             <a:avLst/>
           </a:prstGeom>
           <a:solidFill>
-            <a:srgbClr val="FAFBFC"/>
+            <a:srgbClr val="1D3557"/>
           </a:solidFill>
           <a:ln>
             <a:noFill/>
@@ -4425,8 +4474,8 @@
         </p:nvSpPr>
         <p:spPr>
           <a:xfrm>
-            <a:off x="402336" y="301752"/>
-            <a:ext cx="8348472" cy="795528"/>
+            <a:off x="603504" y="1847088"/>
+            <a:ext cx="7946136" cy="1399032"/>
           </a:xfrm>
           <a:prstGeom prst="rect">
             <a:avLst/>
@@ -4440,71 +4489,24 @@
           <a:lstStyle/>
           <a:p>
             <a:r>
-              <a:rPr sz="2800" b="1">
-                <a:solidFill>
-                  <a:srgbClr val="0F0F0F"/>
-                </a:solidFill>
-                <a:latin typeface="Fira Sans"/>
-              </a:rPr>
-              <a:t>El intervalo de confianza del 95%</a:t>
-            </a:r>
-          </a:p>
-        </p:txBody>
-      </p:sp>
-      <p:pic>
-        <p:nvPicPr>
-          <p:cNvPr id="4" name="Picture 3" descr="c5_09_formula_ic.png"/>
-          <p:cNvPicPr>
-            <a:picLocks noChangeAspect="1"/>
-          </p:cNvPicPr>
-          <p:nvPr/>
-        </p:nvPicPr>
-        <p:blipFill>
-          <a:blip r:embed="rId2"/>
-          <a:stretch>
-            <a:fillRect/>
-          </a:stretch>
-        </p:blipFill>
-        <p:spPr>
-          <a:xfrm>
-            <a:off x="699515" y="1402487"/>
-            <a:ext cx="7744968" cy="2635704"/>
-          </a:xfrm>
-          <a:prstGeom prst="rect">
-            <a:avLst/>
-          </a:prstGeom>
-        </p:spPr>
-      </p:pic>
-      <p:sp>
-        <p:nvSpPr>
-          <p:cNvPr id="5" name="TextBox 4"/>
-          <p:cNvSpPr txBox="1"/>
-          <p:nvPr/>
-        </p:nvSpPr>
-        <p:spPr>
-          <a:xfrm>
-            <a:off x="704088" y="4434840"/>
-            <a:ext cx="7744968" cy="457200"/>
-          </a:xfrm>
-          <a:prstGeom prst="rect">
-            <a:avLst/>
-          </a:prstGeom>
-          <a:noFill/>
-        </p:spPr>
-        <p:txBody>
-          <a:bodyPr wrap="square">
-            <a:spAutoFit/>
-          </a:bodyPr>
-          <a:lstStyle/>
-          <a:p>
-            <a:r>
-              <a:rPr sz="1300" b="0">
-                <a:solidFill>
-                  <a:srgbClr val="333333"/>
-                </a:solidFill>
-                <a:latin typeface="Fira Sans"/>
-              </a:rPr>
-              <a:t>Se lee sobre el procedimiento: si repitiéramos el muestreo, el 95% de los intervalos atraparía la media real. Este intervalo en particular la atrapa o no; nunca sabremos cuál de los dos.</a:t>
+              <a:rPr sz="3400" b="1">
+                <a:solidFill>
+                  <a:srgbClr val="FFFFFF"/>
+                </a:solidFill>
+                <a:latin typeface="Fira Sans"/>
+              </a:rPr>
+              <a:t>Intervalos de confianza</a:t>
+            </a:r>
+          </a:p>
+          <a:p>
+            <a:r>
+              <a:rPr sz="1800" b="0">
+                <a:solidFill>
+                  <a:srgbClr val="E0A437"/>
+                </a:solidFill>
+                <a:latin typeface="Fira Sans"/>
+              </a:rPr>
+              <a:t>Del error estándar a un rango honesto</a:t>
             </a:r>
           </a:p>
         </p:txBody>
@@ -4600,14 +4602,14 @@
                 </a:solidFill>
                 <a:latin typeface="Fira Sans"/>
               </a:rPr>
-              <a:t>Comprobado con la población</a:t>
+              <a:t>De la distribución muestral al intervalo</a:t>
             </a:r>
           </a:p>
         </p:txBody>
       </p:sp>
       <p:pic>
         <p:nvPicPr>
-          <p:cNvPr id="4" name="Picture 3" descr="c5_10_cobertura.png"/>
+          <p:cNvPr id="4" name="Picture 3" descr="c5_18_puente_ic.png"/>
           <p:cNvPicPr>
             <a:picLocks noChangeAspect="1"/>
           </p:cNvPicPr>
@@ -4621,8 +4623,8 @@
         </p:blipFill>
         <p:spPr>
           <a:xfrm>
-            <a:off x="1060186" y="1143000"/>
-            <a:ext cx="7023627" cy="3154680"/>
+            <a:off x="699515" y="1493845"/>
+            <a:ext cx="7744968" cy="2452988"/>
           </a:xfrm>
           <a:prstGeom prst="rect">
             <a:avLst/>
@@ -4658,7 +4660,7 @@
                 </a:solidFill>
                 <a:latin typeface="Fira Sans"/>
               </a:rPr>
-              <a:t>100 muestras de 100 viajes, 100 intervalos: los rojos no atrapan la media. Cerca del 95% lo hace; con cola larga y n = 100, un poco menos.</a:t>
+              <a:t>Paso 1: por el TCL las medias muestrales son normales, así que el 95% cae a menos de 1,96 EE de μ. Paso 2, la misma frase al revés: μ está a menos de 1,96 EE de la media de mi muestra en el 95% de las muestras. Ese rango es el intervalo.</a:t>
             </a:r>
           </a:p>
         </p:txBody>
@@ -4696,7 +4698,7 @@
             <a:avLst/>
           </a:prstGeom>
           <a:solidFill>
-            <a:srgbClr val="1D3557"/>
+            <a:srgbClr val="FAFBFC"/>
           </a:solidFill>
           <a:ln>
             <a:noFill/>
@@ -4733,8 +4735,8 @@
         </p:nvSpPr>
         <p:spPr>
           <a:xfrm>
-            <a:off x="603504" y="1847088"/>
-            <a:ext cx="7946136" cy="1399032"/>
+            <a:off x="402336" y="301752"/>
+            <a:ext cx="8348472" cy="795528"/>
           </a:xfrm>
           <a:prstGeom prst="rect">
             <a:avLst/>
@@ -4748,24 +4750,71 @@
           <a:lstStyle/>
           <a:p>
             <a:r>
-              <a:rPr sz="3400" b="1">
-                <a:solidFill>
-                  <a:srgbClr val="FFFFFF"/>
-                </a:solidFill>
-                <a:latin typeface="Fira Sans"/>
-              </a:rPr>
-              <a:t>Prueba de hipótesis y valor p</a:t>
-            </a:r>
-          </a:p>
-          <a:p>
-            <a:r>
-              <a:rPr sz="1800" b="0">
-                <a:solidFill>
-                  <a:srgbClr val="E0A437"/>
-                </a:solidFill>
-                <a:latin typeface="Fira Sans"/>
-              </a:rPr>
-              <a:t>La pregunta pendiente: ¿la pendiente es real o azar?</a:t>
+              <a:rPr sz="2800" b="1">
+                <a:solidFill>
+                  <a:srgbClr val="0F0F0F"/>
+                </a:solidFill>
+                <a:latin typeface="Fira Sans"/>
+              </a:rPr>
+              <a:t>El intervalo de confianza del 95%</a:t>
+            </a:r>
+          </a:p>
+        </p:txBody>
+      </p:sp>
+      <p:pic>
+        <p:nvPicPr>
+          <p:cNvPr id="4" name="Picture 3" descr="c5_09_formula_ic.png"/>
+          <p:cNvPicPr>
+            <a:picLocks noChangeAspect="1"/>
+          </p:cNvPicPr>
+          <p:nvPr/>
+        </p:nvPicPr>
+        <p:blipFill>
+          <a:blip r:embed="rId2"/>
+          <a:stretch>
+            <a:fillRect/>
+          </a:stretch>
+        </p:blipFill>
+        <p:spPr>
+          <a:xfrm>
+            <a:off x="699515" y="1402487"/>
+            <a:ext cx="7744968" cy="2635704"/>
+          </a:xfrm>
+          <a:prstGeom prst="rect">
+            <a:avLst/>
+          </a:prstGeom>
+        </p:spPr>
+      </p:pic>
+      <p:sp>
+        <p:nvSpPr>
+          <p:cNvPr id="5" name="TextBox 4"/>
+          <p:cNvSpPr txBox="1"/>
+          <p:nvPr/>
+        </p:nvSpPr>
+        <p:spPr>
+          <a:xfrm>
+            <a:off x="704088" y="4434840"/>
+            <a:ext cx="7744968" cy="457200"/>
+          </a:xfrm>
+          <a:prstGeom prst="rect">
+            <a:avLst/>
+          </a:prstGeom>
+          <a:noFill/>
+        </p:spPr>
+        <p:txBody>
+          <a:bodyPr wrap="square">
+            <a:spAutoFit/>
+          </a:bodyPr>
+          <a:lstStyle/>
+          <a:p>
+            <a:r>
+              <a:rPr sz="1300" b="0">
+                <a:solidFill>
+                  <a:srgbClr val="333333"/>
+                </a:solidFill>
+                <a:latin typeface="Fira Sans"/>
+              </a:rPr>
+              <a:t>Se lee sobre el procedimiento: si repitiéramos el muestreo, el 95% de los intervalos atraparía la media real. Este intervalo en particular la atrapa o no; nunca sabremos cuál de los dos.</a:t>
             </a:r>
           </a:p>
         </p:txBody>
@@ -5064,21 +5113,45 @@
                 </a:solidFill>
                 <a:latin typeface="Fira Sans"/>
               </a:rPr>
-              <a:t>La lógica de la prueba</a:t>
-            </a:r>
-          </a:p>
-        </p:txBody>
-      </p:sp>
-      <p:sp>
-        <p:nvSpPr>
-          <p:cNvPr id="4" name="TextBox 3"/>
+              <a:t>Comprobado con la población</a:t>
+            </a:r>
+          </a:p>
+        </p:txBody>
+      </p:sp>
+      <p:pic>
+        <p:nvPicPr>
+          <p:cNvPr id="4" name="Picture 3" descr="c5_10_cobertura.png"/>
+          <p:cNvPicPr>
+            <a:picLocks noChangeAspect="1"/>
+          </p:cNvPicPr>
+          <p:nvPr/>
+        </p:nvPicPr>
+        <p:blipFill>
+          <a:blip r:embed="rId2"/>
+          <a:stretch>
+            <a:fillRect/>
+          </a:stretch>
+        </p:blipFill>
+        <p:spPr>
+          <a:xfrm>
+            <a:off x="1060186" y="1143000"/>
+            <a:ext cx="7023627" cy="3154680"/>
+          </a:xfrm>
+          <a:prstGeom prst="rect">
+            <a:avLst/>
+          </a:prstGeom>
+        </p:spPr>
+      </p:pic>
+      <p:sp>
+        <p:nvSpPr>
+          <p:cNvPr id="5" name="TextBox 4"/>
           <p:cNvSpPr txBox="1"/>
           <p:nvPr/>
         </p:nvSpPr>
         <p:spPr>
           <a:xfrm>
-            <a:off x="704088" y="1353312"/>
-            <a:ext cx="7744968" cy="3300984"/>
+            <a:off x="704088" y="4434840"/>
+            <a:ext cx="7744968" cy="457200"/>
           </a:xfrm>
           <a:prstGeom prst="rect">
             <a:avLst/>
@@ -5091,115 +5164,14 @@
           </a:bodyPr>
           <a:lstStyle/>
           <a:p>
-            <a:pPr>
-              <a:lnSpc>
-                <a:spcPct val="112000"/>
-              </a:lnSpc>
-              <a:spcAft>
-                <a:spcPts val="900"/>
-              </a:spcAft>
-            </a:pPr>
-            <a:r>
-              <a:rPr sz="1800" b="1">
-                <a:solidFill>
-                  <a:srgbClr val="E0A437"/>
-                </a:solidFill>
-                <a:latin typeface="Fira Sans"/>
-              </a:rPr>
-              <a:t>▸ </a:t>
-            </a:r>
-            <a:r>
-              <a:rPr sz="1800" b="1">
-                <a:solidFill>
-                  <a:srgbClr val="1D3557"/>
-                </a:solidFill>
-                <a:latin typeface="Fira Sans"/>
-              </a:rPr>
-              <a:t>Hipótesis nula H0: la pendiente real es 0, el ingreso no tiene efecto sobre la duración. Alternativa H1: no es 0.</a:t>
-            </a:r>
-          </a:p>
-          <a:p>
-            <a:pPr>
-              <a:lnSpc>
-                <a:spcPct val="112000"/>
-              </a:lnSpc>
-              <a:spcAft>
-                <a:spcPts val="900"/>
-              </a:spcAft>
-            </a:pPr>
-            <a:r>
-              <a:rPr sz="1800" b="1">
-                <a:solidFill>
-                  <a:srgbClr val="E0A437"/>
-                </a:solidFill>
-                <a:latin typeface="Fira Sans"/>
-              </a:rPr>
-              <a:t>▸ </a:t>
-            </a:r>
-            <a:r>
-              <a:rPr sz="1800" b="0">
-                <a:solidFill>
-                  <a:srgbClr val="000000"/>
-                </a:solidFill>
-                <a:latin typeface="Fira Sans"/>
-              </a:rPr>
-              <a:t>Si H0 fuera cierta, ¿qué tan raro sería obtener una pendiente como la nuestra solo por azar de qué comunas cayeron en la muestra?</a:t>
-            </a:r>
-          </a:p>
-          <a:p>
-            <a:pPr>
-              <a:lnSpc>
-                <a:spcPct val="112000"/>
-              </a:lnSpc>
-              <a:spcAft>
-                <a:spcPts val="900"/>
-              </a:spcAft>
-            </a:pPr>
-            <a:r>
-              <a:rPr sz="1800" b="1">
-                <a:solidFill>
-                  <a:srgbClr val="E0A437"/>
-                </a:solidFill>
-                <a:latin typeface="Fira Sans"/>
-              </a:rPr>
-              <a:t>▸ </a:t>
-            </a:r>
-            <a:r>
-              <a:rPr sz="1800" b="0">
-                <a:solidFill>
-                  <a:srgbClr val="000000"/>
-                </a:solidFill>
-                <a:latin typeface="Fira Sans"/>
-              </a:rPr>
-              <a:t>Esa probabilidad es el valor p. Convención: si p &lt; 0,05, se rechaza H0 y el efecto se declara significativo.</a:t>
-            </a:r>
-          </a:p>
-          <a:p>
-            <a:pPr>
-              <a:lnSpc>
-                <a:spcPct val="112000"/>
-              </a:lnSpc>
-              <a:spcAft>
-                <a:spcPts val="900"/>
-              </a:spcAft>
-            </a:pPr>
-            <a:r>
-              <a:rPr sz="1800" b="1">
-                <a:solidFill>
-                  <a:srgbClr val="E0A437"/>
-                </a:solidFill>
-                <a:latin typeface="Fira Sans"/>
-              </a:rPr>
-              <a:t>▸ </a:t>
-            </a:r>
-            <a:r>
-              <a:rPr sz="1800" b="0">
-                <a:solidFill>
-                  <a:srgbClr val="000000"/>
-                </a:solidFill>
-                <a:latin typeface="Fira Sans"/>
-              </a:rPr>
-              <a:t>El estadístico que lo mide: t = coeficiente / error estándar, a cuántos errores estándar del cero está la pendiente.</a:t>
+            <a:r>
+              <a:rPr sz="1300" b="0">
+                <a:solidFill>
+                  <a:srgbClr val="333333"/>
+                </a:solidFill>
+                <a:latin typeface="Fira Sans"/>
+              </a:rPr>
+              <a:t>100 muestras de 100 viajes, 100 intervalos: los rojos no atrapan la media. Cerca del 95% lo hace; con cola larga y n = 100, un poco menos.</a:t>
             </a:r>
           </a:p>
         </p:txBody>
@@ -5237,7 +5209,7 @@
             <a:avLst/>
           </a:prstGeom>
           <a:solidFill>
-            <a:srgbClr val="FAFBFC"/>
+            <a:srgbClr val="1D3557"/>
           </a:solidFill>
           <a:ln>
             <a:noFill/>
@@ -5274,8 +5246,8 @@
         </p:nvSpPr>
         <p:spPr>
           <a:xfrm>
-            <a:off x="402336" y="301752"/>
-            <a:ext cx="8348472" cy="795528"/>
+            <a:off x="603504" y="1847088"/>
+            <a:ext cx="7946136" cy="1399032"/>
           </a:xfrm>
           <a:prstGeom prst="rect">
             <a:avLst/>
@@ -5289,71 +5261,24 @@
           <a:lstStyle/>
           <a:p>
             <a:r>
-              <a:rPr sz="2800" b="1">
-                <a:solidFill>
-                  <a:srgbClr val="0F0F0F"/>
-                </a:solidFill>
-                <a:latin typeface="Fira Sans"/>
-              </a:rPr>
-              <a:t>El summary completo, por fin</a:t>
-            </a:r>
-          </a:p>
-        </p:txBody>
-      </p:sp>
-      <p:pic>
-        <p:nvPicPr>
-          <p:cNvPr id="4" name="Picture 3" descr="c5_11_summary_completo.png"/>
-          <p:cNvPicPr>
-            <a:picLocks noChangeAspect="1"/>
-          </p:cNvPicPr>
-          <p:nvPr/>
-        </p:nvPicPr>
-        <p:blipFill>
-          <a:blip r:embed="rId2"/>
-          <a:stretch>
-            <a:fillRect/>
-          </a:stretch>
-        </p:blipFill>
-        <p:spPr>
-          <a:xfrm>
-            <a:off x="699515" y="1447565"/>
-            <a:ext cx="7744968" cy="2545549"/>
-          </a:xfrm>
-          <a:prstGeom prst="rect">
-            <a:avLst/>
-          </a:prstGeom>
-        </p:spPr>
-      </p:pic>
-      <p:sp>
-        <p:nvSpPr>
-          <p:cNvPr id="5" name="TextBox 4"/>
-          <p:cNvSpPr txBox="1"/>
-          <p:nvPr/>
-        </p:nvSpPr>
-        <p:spPr>
-          <a:xfrm>
-            <a:off x="704088" y="4434840"/>
-            <a:ext cx="7744968" cy="457200"/>
-          </a:xfrm>
-          <a:prstGeom prst="rect">
-            <a:avLst/>
-          </a:prstGeom>
-          <a:noFill/>
-        </p:spPr>
-        <p:txBody>
-          <a:bodyPr wrap="square">
-            <a:spAutoFit/>
-          </a:bodyPr>
-          <a:lstStyle/>
-          <a:p>
-            <a:r>
-              <a:rPr sz="1300" b="0">
-                <a:solidFill>
-                  <a:srgbClr val="333333"/>
-                </a:solidFill>
-                <a:latin typeface="Fira Sans"/>
-              </a:rPr>
-              <a:t>La pendiente −4,81 con error estándar 2,02: t = −2,39. Si la real fuera 0, un t así de lejos ocurre el 2,1% de las veces: p = 0,021. El intervalo [−8,9; −0,75] no incluye el 0.</a:t>
+              <a:rPr sz="3400" b="1">
+                <a:solidFill>
+                  <a:srgbClr val="FFFFFF"/>
+                </a:solidFill>
+                <a:latin typeface="Fira Sans"/>
+              </a:rPr>
+              <a:t>Prueba de hipótesis y valor p</a:t>
+            </a:r>
+          </a:p>
+          <a:p>
+            <a:r>
+              <a:rPr sz="1800" b="0">
+                <a:solidFill>
+                  <a:srgbClr val="E0A437"/>
+                </a:solidFill>
+                <a:latin typeface="Fira Sans"/>
+              </a:rPr>
+              <a:t>La pregunta pendiente: ¿la pendiente es real o azar?</a:t>
             </a:r>
           </a:p>
         </p:txBody>
@@ -5449,45 +5374,21 @@
                 </a:solidFill>
                 <a:latin typeface="Fira Sans"/>
               </a:rPr>
-              <a:t>El valor p, dibujado</a:t>
-            </a:r>
-          </a:p>
-        </p:txBody>
-      </p:sp>
-      <p:pic>
-        <p:nvPicPr>
-          <p:cNvPr id="4" name="Picture 3" descr="c5_12_valor_p.png"/>
-          <p:cNvPicPr>
-            <a:picLocks noChangeAspect="1"/>
-          </p:cNvPicPr>
-          <p:nvPr/>
-        </p:nvPicPr>
-        <p:blipFill>
-          <a:blip r:embed="rId2"/>
-          <a:stretch>
-            <a:fillRect/>
-          </a:stretch>
-        </p:blipFill>
-        <p:spPr>
-          <a:xfrm>
-            <a:off x="858678" y="1143000"/>
-            <a:ext cx="7426642" cy="3154680"/>
-          </a:xfrm>
-          <a:prstGeom prst="rect">
-            <a:avLst/>
-          </a:prstGeom>
-        </p:spPr>
-      </p:pic>
-      <p:sp>
-        <p:nvSpPr>
-          <p:cNvPr id="5" name="TextBox 4"/>
+              <a:t>La lógica de la prueba</a:t>
+            </a:r>
+          </a:p>
+        </p:txBody>
+      </p:sp>
+      <p:sp>
+        <p:nvSpPr>
+          <p:cNvPr id="4" name="TextBox 3"/>
           <p:cNvSpPr txBox="1"/>
           <p:nvPr/>
         </p:nvSpPr>
         <p:spPr>
           <a:xfrm>
-            <a:off x="704088" y="4434840"/>
-            <a:ext cx="7744968" cy="457200"/>
+            <a:off x="704088" y="1353312"/>
+            <a:ext cx="7744968" cy="3300984"/>
           </a:xfrm>
           <a:prstGeom prst="rect">
             <a:avLst/>
@@ -5500,14 +5401,115 @@
           </a:bodyPr>
           <a:lstStyle/>
           <a:p>
-            <a:r>
-              <a:rPr sz="1300" b="0">
-                <a:solidFill>
-                  <a:srgbClr val="333333"/>
-                </a:solidFill>
-                <a:latin typeface="Fira Sans"/>
-              </a:rPr>
-              <a:t>Con 45 puntos se usa la distribución t (una normal algo más ancha, por estimar σ con s). El área dorada de las dos colas más allá del t observado es el valor p.</a:t>
+            <a:pPr>
+              <a:lnSpc>
+                <a:spcPct val="112000"/>
+              </a:lnSpc>
+              <a:spcAft>
+                <a:spcPts val="900"/>
+              </a:spcAft>
+            </a:pPr>
+            <a:r>
+              <a:rPr sz="1800" b="1">
+                <a:solidFill>
+                  <a:srgbClr val="E0A437"/>
+                </a:solidFill>
+                <a:latin typeface="Fira Sans"/>
+              </a:rPr>
+              <a:t>▸ </a:t>
+            </a:r>
+            <a:r>
+              <a:rPr sz="1800" b="1">
+                <a:solidFill>
+                  <a:srgbClr val="1D3557"/>
+                </a:solidFill>
+                <a:latin typeface="Fira Sans"/>
+              </a:rPr>
+              <a:t>Hipótesis nula H0: la pendiente real es 0, el ingreso no tiene efecto sobre la duración. Alternativa H1: no es 0.</a:t>
+            </a:r>
+          </a:p>
+          <a:p>
+            <a:pPr>
+              <a:lnSpc>
+                <a:spcPct val="112000"/>
+              </a:lnSpc>
+              <a:spcAft>
+                <a:spcPts val="900"/>
+              </a:spcAft>
+            </a:pPr>
+            <a:r>
+              <a:rPr sz="1800" b="1">
+                <a:solidFill>
+                  <a:srgbClr val="E0A437"/>
+                </a:solidFill>
+                <a:latin typeface="Fira Sans"/>
+              </a:rPr>
+              <a:t>▸ </a:t>
+            </a:r>
+            <a:r>
+              <a:rPr sz="1800" b="0">
+                <a:solidFill>
+                  <a:srgbClr val="000000"/>
+                </a:solidFill>
+                <a:latin typeface="Fira Sans"/>
+              </a:rPr>
+              <a:t>Si H0 fuera cierta, ¿qué tan raro sería obtener una pendiente como la nuestra solo por azar de qué comunas cayeron en la muestra?</a:t>
+            </a:r>
+          </a:p>
+          <a:p>
+            <a:pPr>
+              <a:lnSpc>
+                <a:spcPct val="112000"/>
+              </a:lnSpc>
+              <a:spcAft>
+                <a:spcPts val="900"/>
+              </a:spcAft>
+            </a:pPr>
+            <a:r>
+              <a:rPr sz="1800" b="1">
+                <a:solidFill>
+                  <a:srgbClr val="E0A437"/>
+                </a:solidFill>
+                <a:latin typeface="Fira Sans"/>
+              </a:rPr>
+              <a:t>▸ </a:t>
+            </a:r>
+            <a:r>
+              <a:rPr sz="1800" b="0">
+                <a:solidFill>
+                  <a:srgbClr val="000000"/>
+                </a:solidFill>
+                <a:latin typeface="Fira Sans"/>
+              </a:rPr>
+              <a:t>Esa probabilidad es el valor p. Convención: si p &lt; 0,05, se rechaza H0 y el efecto se declara significativo.</a:t>
+            </a:r>
+          </a:p>
+          <a:p>
+            <a:pPr>
+              <a:lnSpc>
+                <a:spcPct val="112000"/>
+              </a:lnSpc>
+              <a:spcAft>
+                <a:spcPts val="900"/>
+              </a:spcAft>
+            </a:pPr>
+            <a:r>
+              <a:rPr sz="1800" b="1">
+                <a:solidFill>
+                  <a:srgbClr val="E0A437"/>
+                </a:solidFill>
+                <a:latin typeface="Fira Sans"/>
+              </a:rPr>
+              <a:t>▸ </a:t>
+            </a:r>
+            <a:r>
+              <a:rPr sz="1800" b="0">
+                <a:solidFill>
+                  <a:srgbClr val="000000"/>
+                </a:solidFill>
+                <a:latin typeface="Fira Sans"/>
+              </a:rPr>
+              <a:t>El estadístico que lo mide: t = coeficiente / error estándar, a cuántos errores estándar del cero está la pendiente.</a:t>
             </a:r>
           </a:p>
         </p:txBody>
@@ -5603,114 +5605,35 @@
                 </a:solidFill>
                 <a:latin typeface="Fira Sans"/>
               </a:rPr>
-              <a:t>t y p, a mano</a:t>
-            </a:r>
-          </a:p>
-        </p:txBody>
-      </p:sp>
-      <p:sp>
-        <p:nvSpPr>
-          <p:cNvPr id="4" name="Rectangle 3"/>
-          <p:cNvSpPr/>
-          <p:nvPr/>
-        </p:nvSpPr>
-        <p:spPr>
-          <a:xfrm>
-            <a:off x="704088" y="1280160"/>
-            <a:ext cx="7744968" cy="2880360"/>
-          </a:xfrm>
-          <a:prstGeom prst="rect">
-            <a:avLst/>
-          </a:prstGeom>
-          <a:solidFill>
-            <a:srgbClr val="F0F2F5"/>
-          </a:solidFill>
-          <a:ln>
-            <a:solidFill>
-              <a:srgbClr val="D8DDE3"/>
-            </a:solidFill>
-          </a:ln>
-          <a:effectLst/>
-        </p:spPr>
-        <p:style>
-          <a:lnRef idx="1">
-            <a:schemeClr val="accent1"/>
-          </a:lnRef>
-          <a:fillRef idx="3">
-            <a:schemeClr val="accent1"/>
-          </a:fillRef>
-          <a:effectRef idx="2">
-            <a:schemeClr val="accent1"/>
-          </a:effectRef>
-          <a:fontRef idx="minor">
-            <a:schemeClr val="lt1"/>
-          </a:fontRef>
-        </p:style>
-        <p:txBody>
-          <a:bodyPr rtlCol="0" anchor="ctr" wrap="square" lIns="228600" tIns="137160"/>
-          <a:lstStyle/>
-          <a:p>
-            <a:pPr/>
-            <a:r>
-              <a:rPr sz="1500" b="0">
-                <a:solidFill>
-                  <a:srgbClr val="1D3557"/>
-                </a:solidFill>
-                <a:latin typeface="Menlo"/>
-              </a:rPr>
-              <a:t>b, ee = modelo.params["ingreso"], modelo.bse["ingreso"]</a:t>
-            </a:r>
-          </a:p>
-          <a:p>
-            <a:pPr/>
-            <a:r>
-              <a:rPr sz="1500" b="0">
-                <a:solidFill>
-                  <a:srgbClr val="1D3557"/>
-                </a:solidFill>
-                <a:latin typeface="Menlo"/>
-              </a:rPr>
-              <a:t>t = b / ee                                 # -2.39</a:t>
-            </a:r>
-          </a:p>
-          <a:p>
-            <a:pPr/>
-            <a:r>
-              <a:rPr sz="1500" b="0">
-                <a:solidFill>
-                  <a:srgbClr val="1D3557"/>
-                </a:solidFill>
-                <a:latin typeface="Menlo"/>
-              </a:rPr>
-              <a:t/>
-            </a:r>
-          </a:p>
-          <a:p>
-            <a:pPr/>
-            <a:r>
-              <a:rPr sz="1500" b="0">
-                <a:solidFill>
-                  <a:srgbClr val="1D3557"/>
-                </a:solidFill>
-                <a:latin typeface="Menlo"/>
-              </a:rPr>
-              <a:t># Dos colas de la t con n - 2 grados de libertad</a:t>
-            </a:r>
-          </a:p>
-          <a:p>
-            <a:pPr/>
-            <a:r>
-              <a:rPr sz="1500" b="0">
-                <a:solidFill>
-                  <a:srgbClr val="1D3557"/>
-                </a:solidFill>
-                <a:latin typeface="Menlo"/>
-              </a:rPr>
-              <a:t>p = 2 * (1 - stats.t.cdf(abs(t), df=43))   # 0.021</a:t>
-            </a:r>
-          </a:p>
-        </p:txBody>
-      </p:sp>
+              <a:t>El summary completo, por fin</a:t>
+            </a:r>
+          </a:p>
+        </p:txBody>
+      </p:sp>
+      <p:pic>
+        <p:nvPicPr>
+          <p:cNvPr id="4" name="Picture 3" descr="c5_11_summary_completo.png"/>
+          <p:cNvPicPr>
+            <a:picLocks noChangeAspect="1"/>
+          </p:cNvPicPr>
+          <p:nvPr/>
+        </p:nvPicPr>
+        <p:blipFill>
+          <a:blip r:embed="rId2"/>
+          <a:stretch>
+            <a:fillRect/>
+          </a:stretch>
+        </p:blipFill>
+        <p:spPr>
+          <a:xfrm>
+            <a:off x="699515" y="1447565"/>
+            <a:ext cx="7744968" cy="2545549"/>
+          </a:xfrm>
+          <a:prstGeom prst="rect">
+            <a:avLst/>
+          </a:prstGeom>
+        </p:spPr>
+      </p:pic>
       <p:sp>
         <p:nvSpPr>
           <p:cNvPr id="5" name="TextBox 4"/>
@@ -5719,8 +5642,8 @@
         </p:nvSpPr>
         <p:spPr>
           <a:xfrm>
-            <a:off x="704088" y="4389120"/>
-            <a:ext cx="7744968" cy="1097280"/>
+            <a:off x="704088" y="4434840"/>
+            <a:ext cx="7744968" cy="457200"/>
           </a:xfrm>
           <a:prstGeom prst="rect">
             <a:avLst/>
@@ -5733,31 +5656,14 @@
           </a:bodyPr>
           <a:lstStyle/>
           <a:p>
-            <a:pPr>
-              <a:lnSpc>
-                <a:spcPct val="112000"/>
-              </a:lnSpc>
-              <a:spcAft>
-                <a:spcPts val="900"/>
-              </a:spcAft>
-            </a:pPr>
-            <a:r>
-              <a:rPr sz="1600" b="1">
-                <a:solidFill>
-                  <a:srgbClr val="E0A437"/>
-                </a:solidFill>
-                <a:latin typeface="Fira Sans"/>
-              </a:rPr>
-              <a:t>▸ </a:t>
-            </a:r>
-            <a:r>
-              <a:rPr sz="1600" b="0">
-                <a:solidFill>
-                  <a:srgbClr val="000000"/>
-                </a:solidFill>
-                <a:latin typeface="Fira Sans"/>
-              </a:rPr>
-              <a:t>Lo que statsmodels imprime sale de esta cuenta: el coeficiente en unidades de su error estándar, y el área que deja en las colas.</a:t>
+            <a:r>
+              <a:rPr sz="1300" b="0">
+                <a:solidFill>
+                  <a:srgbClr val="333333"/>
+                </a:solidFill>
+                <a:latin typeface="Fira Sans"/>
+              </a:rPr>
+              <a:t>La pendiente −4,81 con error estándar 2,02: t = −2,39. Si la real fuera 0, un t así de lejos ocurre el 2,1% de las veces: p = 0,021. El intervalo [−8,9; −0,75] no incluye el 0.</a:t>
             </a:r>
           </a:p>
         </p:txBody>
@@ -5853,21 +5759,45 @@
                 </a:solidFill>
                 <a:latin typeface="Fira Sans"/>
               </a:rPr>
-              <a:t>La respuesta, y su letra chica</a:t>
-            </a:r>
-          </a:p>
-        </p:txBody>
-      </p:sp>
-      <p:sp>
-        <p:nvSpPr>
-          <p:cNvPr id="4" name="TextBox 3"/>
+              <a:t>El valor p, dibujado</a:t>
+            </a:r>
+          </a:p>
+        </p:txBody>
+      </p:sp>
+      <p:pic>
+        <p:nvPicPr>
+          <p:cNvPr id="4" name="Picture 3" descr="c5_12_valor_p.png"/>
+          <p:cNvPicPr>
+            <a:picLocks noChangeAspect="1"/>
+          </p:cNvPicPr>
+          <p:nvPr/>
+        </p:nvPicPr>
+        <p:blipFill>
+          <a:blip r:embed="rId2"/>
+          <a:stretch>
+            <a:fillRect/>
+          </a:stretch>
+        </p:blipFill>
+        <p:spPr>
+          <a:xfrm>
+            <a:off x="858678" y="1143000"/>
+            <a:ext cx="7426642" cy="3154680"/>
+          </a:xfrm>
+          <a:prstGeom prst="rect">
+            <a:avLst/>
+          </a:prstGeom>
+        </p:spPr>
+      </p:pic>
+      <p:sp>
+        <p:nvSpPr>
+          <p:cNvPr id="5" name="TextBox 4"/>
           <p:cNvSpPr txBox="1"/>
           <p:nvPr/>
         </p:nvSpPr>
         <p:spPr>
           <a:xfrm>
-            <a:off x="704088" y="1353312"/>
-            <a:ext cx="7744968" cy="3300984"/>
+            <a:off x="704088" y="4434840"/>
+            <a:ext cx="7744968" cy="457200"/>
           </a:xfrm>
           <a:prstGeom prst="rect">
             <a:avLst/>
@@ -5880,115 +5810,14 @@
           </a:bodyPr>
           <a:lstStyle/>
           <a:p>
-            <a:pPr>
-              <a:lnSpc>
-                <a:spcPct val="112000"/>
-              </a:lnSpc>
-              <a:spcAft>
-                <a:spcPts val="900"/>
-              </a:spcAft>
-            </a:pPr>
-            <a:r>
-              <a:rPr sz="1800" b="1">
-                <a:solidFill>
-                  <a:srgbClr val="E0A437"/>
-                </a:solidFill>
-                <a:latin typeface="Fira Sans"/>
-              </a:rPr>
-              <a:t>▸ </a:t>
-            </a:r>
-            <a:r>
-              <a:rPr sz="1800" b="1">
-                <a:solidFill>
-                  <a:srgbClr val="1D3557"/>
-                </a:solidFill>
-                <a:latin typeface="Fira Sans"/>
-              </a:rPr>
-              <a:t>La pendiente de −4,8 no parece azar: p = 0,021 y el intervalo [−8,9; −0,75] no incluye el 0. Rechazamos H0.</a:t>
-            </a:r>
-          </a:p>
-          <a:p>
-            <a:pPr>
-              <a:lnSpc>
-                <a:spcPct val="112000"/>
-              </a:lnSpc>
-              <a:spcAft>
-                <a:spcPts val="900"/>
-              </a:spcAft>
-            </a:pPr>
-            <a:r>
-              <a:rPr sz="1800" b="1">
-                <a:solidFill>
-                  <a:srgbClr val="E0A437"/>
-                </a:solidFill>
-                <a:latin typeface="Fira Sans"/>
-              </a:rPr>
-              <a:t>▸ </a:t>
-            </a:r>
-            <a:r>
-              <a:rPr sz="1800" b="0">
-                <a:solidFill>
-                  <a:srgbClr val="000000"/>
-                </a:solidFill>
-                <a:latin typeface="Fira Sans"/>
-              </a:rPr>
-              <a:t>Pero el valor p depende del efecto y del tamaño de la muestra: la motorización (18 mil hogares) tiene t = 80 y p prácticamente 0; las comunas, con 45 puntos, apenas cruzan el umbral.</a:t>
-            </a:r>
-          </a:p>
-          <a:p>
-            <a:pPr>
-              <a:lnSpc>
-                <a:spcPct val="112000"/>
-              </a:lnSpc>
-              <a:spcAft>
-                <a:spcPts val="900"/>
-              </a:spcAft>
-            </a:pPr>
-            <a:r>
-              <a:rPr sz="1800" b="1">
-                <a:solidFill>
-                  <a:srgbClr val="E0A437"/>
-                </a:solidFill>
-                <a:latin typeface="Fira Sans"/>
-              </a:rPr>
-              <a:t>▸ </a:t>
-            </a:r>
-            <a:r>
-              <a:rPr sz="1800" b="0">
-                <a:solidFill>
-                  <a:srgbClr val="000000"/>
-                </a:solidFill>
-                <a:latin typeface="Fira Sans"/>
-              </a:rPr>
-              <a:t>Significativo no es importante: el tamaño del efecto lo dice el coeficiente; su precisión, el intervalo.</a:t>
-            </a:r>
-          </a:p>
-          <a:p>
-            <a:pPr>
-              <a:lnSpc>
-                <a:spcPct val="112000"/>
-              </a:lnSpc>
-              <a:spcAft>
-                <a:spcPts val="900"/>
-              </a:spcAft>
-            </a:pPr>
-            <a:r>
-              <a:rPr sz="1800" b="1">
-                <a:solidFill>
-                  <a:srgbClr val="E0A437"/>
-                </a:solidFill>
-                <a:latin typeface="Fira Sans"/>
-              </a:rPr>
-              <a:t>▸ </a:t>
-            </a:r>
-            <a:r>
-              <a:rPr sz="1800" b="0">
-                <a:solidFill>
-                  <a:srgbClr val="000000"/>
-                </a:solidFill>
-                <a:latin typeface="Fira Sans"/>
-              </a:rPr>
-              <a:t>Correlación no es causalidad, tampoco con p pequeño: seguimos reportando asociación.</a:t>
+            <a:r>
+              <a:rPr sz="1300" b="0">
+                <a:solidFill>
+                  <a:srgbClr val="333333"/>
+                </a:solidFill>
+                <a:latin typeface="Fira Sans"/>
+              </a:rPr>
+              <a:t>Con 45 puntos se usa la distribución t (una normal algo más ancha, por estimar σ con s). El área dorada de las dos colas más allá del t observado es el valor p.</a:t>
             </a:r>
           </a:p>
         </p:txBody>
@@ -6084,21 +5913,124 @@
                 </a:solidFill>
                 <a:latin typeface="Fira Sans"/>
               </a:rPr>
-              <a:t>Qué supone la regresión para inferir</a:t>
-            </a:r>
-          </a:p>
-        </p:txBody>
-      </p:sp>
-      <p:sp>
-        <p:nvSpPr>
-          <p:cNvPr id="4" name="TextBox 3"/>
+              <a:t>t y p, a mano</a:t>
+            </a:r>
+          </a:p>
+        </p:txBody>
+      </p:sp>
+      <p:sp>
+        <p:nvSpPr>
+          <p:cNvPr id="4" name="Rectangle 3"/>
+          <p:cNvSpPr/>
+          <p:nvPr/>
+        </p:nvSpPr>
+        <p:spPr>
+          <a:xfrm>
+            <a:off x="704088" y="1280160"/>
+            <a:ext cx="7744968" cy="2880360"/>
+          </a:xfrm>
+          <a:prstGeom prst="rect">
+            <a:avLst/>
+          </a:prstGeom>
+          <a:solidFill>
+            <a:srgbClr val="F0F2F5"/>
+          </a:solidFill>
+          <a:ln>
+            <a:solidFill>
+              <a:srgbClr val="D8DDE3"/>
+            </a:solidFill>
+          </a:ln>
+          <a:effectLst/>
+        </p:spPr>
+        <p:style>
+          <a:lnRef idx="1">
+            <a:schemeClr val="accent1"/>
+          </a:lnRef>
+          <a:fillRef idx="3">
+            <a:schemeClr val="accent1"/>
+          </a:fillRef>
+          <a:effectRef idx="2">
+            <a:schemeClr val="accent1"/>
+          </a:effectRef>
+          <a:fontRef idx="minor">
+            <a:schemeClr val="lt1"/>
+          </a:fontRef>
+        </p:style>
+        <p:txBody>
+          <a:bodyPr rtlCol="0" anchor="ctr" wrap="square" lIns="228600" tIns="137160"/>
+          <a:lstStyle/>
+          <a:p>
+            <a:pPr/>
+            <a:r>
+              <a:rPr sz="1500" b="0">
+                <a:solidFill>
+                  <a:srgbClr val="1D3557"/>
+                </a:solidFill>
+                <a:latin typeface="Menlo"/>
+              </a:rPr>
+              <a:t>b, ee = modelo.params["ingreso"], modelo.bse["ingreso"]</a:t>
+            </a:r>
+          </a:p>
+          <a:p>
+            <a:pPr/>
+            <a:r>
+              <a:rPr sz="1500" b="0">
+                <a:solidFill>
+                  <a:srgbClr val="1D3557"/>
+                </a:solidFill>
+                <a:latin typeface="Menlo"/>
+              </a:rPr>
+              <a:t>t = b / ee                                 # -2.39</a:t>
+            </a:r>
+          </a:p>
+          <a:p>
+            <a:pPr/>
+            <a:r>
+              <a:rPr sz="1500" b="0">
+                <a:solidFill>
+                  <a:srgbClr val="1D3557"/>
+                </a:solidFill>
+                <a:latin typeface="Menlo"/>
+              </a:rPr>
+              <a:t/>
+            </a:r>
+          </a:p>
+          <a:p>
+            <a:pPr/>
+            <a:r>
+              <a:rPr sz="1500" b="0">
+                <a:solidFill>
+                  <a:srgbClr val="1D3557"/>
+                </a:solidFill>
+                <a:latin typeface="Menlo"/>
+              </a:rPr>
+              <a:t># Dos colas de la t con n - 2 grados de libertad</a:t>
+            </a:r>
+          </a:p>
+          <a:p>
+            <a:pPr/>
+            <a:r>
+              <a:rPr sz="1500" b="0">
+                <a:solidFill>
+                  <a:srgbClr val="1D3557"/>
+                </a:solidFill>
+                <a:latin typeface="Menlo"/>
+              </a:rPr>
+              <a:t>p = 2 * (1 - stats.t.cdf(abs(t), df=43))   # 0.021</a:t>
+            </a:r>
+          </a:p>
+        </p:txBody>
+      </p:sp>
+      <p:sp>
+        <p:nvSpPr>
+          <p:cNvPr id="5" name="TextBox 4"/>
           <p:cNvSpPr txBox="1"/>
           <p:nvPr/>
         </p:nvSpPr>
         <p:spPr>
           <a:xfrm>
-            <a:off x="704088" y="1353312"/>
-            <a:ext cx="7744968" cy="3300984"/>
+            <a:off x="704088" y="4389120"/>
+            <a:ext cx="7744968" cy="1097280"/>
           </a:xfrm>
           <a:prstGeom prst="rect">
             <a:avLst/>
@@ -6120,7 +6052,7 @@
               </a:spcAft>
             </a:pPr>
             <a:r>
-              <a:rPr sz="1800" b="1">
+              <a:rPr sz="1600" b="1">
                 <a:solidFill>
                   <a:srgbClr val="E0A437"/>
                 </a:solidFill>
@@ -6129,97 +6061,13 @@
               <a:t>▸ </a:t>
             </a:r>
             <a:r>
-              <a:rPr sz="1800" b="1">
-                <a:solidFill>
-                  <a:srgbClr val="1D3557"/>
-                </a:solidFill>
-                <a:latin typeface="Fira Sans"/>
-              </a:rPr>
-              <a:t>No que las variables sean normales. Los t y p del summary suponen residuos independientes, con la misma varianza y, con n chico, normales.</a:t>
-            </a:r>
-          </a:p>
-          <a:p>
-            <a:pPr>
-              <a:lnSpc>
-                <a:spcPct val="112000"/>
-              </a:lnSpc>
-              <a:spcAft>
-                <a:spcPts val="900"/>
-              </a:spcAft>
-            </a:pPr>
-            <a:r>
-              <a:rPr sz="1800" b="1">
-                <a:solidFill>
-                  <a:srgbClr val="E0A437"/>
-                </a:solidFill>
-                <a:latin typeface="Fira Sans"/>
-              </a:rPr>
-              <a:t>▸ </a:t>
-            </a:r>
-            <a:r>
-              <a:rPr sz="1800" b="0">
+              <a:rPr sz="1600" b="0">
                 <a:solidFill>
                   <a:srgbClr val="000000"/>
                 </a:solidFill>
                 <a:latin typeface="Fira Sans"/>
               </a:rPr>
-              <a:t>Con n grande el TCL hace el trabajo: un coeficiente es un promedio ponderado de los y, y los promedios se vuelven normales.</a:t>
-            </a:r>
-          </a:p>
-          <a:p>
-            <a:pPr>
-              <a:lnSpc>
-                <a:spcPct val="112000"/>
-              </a:lnSpc>
-              <a:spcAft>
-                <a:spcPts val="900"/>
-              </a:spcAft>
-            </a:pPr>
-            <a:r>
-              <a:rPr sz="1800" b="1">
-                <a:solidFill>
-                  <a:srgbClr val="E0A437"/>
-                </a:solidFill>
-                <a:latin typeface="Fira Sans"/>
-              </a:rPr>
-              <a:t>▸ </a:t>
-            </a:r>
-            <a:r>
-              <a:rPr sz="1800" b="0">
-                <a:solidFill>
-                  <a:srgbClr val="000000"/>
-                </a:solidFill>
-                <a:latin typeface="Fira Sans"/>
-              </a:rPr>
-              <a:t>Lo que sí daña la inferencia: colas largas y atípicos, que inflan el error estándar. El log de la clase 4 también ayuda aquí.</a:t>
-            </a:r>
-          </a:p>
-          <a:p>
-            <a:pPr>
-              <a:lnSpc>
-                <a:spcPct val="112000"/>
-              </a:lnSpc>
-              <a:spcAft>
-                <a:spcPts val="900"/>
-              </a:spcAft>
-            </a:pPr>
-            <a:r>
-              <a:rPr sz="1800" b="1">
-                <a:solidFill>
-                  <a:srgbClr val="E0A437"/>
-                </a:solidFill>
-                <a:latin typeface="Fira Sans"/>
-              </a:rPr>
-              <a:t>▸ </a:t>
-            </a:r>
-            <a:r>
-              <a:rPr sz="1800" b="0">
-                <a:solidFill>
-                  <a:srgbClr val="000000"/>
-                </a:solidFill>
-                <a:latin typeface="Fira Sans"/>
-              </a:rPr>
-              <a:t>Con 45 comunas los supuestos pesan; con 113 mil viajes, casi nada.</a:t>
+              <a:t>Lo que statsmodels imprime sale de esta cuenta: el coeficiente en unidades de su error estándar, y el área que deja en las colas.</a:t>
             </a:r>
           </a:p>
         </p:txBody>
@@ -6257,7 +6105,7 @@
             <a:avLst/>
           </a:prstGeom>
           <a:solidFill>
-            <a:srgbClr val="1D3557"/>
+            <a:srgbClr val="FAFBFC"/>
           </a:solidFill>
           <a:ln>
             <a:noFill/>
@@ -6294,8 +6142,8 @@
         </p:nvSpPr>
         <p:spPr>
           <a:xfrm>
-            <a:off x="603504" y="1847088"/>
-            <a:ext cx="7946136" cy="1399032"/>
+            <a:off x="402336" y="301752"/>
+            <a:ext cx="8348472" cy="795528"/>
           </a:xfrm>
           <a:prstGeom prst="rect">
             <a:avLst/>
@@ -6309,24 +6157,148 @@
           <a:lstStyle/>
           <a:p>
             <a:r>
-              <a:rPr sz="3400" b="1">
-                <a:solidFill>
-                  <a:srgbClr val="FFFFFF"/>
-                </a:solidFill>
-                <a:latin typeface="Fira Sans"/>
-              </a:rPr>
-              <a:t>Bootstrap</a:t>
-            </a:r>
-          </a:p>
-          <a:p>
+              <a:rPr sz="2800" b="1">
+                <a:solidFill>
+                  <a:srgbClr val="0F0F0F"/>
+                </a:solidFill>
+                <a:latin typeface="Fira Sans"/>
+              </a:rPr>
+              <a:t>La respuesta, y su letra chica</a:t>
+            </a:r>
+          </a:p>
+        </p:txBody>
+      </p:sp>
+      <p:sp>
+        <p:nvSpPr>
+          <p:cNvPr id="4" name="TextBox 3"/>
+          <p:cNvSpPr txBox="1"/>
+          <p:nvPr/>
+        </p:nvSpPr>
+        <p:spPr>
+          <a:xfrm>
+            <a:off x="704088" y="1353312"/>
+            <a:ext cx="7744968" cy="3300984"/>
+          </a:xfrm>
+          <a:prstGeom prst="rect">
+            <a:avLst/>
+          </a:prstGeom>
+          <a:noFill/>
+        </p:spPr>
+        <p:txBody>
+          <a:bodyPr wrap="square">
+            <a:spAutoFit/>
+          </a:bodyPr>
+          <a:lstStyle/>
+          <a:p>
+            <a:pPr>
+              <a:lnSpc>
+                <a:spcPct val="112000"/>
+              </a:lnSpc>
+              <a:spcAft>
+                <a:spcPts val="900"/>
+              </a:spcAft>
+            </a:pPr>
+            <a:r>
+              <a:rPr sz="1800" b="1">
+                <a:solidFill>
+                  <a:srgbClr val="E0A437"/>
+                </a:solidFill>
+                <a:latin typeface="Fira Sans"/>
+              </a:rPr>
+              <a:t>▸ </a:t>
+            </a:r>
+            <a:r>
+              <a:rPr sz="1800" b="1">
+                <a:solidFill>
+                  <a:srgbClr val="1D3557"/>
+                </a:solidFill>
+                <a:latin typeface="Fira Sans"/>
+              </a:rPr>
+              <a:t>La pendiente de −4,8 no parece azar: p = 0,021 y el intervalo [−8,9; −0,75] no incluye el 0. Rechazamos H0.</a:t>
+            </a:r>
+          </a:p>
+          <a:p>
+            <a:pPr>
+              <a:lnSpc>
+                <a:spcPct val="112000"/>
+              </a:lnSpc>
+              <a:spcAft>
+                <a:spcPts val="900"/>
+              </a:spcAft>
+            </a:pPr>
+            <a:r>
+              <a:rPr sz="1800" b="1">
+                <a:solidFill>
+                  <a:srgbClr val="E0A437"/>
+                </a:solidFill>
+                <a:latin typeface="Fira Sans"/>
+              </a:rPr>
+              <a:t>▸ </a:t>
+            </a:r>
             <a:r>
               <a:rPr sz="1800" b="0">
                 <a:solidFill>
+                  <a:srgbClr val="000000"/>
+                </a:solidFill>
+                <a:latin typeface="Fira Sans"/>
+              </a:rPr>
+              <a:t>Pero el valor p depende del efecto y del tamaño de la muestra: la motorización (18 mil hogares) tiene t = 80 y p prácticamente 0; las comunas, con 45 puntos, apenas cruzan el umbral.</a:t>
+            </a:r>
+          </a:p>
+          <a:p>
+            <a:pPr>
+              <a:lnSpc>
+                <a:spcPct val="112000"/>
+              </a:lnSpc>
+              <a:spcAft>
+                <a:spcPts val="900"/>
+              </a:spcAft>
+            </a:pPr>
+            <a:r>
+              <a:rPr sz="1800" b="1">
+                <a:solidFill>
                   <a:srgbClr val="E0A437"/>
                 </a:solidFill>
                 <a:latin typeface="Fira Sans"/>
               </a:rPr>
-              <a:t>La misma respuesta, sin fórmulas</a:t>
+              <a:t>▸ </a:t>
+            </a:r>
+            <a:r>
+              <a:rPr sz="1800" b="0">
+                <a:solidFill>
+                  <a:srgbClr val="000000"/>
+                </a:solidFill>
+                <a:latin typeface="Fira Sans"/>
+              </a:rPr>
+              <a:t>Significativo no es importante: el tamaño del efecto lo dice el coeficiente; su precisión, el intervalo.</a:t>
+            </a:r>
+          </a:p>
+          <a:p>
+            <a:pPr>
+              <a:lnSpc>
+                <a:spcPct val="112000"/>
+              </a:lnSpc>
+              <a:spcAft>
+                <a:spcPts val="900"/>
+              </a:spcAft>
+            </a:pPr>
+            <a:r>
+              <a:rPr sz="1800" b="1">
+                <a:solidFill>
+                  <a:srgbClr val="E0A437"/>
+                </a:solidFill>
+                <a:latin typeface="Fira Sans"/>
+              </a:rPr>
+              <a:t>▸ </a:t>
+            </a:r>
+            <a:r>
+              <a:rPr sz="1800" b="0">
+                <a:solidFill>
+                  <a:srgbClr val="000000"/>
+                </a:solidFill>
+                <a:latin typeface="Fira Sans"/>
+              </a:rPr>
+              <a:t>Correlación no es causalidad, tampoco con p pequeño: seguimos reportando asociación.</a:t>
             </a:r>
           </a:p>
         </p:txBody>
@@ -6422,124 +6394,21 @@
                 </a:solidFill>
                 <a:latin typeface="Fira Sans"/>
               </a:rPr>
-              <a:t>Remuestrear los datos</a:t>
-            </a:r>
-          </a:p>
-        </p:txBody>
-      </p:sp>
-      <p:sp>
-        <p:nvSpPr>
-          <p:cNvPr id="4" name="Rectangle 3"/>
-          <p:cNvSpPr/>
-          <p:nvPr/>
-        </p:nvSpPr>
-        <p:spPr>
-          <a:xfrm>
-            <a:off x="704088" y="1280160"/>
-            <a:ext cx="7744968" cy="2880360"/>
-          </a:xfrm>
-          <a:prstGeom prst="rect">
-            <a:avLst/>
-          </a:prstGeom>
-          <a:solidFill>
-            <a:srgbClr val="F0F2F5"/>
-          </a:solidFill>
-          <a:ln>
-            <a:solidFill>
-              <a:srgbClr val="D8DDE3"/>
-            </a:solidFill>
-          </a:ln>
-          <a:effectLst/>
-        </p:spPr>
-        <p:style>
-          <a:lnRef idx="1">
-            <a:schemeClr val="accent1"/>
-          </a:lnRef>
-          <a:fillRef idx="3">
-            <a:schemeClr val="accent1"/>
-          </a:fillRef>
-          <a:effectRef idx="2">
-            <a:schemeClr val="accent1"/>
-          </a:effectRef>
-          <a:fontRef idx="minor">
-            <a:schemeClr val="lt1"/>
-          </a:fontRef>
-        </p:style>
-        <p:txBody>
-          <a:bodyPr rtlCol="0" anchor="ctr" wrap="square" lIns="228600" tIns="137160"/>
-          <a:lstStyle/>
-          <a:p>
-            <a:pPr/>
-            <a:r>
-              <a:rPr sz="1500" b="0">
-                <a:solidFill>
-                  <a:srgbClr val="1D3557"/>
-                </a:solidFill>
-                <a:latin typeface="Menlo"/>
-              </a:rPr>
-              <a:t>pendientes = []</a:t>
-            </a:r>
-          </a:p>
-          <a:p>
-            <a:pPr/>
-            <a:r>
-              <a:rPr sz="1500" b="0">
-                <a:solidFill>
-                  <a:srgbClr val="1D3557"/>
-                </a:solidFill>
-                <a:latin typeface="Menlo"/>
-              </a:rPr>
-              <a:t>for _ in range(2000):</a:t>
-            </a:r>
-          </a:p>
-          <a:p>
-            <a:pPr/>
-            <a:r>
-              <a:rPr sz="1500" b="0">
-                <a:solidFill>
-                  <a:srgbClr val="1D3557"/>
-                </a:solidFill>
-                <a:latin typeface="Menlo"/>
-              </a:rPr>
-              <a:t>    idx = rng.integers(0, 45, 45)     # 45 comunas, con reemplazo</a:t>
-            </a:r>
-          </a:p>
-          <a:p>
-            <a:pPr/>
-            <a:r>
-              <a:rPr sz="1500" b="0">
-                <a:solidFill>
-                  <a:srgbClr val="1D3557"/>
-                </a:solidFill>
-                <a:latin typeface="Menlo"/>
-              </a:rPr>
-              <a:t>    pendientes.append(np.polyfit(x[idx], y[idx], 1)[0])</a:t>
-            </a:r>
-          </a:p>
-          <a:p>
-            <a:pPr/>
-            <a:r>
-              <a:rPr sz="1500" b="0">
-                <a:solidFill>
-                  <a:srgbClr val="1D3557"/>
-                </a:solidFill>
-                <a:latin typeface="Menlo"/>
-              </a:rPr>
-              <a:t>np.percentile(pendientes, [2.5, 97.5])</a:t>
-            </a:r>
-          </a:p>
-        </p:txBody>
-      </p:sp>
-      <p:sp>
-        <p:nvSpPr>
-          <p:cNvPr id="5" name="TextBox 4"/>
+              <a:t>Qué supone la regresión para inferir</a:t>
+            </a:r>
+          </a:p>
+        </p:txBody>
+      </p:sp>
+      <p:sp>
+        <p:nvSpPr>
+          <p:cNvPr id="4" name="TextBox 3"/>
           <p:cNvSpPr txBox="1"/>
           <p:nvPr/>
         </p:nvSpPr>
         <p:spPr>
           <a:xfrm>
-            <a:off x="704088" y="4389120"/>
-            <a:ext cx="7744968" cy="1097280"/>
+            <a:off x="704088" y="1353312"/>
+            <a:ext cx="7744968" cy="3300984"/>
           </a:xfrm>
           <a:prstGeom prst="rect">
             <a:avLst/>
@@ -6561,7 +6430,7 @@
               </a:spcAft>
             </a:pPr>
             <a:r>
-              <a:rPr sz="1600" b="1">
+              <a:rPr sz="1800" b="1">
                 <a:solidFill>
                   <a:srgbClr val="E0A437"/>
                 </a:solidFill>
@@ -6570,13 +6439,97 @@
               <a:t>▸ </a:t>
             </a:r>
             <a:r>
-              <a:rPr sz="1600" b="0">
+              <a:rPr sz="1800" b="1">
+                <a:solidFill>
+                  <a:srgbClr val="1D3557"/>
+                </a:solidFill>
+                <a:latin typeface="Fira Sans"/>
+              </a:rPr>
+              <a:t>No que las variables sean normales. Los t y p del summary suponen residuos independientes, con la misma varianza y, con n chico, normales.</a:t>
+            </a:r>
+          </a:p>
+          <a:p>
+            <a:pPr>
+              <a:lnSpc>
+                <a:spcPct val="112000"/>
+              </a:lnSpc>
+              <a:spcAft>
+                <a:spcPts val="900"/>
+              </a:spcAft>
+            </a:pPr>
+            <a:r>
+              <a:rPr sz="1800" b="1">
+                <a:solidFill>
+                  <a:srgbClr val="E0A437"/>
+                </a:solidFill>
+                <a:latin typeface="Fira Sans"/>
+              </a:rPr>
+              <a:t>▸ </a:t>
+            </a:r>
+            <a:r>
+              <a:rPr sz="1800" b="0">
                 <a:solidFill>
                   <a:srgbClr val="000000"/>
                 </a:solidFill>
                 <a:latin typeface="Fira Sans"/>
               </a:rPr>
-              <a:t>Sacar 45 comunas con reemplazo imita el azar del muestreo: algunas se repiten, otras quedan fuera. La distribución de las 2.000 pendientes dice cuánto se mueve la nuestra.</a:t>
+              <a:t>Con n grande el TCL hace el trabajo: un coeficiente es un promedio ponderado de los y, y los promedios se vuelven normales.</a:t>
+            </a:r>
+          </a:p>
+          <a:p>
+            <a:pPr>
+              <a:lnSpc>
+                <a:spcPct val="112000"/>
+              </a:lnSpc>
+              <a:spcAft>
+                <a:spcPts val="900"/>
+              </a:spcAft>
+            </a:pPr>
+            <a:r>
+              <a:rPr sz="1800" b="1">
+                <a:solidFill>
+                  <a:srgbClr val="E0A437"/>
+                </a:solidFill>
+                <a:latin typeface="Fira Sans"/>
+              </a:rPr>
+              <a:t>▸ </a:t>
+            </a:r>
+            <a:r>
+              <a:rPr sz="1800" b="0">
+                <a:solidFill>
+                  <a:srgbClr val="000000"/>
+                </a:solidFill>
+                <a:latin typeface="Fira Sans"/>
+              </a:rPr>
+              <a:t>Lo que sí daña la inferencia: colas largas y atípicos, que inflan el error estándar. El log de la clase 4 también ayuda aquí.</a:t>
+            </a:r>
+          </a:p>
+          <a:p>
+            <a:pPr>
+              <a:lnSpc>
+                <a:spcPct val="112000"/>
+              </a:lnSpc>
+              <a:spcAft>
+                <a:spcPts val="900"/>
+              </a:spcAft>
+            </a:pPr>
+            <a:r>
+              <a:rPr sz="1800" b="1">
+                <a:solidFill>
+                  <a:srgbClr val="E0A437"/>
+                </a:solidFill>
+                <a:latin typeface="Fira Sans"/>
+              </a:rPr>
+              <a:t>▸ </a:t>
+            </a:r>
+            <a:r>
+              <a:rPr sz="1800" b="0">
+                <a:solidFill>
+                  <a:srgbClr val="000000"/>
+                </a:solidFill>
+                <a:latin typeface="Fira Sans"/>
+              </a:rPr>
+              <a:t>Con 45 comunas los supuestos pesan; con 113 mil viajes, casi nada.</a:t>
             </a:r>
           </a:p>
         </p:txBody>
@@ -6614,7 +6567,7 @@
             <a:avLst/>
           </a:prstGeom>
           <a:solidFill>
-            <a:srgbClr val="FAFBFC"/>
+            <a:srgbClr val="1D3557"/>
           </a:solidFill>
           <a:ln>
             <a:noFill/>
@@ -6651,8 +6604,8 @@
         </p:nvSpPr>
         <p:spPr>
           <a:xfrm>
-            <a:off x="402336" y="301752"/>
-            <a:ext cx="8348472" cy="795528"/>
+            <a:off x="603504" y="1847088"/>
+            <a:ext cx="7946136" cy="1399032"/>
           </a:xfrm>
           <a:prstGeom prst="rect">
             <a:avLst/>
@@ -6666,71 +6619,24 @@
           <a:lstStyle/>
           <a:p>
             <a:r>
-              <a:rPr sz="2800" b="1">
-                <a:solidFill>
-                  <a:srgbClr val="0F0F0F"/>
-                </a:solidFill>
-                <a:latin typeface="Fira Sans"/>
-              </a:rPr>
-              <a:t>La pendiente, remuestreada</a:t>
-            </a:r>
-          </a:p>
-        </p:txBody>
-      </p:sp>
-      <p:pic>
-        <p:nvPicPr>
-          <p:cNvPr id="4" name="Picture 3" descr="c5_13_bootstrap.png"/>
-          <p:cNvPicPr>
-            <a:picLocks noChangeAspect="1"/>
-          </p:cNvPicPr>
-          <p:nvPr/>
-        </p:nvPicPr>
-        <p:blipFill>
-          <a:blip r:embed="rId2"/>
-          <a:stretch>
-            <a:fillRect/>
-          </a:stretch>
-        </p:blipFill>
-        <p:spPr>
-          <a:xfrm>
-            <a:off x="1022984" y="1143000"/>
-            <a:ext cx="7098030" cy="3154680"/>
-          </a:xfrm>
-          <a:prstGeom prst="rect">
-            <a:avLst/>
-          </a:prstGeom>
-        </p:spPr>
-      </p:pic>
-      <p:sp>
-        <p:nvSpPr>
-          <p:cNvPr id="5" name="TextBox 4"/>
-          <p:cNvSpPr txBox="1"/>
-          <p:nvPr/>
-        </p:nvSpPr>
-        <p:spPr>
-          <a:xfrm>
-            <a:off x="704088" y="4434840"/>
-            <a:ext cx="7744968" cy="457200"/>
-          </a:xfrm>
-          <a:prstGeom prst="rect">
-            <a:avLst/>
-          </a:prstGeom>
-          <a:noFill/>
-        </p:spPr>
-        <p:txBody>
-          <a:bodyPr wrap="square">
-            <a:spAutoFit/>
-          </a:bodyPr>
-          <a:lstStyle/>
-          <a:p>
-            <a:r>
-              <a:rPr sz="1300" b="0">
-                <a:solidFill>
-                  <a:srgbClr val="333333"/>
-                </a:solidFill>
-                <a:latin typeface="Fira Sans"/>
-              </a:rPr>
-              <a:t>El intervalo bootstrap se parece al de statsmodels y casi ninguna remuestra llega al 0: la misma conclusión por un camino que solo usa el computador. Sirve para cualquier estadístico.</a:t>
+              <a:rPr sz="3400" b="1">
+                <a:solidFill>
+                  <a:srgbClr val="FFFFFF"/>
+                </a:solidFill>
+                <a:latin typeface="Fira Sans"/>
+              </a:rPr>
+              <a:t>Bootstrap</a:t>
+            </a:r>
+          </a:p>
+          <a:p>
+            <a:r>
+              <a:rPr sz="1800" b="0">
+                <a:solidFill>
+                  <a:srgbClr val="E0A437"/>
+                </a:solidFill>
+                <a:latin typeface="Fira Sans"/>
+              </a:rPr>
+              <a:t>La misma respuesta, sin fórmulas</a:t>
             </a:r>
           </a:p>
         </p:txBody>
@@ -6768,7 +6674,7 @@
             <a:avLst/>
           </a:prstGeom>
           <a:solidFill>
-            <a:srgbClr val="1D3557"/>
+            <a:srgbClr val="FAFBFC"/>
           </a:solidFill>
           <a:ln>
             <a:noFill/>
@@ -6805,8 +6711,8 @@
         </p:nvSpPr>
         <p:spPr>
           <a:xfrm>
-            <a:off x="603504" y="1847088"/>
-            <a:ext cx="7946136" cy="1399032"/>
+            <a:off x="402336" y="301752"/>
+            <a:ext cx="8348472" cy="795528"/>
           </a:xfrm>
           <a:prstGeom prst="rect">
             <a:avLst/>
@@ -6820,24 +6726,167 @@
           <a:lstStyle/>
           <a:p>
             <a:r>
-              <a:rPr sz="3400" b="1">
-                <a:solidFill>
-                  <a:srgbClr val="FFFFFF"/>
-                </a:solidFill>
-                <a:latin typeface="Fira Sans"/>
-              </a:rPr>
-              <a:t>¿Qué hogares tienen auto?</a:t>
-            </a:r>
-          </a:p>
-          <a:p>
-            <a:r>
-              <a:rPr sz="1800" b="0">
+              <a:rPr sz="2800" b="1">
+                <a:solidFill>
+                  <a:srgbClr val="0F0F0F"/>
+                </a:solidFill>
+                <a:latin typeface="Fira Sans"/>
+              </a:rPr>
+              <a:t>Remuestrear los datos</a:t>
+            </a:r>
+          </a:p>
+        </p:txBody>
+      </p:sp>
+      <p:sp>
+        <p:nvSpPr>
+          <p:cNvPr id="4" name="Rectangle 3"/>
+          <p:cNvSpPr/>
+          <p:nvPr/>
+        </p:nvSpPr>
+        <p:spPr>
+          <a:xfrm>
+            <a:off x="704088" y="1280160"/>
+            <a:ext cx="7744968" cy="2880360"/>
+          </a:xfrm>
+          <a:prstGeom prst="rect">
+            <a:avLst/>
+          </a:prstGeom>
+          <a:solidFill>
+            <a:srgbClr val="F0F2F5"/>
+          </a:solidFill>
+          <a:ln>
+            <a:solidFill>
+              <a:srgbClr val="D8DDE3"/>
+            </a:solidFill>
+          </a:ln>
+          <a:effectLst/>
+        </p:spPr>
+        <p:style>
+          <a:lnRef idx="1">
+            <a:schemeClr val="accent1"/>
+          </a:lnRef>
+          <a:fillRef idx="3">
+            <a:schemeClr val="accent1"/>
+          </a:fillRef>
+          <a:effectRef idx="2">
+            <a:schemeClr val="accent1"/>
+          </a:effectRef>
+          <a:fontRef idx="minor">
+            <a:schemeClr val="lt1"/>
+          </a:fontRef>
+        </p:style>
+        <p:txBody>
+          <a:bodyPr rtlCol="0" anchor="ctr" wrap="square" lIns="228600" tIns="137160"/>
+          <a:lstStyle/>
+          <a:p>
+            <a:pPr/>
+            <a:r>
+              <a:rPr sz="1500" b="0">
+                <a:solidFill>
+                  <a:srgbClr val="1D3557"/>
+                </a:solidFill>
+                <a:latin typeface="Menlo"/>
+              </a:rPr>
+              <a:t>pendientes = []</a:t>
+            </a:r>
+          </a:p>
+          <a:p>
+            <a:pPr/>
+            <a:r>
+              <a:rPr sz="1500" b="0">
+                <a:solidFill>
+                  <a:srgbClr val="1D3557"/>
+                </a:solidFill>
+                <a:latin typeface="Menlo"/>
+              </a:rPr>
+              <a:t>for _ in range(2000):</a:t>
+            </a:r>
+          </a:p>
+          <a:p>
+            <a:pPr/>
+            <a:r>
+              <a:rPr sz="1500" b="0">
+                <a:solidFill>
+                  <a:srgbClr val="1D3557"/>
+                </a:solidFill>
+                <a:latin typeface="Menlo"/>
+              </a:rPr>
+              <a:t>    idx = rng.integers(0, 45, 45)     # 45 comunas, con reemplazo</a:t>
+            </a:r>
+          </a:p>
+          <a:p>
+            <a:pPr/>
+            <a:r>
+              <a:rPr sz="1500" b="0">
+                <a:solidFill>
+                  <a:srgbClr val="1D3557"/>
+                </a:solidFill>
+                <a:latin typeface="Menlo"/>
+              </a:rPr>
+              <a:t>    pendientes.append(np.polyfit(x[idx], y[idx], 1)[0])</a:t>
+            </a:r>
+          </a:p>
+          <a:p>
+            <a:pPr/>
+            <a:r>
+              <a:rPr sz="1500" b="0">
+                <a:solidFill>
+                  <a:srgbClr val="1D3557"/>
+                </a:solidFill>
+                <a:latin typeface="Menlo"/>
+              </a:rPr>
+              <a:t>np.percentile(pendientes, [2.5, 97.5])</a:t>
+            </a:r>
+          </a:p>
+        </p:txBody>
+      </p:sp>
+      <p:sp>
+        <p:nvSpPr>
+          <p:cNvPr id="5" name="TextBox 4"/>
+          <p:cNvSpPr txBox="1"/>
+          <p:nvPr/>
+        </p:nvSpPr>
+        <p:spPr>
+          <a:xfrm>
+            <a:off x="704088" y="4389120"/>
+            <a:ext cx="7744968" cy="1097280"/>
+          </a:xfrm>
+          <a:prstGeom prst="rect">
+            <a:avLst/>
+          </a:prstGeom>
+          <a:noFill/>
+        </p:spPr>
+        <p:txBody>
+          <a:bodyPr wrap="square">
+            <a:spAutoFit/>
+          </a:bodyPr>
+          <a:lstStyle/>
+          <a:p>
+            <a:pPr>
+              <a:lnSpc>
+                <a:spcPct val="112000"/>
+              </a:lnSpc>
+              <a:spcAft>
+                <a:spcPts val="900"/>
+              </a:spcAft>
+            </a:pPr>
+            <a:r>
+              <a:rPr sz="1600" b="1">
                 <a:solidFill>
                   <a:srgbClr val="E0A437"/>
                 </a:solidFill>
                 <a:latin typeface="Fira Sans"/>
               </a:rPr>
-              <a:t>Explicar un sí o no (tiene auto) con el ingreso del hogar: la regresión logística, y con ella, clasificar</a:t>
+              <a:t>▸ </a:t>
+            </a:r>
+            <a:r>
+              <a:rPr sz="1600" b="0">
+                <a:solidFill>
+                  <a:srgbClr val="000000"/>
+                </a:solidFill>
+                <a:latin typeface="Fira Sans"/>
+              </a:rPr>
+              <a:t>Sacar 45 comunas con reemplazo imita el azar del muestreo: algunas se repiten, otras quedan fuera. La distribución de las 2.000 pendientes dice cuánto se mueve la nuestra.</a:t>
             </a:r>
           </a:p>
         </p:txBody>
@@ -7012,7 +7061,7 @@
                 </a:solidFill>
                 <a:latin typeface="Fira Sans"/>
               </a:rPr>
-              <a:t>2. Muestra y población: la distribución muestral y el error estándar.</a:t>
+              <a:t>2. Inferencia: muestra y población, la distribución muestral y el error estándar.</a:t>
             </a:r>
           </a:p>
           <a:p>
@@ -7220,14 +7269,14 @@
                 </a:solidFill>
                 <a:latin typeface="Fira Sans"/>
               </a:rPr>
-              <a:t>La recta no sirve para un sí o no</a:t>
+              <a:t>La pendiente, remuestreada</a:t>
             </a:r>
           </a:p>
         </p:txBody>
       </p:sp>
       <p:pic>
         <p:nvPicPr>
-          <p:cNvPr id="4" name="Picture 3" descr="c5_15_recta_vs_logistica.png"/>
+          <p:cNvPr id="4" name="Picture 3" descr="c5_13_bootstrap.png"/>
           <p:cNvPicPr>
             <a:picLocks noChangeAspect="1"/>
           </p:cNvPicPr>
@@ -7241,8 +7290,8 @@
         </p:blipFill>
         <p:spPr>
           <a:xfrm>
-            <a:off x="1208992" y="1143000"/>
-            <a:ext cx="6726015" cy="3154680"/>
+            <a:off x="1022984" y="1143000"/>
+            <a:ext cx="7098030" cy="3154680"/>
           </a:xfrm>
           <a:prstGeom prst="rect">
             <a:avLst/>
@@ -7278,7 +7327,7 @@
                 </a:solidFill>
                 <a:latin typeface="Fira Sans"/>
               </a:rPr>
-              <a:t>Sobre un 0/1, la recta predice 1,39 a los 5 millones y valores negativos abajo: no respeta que la respuesta vive entre 0 y 1. La logística pasa la recta por una S y queda siempre en el rango.</a:t>
+              <a:t>El intervalo bootstrap se parece al de statsmodels y casi ninguna remuestra llega al 0: la misma conclusión por un camino que solo usa el computador. Sirve para cualquier estadístico.</a:t>
             </a:r>
           </a:p>
         </p:txBody>
@@ -7316,7 +7365,7 @@
             <a:avLst/>
           </a:prstGeom>
           <a:solidFill>
-            <a:srgbClr val="FAFBFC"/>
+            <a:srgbClr val="1D3557"/>
           </a:solidFill>
           <a:ln>
             <a:noFill/>
@@ -7353,8 +7402,8 @@
         </p:nvSpPr>
         <p:spPr>
           <a:xfrm>
-            <a:off x="402336" y="301752"/>
-            <a:ext cx="8348472" cy="795528"/>
+            <a:off x="603504" y="1847088"/>
+            <a:ext cx="7946136" cy="1399032"/>
           </a:xfrm>
           <a:prstGeom prst="rect">
             <a:avLst/>
@@ -7368,71 +7417,24 @@
           <a:lstStyle/>
           <a:p>
             <a:r>
-              <a:rPr sz="2800" b="1">
-                <a:solidFill>
-                  <a:srgbClr val="0F0F0F"/>
-                </a:solidFill>
-                <a:latin typeface="Fira Sans"/>
-              </a:rPr>
-              <a:t>La regresión logística</a:t>
-            </a:r>
-          </a:p>
-        </p:txBody>
-      </p:sp>
-      <p:pic>
-        <p:nvPicPr>
-          <p:cNvPr id="4" name="Picture 3" descr="c5_16_formula_logistica.png"/>
-          <p:cNvPicPr>
-            <a:picLocks noChangeAspect="1"/>
-          </p:cNvPicPr>
-          <p:nvPr/>
-        </p:nvPicPr>
-        <p:blipFill>
-          <a:blip r:embed="rId2"/>
-          <a:stretch>
-            <a:fillRect/>
-          </a:stretch>
-        </p:blipFill>
-        <p:spPr>
-          <a:xfrm>
-            <a:off x="699515" y="1262245"/>
-            <a:ext cx="7744968" cy="2916190"/>
-          </a:xfrm>
-          <a:prstGeom prst="rect">
-            <a:avLst/>
-          </a:prstGeom>
-        </p:spPr>
-      </p:pic>
-      <p:sp>
-        <p:nvSpPr>
-          <p:cNvPr id="5" name="TextBox 4"/>
-          <p:cNvSpPr txBox="1"/>
-          <p:nvPr/>
-        </p:nvSpPr>
-        <p:spPr>
-          <a:xfrm>
-            <a:off x="704088" y="4434840"/>
-            <a:ext cx="7744968" cy="457200"/>
-          </a:xfrm>
-          <a:prstGeom prst="rect">
-            <a:avLst/>
-          </a:prstGeom>
-          <a:noFill/>
-        </p:spPr>
-        <p:txBody>
-          <a:bodyPr wrap="square">
-            <a:spAutoFit/>
-          </a:bodyPr>
-          <a:lstStyle/>
-          <a:p>
-            <a:r>
-              <a:rPr sz="1300" b="0">
-                <a:solidFill>
-                  <a:srgbClr val="333333"/>
-                </a:solidFill>
-                <a:latin typeface="Fira Sans"/>
-              </a:rPr>
-              <a:t>La misma recta a + b·x, pero dentro de la sigmoide. La respuesta es una Bernoulli (la binomial con n = 1) cuya probabilidad depende de x.</a:t>
+              <a:rPr sz="3400" b="1">
+                <a:solidFill>
+                  <a:srgbClr val="FFFFFF"/>
+                </a:solidFill>
+                <a:latin typeface="Fira Sans"/>
+              </a:rPr>
+              <a:t>¿Qué hogares tienen auto?</a:t>
+            </a:r>
+          </a:p>
+          <a:p>
+            <a:r>
+              <a:rPr sz="1800" b="0">
+                <a:solidFill>
+                  <a:srgbClr val="E0A437"/>
+                </a:solidFill>
+                <a:latin typeface="Fira Sans"/>
+              </a:rPr>
+              <a:t>Explicar un sí o no (tiene auto) con el ingreso del hogar: la regresión logística, y con ella, clasificar</a:t>
             </a:r>
           </a:p>
         </p:txBody>
@@ -7528,114 +7530,35 @@
                 </a:solidFill>
                 <a:latin typeface="Fira Sans"/>
               </a:rPr>
-              <a:t>La logística en statsmodels</a:t>
-            </a:r>
-          </a:p>
-        </p:txBody>
-      </p:sp>
-      <p:sp>
-        <p:nvSpPr>
-          <p:cNvPr id="4" name="Rectangle 3"/>
-          <p:cNvSpPr/>
-          <p:nvPr/>
-        </p:nvSpPr>
-        <p:spPr>
-          <a:xfrm>
-            <a:off x="704088" y="1280160"/>
-            <a:ext cx="7744968" cy="2880360"/>
-          </a:xfrm>
-          <a:prstGeom prst="rect">
-            <a:avLst/>
-          </a:prstGeom>
-          <a:solidFill>
-            <a:srgbClr val="F0F2F5"/>
-          </a:solidFill>
-          <a:ln>
-            <a:solidFill>
-              <a:srgbClr val="D8DDE3"/>
-            </a:solidFill>
-          </a:ln>
-          <a:effectLst/>
-        </p:spPr>
-        <p:style>
-          <a:lnRef idx="1">
-            <a:schemeClr val="accent1"/>
-          </a:lnRef>
-          <a:fillRef idx="3">
-            <a:schemeClr val="accent1"/>
-          </a:fillRef>
-          <a:effectRef idx="2">
-            <a:schemeClr val="accent1"/>
-          </a:effectRef>
-          <a:fontRef idx="minor">
-            <a:schemeClr val="lt1"/>
-          </a:fontRef>
-        </p:style>
-        <p:txBody>
-          <a:bodyPr rtlCol="0" anchor="ctr" wrap="square" lIns="228600" tIns="137160"/>
-          <a:lstStyle/>
-          <a:p>
-            <a:pPr/>
-            <a:r>
-              <a:rPr sz="1500" b="0">
-                <a:solidFill>
-                  <a:srgbClr val="1D3557"/>
-                </a:solidFill>
-                <a:latin typeface="Menlo"/>
-              </a:rPr>
-              <a:t>logistica = sm.GLM(h["tiene_auto"], sm.add_constant(ingreso),</a:t>
-            </a:r>
-          </a:p>
-          <a:p>
-            <a:pPr/>
-            <a:r>
-              <a:rPr sz="1500" b="0">
-                <a:solidFill>
-                  <a:srgbClr val="1D3557"/>
-                </a:solidFill>
-                <a:latin typeface="Menlo"/>
-              </a:rPr>
-              <a:t>                   family=sm.families.Binomial(),</a:t>
-            </a:r>
-          </a:p>
-          <a:p>
-            <a:pPr/>
-            <a:r>
-              <a:rPr sz="1500" b="0">
-                <a:solidFill>
-                  <a:srgbClr val="1D3557"/>
-                </a:solidFill>
-                <a:latin typeface="Menlo"/>
-              </a:rPr>
-              <a:t>                   freq_weights=h["Factor"]).fit()</a:t>
-            </a:r>
-          </a:p>
-          <a:p>
-            <a:pPr/>
-            <a:r>
-              <a:rPr sz="1500" b="0">
-                <a:solidFill>
-                  <a:srgbClr val="1D3557"/>
-                </a:solidFill>
-                <a:latin typeface="Menlo"/>
-              </a:rPr>
-              <a:t/>
-            </a:r>
-          </a:p>
-          <a:p>
-            <a:pPr/>
-            <a:r>
-              <a:rPr sz="1500" b="0">
-                <a:solidFill>
-                  <a:srgbClr val="1D3557"/>
-                </a:solidFill>
-                <a:latin typeface="Menlo"/>
-              </a:rPr>
-              <a:t>np.exp(logistica.params["IngresoHogar"])   # 8.9</a:t>
-            </a:r>
-          </a:p>
-        </p:txBody>
-      </p:sp>
+              <a:t>La recta no sirve para un sí o no</a:t>
+            </a:r>
+          </a:p>
+        </p:txBody>
+      </p:sp>
+      <p:pic>
+        <p:nvPicPr>
+          <p:cNvPr id="4" name="Picture 3" descr="c5_15_recta_vs_logistica.png"/>
+          <p:cNvPicPr>
+            <a:picLocks noChangeAspect="1"/>
+          </p:cNvPicPr>
+          <p:nvPr/>
+        </p:nvPicPr>
+        <p:blipFill>
+          <a:blip r:embed="rId2"/>
+          <a:stretch>
+            <a:fillRect/>
+          </a:stretch>
+        </p:blipFill>
+        <p:spPr>
+          <a:xfrm>
+            <a:off x="1208992" y="1143000"/>
+            <a:ext cx="6726015" cy="3154680"/>
+          </a:xfrm>
+          <a:prstGeom prst="rect">
+            <a:avLst/>
+          </a:prstGeom>
+        </p:spPr>
+      </p:pic>
       <p:sp>
         <p:nvSpPr>
           <p:cNvPr id="5" name="TextBox 4"/>
@@ -7644,8 +7567,8 @@
         </p:nvSpPr>
         <p:spPr>
           <a:xfrm>
-            <a:off x="704088" y="4389120"/>
-            <a:ext cx="7744968" cy="1097280"/>
+            <a:off x="704088" y="4434840"/>
+            <a:ext cx="7744968" cy="457200"/>
           </a:xfrm>
           <a:prstGeom prst="rect">
             <a:avLst/>
@@ -7658,31 +7581,14 @@
           </a:bodyPr>
           <a:lstStyle/>
           <a:p>
-            <a:pPr>
-              <a:lnSpc>
-                <a:spcPct val="112000"/>
-              </a:lnSpc>
-              <a:spcAft>
-                <a:spcPts val="900"/>
-              </a:spcAft>
-            </a:pPr>
-            <a:r>
-              <a:rPr sz="1600" b="1">
-                <a:solidFill>
-                  <a:srgbClr val="E0A437"/>
-                </a:solidFill>
-                <a:latin typeface="Fira Sans"/>
-              </a:rPr>
-              <a:t>▸ </a:t>
-            </a:r>
-            <a:r>
-              <a:rPr sz="1600" b="0">
-                <a:solidFill>
-                  <a:srgbClr val="000000"/>
-                </a:solidFill>
-                <a:latin typeface="Fira Sans"/>
-              </a:rPr>
-              <a:t>GLM con familia binomial, ponderado con el factor. Lectura multiplicativa, como el log de la clase 4: cada millón multiplica las chances de tener auto por 8,9.</a:t>
+            <a:r>
+              <a:rPr sz="1300" b="0">
+                <a:solidFill>
+                  <a:srgbClr val="333333"/>
+                </a:solidFill>
+                <a:latin typeface="Fira Sans"/>
+              </a:rPr>
+              <a:t>Sobre un 0/1, la recta predice 1,39 a los 5 millones y valores negativos abajo: no respeta que la respuesta vive entre 0 y 1. La logística pasa la recta por una S y queda siempre en el rango.</a:t>
             </a:r>
           </a:p>
         </p:txBody>
@@ -7778,14 +7684,14 @@
                 </a:solidFill>
                 <a:latin typeface="Fira Sans"/>
               </a:rPr>
-              <a:t>Clasificar: de la probabilidad a la decisión</a:t>
+              <a:t>La regresión logística</a:t>
             </a:r>
           </a:p>
         </p:txBody>
       </p:sp>
       <p:pic>
         <p:nvPicPr>
-          <p:cNvPr id="4" name="Picture 3" descr="c5_17_clasificacion.png"/>
+          <p:cNvPr id="4" name="Picture 3" descr="c5_16_formula_logistica.png"/>
           <p:cNvPicPr>
             <a:picLocks noChangeAspect="1"/>
           </p:cNvPicPr>
@@ -7799,8 +7705,8 @@
         </p:blipFill>
         <p:spPr>
           <a:xfrm>
-            <a:off x="1042506" y="1143000"/>
-            <a:ext cx="7058986" cy="3154680"/>
+            <a:off x="699515" y="1262245"/>
+            <a:ext cx="7744968" cy="2916190"/>
           </a:xfrm>
           <a:prstGeom prst="rect">
             <a:avLst/>
@@ -7836,7 +7742,7 @@
                 </a:solidFill>
                 <a:latin typeface="Fira Sans"/>
               </a:rPr>
-              <a:t>Predecir "tiene auto" cuando P supera 0,5 (desde 0,86 millones). Acierta el 70%, contra el 61% de decir siempre "no": la comparación con la base es obligatoria. Dónde se equivoca lo dice la matriz de confusión (un crosstab).</a:t>
+              <a:t>La misma recta a + b·x, pero dentro de la sigmoide. La respuesta es una Bernoulli (la binomial con n = 1) cuya probabilidad depende de x.</a:t>
             </a:r>
           </a:p>
         </p:txBody>
@@ -7874,7 +7780,7 @@
             <a:avLst/>
           </a:prstGeom>
           <a:solidFill>
-            <a:srgbClr val="1D3557"/>
+            <a:srgbClr val="FAFBFC"/>
           </a:solidFill>
           <a:ln>
             <a:noFill/>
@@ -7911,8 +7817,8 @@
         </p:nvSpPr>
         <p:spPr>
           <a:xfrm>
-            <a:off x="603504" y="1847088"/>
-            <a:ext cx="7946136" cy="1399032"/>
+            <a:off x="402336" y="301752"/>
+            <a:ext cx="8348472" cy="795528"/>
           </a:xfrm>
           <a:prstGeom prst="rect">
             <a:avLst/>
@@ -7926,24 +7832,167 @@
           <a:lstStyle/>
           <a:p>
             <a:r>
-              <a:rPr sz="3400" b="1">
-                <a:solidFill>
-                  <a:srgbClr val="FFFFFF"/>
-                </a:solidFill>
-                <a:latin typeface="Fira Sans"/>
-              </a:rPr>
-              <a:t>La trampa de las comparaciones múltiples</a:t>
-            </a:r>
-          </a:p>
-          <a:p>
-            <a:r>
-              <a:rPr sz="1800" b="0">
+              <a:rPr sz="2800" b="1">
+                <a:solidFill>
+                  <a:srgbClr val="0F0F0F"/>
+                </a:solidFill>
+                <a:latin typeface="Fira Sans"/>
+              </a:rPr>
+              <a:t>La logística en statsmodels</a:t>
+            </a:r>
+          </a:p>
+        </p:txBody>
+      </p:sp>
+      <p:sp>
+        <p:nvSpPr>
+          <p:cNvPr id="4" name="Rectangle 3"/>
+          <p:cNvSpPr/>
+          <p:nvPr/>
+        </p:nvSpPr>
+        <p:spPr>
+          <a:xfrm>
+            <a:off x="704088" y="1280160"/>
+            <a:ext cx="7744968" cy="2880360"/>
+          </a:xfrm>
+          <a:prstGeom prst="rect">
+            <a:avLst/>
+          </a:prstGeom>
+          <a:solidFill>
+            <a:srgbClr val="F0F2F5"/>
+          </a:solidFill>
+          <a:ln>
+            <a:solidFill>
+              <a:srgbClr val="D8DDE3"/>
+            </a:solidFill>
+          </a:ln>
+          <a:effectLst/>
+        </p:spPr>
+        <p:style>
+          <a:lnRef idx="1">
+            <a:schemeClr val="accent1"/>
+          </a:lnRef>
+          <a:fillRef idx="3">
+            <a:schemeClr val="accent1"/>
+          </a:fillRef>
+          <a:effectRef idx="2">
+            <a:schemeClr val="accent1"/>
+          </a:effectRef>
+          <a:fontRef idx="minor">
+            <a:schemeClr val="lt1"/>
+          </a:fontRef>
+        </p:style>
+        <p:txBody>
+          <a:bodyPr rtlCol="0" anchor="ctr" wrap="square" lIns="228600" tIns="137160"/>
+          <a:lstStyle/>
+          <a:p>
+            <a:pPr/>
+            <a:r>
+              <a:rPr sz="1500" b="0">
+                <a:solidFill>
+                  <a:srgbClr val="1D3557"/>
+                </a:solidFill>
+                <a:latin typeface="Menlo"/>
+              </a:rPr>
+              <a:t>logistica = sm.GLM(h["tiene_auto"], sm.add_constant(ingreso),</a:t>
+            </a:r>
+          </a:p>
+          <a:p>
+            <a:pPr/>
+            <a:r>
+              <a:rPr sz="1500" b="0">
+                <a:solidFill>
+                  <a:srgbClr val="1D3557"/>
+                </a:solidFill>
+                <a:latin typeface="Menlo"/>
+              </a:rPr>
+              <a:t>                   family=sm.families.Binomial(),</a:t>
+            </a:r>
+          </a:p>
+          <a:p>
+            <a:pPr/>
+            <a:r>
+              <a:rPr sz="1500" b="0">
+                <a:solidFill>
+                  <a:srgbClr val="1D3557"/>
+                </a:solidFill>
+                <a:latin typeface="Menlo"/>
+              </a:rPr>
+              <a:t>                   freq_weights=h["Factor"]).fit()</a:t>
+            </a:r>
+          </a:p>
+          <a:p>
+            <a:pPr/>
+            <a:r>
+              <a:rPr sz="1500" b="0">
+                <a:solidFill>
+                  <a:srgbClr val="1D3557"/>
+                </a:solidFill>
+                <a:latin typeface="Menlo"/>
+              </a:rPr>
+              <a:t/>
+            </a:r>
+          </a:p>
+          <a:p>
+            <a:pPr/>
+            <a:r>
+              <a:rPr sz="1500" b="0">
+                <a:solidFill>
+                  <a:srgbClr val="1D3557"/>
+                </a:solidFill>
+                <a:latin typeface="Menlo"/>
+              </a:rPr>
+              <a:t>np.exp(logistica.params["IngresoHogar"])   # 8.9</a:t>
+            </a:r>
+          </a:p>
+        </p:txBody>
+      </p:sp>
+      <p:sp>
+        <p:nvSpPr>
+          <p:cNvPr id="5" name="TextBox 4"/>
+          <p:cNvSpPr txBox="1"/>
+          <p:nvPr/>
+        </p:nvSpPr>
+        <p:spPr>
+          <a:xfrm>
+            <a:off x="704088" y="4389120"/>
+            <a:ext cx="7744968" cy="1097280"/>
+          </a:xfrm>
+          <a:prstGeom prst="rect">
+            <a:avLst/>
+          </a:prstGeom>
+          <a:noFill/>
+        </p:spPr>
+        <p:txBody>
+          <a:bodyPr wrap="square">
+            <a:spAutoFit/>
+          </a:bodyPr>
+          <a:lstStyle/>
+          <a:p>
+            <a:pPr>
+              <a:lnSpc>
+                <a:spcPct val="112000"/>
+              </a:lnSpc>
+              <a:spcAft>
+                <a:spcPts val="900"/>
+              </a:spcAft>
+            </a:pPr>
+            <a:r>
+              <a:rPr sz="1600" b="1">
                 <a:solidFill>
                   <a:srgbClr val="E0A437"/>
                 </a:solidFill>
                 <a:latin typeface="Fira Sans"/>
               </a:rPr>
-              <a:t>Qué pasa con el valor p cuando se prueba de todo</a:t>
+              <a:t>▸ </a:t>
+            </a:r>
+            <a:r>
+              <a:rPr sz="1600" b="0">
+                <a:solidFill>
+                  <a:srgbClr val="000000"/>
+                </a:solidFill>
+                <a:latin typeface="Fira Sans"/>
+              </a:rPr>
+              <a:t>GLM con familia binomial, ponderado con el factor. Lectura multiplicativa, como el log de la clase 4: cada millón multiplica las chances de tener auto por 8,9.</a:t>
             </a:r>
           </a:p>
         </p:txBody>
@@ -8039,14 +8088,14 @@
                 </a:solidFill>
                 <a:latin typeface="Fira Sans"/>
               </a:rPr>
-              <a:t>20 variables de puro ruido</a:t>
+              <a:t>Clasificar: de la probabilidad a la decisión</a:t>
             </a:r>
           </a:p>
         </p:txBody>
       </p:sp>
       <p:pic>
         <p:nvPicPr>
-          <p:cNvPr id="4" name="Picture 3" descr="c5_14_comparaciones_multiples.png"/>
+          <p:cNvPr id="4" name="Picture 3" descr="c5_17_clasificacion.png"/>
           <p:cNvPicPr>
             <a:picLocks noChangeAspect="1"/>
           </p:cNvPicPr>
@@ -8060,8 +8109,8 @@
         </p:blipFill>
         <p:spPr>
           <a:xfrm>
-            <a:off x="759392" y="1143000"/>
-            <a:ext cx="7625215" cy="3154680"/>
+            <a:off x="1042506" y="1143000"/>
+            <a:ext cx="7058986" cy="3154680"/>
           </a:xfrm>
           <a:prstGeom prst="rect">
             <a:avLst/>
@@ -8097,7 +8146,7 @@
                 </a:solidFill>
                 <a:latin typeface="Fira Sans"/>
               </a:rPr>
-              <a:t>Números al azar, sin relación con nada, probados contra la duración por comuna: con 20 intentos y umbral 0,05 se espera una falsa alarma. Es lo que pasa al recorrer una matriz de correlación buscando la que dé.</a:t>
+              <a:t>Predecir "tiene auto" cuando P supera 0,5 (desde 0,86 millones). Acierta el 70%, contra el 61% de decir siempre "no": la comparación con la base es obligatoria. Dónde se equivoca lo dice la matriz de confusión (un crosstab).</a:t>
             </a:r>
           </a:p>
         </p:txBody>
@@ -8135,7 +8184,7 @@
             <a:avLst/>
           </a:prstGeom>
           <a:solidFill>
-            <a:srgbClr val="FAFBFC"/>
+            <a:srgbClr val="1D3557"/>
           </a:solidFill>
           <a:ln>
             <a:noFill/>
@@ -8172,8 +8221,8 @@
         </p:nvSpPr>
         <p:spPr>
           <a:xfrm>
-            <a:off x="402336" y="301752"/>
-            <a:ext cx="8348472" cy="795528"/>
+            <a:off x="603504" y="1847088"/>
+            <a:ext cx="7946136" cy="1399032"/>
           </a:xfrm>
           <a:prstGeom prst="rect">
             <a:avLst/>
@@ -8187,148 +8236,24 @@
           <a:lstStyle/>
           <a:p>
             <a:r>
-              <a:rPr sz="2800" b="1">
-                <a:solidFill>
-                  <a:srgbClr val="0F0F0F"/>
-                </a:solidFill>
-                <a:latin typeface="Fira Sans"/>
-              </a:rPr>
-              <a:t>Reglas para el EDA del proyecto</a:t>
-            </a:r>
-          </a:p>
-        </p:txBody>
-      </p:sp>
-      <p:sp>
-        <p:nvSpPr>
-          <p:cNvPr id="4" name="TextBox 3"/>
-          <p:cNvSpPr txBox="1"/>
-          <p:nvPr/>
-        </p:nvSpPr>
-        <p:spPr>
-          <a:xfrm>
-            <a:off x="704088" y="1353312"/>
-            <a:ext cx="7744968" cy="3300984"/>
-          </a:xfrm>
-          <a:prstGeom prst="rect">
-            <a:avLst/>
-          </a:prstGeom>
-          <a:noFill/>
-        </p:spPr>
-        <p:txBody>
-          <a:bodyPr wrap="square">
-            <a:spAutoFit/>
-          </a:bodyPr>
-          <a:lstStyle/>
-          <a:p>
-            <a:pPr>
-              <a:lnSpc>
-                <a:spcPct val="112000"/>
-              </a:lnSpc>
-              <a:spcAft>
-                <a:spcPts val="900"/>
-              </a:spcAft>
-            </a:pPr>
-            <a:r>
-              <a:rPr sz="1800" b="1">
+              <a:rPr sz="3400" b="1">
+                <a:solidFill>
+                  <a:srgbClr val="FFFFFF"/>
+                </a:solidFill>
+                <a:latin typeface="Fira Sans"/>
+              </a:rPr>
+              <a:t>La trampa de las comparaciones múltiples</a:t>
+            </a:r>
+          </a:p>
+          <a:p>
+            <a:r>
+              <a:rPr sz="1800" b="0">
                 <a:solidFill>
                   <a:srgbClr val="E0A437"/>
                 </a:solidFill>
                 <a:latin typeface="Fira Sans"/>
               </a:rPr>
-              <a:t>▸ </a:t>
-            </a:r>
-            <a:r>
-              <a:rPr sz="1800" b="1">
-                <a:solidFill>
-                  <a:srgbClr val="1D3557"/>
-                </a:solidFill>
-                <a:latin typeface="Fira Sans"/>
-              </a:rPr>
-              <a:t>Reportar cuántas pruebas se hicieron; un hallazgo aislado entre muchos intentos merece desconfianza.</a:t>
-            </a:r>
-          </a:p>
-          <a:p>
-            <a:pPr>
-              <a:lnSpc>
-                <a:spcPct val="112000"/>
-              </a:lnSpc>
-              <a:spcAft>
-                <a:spcPts val="900"/>
-              </a:spcAft>
-            </a:pPr>
-            <a:r>
-              <a:rPr sz="1800" b="1">
-                <a:solidFill>
-                  <a:srgbClr val="E0A437"/>
-                </a:solidFill>
-                <a:latin typeface="Fira Sans"/>
-              </a:rPr>
-              <a:t>▸ </a:t>
-            </a:r>
-            <a:r>
-              <a:rPr sz="1800" b="0">
-                <a:solidFill>
-                  <a:srgbClr val="000000"/>
-                </a:solidFill>
-                <a:latin typeface="Fira Sans"/>
-              </a:rPr>
-              <a:t>La corrección más simple, Bonferroni: dividir el umbral por el número de pruebas (0,05 / 20 = 0,0025).</a:t>
-            </a:r>
-          </a:p>
-          <a:p>
-            <a:pPr>
-              <a:lnSpc>
-                <a:spcPct val="112000"/>
-              </a:lnSpc>
-              <a:spcAft>
-                <a:spcPts val="900"/>
-              </a:spcAft>
-            </a:pPr>
-            <a:r>
-              <a:rPr sz="1800" b="1">
-                <a:solidFill>
-                  <a:srgbClr val="E0A437"/>
-                </a:solidFill>
-                <a:latin typeface="Fira Sans"/>
-              </a:rPr>
-              <a:t>▸ </a:t>
-            </a:r>
-            <a:r>
-              <a:rPr sz="1800" b="0">
-                <a:solidFill>
-                  <a:srgbClr val="000000"/>
-                </a:solidFill>
-                <a:latin typeface="Fira Sans"/>
-              </a:rPr>
-              <a:t>Preferir el intervalo de confianza al valor p: muestra el tamaño del efecto y su precisión.</a:t>
-            </a:r>
-          </a:p>
-          <a:p>
-            <a:pPr>
-              <a:lnSpc>
-                <a:spcPct val="112000"/>
-              </a:lnSpc>
-              <a:spcAft>
-                <a:spcPts val="900"/>
-              </a:spcAft>
-            </a:pPr>
-            <a:r>
-              <a:rPr sz="1800" b="1">
-                <a:solidFill>
-                  <a:srgbClr val="E0A437"/>
-                </a:solidFill>
-                <a:latin typeface="Fira Sans"/>
-              </a:rPr>
-              <a:t>▸ </a:t>
-            </a:r>
-            <a:r>
-              <a:rPr sz="1800" b="0">
-                <a:solidFill>
-                  <a:srgbClr val="000000"/>
-                </a:solidFill>
-                <a:latin typeface="Fira Sans"/>
-              </a:rPr>
-              <a:t>Significativo no es importante, y correlación no es causalidad.</a:t>
+              <a:t>Qué pasa con el valor p cuando se prueba de todo</a:t>
             </a:r>
           </a:p>
         </p:txBody>
@@ -8424,21 +8349,45 @@
                 </a:solidFill>
                 <a:latin typeface="Fira Sans"/>
               </a:rPr>
-              <a:t>Síntesis</a:t>
-            </a:r>
-          </a:p>
-        </p:txBody>
-      </p:sp>
-      <p:sp>
-        <p:nvSpPr>
-          <p:cNvPr id="4" name="TextBox 3"/>
+              <a:t>20 variables de puro ruido</a:t>
+            </a:r>
+          </a:p>
+        </p:txBody>
+      </p:sp>
+      <p:pic>
+        <p:nvPicPr>
+          <p:cNvPr id="4" name="Picture 3" descr="c5_14_comparaciones_multiples.png"/>
+          <p:cNvPicPr>
+            <a:picLocks noChangeAspect="1"/>
+          </p:cNvPicPr>
+          <p:nvPr/>
+        </p:nvPicPr>
+        <p:blipFill>
+          <a:blip r:embed="rId2"/>
+          <a:stretch>
+            <a:fillRect/>
+          </a:stretch>
+        </p:blipFill>
+        <p:spPr>
+          <a:xfrm>
+            <a:off x="759392" y="1143000"/>
+            <a:ext cx="7625215" cy="3154680"/>
+          </a:xfrm>
+          <a:prstGeom prst="rect">
+            <a:avLst/>
+          </a:prstGeom>
+        </p:spPr>
+      </p:pic>
+      <p:sp>
+        <p:nvSpPr>
+          <p:cNvPr id="5" name="TextBox 4"/>
           <p:cNvSpPr txBox="1"/>
           <p:nvPr/>
         </p:nvSpPr>
         <p:spPr>
           <a:xfrm>
-            <a:off x="704088" y="1353312"/>
-            <a:ext cx="7744968" cy="3300984"/>
+            <a:off x="704088" y="4434840"/>
+            <a:ext cx="7744968" cy="457200"/>
           </a:xfrm>
           <a:prstGeom prst="rect">
             <a:avLst/>
@@ -8451,171 +8400,14 @@
           </a:bodyPr>
           <a:lstStyle/>
           <a:p>
-            <a:pPr>
-              <a:lnSpc>
-                <a:spcPct val="112000"/>
-              </a:lnSpc>
-              <a:spcAft>
-                <a:spcPts val="900"/>
-              </a:spcAft>
-            </a:pPr>
-            <a:r>
-              <a:rPr sz="1800" b="1">
-                <a:solidFill>
-                  <a:srgbClr val="E0A437"/>
-                </a:solidFill>
-                <a:latin typeface="Fira Sans"/>
-              </a:rPr>
-              <a:t>▸ </a:t>
-            </a:r>
-            <a:r>
-              <a:rPr sz="1800" b="0">
-                <a:solidFill>
-                  <a:srgbClr val="000000"/>
-                </a:solidFill>
-                <a:latin typeface="Fira Sans"/>
-              </a:rPr>
-              <a:t>Una muestra es una de muchas: todo número calculado se movería con otra muestra, y el error estándar mide cuánto.</a:t>
-            </a:r>
-          </a:p>
-          <a:p>
-            <a:pPr>
-              <a:lnSpc>
-                <a:spcPct val="112000"/>
-              </a:lnSpc>
-              <a:spcAft>
-                <a:spcPts val="900"/>
-              </a:spcAft>
-            </a:pPr>
-            <a:r>
-              <a:rPr sz="1800" b="1">
-                <a:solidFill>
-                  <a:srgbClr val="E0A437"/>
-                </a:solidFill>
-                <a:latin typeface="Fira Sans"/>
-              </a:rPr>
-              <a:t>▸ </a:t>
-            </a:r>
-            <a:r>
-              <a:rPr sz="1800" b="0">
-                <a:solidFill>
-                  <a:srgbClr val="000000"/>
-                </a:solidFill>
-                <a:latin typeface="Fira Sans"/>
-              </a:rPr>
-              <a:t>El teorema central del límite: los promedios se distribuyen normal, aunque los datos no.</a:t>
-            </a:r>
-          </a:p>
-          <a:p>
-            <a:pPr>
-              <a:lnSpc>
-                <a:spcPct val="112000"/>
-              </a:lnSpc>
-              <a:spcAft>
-                <a:spcPts val="900"/>
-              </a:spcAft>
-            </a:pPr>
-            <a:r>
-              <a:rPr sz="1800" b="1">
-                <a:solidFill>
-                  <a:srgbClr val="E0A437"/>
-                </a:solidFill>
-                <a:latin typeface="Fira Sans"/>
-              </a:rPr>
-              <a:t>▸ </a:t>
-            </a:r>
-            <a:r>
-              <a:rPr sz="1800" b="0">
-                <a:solidFill>
-                  <a:srgbClr val="000000"/>
-                </a:solidFill>
-                <a:latin typeface="Fira Sans"/>
-              </a:rPr>
-              <a:t>El intervalo de confianza convierte el error estándar en un rango que atrapa el valor real el 95% de las veces.</a:t>
-            </a:r>
-          </a:p>
-          <a:p>
-            <a:pPr>
-              <a:lnSpc>
-                <a:spcPct val="112000"/>
-              </a:lnSpc>
-              <a:spcAft>
-                <a:spcPts val="900"/>
-              </a:spcAft>
-            </a:pPr>
-            <a:r>
-              <a:rPr sz="1800" b="1">
-                <a:solidFill>
-                  <a:srgbClr val="E0A437"/>
-                </a:solidFill>
-                <a:latin typeface="Fira Sans"/>
-              </a:rPr>
-              <a:t>▸ </a:t>
-            </a:r>
-            <a:r>
-              <a:rPr sz="1800" b="0">
-                <a:solidFill>
-                  <a:srgbClr val="000000"/>
-                </a:solidFill>
-                <a:latin typeface="Fira Sans"/>
-              </a:rPr>
-              <a:t>El valor p responde: si el efecto real fuera cero, ¿qué tan raro sería lo observado? Con p &lt; 0,05, la pendiente de −4,8 es real.</a:t>
-            </a:r>
-          </a:p>
-          <a:p>
-            <a:pPr>
-              <a:lnSpc>
-                <a:spcPct val="112000"/>
-              </a:lnSpc>
-              <a:spcAft>
-                <a:spcPts val="900"/>
-              </a:spcAft>
-            </a:pPr>
-            <a:r>
-              <a:rPr sz="1800" b="1">
-                <a:solidFill>
-                  <a:srgbClr val="E0A437"/>
-                </a:solidFill>
-                <a:latin typeface="Fira Sans"/>
-              </a:rPr>
-              <a:t>▸ </a:t>
-            </a:r>
-            <a:r>
-              <a:rPr sz="1800" b="0">
-                <a:solidFill>
-                  <a:srgbClr val="000000"/>
-                </a:solidFill>
-                <a:latin typeface="Fira Sans"/>
-              </a:rPr>
-              <a:t>Para un sí o no, la regresión logística: la recta dentro de una sigmoide; clasificar es cortar en 0,5 y comparar con la base.</a:t>
-            </a:r>
-          </a:p>
-          <a:p>
-            <a:pPr>
-              <a:lnSpc>
-                <a:spcPct val="112000"/>
-              </a:lnSpc>
-              <a:spcAft>
-                <a:spcPts val="900"/>
-              </a:spcAft>
-            </a:pPr>
-            <a:r>
-              <a:rPr sz="1800" b="1">
-                <a:solidFill>
-                  <a:srgbClr val="E0A437"/>
-                </a:solidFill>
-                <a:latin typeface="Fira Sans"/>
-              </a:rPr>
-              <a:t>▸ </a:t>
-            </a:r>
-            <a:r>
-              <a:rPr sz="1800" b="1">
-                <a:solidFill>
-                  <a:srgbClr val="1D3557"/>
-                </a:solidFill>
-                <a:latin typeface="Fira Sans"/>
-              </a:rPr>
-              <a:t>Para el EDA del lunes 15: intervalos, y cuidado con probar de todo.</a:t>
+            <a:r>
+              <a:rPr sz="1300" b="0">
+                <a:solidFill>
+                  <a:srgbClr val="333333"/>
+                </a:solidFill>
+                <a:latin typeface="Fira Sans"/>
+              </a:rPr>
+              <a:t>Números al azar, sin relación con nada, probados contra la duración por comuna: con 20 intentos y umbral 0,05 se espera una falsa alarma. Es lo que pasa al recorrer una matriz de correlación buscando la que dé.</a:t>
             </a:r>
           </a:p>
         </p:txBody>
@@ -8653,7 +8445,7 @@
             <a:avLst/>
           </a:prstGeom>
           <a:solidFill>
-            <a:srgbClr val="1D3557"/>
+            <a:srgbClr val="FAFBFC"/>
           </a:solidFill>
           <a:ln>
             <a:noFill/>
@@ -8690,8 +8482,8 @@
         </p:nvSpPr>
         <p:spPr>
           <a:xfrm>
-            <a:off x="603504" y="1847088"/>
-            <a:ext cx="7946136" cy="1399032"/>
+            <a:off x="402336" y="301752"/>
+            <a:ext cx="8348472" cy="795528"/>
           </a:xfrm>
           <a:prstGeom prst="rect">
             <a:avLst/>
@@ -8705,24 +8497,148 @@
           <a:lstStyle/>
           <a:p>
             <a:r>
-              <a:rPr sz="3400" b="1">
-                <a:solidFill>
-                  <a:srgbClr val="FFFFFF"/>
-                </a:solidFill>
-                <a:latin typeface="Fira Sans"/>
-              </a:rPr>
-              <a:t>Recreo</a:t>
-            </a:r>
-          </a:p>
-          <a:p>
+              <a:rPr sz="2800" b="1">
+                <a:solidFill>
+                  <a:srgbClr val="0F0F0F"/>
+                </a:solidFill>
+                <a:latin typeface="Fira Sans"/>
+              </a:rPr>
+              <a:t>Reglas para el EDA del proyecto</a:t>
+            </a:r>
+          </a:p>
+        </p:txBody>
+      </p:sp>
+      <p:sp>
+        <p:nvSpPr>
+          <p:cNvPr id="4" name="TextBox 3"/>
+          <p:cNvSpPr txBox="1"/>
+          <p:nvPr/>
+        </p:nvSpPr>
+        <p:spPr>
+          <a:xfrm>
+            <a:off x="704088" y="1353312"/>
+            <a:ext cx="7744968" cy="3300984"/>
+          </a:xfrm>
+          <a:prstGeom prst="rect">
+            <a:avLst/>
+          </a:prstGeom>
+          <a:noFill/>
+        </p:spPr>
+        <p:txBody>
+          <a:bodyPr wrap="square">
+            <a:spAutoFit/>
+          </a:bodyPr>
+          <a:lstStyle/>
+          <a:p>
+            <a:pPr>
+              <a:lnSpc>
+                <a:spcPct val="112000"/>
+              </a:lnSpc>
+              <a:spcAft>
+                <a:spcPts val="900"/>
+              </a:spcAft>
+            </a:pPr>
+            <a:r>
+              <a:rPr sz="1800" b="1">
+                <a:solidFill>
+                  <a:srgbClr val="E0A437"/>
+                </a:solidFill>
+                <a:latin typeface="Fira Sans"/>
+              </a:rPr>
+              <a:t>▸ </a:t>
+            </a:r>
+            <a:r>
+              <a:rPr sz="1800" b="1">
+                <a:solidFill>
+                  <a:srgbClr val="1D3557"/>
+                </a:solidFill>
+                <a:latin typeface="Fira Sans"/>
+              </a:rPr>
+              <a:t>Reportar cuántas pruebas se hicieron; un hallazgo aislado entre muchos intentos merece desconfianza.</a:t>
+            </a:r>
+          </a:p>
+          <a:p>
+            <a:pPr>
+              <a:lnSpc>
+                <a:spcPct val="112000"/>
+              </a:lnSpc>
+              <a:spcAft>
+                <a:spcPts val="900"/>
+              </a:spcAft>
+            </a:pPr>
+            <a:r>
+              <a:rPr sz="1800" b="1">
+                <a:solidFill>
+                  <a:srgbClr val="E0A437"/>
+                </a:solidFill>
+                <a:latin typeface="Fira Sans"/>
+              </a:rPr>
+              <a:t>▸ </a:t>
+            </a:r>
             <a:r>
               <a:rPr sz="1800" b="0">
                 <a:solidFill>
+                  <a:srgbClr val="000000"/>
+                </a:solidFill>
+                <a:latin typeface="Fira Sans"/>
+              </a:rPr>
+              <a:t>La corrección más simple, Bonferroni: dividir el umbral por el número de pruebas (0,05 / 20 = 0,0025).</a:t>
+            </a:r>
+          </a:p>
+          <a:p>
+            <a:pPr>
+              <a:lnSpc>
+                <a:spcPct val="112000"/>
+              </a:lnSpc>
+              <a:spcAft>
+                <a:spcPts val="900"/>
+              </a:spcAft>
+            </a:pPr>
+            <a:r>
+              <a:rPr sz="1800" b="1">
+                <a:solidFill>
                   <a:srgbClr val="E0A437"/>
                 </a:solidFill>
                 <a:latin typeface="Fira Sans"/>
               </a:rPr>
-              <a:t>10 minutos · al volver: manos al teclado, con el notebook</a:t>
+              <a:t>▸ </a:t>
+            </a:r>
+            <a:r>
+              <a:rPr sz="1800" b="0">
+                <a:solidFill>
+                  <a:srgbClr val="000000"/>
+                </a:solidFill>
+                <a:latin typeface="Fira Sans"/>
+              </a:rPr>
+              <a:t>Preferir el intervalo de confianza al valor p: muestra el tamaño del efecto y su precisión.</a:t>
+            </a:r>
+          </a:p>
+          <a:p>
+            <a:pPr>
+              <a:lnSpc>
+                <a:spcPct val="112000"/>
+              </a:lnSpc>
+              <a:spcAft>
+                <a:spcPts val="900"/>
+              </a:spcAft>
+            </a:pPr>
+            <a:r>
+              <a:rPr sz="1800" b="1">
+                <a:solidFill>
+                  <a:srgbClr val="E0A437"/>
+                </a:solidFill>
+                <a:latin typeface="Fira Sans"/>
+              </a:rPr>
+              <a:t>▸ </a:t>
+            </a:r>
+            <a:r>
+              <a:rPr sz="1800" b="0">
+                <a:solidFill>
+                  <a:srgbClr val="000000"/>
+                </a:solidFill>
+                <a:latin typeface="Fira Sans"/>
+              </a:rPr>
+              <a:t>Significativo no es importante, y correlación no es causalidad.</a:t>
             </a:r>
           </a:p>
         </p:txBody>
@@ -8818,7 +8734,7 @@
                 </a:solidFill>
                 <a:latin typeface="Fira Sans"/>
               </a:rPr>
-              <a:t>Próxima clase</a:t>
+              <a:t>Síntesis</a:t>
             </a:r>
           </a:p>
         </p:txBody>
@@ -8869,7 +8785,7 @@
                 </a:solidFill>
                 <a:latin typeface="Fira Sans"/>
               </a:rPr>
-              <a:t>Jueves 10: regresión lineal en profundidad: supuestos, diagnósticos con los residuos y evaluación fuera de la muestra.</a:t>
+              <a:t>Una muestra es una de muchas: todo número calculado se movería con otra muestra, y el error estándar mide cuánto.</a:t>
             </a:r>
           </a:p>
           <a:p>
@@ -8897,7 +8813,7 @@
                 </a:solidFill>
                 <a:latin typeface="Fira Sans"/>
               </a:rPr>
-              <a:t>Con lo de hoy ya se puede leer completo el summary de cualquier modelo.</a:t>
+              <a:t>El teorema central del límite: los promedios se distribuyen normal, aunque los datos no.</a:t>
             </a:r>
           </a:p>
           <a:p>
@@ -8919,13 +8835,97 @@
               <a:t>▸ </a:t>
             </a:r>
             <a:r>
+              <a:rPr sz="1800" b="0">
+                <a:solidFill>
+                  <a:srgbClr val="000000"/>
+                </a:solidFill>
+                <a:latin typeface="Fira Sans"/>
+              </a:rPr>
+              <a:t>El intervalo de confianza convierte el error estándar en un rango que atrapa el valor real el 95% de las veces.</a:t>
+            </a:r>
+          </a:p>
+          <a:p>
+            <a:pPr>
+              <a:lnSpc>
+                <a:spcPct val="112000"/>
+              </a:lnSpc>
+              <a:spcAft>
+                <a:spcPts val="900"/>
+              </a:spcAft>
+            </a:pPr>
+            <a:r>
               <a:rPr sz="1800" b="1">
                 <a:solidFill>
+                  <a:srgbClr val="E0A437"/>
+                </a:solidFill>
+                <a:latin typeface="Fira Sans"/>
+              </a:rPr>
+              <a:t>▸ </a:t>
+            </a:r>
+            <a:r>
+              <a:rPr sz="1800" b="0">
+                <a:solidFill>
+                  <a:srgbClr val="000000"/>
+                </a:solidFill>
+                <a:latin typeface="Fira Sans"/>
+              </a:rPr>
+              <a:t>El valor p responde: si el efecto real fuera cero, ¿qué tan raro sería lo observado? Con p &lt; 0,05, la pendiente de −4,8 es real.</a:t>
+            </a:r>
+          </a:p>
+          <a:p>
+            <a:pPr>
+              <a:lnSpc>
+                <a:spcPct val="112000"/>
+              </a:lnSpc>
+              <a:spcAft>
+                <a:spcPts val="900"/>
+              </a:spcAft>
+            </a:pPr>
+            <a:r>
+              <a:rPr sz="1800" b="1">
+                <a:solidFill>
+                  <a:srgbClr val="E0A437"/>
+                </a:solidFill>
+                <a:latin typeface="Fira Sans"/>
+              </a:rPr>
+              <a:t>▸ </a:t>
+            </a:r>
+            <a:r>
+              <a:rPr sz="1800" b="0">
+                <a:solidFill>
+                  <a:srgbClr val="000000"/>
+                </a:solidFill>
+                <a:latin typeface="Fira Sans"/>
+              </a:rPr>
+              <a:t>Para un sí o no, la regresión logística: la recta dentro de una sigmoide; clasificar es cortar en 0,5 y comparar con la base.</a:t>
+            </a:r>
+          </a:p>
+          <a:p>
+            <a:pPr>
+              <a:lnSpc>
+                <a:spcPct val="112000"/>
+              </a:lnSpc>
+              <a:spcAft>
+                <a:spcPts val="900"/>
+              </a:spcAft>
+            </a:pPr>
+            <a:r>
+              <a:rPr sz="1800" b="1">
+                <a:solidFill>
+                  <a:srgbClr val="E0A437"/>
+                </a:solidFill>
+                <a:latin typeface="Fira Sans"/>
+              </a:rPr>
+              <a:t>▸ </a:t>
+            </a:r>
+            <a:r>
+              <a:rPr sz="1800" b="1">
+                <a:solidFill>
                   <a:srgbClr val="1D3557"/>
                 </a:solidFill>
                 <a:latin typeface="Fira Sans"/>
               </a:rPr>
-              <a:t>El primer análisis exploratorio se entrega el lunes 15.</a:t>
+              <a:t>Para el EDA del lunes 15: intervalos, y cuidado con probar de todo.</a:t>
             </a:r>
           </a:p>
         </p:txBody>
@@ -9070,6 +9070,316 @@
             <a:avLst/>
           </a:prstGeom>
           <a:solidFill>
+            <a:srgbClr val="1D3557"/>
+          </a:solidFill>
+          <a:ln>
+            <a:noFill/>
+          </a:ln>
+          <a:effectLst/>
+        </p:spPr>
+        <p:style>
+          <a:lnRef idx="1">
+            <a:schemeClr val="accent1"/>
+          </a:lnRef>
+          <a:fillRef idx="3">
+            <a:schemeClr val="accent1"/>
+          </a:fillRef>
+          <a:effectRef idx="2">
+            <a:schemeClr val="accent1"/>
+          </a:effectRef>
+          <a:fontRef idx="minor">
+            <a:schemeClr val="lt1"/>
+          </a:fontRef>
+        </p:style>
+        <p:txBody>
+          <a:bodyPr rtlCol="0" anchor="ctr"/>
+          <a:lstStyle/>
+          <a:p>
+            <a:pPr algn="ctr"/>
+          </a:p>
+        </p:txBody>
+      </p:sp>
+      <p:sp>
+        <p:nvSpPr>
+          <p:cNvPr id="3" name="TextBox 2"/>
+          <p:cNvSpPr txBox="1"/>
+          <p:nvPr/>
+        </p:nvSpPr>
+        <p:spPr>
+          <a:xfrm>
+            <a:off x="603504" y="1847088"/>
+            <a:ext cx="7946136" cy="1399032"/>
+          </a:xfrm>
+          <a:prstGeom prst="rect">
+            <a:avLst/>
+          </a:prstGeom>
+          <a:noFill/>
+        </p:spPr>
+        <p:txBody>
+          <a:bodyPr wrap="square">
+            <a:spAutoFit/>
+          </a:bodyPr>
+          <a:lstStyle/>
+          <a:p>
+            <a:r>
+              <a:rPr sz="3400" b="1">
+                <a:solidFill>
+                  <a:srgbClr val="FFFFFF"/>
+                </a:solidFill>
+                <a:latin typeface="Fira Sans"/>
+              </a:rPr>
+              <a:t>Recreo</a:t>
+            </a:r>
+          </a:p>
+          <a:p>
+            <a:r>
+              <a:rPr sz="1800" b="0">
+                <a:solidFill>
+                  <a:srgbClr val="E0A437"/>
+                </a:solidFill>
+                <a:latin typeface="Fira Sans"/>
+              </a:rPr>
+              <a:t>10 minutos · al volver: manos al teclado, con el notebook</a:t>
+            </a:r>
+          </a:p>
+        </p:txBody>
+      </p:sp>
+    </p:spTree>
+  </p:cSld>
+  <p:clrMapOvr>
+    <a:masterClrMapping/>
+  </p:clrMapOvr>
+</p:sld>
+</file>
+
+<file path=ppt/slides/slide41.xml><?xml version="1.0" encoding="utf-8"?>
+<p:sld xmlns:a="http://schemas.openxmlformats.org/drawingml/2006/main" xmlns:p="http://schemas.openxmlformats.org/presentationml/2006/main" xmlns:r="http://schemas.openxmlformats.org/officeDocument/2006/relationships">
+  <p:cSld>
+    <p:spTree>
+      <p:nvGrpSpPr>
+        <p:cNvPr id="1" name=""/>
+        <p:cNvGrpSpPr/>
+        <p:nvPr/>
+      </p:nvGrpSpPr>
+      <p:grpSpPr/>
+      <p:sp>
+        <p:nvSpPr>
+          <p:cNvPr id="2" name="Rectangle 1"/>
+          <p:cNvSpPr/>
+          <p:nvPr/>
+        </p:nvSpPr>
+        <p:spPr>
+          <a:xfrm>
+            <a:off x="0" y="0"/>
+            <a:ext cx="9144000" cy="5138928"/>
+          </a:xfrm>
+          <a:prstGeom prst="rect">
+            <a:avLst/>
+          </a:prstGeom>
+          <a:solidFill>
+            <a:srgbClr val="FAFBFC"/>
+          </a:solidFill>
+          <a:ln>
+            <a:noFill/>
+          </a:ln>
+          <a:effectLst/>
+        </p:spPr>
+        <p:style>
+          <a:lnRef idx="1">
+            <a:schemeClr val="accent1"/>
+          </a:lnRef>
+          <a:fillRef idx="3">
+            <a:schemeClr val="accent1"/>
+          </a:fillRef>
+          <a:effectRef idx="2">
+            <a:schemeClr val="accent1"/>
+          </a:effectRef>
+          <a:fontRef idx="minor">
+            <a:schemeClr val="lt1"/>
+          </a:fontRef>
+        </p:style>
+        <p:txBody>
+          <a:bodyPr rtlCol="0" anchor="ctr"/>
+          <a:lstStyle/>
+          <a:p>
+            <a:pPr algn="ctr"/>
+          </a:p>
+        </p:txBody>
+      </p:sp>
+      <p:sp>
+        <p:nvSpPr>
+          <p:cNvPr id="3" name="TextBox 2"/>
+          <p:cNvSpPr txBox="1"/>
+          <p:nvPr/>
+        </p:nvSpPr>
+        <p:spPr>
+          <a:xfrm>
+            <a:off x="402336" y="301752"/>
+            <a:ext cx="8348472" cy="795528"/>
+          </a:xfrm>
+          <a:prstGeom prst="rect">
+            <a:avLst/>
+          </a:prstGeom>
+          <a:noFill/>
+        </p:spPr>
+        <p:txBody>
+          <a:bodyPr wrap="square">
+            <a:spAutoFit/>
+          </a:bodyPr>
+          <a:lstStyle/>
+          <a:p>
+            <a:r>
+              <a:rPr sz="2800" b="1">
+                <a:solidFill>
+                  <a:srgbClr val="0F0F0F"/>
+                </a:solidFill>
+                <a:latin typeface="Fira Sans"/>
+              </a:rPr>
+              <a:t>Próxima clase</a:t>
+            </a:r>
+          </a:p>
+        </p:txBody>
+      </p:sp>
+      <p:sp>
+        <p:nvSpPr>
+          <p:cNvPr id="4" name="TextBox 3"/>
+          <p:cNvSpPr txBox="1"/>
+          <p:nvPr/>
+        </p:nvSpPr>
+        <p:spPr>
+          <a:xfrm>
+            <a:off x="704088" y="1353312"/>
+            <a:ext cx="7744968" cy="3300984"/>
+          </a:xfrm>
+          <a:prstGeom prst="rect">
+            <a:avLst/>
+          </a:prstGeom>
+          <a:noFill/>
+        </p:spPr>
+        <p:txBody>
+          <a:bodyPr wrap="square">
+            <a:spAutoFit/>
+          </a:bodyPr>
+          <a:lstStyle/>
+          <a:p>
+            <a:pPr>
+              <a:lnSpc>
+                <a:spcPct val="112000"/>
+              </a:lnSpc>
+              <a:spcAft>
+                <a:spcPts val="900"/>
+              </a:spcAft>
+            </a:pPr>
+            <a:r>
+              <a:rPr sz="1800" b="1">
+                <a:solidFill>
+                  <a:srgbClr val="E0A437"/>
+                </a:solidFill>
+                <a:latin typeface="Fira Sans"/>
+              </a:rPr>
+              <a:t>▸ </a:t>
+            </a:r>
+            <a:r>
+              <a:rPr sz="1800" b="0">
+                <a:solidFill>
+                  <a:srgbClr val="000000"/>
+                </a:solidFill>
+                <a:latin typeface="Fira Sans"/>
+              </a:rPr>
+              <a:t>Jueves 10: regresión lineal en profundidad: supuestos, diagnósticos con los residuos y evaluación fuera de la muestra.</a:t>
+            </a:r>
+          </a:p>
+          <a:p>
+            <a:pPr>
+              <a:lnSpc>
+                <a:spcPct val="112000"/>
+              </a:lnSpc>
+              <a:spcAft>
+                <a:spcPts val="900"/>
+              </a:spcAft>
+            </a:pPr>
+            <a:r>
+              <a:rPr sz="1800" b="1">
+                <a:solidFill>
+                  <a:srgbClr val="E0A437"/>
+                </a:solidFill>
+                <a:latin typeface="Fira Sans"/>
+              </a:rPr>
+              <a:t>▸ </a:t>
+            </a:r>
+            <a:r>
+              <a:rPr sz="1800" b="0">
+                <a:solidFill>
+                  <a:srgbClr val="000000"/>
+                </a:solidFill>
+                <a:latin typeface="Fira Sans"/>
+              </a:rPr>
+              <a:t>Con lo de hoy ya se puede leer completo el summary de cualquier modelo.</a:t>
+            </a:r>
+          </a:p>
+          <a:p>
+            <a:pPr>
+              <a:lnSpc>
+                <a:spcPct val="112000"/>
+              </a:lnSpc>
+              <a:spcAft>
+                <a:spcPts val="900"/>
+              </a:spcAft>
+            </a:pPr>
+            <a:r>
+              <a:rPr sz="1800" b="1">
+                <a:solidFill>
+                  <a:srgbClr val="E0A437"/>
+                </a:solidFill>
+                <a:latin typeface="Fira Sans"/>
+              </a:rPr>
+              <a:t>▸ </a:t>
+            </a:r>
+            <a:r>
+              <a:rPr sz="1800" b="1">
+                <a:solidFill>
+                  <a:srgbClr val="1D3557"/>
+                </a:solidFill>
+                <a:latin typeface="Fira Sans"/>
+              </a:rPr>
+              <a:t>El primer análisis exploratorio se entrega el lunes 15.</a:t>
+            </a:r>
+          </a:p>
+        </p:txBody>
+      </p:sp>
+    </p:spTree>
+  </p:cSld>
+  <p:clrMapOvr>
+    <a:masterClrMapping/>
+  </p:clrMapOvr>
+</p:sld>
+</file>
+
+<file path=ppt/slides/slide42.xml><?xml version="1.0" encoding="utf-8"?>
+<p:sld xmlns:a="http://schemas.openxmlformats.org/drawingml/2006/main" xmlns:p="http://schemas.openxmlformats.org/presentationml/2006/main" xmlns:r="http://schemas.openxmlformats.org/officeDocument/2006/relationships">
+  <p:cSld>
+    <p:spTree>
+      <p:nvGrpSpPr>
+        <p:cNvPr id="1" name=""/>
+        <p:cNvGrpSpPr/>
+        <p:nvPr/>
+      </p:nvGrpSpPr>
+      <p:grpSpPr/>
+      <p:sp>
+        <p:nvSpPr>
+          <p:cNvPr id="2" name="Rectangle 1"/>
+          <p:cNvSpPr/>
+          <p:nvPr/>
+        </p:nvSpPr>
+        <p:spPr>
+          <a:xfrm>
+            <a:off x="0" y="0"/>
+            <a:ext cx="9144000" cy="5138928"/>
+          </a:xfrm>
+          <a:prstGeom prst="rect">
+            <a:avLst/>
+          </a:prstGeom>
+          <a:solidFill>
             <a:srgbClr val="FAFBFC"/>
           </a:solidFill>
           <a:ln>
@@ -9265,7 +9575,7 @@
             <a:avLst/>
           </a:prstGeom>
           <a:solidFill>
-            <a:srgbClr val="1D3557"/>
+            <a:srgbClr val="FAFBFC"/>
           </a:solidFill>
           <a:ln>
             <a:noFill/>
@@ -9302,8 +9612,8 @@
         </p:nvSpPr>
         <p:spPr>
           <a:xfrm>
-            <a:off x="603504" y="1847088"/>
-            <a:ext cx="7946136" cy="1399032"/>
+            <a:off x="402336" y="301752"/>
+            <a:ext cx="8348472" cy="795528"/>
           </a:xfrm>
           <a:prstGeom prst="rect">
             <a:avLst/>
@@ -9317,24 +9627,148 @@
           <a:lstStyle/>
           <a:p>
             <a:r>
-              <a:rPr sz="3400" b="1">
-                <a:solidFill>
-                  <a:srgbClr val="FFFFFF"/>
-                </a:solidFill>
-                <a:latin typeface="Fira Sans"/>
-              </a:rPr>
-              <a:t>Probabilidad</a:t>
-            </a:r>
-          </a:p>
-          <a:p>
+              <a:rPr sz="2800" b="1">
+                <a:solidFill>
+                  <a:srgbClr val="0F0F0F"/>
+                </a:solidFill>
+                <a:latin typeface="Fira Sans"/>
+              </a:rPr>
+              <a:t>Descriptiva e inferencia</a:t>
+            </a:r>
+          </a:p>
+        </p:txBody>
+      </p:sp>
+      <p:sp>
+        <p:nvSpPr>
+          <p:cNvPr id="4" name="TextBox 3"/>
+          <p:cNvSpPr txBox="1"/>
+          <p:nvPr/>
+        </p:nvSpPr>
+        <p:spPr>
+          <a:xfrm>
+            <a:off x="704088" y="1353312"/>
+            <a:ext cx="7744968" cy="3300984"/>
+          </a:xfrm>
+          <a:prstGeom prst="rect">
+            <a:avLst/>
+          </a:prstGeom>
+          <a:noFill/>
+        </p:spPr>
+        <p:txBody>
+          <a:bodyPr wrap="square">
+            <a:spAutoFit/>
+          </a:bodyPr>
+          <a:lstStyle/>
+          <a:p>
+            <a:pPr>
+              <a:lnSpc>
+                <a:spcPct val="112000"/>
+              </a:lnSpc>
+              <a:spcAft>
+                <a:spcPts val="900"/>
+              </a:spcAft>
+            </a:pPr>
+            <a:r>
+              <a:rPr sz="1800" b="1">
+                <a:solidFill>
+                  <a:srgbClr val="E0A437"/>
+                </a:solidFill>
+                <a:latin typeface="Fira Sans"/>
+              </a:rPr>
+              <a:t>▸ </a:t>
+            </a:r>
+            <a:r>
+              <a:rPr sz="1800" b="1">
+                <a:solidFill>
+                  <a:srgbClr val="1D3557"/>
+                </a:solidFill>
+                <a:latin typeface="Fira Sans"/>
+              </a:rPr>
+              <a:t>Estadística descriptiva, clases 2 a 4: resume y grafica la tabla que tenemos. Sus números hablan solo de esas filas, no de los viajes que nadie encuestó.</a:t>
+            </a:r>
+          </a:p>
+          <a:p>
+            <a:pPr>
+              <a:lnSpc>
+                <a:spcPct val="112000"/>
+              </a:lnSpc>
+              <a:spcAft>
+                <a:spcPts val="900"/>
+              </a:spcAft>
+            </a:pPr>
+            <a:r>
+              <a:rPr sz="1800" b="1">
+                <a:solidFill>
+                  <a:srgbClr val="E0A437"/>
+                </a:solidFill>
+                <a:latin typeface="Fira Sans"/>
+              </a:rPr>
+              <a:t>▸ </a:t>
+            </a:r>
+            <a:r>
+              <a:rPr sz="1800" b="1">
+                <a:solidFill>
+                  <a:srgbClr val="1D3557"/>
+                </a:solidFill>
+                <a:latin typeface="Fira Sans"/>
+              </a:rPr>
+              <a:t>Inferencia estadística: usa esos mismos datos para hablar de la población de la que salieron, y dice cuánta incertidumbre trae esa afirmación.</a:t>
+            </a:r>
+          </a:p>
+          <a:p>
+            <a:pPr>
+              <a:lnSpc>
+                <a:spcPct val="112000"/>
+              </a:lnSpc>
+              <a:spcAft>
+                <a:spcPts val="900"/>
+              </a:spcAft>
+            </a:pPr>
+            <a:r>
+              <a:rPr sz="1800" b="1">
+                <a:solidFill>
+                  <a:srgbClr val="E0A437"/>
+                </a:solidFill>
+                <a:latin typeface="Fira Sans"/>
+              </a:rPr>
+              <a:t>▸ </a:t>
+            </a:r>
             <a:r>
               <a:rPr sz="1800" b="0">
                 <a:solidFill>
+                  <a:srgbClr val="000000"/>
+                </a:solidFill>
+                <a:latin typeface="Fira Sans"/>
+              </a:rPr>
+              <a:t>Sus dos preguntas: ¿cuánto vale? (estimación, con un intervalo) y ¿es real o azar? (prueba de hipótesis, con un valor p).</a:t>
+            </a:r>
+          </a:p>
+          <a:p>
+            <a:pPr>
+              <a:lnSpc>
+                <a:spcPct val="112000"/>
+              </a:lnSpc>
+              <a:spcAft>
+                <a:spcPts val="900"/>
+              </a:spcAft>
+            </a:pPr>
+            <a:r>
+              <a:rPr sz="1800" b="1">
+                <a:solidFill>
                   <a:srgbClr val="E0A437"/>
                 </a:solidFill>
                 <a:latin typeface="Fira Sans"/>
               </a:rPr>
-              <a:t>Variables aleatorias y distribuciones</a:t>
+              <a:t>▸ </a:t>
+            </a:r>
+            <a:r>
+              <a:rPr sz="1800" b="0">
+                <a:solidFill>
+                  <a:srgbClr val="000000"/>
+                </a:solidFill>
+                <a:latin typeface="Fira Sans"/>
+              </a:rPr>
+              <a:t>La probabilidad es el lenguaje de esa incertidumbre; por eso va primero.</a:t>
             </a:r>
           </a:p>
         </p:txBody>
@@ -9430,14 +9864,14 @@
                 </a:solidFill>
                 <a:latin typeface="Fira Sans"/>
               </a:rPr>
-              <a:t>Una variable aleatoria y su distribución</a:t>
+              <a:t>Por qué aparece la normal</a:t>
             </a:r>
           </a:p>
         </p:txBody>
       </p:sp>
       <p:pic>
         <p:nvPicPr>
-          <p:cNvPr id="4" name="Picture 3" descr="c5_01_distribucion_duracion.png"/>
+          <p:cNvPr id="4" name="Picture 3" descr="c5_19_camino.png"/>
           <p:cNvPicPr>
             <a:picLocks noChangeAspect="1"/>
           </p:cNvPicPr>
@@ -9451,8 +9885,8 @@
         </p:blipFill>
         <p:spPr>
           <a:xfrm>
-            <a:off x="1198678" y="1143000"/>
-            <a:ext cx="6746642" cy="3154680"/>
+            <a:off x="699515" y="1556104"/>
+            <a:ext cx="7744968" cy="2328471"/>
           </a:xfrm>
           <a:prstGeom prst="rect">
             <a:avLst/>
@@ -9488,7 +9922,7 @@
                 </a:solidFill>
                 <a:latin typeface="Fira Sans"/>
               </a:rPr>
-              <a:t>La duración del próximo viaje depende del azar: es una variable aleatoria. Su distribución dice qué valores toma y con qué frecuencia: en la población, el histograma. La esperanza es su media.</a:t>
+              <a:t>No porque los datos sean normales (la duración no lo es), sino porque los promedios lo son: al repetir la muestra, la media y la pendiente se reparten como una campana alrededor del valor real. De esa campana sale el 1,96 que construye el intervalo y el valor p.</a:t>
             </a:r>
           </a:p>
         </p:txBody>
@@ -9526,7 +9960,7 @@
             <a:avLst/>
           </a:prstGeom>
           <a:solidFill>
-            <a:srgbClr val="FAFBFC"/>
+            <a:srgbClr val="1D3557"/>
           </a:solidFill>
           <a:ln>
             <a:noFill/>
@@ -9563,8 +9997,8 @@
         </p:nvSpPr>
         <p:spPr>
           <a:xfrm>
-            <a:off x="402336" y="301752"/>
-            <a:ext cx="8348472" cy="795528"/>
+            <a:off x="603504" y="1847088"/>
+            <a:ext cx="7946136" cy="1399032"/>
           </a:xfrm>
           <a:prstGeom prst="rect">
             <a:avLst/>
@@ -9578,71 +10012,24 @@
           <a:lstStyle/>
           <a:p>
             <a:r>
-              <a:rPr sz="2800" b="1">
-                <a:solidFill>
-                  <a:srgbClr val="0F0F0F"/>
-                </a:solidFill>
-                <a:latin typeface="Fira Sans"/>
-              </a:rPr>
-              <a:t>La distribución normal</a:t>
-            </a:r>
-          </a:p>
-        </p:txBody>
-      </p:sp>
-      <p:pic>
-        <p:nvPicPr>
-          <p:cNvPr id="4" name="Picture 3" descr="c5_03_normal_regla.png"/>
-          <p:cNvPicPr>
-            <a:picLocks noChangeAspect="1"/>
-          </p:cNvPicPr>
-          <p:nvPr/>
-        </p:nvPicPr>
-        <p:blipFill>
-          <a:blip r:embed="rId2"/>
-          <a:stretch>
-            <a:fillRect/>
-          </a:stretch>
-        </p:blipFill>
-        <p:spPr>
-          <a:xfrm>
-            <a:off x="699515" y="1438850"/>
-            <a:ext cx="7744968" cy="2562978"/>
-          </a:xfrm>
-          <a:prstGeom prst="rect">
-            <a:avLst/>
-          </a:prstGeom>
-        </p:spPr>
-      </p:pic>
-      <p:sp>
-        <p:nvSpPr>
-          <p:cNvPr id="5" name="TextBox 4"/>
-          <p:cNvSpPr txBox="1"/>
-          <p:nvPr/>
-        </p:nvSpPr>
-        <p:spPr>
-          <a:xfrm>
-            <a:off x="704088" y="4434840"/>
-            <a:ext cx="7744968" cy="457200"/>
-          </a:xfrm>
-          <a:prstGeom prst="rect">
-            <a:avLst/>
-          </a:prstGeom>
-          <a:noFill/>
-        </p:spPr>
-        <p:txBody>
-          <a:bodyPr wrap="square">
-            <a:spAutoFit/>
-          </a:bodyPr>
-          <a:lstStyle/>
-          <a:p>
-            <a:r>
-              <a:rPr sz="1300" b="0">
-                <a:solidFill>
-                  <a:srgbClr val="333333"/>
-                </a:solidFill>
-                <a:latin typeface="Fira Sans"/>
-              </a:rPr>
-              <a:t>La campana tiene dos parámetros: μ, la media, y σ, la desviación estándar. El 95% de los valores cae a menos de 1,96 σ de la media; ese 1,96 vuelve en los intervalos de confianza.</a:t>
+              <a:rPr sz="3400" b="1">
+                <a:solidFill>
+                  <a:srgbClr val="FFFFFF"/>
+                </a:solidFill>
+                <a:latin typeface="Fira Sans"/>
+              </a:rPr>
+              <a:t>Probabilidad</a:t>
+            </a:r>
+          </a:p>
+          <a:p>
+            <a:r>
+              <a:rPr sz="1800" b="0">
+                <a:solidFill>
+                  <a:srgbClr val="E0A437"/>
+                </a:solidFill>
+                <a:latin typeface="Fira Sans"/>
+              </a:rPr>
+              <a:t>El lenguaje de la incertidumbre: variables aleatorias y distribuciones</a:t>
             </a:r>
           </a:p>
         </p:txBody>
@@ -9738,14 +10125,14 @@
                 </a:solidFill>
                 <a:latin typeface="Fira Sans"/>
               </a:rPr>
-              <a:t>¿Es normal la duración? En minutos no; en log, casi</a:t>
+              <a:t>Una variable aleatoria y su distribución</a:t>
             </a:r>
           </a:p>
         </p:txBody>
       </p:sp>
       <p:pic>
         <p:nvPicPr>
-          <p:cNvPr id="4" name="Picture 3" descr="c5_02_normal_log.png"/>
+          <p:cNvPr id="4" name="Picture 3" descr="c5_01_distribucion_duracion.png"/>
           <p:cNvPicPr>
             <a:picLocks noChangeAspect="1"/>
           </p:cNvPicPr>
@@ -9759,8 +10146,8 @@
         </p:blipFill>
         <p:spPr>
           <a:xfrm>
-            <a:off x="699515" y="1443171"/>
-            <a:ext cx="7744968" cy="2554337"/>
+            <a:off x="1198678" y="1143000"/>
+            <a:ext cx="6746642" cy="3154680"/>
           </a:xfrm>
           <a:prstGeom prst="rect">
             <a:avLst/>
@@ -9796,7 +10183,7 @@
                 </a:solidFill>
                 <a:latin typeface="Fira Sans"/>
               </a:rPr>
-              <a:t>La cola larga (asimetría 5,3) se aleja de la normal; en log la variable se acomoda a la campana. Es la razón de fondo del log de la clase 4.</a:t>
+              <a:t>La duración del próximo viaje depende del azar: es una variable aleatoria. Su distribución dice qué valores toma y con qué frecuencia: en la población, el histograma. La esperanza es su media.</a:t>
             </a:r>
           </a:p>
         </p:txBody>
@@ -9892,14 +10279,14 @@
                 </a:solidFill>
                 <a:latin typeface="Fira Sans"/>
               </a:rPr>
-              <a:t>Una distribución para contar: la binomial</a:t>
+              <a:t>La distribución normal</a:t>
             </a:r>
           </a:p>
         </p:txBody>
       </p:sp>
       <p:pic>
         <p:nvPicPr>
-          <p:cNvPr id="4" name="Picture 3" descr="c5_04_binomial.png"/>
+          <p:cNvPr id="4" name="Picture 3" descr="c5_03_normal_regla.png"/>
           <p:cNvPicPr>
             <a:picLocks noChangeAspect="1"/>
           </p:cNvPicPr>
@@ -9913,8 +10300,8 @@
         </p:blipFill>
         <p:spPr>
           <a:xfrm>
-            <a:off x="964643" y="1143000"/>
-            <a:ext cx="7214713" cy="3154680"/>
+            <a:off x="699515" y="1438850"/>
+            <a:ext cx="7744968" cy="2562978"/>
           </a:xfrm>
           <a:prstGeom prst="rect">
             <a:avLst/>
@@ -9950,7 +10337,7 @@
                 </a:solidFill>
                 <a:latin typeface="Fira Sans"/>
               </a:rPr>
-              <a:t>El número de éxitos en n intentos independientes con probabilidad p: cuántos viajes en auto entre 20 tomados al azar. Otra distribución con nombre y fórmula.</a:t>
+              <a:t>La campana tiene dos parámetros: μ, la media, y σ, la desviación estándar. El 95% de los valores cae a menos de 1,96 σ de la media. Es la distribución de la inferencia porque los promedios la siguen; ese 1,96 vuelve en los intervalos de confianza.</a:t>
             </a:r>
           </a:p>
         </p:txBody>

</xml_diff>

<commit_message>
Clase 5: fórmula de la binomial con leyenda y ejemplo k = 5 en slide y notebook
Co-Authored-By: Claude Fable 5.1 <noreply@anthropic.com>
</commit_message>
<xml_diff>
--- a/presentaciones/clase05_probabilidad_inferencia.pptx
+++ b/presentaciones/clase05_probabilidad_inferencia.pptx
@@ -3639,8 +3639,8 @@
         </p:blipFill>
         <p:spPr>
           <a:xfrm>
-            <a:off x="964643" y="1143000"/>
-            <a:ext cx="7214713" cy="3154680"/>
+            <a:off x="928091" y="1143000"/>
+            <a:ext cx="7287816" cy="3154680"/>
           </a:xfrm>
           <a:prstGeom prst="rect">
             <a:avLst/>
@@ -3676,7 +3676,7 @@
                 </a:solidFill>
                 <a:latin typeface="Fira Sans"/>
               </a:rPr>
-              <a:t>El número de éxitos en n intentos independientes con probabilidad p: cuántos viajes en auto entre 20 tomados al azar. Otra distribución con nombre y fórmula.</a:t>
+              <a:t>El número de éxitos en n intentos independientes con probabilidad p. Cada barra sale de la fórmula: las formas de elegir k viajes entre 20, por p elevado a k, por (1 − p) elevado a 20 − k. En Python, stats.binom.pmf(k, 20, p).</a:t>
             </a:r>
           </a:p>
         </p:txBody>

</xml_diff>

<commit_message>
Clase 5: los tres supuestos de la inferencia con diagramas de datos reales (independencia ida/vuelta, varianza por tramo, normalidad y TCL) en slides y notebook
Co-Authored-By: Claude Fable 5.1 <noreply@anthropic.com>
</commit_message>
<xml_diff>
--- a/presentaciones/clase05_probabilidad_inferencia.pptx
+++ b/presentaciones/clase05_probabilidad_inferencia.pptx
@@ -47,6 +47,8 @@
     <p:sldId id="295" r:id="rId46"/>
     <p:sldId id="296" r:id="rId47"/>
     <p:sldId id="297" r:id="rId48"/>
+    <p:sldId id="298" r:id="rId49"/>
+    <p:sldId id="299" r:id="rId50"/>
   </p:sldIdLst>
   <p:sldSz cx="9144000" cy="5138928" type="screen4x3"/>
   <p:notesSz cx="6858000" cy="9144000"/>
@@ -6394,21 +6396,45 @@
                 </a:solidFill>
                 <a:latin typeface="Fira Sans"/>
               </a:rPr>
-              <a:t>Qué supone la regresión para inferir</a:t>
-            </a:r>
-          </a:p>
-        </p:txBody>
-      </p:sp>
-      <p:sp>
-        <p:nvSpPr>
-          <p:cNvPr id="4" name="TextBox 3"/>
+              <a:t>Supuesto 1: residuos independientes</a:t>
+            </a:r>
+          </a:p>
+        </p:txBody>
+      </p:sp>
+      <p:pic>
+        <p:nvPicPr>
+          <p:cNvPr id="4" name="Picture 3" descr="c5_20_independencia.png"/>
+          <p:cNvPicPr>
+            <a:picLocks noChangeAspect="1"/>
+          </p:cNvPicPr>
+          <p:nvPr/>
+        </p:nvPicPr>
+        <p:blipFill>
+          <a:blip r:embed="rId2"/>
+          <a:stretch>
+            <a:fillRect/>
+          </a:stretch>
+        </p:blipFill>
+        <p:spPr>
+          <a:xfrm>
+            <a:off x="699515" y="1327660"/>
+            <a:ext cx="7744968" cy="2785358"/>
+          </a:xfrm>
+          <a:prstGeom prst="rect">
+            <a:avLst/>
+          </a:prstGeom>
+        </p:spPr>
+      </p:pic>
+      <p:sp>
+        <p:nvSpPr>
+          <p:cNvPr id="5" name="TextBox 4"/>
           <p:cNvSpPr txBox="1"/>
           <p:nvPr/>
         </p:nvSpPr>
         <p:spPr>
           <a:xfrm>
-            <a:off x="704088" y="1353312"/>
-            <a:ext cx="7744968" cy="3300984"/>
+            <a:off x="704088" y="4434840"/>
+            <a:ext cx="7744968" cy="457200"/>
           </a:xfrm>
           <a:prstGeom prst="rect">
             <a:avLst/>
@@ -6421,115 +6447,14 @@
           </a:bodyPr>
           <a:lstStyle/>
           <a:p>
-            <a:pPr>
-              <a:lnSpc>
-                <a:spcPct val="112000"/>
-              </a:lnSpc>
-              <a:spcAft>
-                <a:spcPts val="900"/>
-              </a:spcAft>
-            </a:pPr>
-            <a:r>
-              <a:rPr sz="1800" b="1">
-                <a:solidFill>
-                  <a:srgbClr val="E0A437"/>
-                </a:solidFill>
-                <a:latin typeface="Fira Sans"/>
-              </a:rPr>
-              <a:t>▸ </a:t>
-            </a:r>
-            <a:r>
-              <a:rPr sz="1800" b="1">
-                <a:solidFill>
-                  <a:srgbClr val="1D3557"/>
-                </a:solidFill>
-                <a:latin typeface="Fira Sans"/>
-              </a:rPr>
-              <a:t>No que las variables sean normales. Los t y p del summary suponen residuos independientes, con la misma varianza y, con n chico, normales.</a:t>
-            </a:r>
-          </a:p>
-          <a:p>
-            <a:pPr>
-              <a:lnSpc>
-                <a:spcPct val="112000"/>
-              </a:lnSpc>
-              <a:spcAft>
-                <a:spcPts val="900"/>
-              </a:spcAft>
-            </a:pPr>
-            <a:r>
-              <a:rPr sz="1800" b="1">
-                <a:solidFill>
-                  <a:srgbClr val="E0A437"/>
-                </a:solidFill>
-                <a:latin typeface="Fira Sans"/>
-              </a:rPr>
-              <a:t>▸ </a:t>
-            </a:r>
-            <a:r>
-              <a:rPr sz="1800" b="0">
-                <a:solidFill>
-                  <a:srgbClr val="000000"/>
-                </a:solidFill>
-                <a:latin typeface="Fira Sans"/>
-              </a:rPr>
-              <a:t>Con n grande el TCL hace el trabajo: un coeficiente es un promedio ponderado de los y, y los promedios se vuelven normales.</a:t>
-            </a:r>
-          </a:p>
-          <a:p>
-            <a:pPr>
-              <a:lnSpc>
-                <a:spcPct val="112000"/>
-              </a:lnSpc>
-              <a:spcAft>
-                <a:spcPts val="900"/>
-              </a:spcAft>
-            </a:pPr>
-            <a:r>
-              <a:rPr sz="1800" b="1">
-                <a:solidFill>
-                  <a:srgbClr val="E0A437"/>
-                </a:solidFill>
-                <a:latin typeface="Fira Sans"/>
-              </a:rPr>
-              <a:t>▸ </a:t>
-            </a:r>
-            <a:r>
-              <a:rPr sz="1800" b="0">
-                <a:solidFill>
-                  <a:srgbClr val="000000"/>
-                </a:solidFill>
-                <a:latin typeface="Fira Sans"/>
-              </a:rPr>
-              <a:t>Lo que sí daña la inferencia: colas largas y atípicos, que inflan el error estándar. El log de la clase 4 también ayuda aquí.</a:t>
-            </a:r>
-          </a:p>
-          <a:p>
-            <a:pPr>
-              <a:lnSpc>
-                <a:spcPct val="112000"/>
-              </a:lnSpc>
-              <a:spcAft>
-                <a:spcPts val="900"/>
-              </a:spcAft>
-            </a:pPr>
-            <a:r>
-              <a:rPr sz="1800" b="1">
-                <a:solidFill>
-                  <a:srgbClr val="E0A437"/>
-                </a:solidFill>
-                <a:latin typeface="Fira Sans"/>
-              </a:rPr>
-              <a:t>▸ </a:t>
-            </a:r>
-            <a:r>
-              <a:rPr sz="1800" b="0">
-                <a:solidFill>
-                  <a:srgbClr val="000000"/>
-                </a:solidFill>
-                <a:latin typeface="Fira Sans"/>
-              </a:rPr>
-              <a:t>Con 45 comunas los supuestos pesan; con 113 mil viajes, casi nada.</a:t>
+            <a:r>
+              <a:rPr sz="1300" b="0">
+                <a:solidFill>
+                  <a:srgbClr val="333333"/>
+                </a:solidFill>
+                <a:latin typeface="Fira Sans"/>
+              </a:rPr>
+              <a:t>El residuo de un viaje no debería decir nada del residuo de otro. En la EOD la vuelta se parece a la ida: statsmodels cuenta 102 mil viajes independientes cuando hay menos información, y el error estándar queda demasiado chico.</a:t>
             </a:r>
           </a:p>
         </p:txBody>
@@ -6567,7 +6492,7 @@
             <a:avLst/>
           </a:prstGeom>
           <a:solidFill>
-            <a:srgbClr val="1D3557"/>
+            <a:srgbClr val="FAFBFC"/>
           </a:solidFill>
           <a:ln>
             <a:noFill/>
@@ -6604,8 +6529,8 @@
         </p:nvSpPr>
         <p:spPr>
           <a:xfrm>
-            <a:off x="603504" y="1847088"/>
-            <a:ext cx="7946136" cy="1399032"/>
+            <a:off x="402336" y="301752"/>
+            <a:ext cx="8348472" cy="795528"/>
           </a:xfrm>
           <a:prstGeom prst="rect">
             <a:avLst/>
@@ -6619,24 +6544,71 @@
           <a:lstStyle/>
           <a:p>
             <a:r>
-              <a:rPr sz="3400" b="1">
-                <a:solidFill>
-                  <a:srgbClr val="FFFFFF"/>
-                </a:solidFill>
-                <a:latin typeface="Fira Sans"/>
-              </a:rPr>
-              <a:t>Bootstrap</a:t>
-            </a:r>
-          </a:p>
-          <a:p>
-            <a:r>
-              <a:rPr sz="1800" b="0">
-                <a:solidFill>
-                  <a:srgbClr val="E0A437"/>
-                </a:solidFill>
-                <a:latin typeface="Fira Sans"/>
-              </a:rPr>
-              <a:t>La misma respuesta, sin fórmulas</a:t>
+              <a:rPr sz="2800" b="1">
+                <a:solidFill>
+                  <a:srgbClr val="0F0F0F"/>
+                </a:solidFill>
+                <a:latin typeface="Fira Sans"/>
+              </a:rPr>
+              <a:t>Supuesto 2: la misma varianza en todo el rango</a:t>
+            </a:r>
+          </a:p>
+        </p:txBody>
+      </p:sp>
+      <p:pic>
+        <p:nvPicPr>
+          <p:cNvPr id="4" name="Picture 3" descr="c5_21_varianza.png"/>
+          <p:cNvPicPr>
+            <a:picLocks noChangeAspect="1"/>
+          </p:cNvPicPr>
+          <p:nvPr/>
+        </p:nvPicPr>
+        <p:blipFill>
+          <a:blip r:embed="rId2"/>
+          <a:stretch>
+            <a:fillRect/>
+          </a:stretch>
+        </p:blipFill>
+        <p:spPr>
+          <a:xfrm>
+            <a:off x="699515" y="1453098"/>
+            <a:ext cx="7744968" cy="2534483"/>
+          </a:xfrm>
+          <a:prstGeom prst="rect">
+            <a:avLst/>
+          </a:prstGeom>
+        </p:spPr>
+      </p:pic>
+      <p:sp>
+        <p:nvSpPr>
+          <p:cNvPr id="5" name="TextBox 4"/>
+          <p:cNvSpPr txBox="1"/>
+          <p:nvPr/>
+        </p:nvSpPr>
+        <p:spPr>
+          <a:xfrm>
+            <a:off x="704088" y="4434840"/>
+            <a:ext cx="7744968" cy="457200"/>
+          </a:xfrm>
+          <a:prstGeom prst="rect">
+            <a:avLst/>
+          </a:prstGeom>
+          <a:noFill/>
+        </p:spPr>
+        <p:txBody>
+          <a:bodyPr wrap="square">
+            <a:spAutoFit/>
+          </a:bodyPr>
+          <a:lstStyle/>
+          <a:p>
+            <a:r>
+              <a:rPr sz="1300" b="0">
+                <a:solidFill>
+                  <a:srgbClr val="333333"/>
+                </a:solidFill>
+                <a:latin typeface="Fira Sans"/>
+              </a:rPr>
+              <a:t>Si la dispersión de los residuos crece con x, el error estándar queda mal calculado. Otra razón del log de la clase 4.</a:t>
             </a:r>
           </a:p>
         </p:txBody>
@@ -6732,114 +6704,35 @@
                 </a:solidFill>
                 <a:latin typeface="Fira Sans"/>
               </a:rPr>
-              <a:t>Remuestrear los datos</a:t>
-            </a:r>
-          </a:p>
-        </p:txBody>
-      </p:sp>
-      <p:sp>
-        <p:nvSpPr>
-          <p:cNvPr id="4" name="Rectangle 3"/>
-          <p:cNvSpPr/>
-          <p:nvPr/>
-        </p:nvSpPr>
-        <p:spPr>
-          <a:xfrm>
-            <a:off x="704088" y="1280160"/>
-            <a:ext cx="7744968" cy="2880360"/>
-          </a:xfrm>
-          <a:prstGeom prst="rect">
-            <a:avLst/>
-          </a:prstGeom>
-          <a:solidFill>
-            <a:srgbClr val="F0F2F5"/>
-          </a:solidFill>
-          <a:ln>
-            <a:solidFill>
-              <a:srgbClr val="D8DDE3"/>
-            </a:solidFill>
-          </a:ln>
-          <a:effectLst/>
-        </p:spPr>
-        <p:style>
-          <a:lnRef idx="1">
-            <a:schemeClr val="accent1"/>
-          </a:lnRef>
-          <a:fillRef idx="3">
-            <a:schemeClr val="accent1"/>
-          </a:fillRef>
-          <a:effectRef idx="2">
-            <a:schemeClr val="accent1"/>
-          </a:effectRef>
-          <a:fontRef idx="minor">
-            <a:schemeClr val="lt1"/>
-          </a:fontRef>
-        </p:style>
-        <p:txBody>
-          <a:bodyPr rtlCol="0" anchor="ctr" wrap="square" lIns="228600" tIns="137160"/>
-          <a:lstStyle/>
-          <a:p>
-            <a:pPr/>
-            <a:r>
-              <a:rPr sz="1500" b="0">
-                <a:solidFill>
-                  <a:srgbClr val="1D3557"/>
-                </a:solidFill>
-                <a:latin typeface="Menlo"/>
-              </a:rPr>
-              <a:t>pendientes = []</a:t>
-            </a:r>
-          </a:p>
-          <a:p>
-            <a:pPr/>
-            <a:r>
-              <a:rPr sz="1500" b="0">
-                <a:solidFill>
-                  <a:srgbClr val="1D3557"/>
-                </a:solidFill>
-                <a:latin typeface="Menlo"/>
-              </a:rPr>
-              <a:t>for _ in range(2000):</a:t>
-            </a:r>
-          </a:p>
-          <a:p>
-            <a:pPr/>
-            <a:r>
-              <a:rPr sz="1500" b="0">
-                <a:solidFill>
-                  <a:srgbClr val="1D3557"/>
-                </a:solidFill>
-                <a:latin typeface="Menlo"/>
-              </a:rPr>
-              <a:t>    idx = rng.integers(0, 45, 45)     # 45 comunas, con reemplazo</a:t>
-            </a:r>
-          </a:p>
-          <a:p>
-            <a:pPr/>
-            <a:r>
-              <a:rPr sz="1500" b="0">
-                <a:solidFill>
-                  <a:srgbClr val="1D3557"/>
-                </a:solidFill>
-                <a:latin typeface="Menlo"/>
-              </a:rPr>
-              <a:t>    pendientes.append(np.polyfit(x[idx], y[idx], 1)[0])</a:t>
-            </a:r>
-          </a:p>
-          <a:p>
-            <a:pPr/>
-            <a:r>
-              <a:rPr sz="1500" b="0">
-                <a:solidFill>
-                  <a:srgbClr val="1D3557"/>
-                </a:solidFill>
-                <a:latin typeface="Menlo"/>
-              </a:rPr>
-              <a:t>np.percentile(pendientes, [2.5, 97.5])</a:t>
-            </a:r>
-          </a:p>
-        </p:txBody>
-      </p:sp>
+              <a:t>Supuesto 3: la normalidad</a:t>
+            </a:r>
+          </a:p>
+        </p:txBody>
+      </p:sp>
+      <p:pic>
+        <p:nvPicPr>
+          <p:cNvPr id="4" name="Picture 3" descr="c5_22_normalidad.png"/>
+          <p:cNvPicPr>
+            <a:picLocks noChangeAspect="1"/>
+          </p:cNvPicPr>
+          <p:nvPr/>
+        </p:nvPicPr>
+        <p:blipFill>
+          <a:blip r:embed="rId2"/>
+          <a:stretch>
+            <a:fillRect/>
+          </a:stretch>
+        </p:blipFill>
+        <p:spPr>
+          <a:xfrm>
+            <a:off x="699515" y="1443910"/>
+            <a:ext cx="7744968" cy="2552859"/>
+          </a:xfrm>
+          <a:prstGeom prst="rect">
+            <a:avLst/>
+          </a:prstGeom>
+        </p:spPr>
+      </p:pic>
       <p:sp>
         <p:nvSpPr>
           <p:cNvPr id="5" name="TextBox 4"/>
@@ -6848,8 +6741,8 @@
         </p:nvSpPr>
         <p:spPr>
           <a:xfrm>
-            <a:off x="704088" y="4389120"/>
-            <a:ext cx="7744968" cy="1097280"/>
+            <a:off x="704088" y="4434840"/>
+            <a:ext cx="7744968" cy="457200"/>
           </a:xfrm>
           <a:prstGeom prst="rect">
             <a:avLst/>
@@ -6862,31 +6755,14 @@
           </a:bodyPr>
           <a:lstStyle/>
           <a:p>
-            <a:pPr>
-              <a:lnSpc>
-                <a:spcPct val="112000"/>
-              </a:lnSpc>
-              <a:spcAft>
-                <a:spcPts val="900"/>
-              </a:spcAft>
-            </a:pPr>
-            <a:r>
-              <a:rPr sz="1600" b="1">
-                <a:solidFill>
-                  <a:srgbClr val="E0A437"/>
-                </a:solidFill>
-                <a:latin typeface="Fira Sans"/>
-              </a:rPr>
-              <a:t>▸ </a:t>
-            </a:r>
-            <a:r>
-              <a:rPr sz="1600" b="0">
-                <a:solidFill>
-                  <a:srgbClr val="000000"/>
-                </a:solidFill>
-                <a:latin typeface="Fira Sans"/>
-              </a:rPr>
-              <a:t>Sacar 45 comunas con reemplazo imita el azar del muestreo: algunas se repiten, otras quedan fuera. La distribución de las 2.000 pendientes dice cuánto se mueve la nuestra.</a:t>
+            <a:r>
+              <a:rPr sz="1300" b="0">
+                <a:solidFill>
+                  <a:srgbClr val="333333"/>
+                </a:solidFill>
+                <a:latin typeface="Fira Sans"/>
+              </a:rPr>
+              <a:t>No se supone que las variables sean normales. Con n chico, como las 45 comunas, se supone que los residuos lo son; con n grande el TCL hace el trabajo, porque un coeficiente es un promedio ponderado de los y. Lo que daña son las colas largas y los atípicos.</a:t>
             </a:r>
           </a:p>
         </p:txBody>
@@ -7211,7 +7087,7 @@
             <a:avLst/>
           </a:prstGeom>
           <a:solidFill>
-            <a:srgbClr val="FAFBFC"/>
+            <a:srgbClr val="1D3557"/>
           </a:solidFill>
           <a:ln>
             <a:noFill/>
@@ -7248,8 +7124,8 @@
         </p:nvSpPr>
         <p:spPr>
           <a:xfrm>
-            <a:off x="402336" y="301752"/>
-            <a:ext cx="8348472" cy="795528"/>
+            <a:off x="603504" y="1847088"/>
+            <a:ext cx="7946136" cy="1399032"/>
           </a:xfrm>
           <a:prstGeom prst="rect">
             <a:avLst/>
@@ -7263,71 +7139,24 @@
           <a:lstStyle/>
           <a:p>
             <a:r>
-              <a:rPr sz="2800" b="1">
-                <a:solidFill>
-                  <a:srgbClr val="0F0F0F"/>
-                </a:solidFill>
-                <a:latin typeface="Fira Sans"/>
-              </a:rPr>
-              <a:t>La pendiente, remuestreada</a:t>
-            </a:r>
-          </a:p>
-        </p:txBody>
-      </p:sp>
-      <p:pic>
-        <p:nvPicPr>
-          <p:cNvPr id="4" name="Picture 3" descr="c5_13_bootstrap.png"/>
-          <p:cNvPicPr>
-            <a:picLocks noChangeAspect="1"/>
-          </p:cNvPicPr>
-          <p:nvPr/>
-        </p:nvPicPr>
-        <p:blipFill>
-          <a:blip r:embed="rId2"/>
-          <a:stretch>
-            <a:fillRect/>
-          </a:stretch>
-        </p:blipFill>
-        <p:spPr>
-          <a:xfrm>
-            <a:off x="1022984" y="1143000"/>
-            <a:ext cx="7098030" cy="3154680"/>
-          </a:xfrm>
-          <a:prstGeom prst="rect">
-            <a:avLst/>
-          </a:prstGeom>
-        </p:spPr>
-      </p:pic>
-      <p:sp>
-        <p:nvSpPr>
-          <p:cNvPr id="5" name="TextBox 4"/>
-          <p:cNvSpPr txBox="1"/>
-          <p:nvPr/>
-        </p:nvSpPr>
-        <p:spPr>
-          <a:xfrm>
-            <a:off x="704088" y="4434840"/>
-            <a:ext cx="7744968" cy="457200"/>
-          </a:xfrm>
-          <a:prstGeom prst="rect">
-            <a:avLst/>
-          </a:prstGeom>
-          <a:noFill/>
-        </p:spPr>
-        <p:txBody>
-          <a:bodyPr wrap="square">
-            <a:spAutoFit/>
-          </a:bodyPr>
-          <a:lstStyle/>
-          <a:p>
-            <a:r>
-              <a:rPr sz="1300" b="0">
-                <a:solidFill>
-                  <a:srgbClr val="333333"/>
-                </a:solidFill>
-                <a:latin typeface="Fira Sans"/>
-              </a:rPr>
-              <a:t>El intervalo bootstrap se parece al de statsmodels y casi ninguna remuestra llega al 0: la misma conclusión por un camino que solo usa el computador. Sirve para cualquier estadístico.</a:t>
+              <a:rPr sz="3400" b="1">
+                <a:solidFill>
+                  <a:srgbClr val="FFFFFF"/>
+                </a:solidFill>
+                <a:latin typeface="Fira Sans"/>
+              </a:rPr>
+              <a:t>Bootstrap</a:t>
+            </a:r>
+          </a:p>
+          <a:p>
+            <a:r>
+              <a:rPr sz="1800" b="0">
+                <a:solidFill>
+                  <a:srgbClr val="E0A437"/>
+                </a:solidFill>
+                <a:latin typeface="Fira Sans"/>
+              </a:rPr>
+              <a:t>La misma respuesta, sin fórmulas</a:t>
             </a:r>
           </a:p>
         </p:txBody>
@@ -7365,7 +7194,7 @@
             <a:avLst/>
           </a:prstGeom>
           <a:solidFill>
-            <a:srgbClr val="1D3557"/>
+            <a:srgbClr val="FAFBFC"/>
           </a:solidFill>
           <a:ln>
             <a:noFill/>
@@ -7402,8 +7231,8 @@
         </p:nvSpPr>
         <p:spPr>
           <a:xfrm>
-            <a:off x="603504" y="1847088"/>
-            <a:ext cx="7946136" cy="1399032"/>
+            <a:off x="402336" y="301752"/>
+            <a:ext cx="8348472" cy="795528"/>
           </a:xfrm>
           <a:prstGeom prst="rect">
             <a:avLst/>
@@ -7417,24 +7246,167 @@
           <a:lstStyle/>
           <a:p>
             <a:r>
-              <a:rPr sz="3400" b="1">
-                <a:solidFill>
-                  <a:srgbClr val="FFFFFF"/>
-                </a:solidFill>
-                <a:latin typeface="Fira Sans"/>
-              </a:rPr>
-              <a:t>¿Qué hogares tienen auto?</a:t>
-            </a:r>
-          </a:p>
-          <a:p>
-            <a:r>
-              <a:rPr sz="1800" b="0">
+              <a:rPr sz="2800" b="1">
+                <a:solidFill>
+                  <a:srgbClr val="0F0F0F"/>
+                </a:solidFill>
+                <a:latin typeface="Fira Sans"/>
+              </a:rPr>
+              <a:t>Remuestrear los datos</a:t>
+            </a:r>
+          </a:p>
+        </p:txBody>
+      </p:sp>
+      <p:sp>
+        <p:nvSpPr>
+          <p:cNvPr id="4" name="Rectangle 3"/>
+          <p:cNvSpPr/>
+          <p:nvPr/>
+        </p:nvSpPr>
+        <p:spPr>
+          <a:xfrm>
+            <a:off x="704088" y="1280160"/>
+            <a:ext cx="7744968" cy="2880360"/>
+          </a:xfrm>
+          <a:prstGeom prst="rect">
+            <a:avLst/>
+          </a:prstGeom>
+          <a:solidFill>
+            <a:srgbClr val="F0F2F5"/>
+          </a:solidFill>
+          <a:ln>
+            <a:solidFill>
+              <a:srgbClr val="D8DDE3"/>
+            </a:solidFill>
+          </a:ln>
+          <a:effectLst/>
+        </p:spPr>
+        <p:style>
+          <a:lnRef idx="1">
+            <a:schemeClr val="accent1"/>
+          </a:lnRef>
+          <a:fillRef idx="3">
+            <a:schemeClr val="accent1"/>
+          </a:fillRef>
+          <a:effectRef idx="2">
+            <a:schemeClr val="accent1"/>
+          </a:effectRef>
+          <a:fontRef idx="minor">
+            <a:schemeClr val="lt1"/>
+          </a:fontRef>
+        </p:style>
+        <p:txBody>
+          <a:bodyPr rtlCol="0" anchor="ctr" wrap="square" lIns="228600" tIns="137160"/>
+          <a:lstStyle/>
+          <a:p>
+            <a:pPr/>
+            <a:r>
+              <a:rPr sz="1500" b="0">
+                <a:solidFill>
+                  <a:srgbClr val="1D3557"/>
+                </a:solidFill>
+                <a:latin typeface="Menlo"/>
+              </a:rPr>
+              <a:t>pendientes = []</a:t>
+            </a:r>
+          </a:p>
+          <a:p>
+            <a:pPr/>
+            <a:r>
+              <a:rPr sz="1500" b="0">
+                <a:solidFill>
+                  <a:srgbClr val="1D3557"/>
+                </a:solidFill>
+                <a:latin typeface="Menlo"/>
+              </a:rPr>
+              <a:t>for _ in range(2000):</a:t>
+            </a:r>
+          </a:p>
+          <a:p>
+            <a:pPr/>
+            <a:r>
+              <a:rPr sz="1500" b="0">
+                <a:solidFill>
+                  <a:srgbClr val="1D3557"/>
+                </a:solidFill>
+                <a:latin typeface="Menlo"/>
+              </a:rPr>
+              <a:t>    idx = rng.integers(0, 45, 45)     # 45 comunas, con reemplazo</a:t>
+            </a:r>
+          </a:p>
+          <a:p>
+            <a:pPr/>
+            <a:r>
+              <a:rPr sz="1500" b="0">
+                <a:solidFill>
+                  <a:srgbClr val="1D3557"/>
+                </a:solidFill>
+                <a:latin typeface="Menlo"/>
+              </a:rPr>
+              <a:t>    pendientes.append(np.polyfit(x[idx], y[idx], 1)[0])</a:t>
+            </a:r>
+          </a:p>
+          <a:p>
+            <a:pPr/>
+            <a:r>
+              <a:rPr sz="1500" b="0">
+                <a:solidFill>
+                  <a:srgbClr val="1D3557"/>
+                </a:solidFill>
+                <a:latin typeface="Menlo"/>
+              </a:rPr>
+              <a:t>np.percentile(pendientes, [2.5, 97.5])</a:t>
+            </a:r>
+          </a:p>
+        </p:txBody>
+      </p:sp>
+      <p:sp>
+        <p:nvSpPr>
+          <p:cNvPr id="5" name="TextBox 4"/>
+          <p:cNvSpPr txBox="1"/>
+          <p:nvPr/>
+        </p:nvSpPr>
+        <p:spPr>
+          <a:xfrm>
+            <a:off x="704088" y="4389120"/>
+            <a:ext cx="7744968" cy="1097280"/>
+          </a:xfrm>
+          <a:prstGeom prst="rect">
+            <a:avLst/>
+          </a:prstGeom>
+          <a:noFill/>
+        </p:spPr>
+        <p:txBody>
+          <a:bodyPr wrap="square">
+            <a:spAutoFit/>
+          </a:bodyPr>
+          <a:lstStyle/>
+          <a:p>
+            <a:pPr>
+              <a:lnSpc>
+                <a:spcPct val="112000"/>
+              </a:lnSpc>
+              <a:spcAft>
+                <a:spcPts val="900"/>
+              </a:spcAft>
+            </a:pPr>
+            <a:r>
+              <a:rPr sz="1600" b="1">
                 <a:solidFill>
                   <a:srgbClr val="E0A437"/>
                 </a:solidFill>
                 <a:latin typeface="Fira Sans"/>
               </a:rPr>
-              <a:t>Explicar un sí o no (tiene auto) con el ingreso del hogar: la regresión logística, y con ella, clasificar</a:t>
+              <a:t>▸ </a:t>
+            </a:r>
+            <a:r>
+              <a:rPr sz="1600" b="0">
+                <a:solidFill>
+                  <a:srgbClr val="000000"/>
+                </a:solidFill>
+                <a:latin typeface="Fira Sans"/>
+              </a:rPr>
+              <a:t>Sacar 45 comunas con reemplazo imita el azar del muestreo: algunas se repiten, otras quedan fuera. La distribución de las 2.000 pendientes dice cuánto se mueve la nuestra.</a:t>
             </a:r>
           </a:p>
         </p:txBody>
@@ -7530,14 +7502,14 @@
                 </a:solidFill>
                 <a:latin typeface="Fira Sans"/>
               </a:rPr>
-              <a:t>La recta no sirve para un sí o no</a:t>
+              <a:t>La pendiente, remuestreada</a:t>
             </a:r>
           </a:p>
         </p:txBody>
       </p:sp>
       <p:pic>
         <p:nvPicPr>
-          <p:cNvPr id="4" name="Picture 3" descr="c5_15_recta_vs_logistica.png"/>
+          <p:cNvPr id="4" name="Picture 3" descr="c5_13_bootstrap.png"/>
           <p:cNvPicPr>
             <a:picLocks noChangeAspect="1"/>
           </p:cNvPicPr>
@@ -7551,8 +7523,8 @@
         </p:blipFill>
         <p:spPr>
           <a:xfrm>
-            <a:off x="1208992" y="1143000"/>
-            <a:ext cx="6726015" cy="3154680"/>
+            <a:off x="1022984" y="1143000"/>
+            <a:ext cx="7098030" cy="3154680"/>
           </a:xfrm>
           <a:prstGeom prst="rect">
             <a:avLst/>
@@ -7588,7 +7560,7 @@
                 </a:solidFill>
                 <a:latin typeface="Fira Sans"/>
               </a:rPr>
-              <a:t>Sobre un 0/1, la recta predice 1,39 a los 5 millones y valores negativos abajo: no respeta que la respuesta vive entre 0 y 1. La logística pasa la recta por una S y queda siempre en el rango.</a:t>
+              <a:t>El intervalo bootstrap se parece al de statsmodels y casi ninguna remuestra llega al 0: la misma conclusión por un camino que solo usa el computador. Sirve para cualquier estadístico.</a:t>
             </a:r>
           </a:p>
         </p:txBody>
@@ -7626,7 +7598,7 @@
             <a:avLst/>
           </a:prstGeom>
           <a:solidFill>
-            <a:srgbClr val="FAFBFC"/>
+            <a:srgbClr val="1D3557"/>
           </a:solidFill>
           <a:ln>
             <a:noFill/>
@@ -7663,8 +7635,8 @@
         </p:nvSpPr>
         <p:spPr>
           <a:xfrm>
-            <a:off x="402336" y="301752"/>
-            <a:ext cx="8348472" cy="795528"/>
+            <a:off x="603504" y="1847088"/>
+            <a:ext cx="7946136" cy="1399032"/>
           </a:xfrm>
           <a:prstGeom prst="rect">
             <a:avLst/>
@@ -7678,71 +7650,24 @@
           <a:lstStyle/>
           <a:p>
             <a:r>
-              <a:rPr sz="2800" b="1">
-                <a:solidFill>
-                  <a:srgbClr val="0F0F0F"/>
-                </a:solidFill>
-                <a:latin typeface="Fira Sans"/>
-              </a:rPr>
-              <a:t>La regresión logística</a:t>
-            </a:r>
-          </a:p>
-        </p:txBody>
-      </p:sp>
-      <p:pic>
-        <p:nvPicPr>
-          <p:cNvPr id="4" name="Picture 3" descr="c5_16_formula_logistica.png"/>
-          <p:cNvPicPr>
-            <a:picLocks noChangeAspect="1"/>
-          </p:cNvPicPr>
-          <p:nvPr/>
-        </p:nvPicPr>
-        <p:blipFill>
-          <a:blip r:embed="rId2"/>
-          <a:stretch>
-            <a:fillRect/>
-          </a:stretch>
-        </p:blipFill>
-        <p:spPr>
-          <a:xfrm>
-            <a:off x="699515" y="1262245"/>
-            <a:ext cx="7744968" cy="2916190"/>
-          </a:xfrm>
-          <a:prstGeom prst="rect">
-            <a:avLst/>
-          </a:prstGeom>
-        </p:spPr>
-      </p:pic>
-      <p:sp>
-        <p:nvSpPr>
-          <p:cNvPr id="5" name="TextBox 4"/>
-          <p:cNvSpPr txBox="1"/>
-          <p:nvPr/>
-        </p:nvSpPr>
-        <p:spPr>
-          <a:xfrm>
-            <a:off x="704088" y="4434840"/>
-            <a:ext cx="7744968" cy="457200"/>
-          </a:xfrm>
-          <a:prstGeom prst="rect">
-            <a:avLst/>
-          </a:prstGeom>
-          <a:noFill/>
-        </p:spPr>
-        <p:txBody>
-          <a:bodyPr wrap="square">
-            <a:spAutoFit/>
-          </a:bodyPr>
-          <a:lstStyle/>
-          <a:p>
-            <a:r>
-              <a:rPr sz="1300" b="0">
-                <a:solidFill>
-                  <a:srgbClr val="333333"/>
-                </a:solidFill>
-                <a:latin typeface="Fira Sans"/>
-              </a:rPr>
-              <a:t>La misma recta a + b·x, pero dentro de la sigmoide. La respuesta es una Bernoulli (la binomial con n = 1) cuya probabilidad depende de x.</a:t>
+              <a:rPr sz="3400" b="1">
+                <a:solidFill>
+                  <a:srgbClr val="FFFFFF"/>
+                </a:solidFill>
+                <a:latin typeface="Fira Sans"/>
+              </a:rPr>
+              <a:t>¿Qué hogares tienen auto?</a:t>
+            </a:r>
+          </a:p>
+          <a:p>
+            <a:r>
+              <a:rPr sz="1800" b="0">
+                <a:solidFill>
+                  <a:srgbClr val="E0A437"/>
+                </a:solidFill>
+                <a:latin typeface="Fira Sans"/>
+              </a:rPr>
+              <a:t>Explicar un sí o no (tiene auto) con el ingreso del hogar: la regresión logística, y con ella, clasificar</a:t>
             </a:r>
           </a:p>
         </p:txBody>
@@ -7838,114 +7763,35 @@
                 </a:solidFill>
                 <a:latin typeface="Fira Sans"/>
               </a:rPr>
-              <a:t>La logística en statsmodels</a:t>
-            </a:r>
-          </a:p>
-        </p:txBody>
-      </p:sp>
-      <p:sp>
-        <p:nvSpPr>
-          <p:cNvPr id="4" name="Rectangle 3"/>
-          <p:cNvSpPr/>
-          <p:nvPr/>
-        </p:nvSpPr>
-        <p:spPr>
-          <a:xfrm>
-            <a:off x="704088" y="1280160"/>
-            <a:ext cx="7744968" cy="2880360"/>
-          </a:xfrm>
-          <a:prstGeom prst="rect">
-            <a:avLst/>
-          </a:prstGeom>
-          <a:solidFill>
-            <a:srgbClr val="F0F2F5"/>
-          </a:solidFill>
-          <a:ln>
-            <a:solidFill>
-              <a:srgbClr val="D8DDE3"/>
-            </a:solidFill>
-          </a:ln>
-          <a:effectLst/>
-        </p:spPr>
-        <p:style>
-          <a:lnRef idx="1">
-            <a:schemeClr val="accent1"/>
-          </a:lnRef>
-          <a:fillRef idx="3">
-            <a:schemeClr val="accent1"/>
-          </a:fillRef>
-          <a:effectRef idx="2">
-            <a:schemeClr val="accent1"/>
-          </a:effectRef>
-          <a:fontRef idx="minor">
-            <a:schemeClr val="lt1"/>
-          </a:fontRef>
-        </p:style>
-        <p:txBody>
-          <a:bodyPr rtlCol="0" anchor="ctr" wrap="square" lIns="228600" tIns="137160"/>
-          <a:lstStyle/>
-          <a:p>
-            <a:pPr/>
-            <a:r>
-              <a:rPr sz="1500" b="0">
-                <a:solidFill>
-                  <a:srgbClr val="1D3557"/>
-                </a:solidFill>
-                <a:latin typeface="Menlo"/>
-              </a:rPr>
-              <a:t>logistica = sm.GLM(h["tiene_auto"], sm.add_constant(ingreso),</a:t>
-            </a:r>
-          </a:p>
-          <a:p>
-            <a:pPr/>
-            <a:r>
-              <a:rPr sz="1500" b="0">
-                <a:solidFill>
-                  <a:srgbClr val="1D3557"/>
-                </a:solidFill>
-                <a:latin typeface="Menlo"/>
-              </a:rPr>
-              <a:t>                   family=sm.families.Binomial(),</a:t>
-            </a:r>
-          </a:p>
-          <a:p>
-            <a:pPr/>
-            <a:r>
-              <a:rPr sz="1500" b="0">
-                <a:solidFill>
-                  <a:srgbClr val="1D3557"/>
-                </a:solidFill>
-                <a:latin typeface="Menlo"/>
-              </a:rPr>
-              <a:t>                   freq_weights=h["Factor"]).fit()</a:t>
-            </a:r>
-          </a:p>
-          <a:p>
-            <a:pPr/>
-            <a:r>
-              <a:rPr sz="1500" b="0">
-                <a:solidFill>
-                  <a:srgbClr val="1D3557"/>
-                </a:solidFill>
-                <a:latin typeface="Menlo"/>
-              </a:rPr>
-              <a:t/>
-            </a:r>
-          </a:p>
-          <a:p>
-            <a:pPr/>
-            <a:r>
-              <a:rPr sz="1500" b="0">
-                <a:solidFill>
-                  <a:srgbClr val="1D3557"/>
-                </a:solidFill>
-                <a:latin typeface="Menlo"/>
-              </a:rPr>
-              <a:t>np.exp(logistica.params["IngresoHogar"])   # 8.9</a:t>
-            </a:r>
-          </a:p>
-        </p:txBody>
-      </p:sp>
+              <a:t>La recta no sirve para un sí o no</a:t>
+            </a:r>
+          </a:p>
+        </p:txBody>
+      </p:sp>
+      <p:pic>
+        <p:nvPicPr>
+          <p:cNvPr id="4" name="Picture 3" descr="c5_15_recta_vs_logistica.png"/>
+          <p:cNvPicPr>
+            <a:picLocks noChangeAspect="1"/>
+          </p:cNvPicPr>
+          <p:nvPr/>
+        </p:nvPicPr>
+        <p:blipFill>
+          <a:blip r:embed="rId2"/>
+          <a:stretch>
+            <a:fillRect/>
+          </a:stretch>
+        </p:blipFill>
+        <p:spPr>
+          <a:xfrm>
+            <a:off x="1208992" y="1143000"/>
+            <a:ext cx="6726015" cy="3154680"/>
+          </a:xfrm>
+          <a:prstGeom prst="rect">
+            <a:avLst/>
+          </a:prstGeom>
+        </p:spPr>
+      </p:pic>
       <p:sp>
         <p:nvSpPr>
           <p:cNvPr id="5" name="TextBox 4"/>
@@ -7954,8 +7800,8 @@
         </p:nvSpPr>
         <p:spPr>
           <a:xfrm>
-            <a:off x="704088" y="4389120"/>
-            <a:ext cx="7744968" cy="1097280"/>
+            <a:off x="704088" y="4434840"/>
+            <a:ext cx="7744968" cy="457200"/>
           </a:xfrm>
           <a:prstGeom prst="rect">
             <a:avLst/>
@@ -7968,31 +7814,14 @@
           </a:bodyPr>
           <a:lstStyle/>
           <a:p>
-            <a:pPr>
-              <a:lnSpc>
-                <a:spcPct val="112000"/>
-              </a:lnSpc>
-              <a:spcAft>
-                <a:spcPts val="900"/>
-              </a:spcAft>
-            </a:pPr>
-            <a:r>
-              <a:rPr sz="1600" b="1">
-                <a:solidFill>
-                  <a:srgbClr val="E0A437"/>
-                </a:solidFill>
-                <a:latin typeface="Fira Sans"/>
-              </a:rPr>
-              <a:t>▸ </a:t>
-            </a:r>
-            <a:r>
-              <a:rPr sz="1600" b="0">
-                <a:solidFill>
-                  <a:srgbClr val="000000"/>
-                </a:solidFill>
-                <a:latin typeface="Fira Sans"/>
-              </a:rPr>
-              <a:t>GLM con familia binomial, ponderado con el factor. Lectura multiplicativa, como el log de la clase 4: cada millón multiplica las chances de tener auto por 8,9.</a:t>
+            <a:r>
+              <a:rPr sz="1300" b="0">
+                <a:solidFill>
+                  <a:srgbClr val="333333"/>
+                </a:solidFill>
+                <a:latin typeface="Fira Sans"/>
+              </a:rPr>
+              <a:t>Sobre un 0/1, la recta predice 1,39 a los 5 millones y valores negativos abajo: no respeta que la respuesta vive entre 0 y 1. La logística pasa la recta por una S y queda siempre en el rango.</a:t>
             </a:r>
           </a:p>
         </p:txBody>
@@ -8088,14 +7917,14 @@
                 </a:solidFill>
                 <a:latin typeface="Fira Sans"/>
               </a:rPr>
-              <a:t>Clasificar: de la probabilidad a la decisión</a:t>
+              <a:t>La regresión logística</a:t>
             </a:r>
           </a:p>
         </p:txBody>
       </p:sp>
       <p:pic>
         <p:nvPicPr>
-          <p:cNvPr id="4" name="Picture 3" descr="c5_17_clasificacion.png"/>
+          <p:cNvPr id="4" name="Picture 3" descr="c5_16_formula_logistica.png"/>
           <p:cNvPicPr>
             <a:picLocks noChangeAspect="1"/>
           </p:cNvPicPr>
@@ -8109,8 +7938,8 @@
         </p:blipFill>
         <p:spPr>
           <a:xfrm>
-            <a:off x="1042506" y="1143000"/>
-            <a:ext cx="7058986" cy="3154680"/>
+            <a:off x="699515" y="1262245"/>
+            <a:ext cx="7744968" cy="2916190"/>
           </a:xfrm>
           <a:prstGeom prst="rect">
             <a:avLst/>
@@ -8146,7 +7975,7 @@
                 </a:solidFill>
                 <a:latin typeface="Fira Sans"/>
               </a:rPr>
-              <a:t>Predecir "tiene auto" cuando P supera 0,5 (desde 0,86 millones). Acierta el 70%, contra el 61% de decir siempre "no": la comparación con la base es obligatoria. Dónde se equivoca lo dice la matriz de confusión (un crosstab).</a:t>
+              <a:t>La misma recta a + b·x, pero dentro de la sigmoide. La respuesta es una Bernoulli (la binomial con n = 1) cuya probabilidad depende de x.</a:t>
             </a:r>
           </a:p>
         </p:txBody>
@@ -8184,7 +8013,7 @@
             <a:avLst/>
           </a:prstGeom>
           <a:solidFill>
-            <a:srgbClr val="1D3557"/>
+            <a:srgbClr val="FAFBFC"/>
           </a:solidFill>
           <a:ln>
             <a:noFill/>
@@ -8221,8 +8050,8 @@
         </p:nvSpPr>
         <p:spPr>
           <a:xfrm>
-            <a:off x="603504" y="1847088"/>
-            <a:ext cx="7946136" cy="1399032"/>
+            <a:off x="402336" y="301752"/>
+            <a:ext cx="8348472" cy="795528"/>
           </a:xfrm>
           <a:prstGeom prst="rect">
             <a:avLst/>
@@ -8236,24 +8065,167 @@
           <a:lstStyle/>
           <a:p>
             <a:r>
-              <a:rPr sz="3400" b="1">
-                <a:solidFill>
-                  <a:srgbClr val="FFFFFF"/>
-                </a:solidFill>
-                <a:latin typeface="Fira Sans"/>
-              </a:rPr>
-              <a:t>La trampa de las comparaciones múltiples</a:t>
-            </a:r>
-          </a:p>
-          <a:p>
-            <a:r>
-              <a:rPr sz="1800" b="0">
+              <a:rPr sz="2800" b="1">
+                <a:solidFill>
+                  <a:srgbClr val="0F0F0F"/>
+                </a:solidFill>
+                <a:latin typeface="Fira Sans"/>
+              </a:rPr>
+              <a:t>La logística en statsmodels</a:t>
+            </a:r>
+          </a:p>
+        </p:txBody>
+      </p:sp>
+      <p:sp>
+        <p:nvSpPr>
+          <p:cNvPr id="4" name="Rectangle 3"/>
+          <p:cNvSpPr/>
+          <p:nvPr/>
+        </p:nvSpPr>
+        <p:spPr>
+          <a:xfrm>
+            <a:off x="704088" y="1280160"/>
+            <a:ext cx="7744968" cy="2880360"/>
+          </a:xfrm>
+          <a:prstGeom prst="rect">
+            <a:avLst/>
+          </a:prstGeom>
+          <a:solidFill>
+            <a:srgbClr val="F0F2F5"/>
+          </a:solidFill>
+          <a:ln>
+            <a:solidFill>
+              <a:srgbClr val="D8DDE3"/>
+            </a:solidFill>
+          </a:ln>
+          <a:effectLst/>
+        </p:spPr>
+        <p:style>
+          <a:lnRef idx="1">
+            <a:schemeClr val="accent1"/>
+          </a:lnRef>
+          <a:fillRef idx="3">
+            <a:schemeClr val="accent1"/>
+          </a:fillRef>
+          <a:effectRef idx="2">
+            <a:schemeClr val="accent1"/>
+          </a:effectRef>
+          <a:fontRef idx="minor">
+            <a:schemeClr val="lt1"/>
+          </a:fontRef>
+        </p:style>
+        <p:txBody>
+          <a:bodyPr rtlCol="0" anchor="ctr" wrap="square" lIns="228600" tIns="137160"/>
+          <a:lstStyle/>
+          <a:p>
+            <a:pPr/>
+            <a:r>
+              <a:rPr sz="1500" b="0">
+                <a:solidFill>
+                  <a:srgbClr val="1D3557"/>
+                </a:solidFill>
+                <a:latin typeface="Menlo"/>
+              </a:rPr>
+              <a:t>logistica = sm.GLM(h["tiene_auto"], sm.add_constant(ingreso),</a:t>
+            </a:r>
+          </a:p>
+          <a:p>
+            <a:pPr/>
+            <a:r>
+              <a:rPr sz="1500" b="0">
+                <a:solidFill>
+                  <a:srgbClr val="1D3557"/>
+                </a:solidFill>
+                <a:latin typeface="Menlo"/>
+              </a:rPr>
+              <a:t>                   family=sm.families.Binomial(),</a:t>
+            </a:r>
+          </a:p>
+          <a:p>
+            <a:pPr/>
+            <a:r>
+              <a:rPr sz="1500" b="0">
+                <a:solidFill>
+                  <a:srgbClr val="1D3557"/>
+                </a:solidFill>
+                <a:latin typeface="Menlo"/>
+              </a:rPr>
+              <a:t>                   freq_weights=h["Factor"]).fit()</a:t>
+            </a:r>
+          </a:p>
+          <a:p>
+            <a:pPr/>
+            <a:r>
+              <a:rPr sz="1500" b="0">
+                <a:solidFill>
+                  <a:srgbClr val="1D3557"/>
+                </a:solidFill>
+                <a:latin typeface="Menlo"/>
+              </a:rPr>
+              <a:t/>
+            </a:r>
+          </a:p>
+          <a:p>
+            <a:pPr/>
+            <a:r>
+              <a:rPr sz="1500" b="0">
+                <a:solidFill>
+                  <a:srgbClr val="1D3557"/>
+                </a:solidFill>
+                <a:latin typeface="Menlo"/>
+              </a:rPr>
+              <a:t>np.exp(logistica.params["IngresoHogar"])   # 8.9</a:t>
+            </a:r>
+          </a:p>
+        </p:txBody>
+      </p:sp>
+      <p:sp>
+        <p:nvSpPr>
+          <p:cNvPr id="5" name="TextBox 4"/>
+          <p:cNvSpPr txBox="1"/>
+          <p:nvPr/>
+        </p:nvSpPr>
+        <p:spPr>
+          <a:xfrm>
+            <a:off x="704088" y="4389120"/>
+            <a:ext cx="7744968" cy="1097280"/>
+          </a:xfrm>
+          <a:prstGeom prst="rect">
+            <a:avLst/>
+          </a:prstGeom>
+          <a:noFill/>
+        </p:spPr>
+        <p:txBody>
+          <a:bodyPr wrap="square">
+            <a:spAutoFit/>
+          </a:bodyPr>
+          <a:lstStyle/>
+          <a:p>
+            <a:pPr>
+              <a:lnSpc>
+                <a:spcPct val="112000"/>
+              </a:lnSpc>
+              <a:spcAft>
+                <a:spcPts val="900"/>
+              </a:spcAft>
+            </a:pPr>
+            <a:r>
+              <a:rPr sz="1600" b="1">
                 <a:solidFill>
                   <a:srgbClr val="E0A437"/>
                 </a:solidFill>
                 <a:latin typeface="Fira Sans"/>
               </a:rPr>
-              <a:t>Qué pasa con el valor p cuando se prueba de todo</a:t>
+              <a:t>▸ </a:t>
+            </a:r>
+            <a:r>
+              <a:rPr sz="1600" b="0">
+                <a:solidFill>
+                  <a:srgbClr val="000000"/>
+                </a:solidFill>
+                <a:latin typeface="Fira Sans"/>
+              </a:rPr>
+              <a:t>GLM con familia binomial, ponderado con el factor. Lectura multiplicativa, como el log de la clase 4: cada millón multiplica las chances de tener auto por 8,9.</a:t>
             </a:r>
           </a:p>
         </p:txBody>
@@ -8349,14 +8321,14 @@
                 </a:solidFill>
                 <a:latin typeface="Fira Sans"/>
               </a:rPr>
-              <a:t>20 variables de puro ruido</a:t>
+              <a:t>Clasificar: de la probabilidad a la decisión</a:t>
             </a:r>
           </a:p>
         </p:txBody>
       </p:sp>
       <p:pic>
         <p:nvPicPr>
-          <p:cNvPr id="4" name="Picture 3" descr="c5_14_comparaciones_multiples.png"/>
+          <p:cNvPr id="4" name="Picture 3" descr="c5_17_clasificacion.png"/>
           <p:cNvPicPr>
             <a:picLocks noChangeAspect="1"/>
           </p:cNvPicPr>
@@ -8370,8 +8342,8 @@
         </p:blipFill>
         <p:spPr>
           <a:xfrm>
-            <a:off x="759392" y="1143000"/>
-            <a:ext cx="7625215" cy="3154680"/>
+            <a:off x="1042506" y="1143000"/>
+            <a:ext cx="7058986" cy="3154680"/>
           </a:xfrm>
           <a:prstGeom prst="rect">
             <a:avLst/>
@@ -8407,7 +8379,7 @@
                 </a:solidFill>
                 <a:latin typeface="Fira Sans"/>
               </a:rPr>
-              <a:t>Números al azar, sin relación con nada, probados contra la duración por comuna: con 20 intentos y umbral 0,05 se espera una falsa alarma. Es lo que pasa al recorrer una matriz de correlación buscando la que dé.</a:t>
+              <a:t>Predecir "tiene auto" cuando P supera 0,5 (desde 0,86 millones). Acierta el 70%, contra el 61% de decir siempre "no": la comparación con la base es obligatoria. Dónde se equivoca lo dice la matriz de confusión (un crosstab).</a:t>
             </a:r>
           </a:p>
         </p:txBody>
@@ -8445,7 +8417,7 @@
             <a:avLst/>
           </a:prstGeom>
           <a:solidFill>
-            <a:srgbClr val="FAFBFC"/>
+            <a:srgbClr val="1D3557"/>
           </a:solidFill>
           <a:ln>
             <a:noFill/>
@@ -8482,8 +8454,8 @@
         </p:nvSpPr>
         <p:spPr>
           <a:xfrm>
-            <a:off x="402336" y="301752"/>
-            <a:ext cx="8348472" cy="795528"/>
+            <a:off x="603504" y="1847088"/>
+            <a:ext cx="7946136" cy="1399032"/>
           </a:xfrm>
           <a:prstGeom prst="rect">
             <a:avLst/>
@@ -8497,148 +8469,24 @@
           <a:lstStyle/>
           <a:p>
             <a:r>
-              <a:rPr sz="2800" b="1">
-                <a:solidFill>
-                  <a:srgbClr val="0F0F0F"/>
-                </a:solidFill>
-                <a:latin typeface="Fira Sans"/>
-              </a:rPr>
-              <a:t>Reglas para el EDA del proyecto</a:t>
-            </a:r>
-          </a:p>
-        </p:txBody>
-      </p:sp>
-      <p:sp>
-        <p:nvSpPr>
-          <p:cNvPr id="4" name="TextBox 3"/>
-          <p:cNvSpPr txBox="1"/>
-          <p:nvPr/>
-        </p:nvSpPr>
-        <p:spPr>
-          <a:xfrm>
-            <a:off x="704088" y="1353312"/>
-            <a:ext cx="7744968" cy="3300984"/>
-          </a:xfrm>
-          <a:prstGeom prst="rect">
-            <a:avLst/>
-          </a:prstGeom>
-          <a:noFill/>
-        </p:spPr>
-        <p:txBody>
-          <a:bodyPr wrap="square">
-            <a:spAutoFit/>
-          </a:bodyPr>
-          <a:lstStyle/>
-          <a:p>
-            <a:pPr>
-              <a:lnSpc>
-                <a:spcPct val="112000"/>
-              </a:lnSpc>
-              <a:spcAft>
-                <a:spcPts val="900"/>
-              </a:spcAft>
-            </a:pPr>
-            <a:r>
-              <a:rPr sz="1800" b="1">
+              <a:rPr sz="3400" b="1">
+                <a:solidFill>
+                  <a:srgbClr val="FFFFFF"/>
+                </a:solidFill>
+                <a:latin typeface="Fira Sans"/>
+              </a:rPr>
+              <a:t>La trampa de las comparaciones múltiples</a:t>
+            </a:r>
+          </a:p>
+          <a:p>
+            <a:r>
+              <a:rPr sz="1800" b="0">
                 <a:solidFill>
                   <a:srgbClr val="E0A437"/>
                 </a:solidFill>
                 <a:latin typeface="Fira Sans"/>
               </a:rPr>
-              <a:t>▸ </a:t>
-            </a:r>
-            <a:r>
-              <a:rPr sz="1800" b="1">
-                <a:solidFill>
-                  <a:srgbClr val="1D3557"/>
-                </a:solidFill>
-                <a:latin typeface="Fira Sans"/>
-              </a:rPr>
-              <a:t>Reportar cuántas pruebas se hicieron; un hallazgo aislado entre muchos intentos merece desconfianza.</a:t>
-            </a:r>
-          </a:p>
-          <a:p>
-            <a:pPr>
-              <a:lnSpc>
-                <a:spcPct val="112000"/>
-              </a:lnSpc>
-              <a:spcAft>
-                <a:spcPts val="900"/>
-              </a:spcAft>
-            </a:pPr>
-            <a:r>
-              <a:rPr sz="1800" b="1">
-                <a:solidFill>
-                  <a:srgbClr val="E0A437"/>
-                </a:solidFill>
-                <a:latin typeface="Fira Sans"/>
-              </a:rPr>
-              <a:t>▸ </a:t>
-            </a:r>
-            <a:r>
-              <a:rPr sz="1800" b="0">
-                <a:solidFill>
-                  <a:srgbClr val="000000"/>
-                </a:solidFill>
-                <a:latin typeface="Fira Sans"/>
-              </a:rPr>
-              <a:t>La corrección más simple, Bonferroni: dividir el umbral por el número de pruebas (0,05 / 20 = 0,0025).</a:t>
-            </a:r>
-          </a:p>
-          <a:p>
-            <a:pPr>
-              <a:lnSpc>
-                <a:spcPct val="112000"/>
-              </a:lnSpc>
-              <a:spcAft>
-                <a:spcPts val="900"/>
-              </a:spcAft>
-            </a:pPr>
-            <a:r>
-              <a:rPr sz="1800" b="1">
-                <a:solidFill>
-                  <a:srgbClr val="E0A437"/>
-                </a:solidFill>
-                <a:latin typeface="Fira Sans"/>
-              </a:rPr>
-              <a:t>▸ </a:t>
-            </a:r>
-            <a:r>
-              <a:rPr sz="1800" b="0">
-                <a:solidFill>
-                  <a:srgbClr val="000000"/>
-                </a:solidFill>
-                <a:latin typeface="Fira Sans"/>
-              </a:rPr>
-              <a:t>Preferir el intervalo de confianza al valor p: muestra el tamaño del efecto y su precisión.</a:t>
-            </a:r>
-          </a:p>
-          <a:p>
-            <a:pPr>
-              <a:lnSpc>
-                <a:spcPct val="112000"/>
-              </a:lnSpc>
-              <a:spcAft>
-                <a:spcPts val="900"/>
-              </a:spcAft>
-            </a:pPr>
-            <a:r>
-              <a:rPr sz="1800" b="1">
-                <a:solidFill>
-                  <a:srgbClr val="E0A437"/>
-                </a:solidFill>
-                <a:latin typeface="Fira Sans"/>
-              </a:rPr>
-              <a:t>▸ </a:t>
-            </a:r>
-            <a:r>
-              <a:rPr sz="1800" b="0">
-                <a:solidFill>
-                  <a:srgbClr val="000000"/>
-                </a:solidFill>
-                <a:latin typeface="Fira Sans"/>
-              </a:rPr>
-              <a:t>Significativo no es importante, y correlación no es causalidad.</a:t>
+              <a:t>Qué pasa con el valor p cuando se prueba de todo</a:t>
             </a:r>
           </a:p>
         </p:txBody>
@@ -8734,21 +8582,45 @@
                 </a:solidFill>
                 <a:latin typeface="Fira Sans"/>
               </a:rPr>
-              <a:t>Síntesis</a:t>
-            </a:r>
-          </a:p>
-        </p:txBody>
-      </p:sp>
-      <p:sp>
-        <p:nvSpPr>
-          <p:cNvPr id="4" name="TextBox 3"/>
+              <a:t>20 variables de puro ruido</a:t>
+            </a:r>
+          </a:p>
+        </p:txBody>
+      </p:sp>
+      <p:pic>
+        <p:nvPicPr>
+          <p:cNvPr id="4" name="Picture 3" descr="c5_14_comparaciones_multiples.png"/>
+          <p:cNvPicPr>
+            <a:picLocks noChangeAspect="1"/>
+          </p:cNvPicPr>
+          <p:nvPr/>
+        </p:nvPicPr>
+        <p:blipFill>
+          <a:blip r:embed="rId2"/>
+          <a:stretch>
+            <a:fillRect/>
+          </a:stretch>
+        </p:blipFill>
+        <p:spPr>
+          <a:xfrm>
+            <a:off x="759392" y="1143000"/>
+            <a:ext cx="7625215" cy="3154680"/>
+          </a:xfrm>
+          <a:prstGeom prst="rect">
+            <a:avLst/>
+          </a:prstGeom>
+        </p:spPr>
+      </p:pic>
+      <p:sp>
+        <p:nvSpPr>
+          <p:cNvPr id="5" name="TextBox 4"/>
           <p:cNvSpPr txBox="1"/>
           <p:nvPr/>
         </p:nvSpPr>
         <p:spPr>
           <a:xfrm>
-            <a:off x="704088" y="1353312"/>
-            <a:ext cx="7744968" cy="3300984"/>
+            <a:off x="704088" y="4434840"/>
+            <a:ext cx="7744968" cy="457200"/>
           </a:xfrm>
           <a:prstGeom prst="rect">
             <a:avLst/>
@@ -8761,171 +8633,14 @@
           </a:bodyPr>
           <a:lstStyle/>
           <a:p>
-            <a:pPr>
-              <a:lnSpc>
-                <a:spcPct val="112000"/>
-              </a:lnSpc>
-              <a:spcAft>
-                <a:spcPts val="900"/>
-              </a:spcAft>
-            </a:pPr>
-            <a:r>
-              <a:rPr sz="1800" b="1">
-                <a:solidFill>
-                  <a:srgbClr val="E0A437"/>
-                </a:solidFill>
-                <a:latin typeface="Fira Sans"/>
-              </a:rPr>
-              <a:t>▸ </a:t>
-            </a:r>
-            <a:r>
-              <a:rPr sz="1800" b="0">
-                <a:solidFill>
-                  <a:srgbClr val="000000"/>
-                </a:solidFill>
-                <a:latin typeface="Fira Sans"/>
-              </a:rPr>
-              <a:t>Una muestra es una de muchas: todo número calculado se movería con otra muestra, y el error estándar mide cuánto.</a:t>
-            </a:r>
-          </a:p>
-          <a:p>
-            <a:pPr>
-              <a:lnSpc>
-                <a:spcPct val="112000"/>
-              </a:lnSpc>
-              <a:spcAft>
-                <a:spcPts val="900"/>
-              </a:spcAft>
-            </a:pPr>
-            <a:r>
-              <a:rPr sz="1800" b="1">
-                <a:solidFill>
-                  <a:srgbClr val="E0A437"/>
-                </a:solidFill>
-                <a:latin typeface="Fira Sans"/>
-              </a:rPr>
-              <a:t>▸ </a:t>
-            </a:r>
-            <a:r>
-              <a:rPr sz="1800" b="0">
-                <a:solidFill>
-                  <a:srgbClr val="000000"/>
-                </a:solidFill>
-                <a:latin typeface="Fira Sans"/>
-              </a:rPr>
-              <a:t>El teorema central del límite: los promedios se distribuyen normal, aunque los datos no.</a:t>
-            </a:r>
-          </a:p>
-          <a:p>
-            <a:pPr>
-              <a:lnSpc>
-                <a:spcPct val="112000"/>
-              </a:lnSpc>
-              <a:spcAft>
-                <a:spcPts val="900"/>
-              </a:spcAft>
-            </a:pPr>
-            <a:r>
-              <a:rPr sz="1800" b="1">
-                <a:solidFill>
-                  <a:srgbClr val="E0A437"/>
-                </a:solidFill>
-                <a:latin typeface="Fira Sans"/>
-              </a:rPr>
-              <a:t>▸ </a:t>
-            </a:r>
-            <a:r>
-              <a:rPr sz="1800" b="0">
-                <a:solidFill>
-                  <a:srgbClr val="000000"/>
-                </a:solidFill>
-                <a:latin typeface="Fira Sans"/>
-              </a:rPr>
-              <a:t>El intervalo de confianza convierte el error estándar en un rango que atrapa el valor real el 95% de las veces.</a:t>
-            </a:r>
-          </a:p>
-          <a:p>
-            <a:pPr>
-              <a:lnSpc>
-                <a:spcPct val="112000"/>
-              </a:lnSpc>
-              <a:spcAft>
-                <a:spcPts val="900"/>
-              </a:spcAft>
-            </a:pPr>
-            <a:r>
-              <a:rPr sz="1800" b="1">
-                <a:solidFill>
-                  <a:srgbClr val="E0A437"/>
-                </a:solidFill>
-                <a:latin typeface="Fira Sans"/>
-              </a:rPr>
-              <a:t>▸ </a:t>
-            </a:r>
-            <a:r>
-              <a:rPr sz="1800" b="0">
-                <a:solidFill>
-                  <a:srgbClr val="000000"/>
-                </a:solidFill>
-                <a:latin typeface="Fira Sans"/>
-              </a:rPr>
-              <a:t>El valor p responde: si el efecto real fuera cero, ¿qué tan raro sería lo observado? Con p &lt; 0,05, la pendiente de −4,8 es real.</a:t>
-            </a:r>
-          </a:p>
-          <a:p>
-            <a:pPr>
-              <a:lnSpc>
-                <a:spcPct val="112000"/>
-              </a:lnSpc>
-              <a:spcAft>
-                <a:spcPts val="900"/>
-              </a:spcAft>
-            </a:pPr>
-            <a:r>
-              <a:rPr sz="1800" b="1">
-                <a:solidFill>
-                  <a:srgbClr val="E0A437"/>
-                </a:solidFill>
-                <a:latin typeface="Fira Sans"/>
-              </a:rPr>
-              <a:t>▸ </a:t>
-            </a:r>
-            <a:r>
-              <a:rPr sz="1800" b="0">
-                <a:solidFill>
-                  <a:srgbClr val="000000"/>
-                </a:solidFill>
-                <a:latin typeface="Fira Sans"/>
-              </a:rPr>
-              <a:t>Para un sí o no, la regresión logística: la recta dentro de una sigmoide; clasificar es cortar en 0,5 y comparar con la base.</a:t>
-            </a:r>
-          </a:p>
-          <a:p>
-            <a:pPr>
-              <a:lnSpc>
-                <a:spcPct val="112000"/>
-              </a:lnSpc>
-              <a:spcAft>
-                <a:spcPts val="900"/>
-              </a:spcAft>
-            </a:pPr>
-            <a:r>
-              <a:rPr sz="1800" b="1">
-                <a:solidFill>
-                  <a:srgbClr val="E0A437"/>
-                </a:solidFill>
-                <a:latin typeface="Fira Sans"/>
-              </a:rPr>
-              <a:t>▸ </a:t>
-            </a:r>
-            <a:r>
-              <a:rPr sz="1800" b="1">
-                <a:solidFill>
-                  <a:srgbClr val="1D3557"/>
-                </a:solidFill>
-                <a:latin typeface="Fira Sans"/>
-              </a:rPr>
-              <a:t>Para el EDA del lunes 15: intervalos, y cuidado con probar de todo.</a:t>
+            <a:r>
+              <a:rPr sz="1300" b="0">
+                <a:solidFill>
+                  <a:srgbClr val="333333"/>
+                </a:solidFill>
+                <a:latin typeface="Fira Sans"/>
+              </a:rPr>
+              <a:t>Números al azar, sin relación con nada, probados contra la duración por comuna: con 20 intentos y umbral 0,05 se espera una falsa alarma. Es lo que pasa al recorrer una matriz de correlación buscando la que dé.</a:t>
             </a:r>
           </a:p>
         </p:txBody>
@@ -9070,7 +8785,7 @@
             <a:avLst/>
           </a:prstGeom>
           <a:solidFill>
-            <a:srgbClr val="1D3557"/>
+            <a:srgbClr val="FAFBFC"/>
           </a:solidFill>
           <a:ln>
             <a:noFill/>
@@ -9107,8 +8822,8 @@
         </p:nvSpPr>
         <p:spPr>
           <a:xfrm>
-            <a:off x="603504" y="1847088"/>
-            <a:ext cx="7946136" cy="1399032"/>
+            <a:off x="402336" y="301752"/>
+            <a:ext cx="8348472" cy="795528"/>
           </a:xfrm>
           <a:prstGeom prst="rect">
             <a:avLst/>
@@ -9122,24 +8837,148 @@
           <a:lstStyle/>
           <a:p>
             <a:r>
-              <a:rPr sz="3400" b="1">
-                <a:solidFill>
-                  <a:srgbClr val="FFFFFF"/>
-                </a:solidFill>
-                <a:latin typeface="Fira Sans"/>
-              </a:rPr>
-              <a:t>Recreo</a:t>
-            </a:r>
-          </a:p>
-          <a:p>
+              <a:rPr sz="2800" b="1">
+                <a:solidFill>
+                  <a:srgbClr val="0F0F0F"/>
+                </a:solidFill>
+                <a:latin typeface="Fira Sans"/>
+              </a:rPr>
+              <a:t>Reglas para el EDA del proyecto</a:t>
+            </a:r>
+          </a:p>
+        </p:txBody>
+      </p:sp>
+      <p:sp>
+        <p:nvSpPr>
+          <p:cNvPr id="4" name="TextBox 3"/>
+          <p:cNvSpPr txBox="1"/>
+          <p:nvPr/>
+        </p:nvSpPr>
+        <p:spPr>
+          <a:xfrm>
+            <a:off x="704088" y="1353312"/>
+            <a:ext cx="7744968" cy="3300984"/>
+          </a:xfrm>
+          <a:prstGeom prst="rect">
+            <a:avLst/>
+          </a:prstGeom>
+          <a:noFill/>
+        </p:spPr>
+        <p:txBody>
+          <a:bodyPr wrap="square">
+            <a:spAutoFit/>
+          </a:bodyPr>
+          <a:lstStyle/>
+          <a:p>
+            <a:pPr>
+              <a:lnSpc>
+                <a:spcPct val="112000"/>
+              </a:lnSpc>
+              <a:spcAft>
+                <a:spcPts val="900"/>
+              </a:spcAft>
+            </a:pPr>
+            <a:r>
+              <a:rPr sz="1800" b="1">
+                <a:solidFill>
+                  <a:srgbClr val="E0A437"/>
+                </a:solidFill>
+                <a:latin typeface="Fira Sans"/>
+              </a:rPr>
+              <a:t>▸ </a:t>
+            </a:r>
+            <a:r>
+              <a:rPr sz="1800" b="1">
+                <a:solidFill>
+                  <a:srgbClr val="1D3557"/>
+                </a:solidFill>
+                <a:latin typeface="Fira Sans"/>
+              </a:rPr>
+              <a:t>Reportar cuántas pruebas se hicieron; un hallazgo aislado entre muchos intentos merece desconfianza.</a:t>
+            </a:r>
+          </a:p>
+          <a:p>
+            <a:pPr>
+              <a:lnSpc>
+                <a:spcPct val="112000"/>
+              </a:lnSpc>
+              <a:spcAft>
+                <a:spcPts val="900"/>
+              </a:spcAft>
+            </a:pPr>
+            <a:r>
+              <a:rPr sz="1800" b="1">
+                <a:solidFill>
+                  <a:srgbClr val="E0A437"/>
+                </a:solidFill>
+                <a:latin typeface="Fira Sans"/>
+              </a:rPr>
+              <a:t>▸ </a:t>
+            </a:r>
             <a:r>
               <a:rPr sz="1800" b="0">
                 <a:solidFill>
+                  <a:srgbClr val="000000"/>
+                </a:solidFill>
+                <a:latin typeface="Fira Sans"/>
+              </a:rPr>
+              <a:t>La corrección más simple, Bonferroni: dividir el umbral por el número de pruebas (0,05 / 20 = 0,0025).</a:t>
+            </a:r>
+          </a:p>
+          <a:p>
+            <a:pPr>
+              <a:lnSpc>
+                <a:spcPct val="112000"/>
+              </a:lnSpc>
+              <a:spcAft>
+                <a:spcPts val="900"/>
+              </a:spcAft>
+            </a:pPr>
+            <a:r>
+              <a:rPr sz="1800" b="1">
+                <a:solidFill>
                   <a:srgbClr val="E0A437"/>
                 </a:solidFill>
                 <a:latin typeface="Fira Sans"/>
               </a:rPr>
-              <a:t>10 minutos · al volver: manos al teclado, con el notebook</a:t>
+              <a:t>▸ </a:t>
+            </a:r>
+            <a:r>
+              <a:rPr sz="1800" b="0">
+                <a:solidFill>
+                  <a:srgbClr val="000000"/>
+                </a:solidFill>
+                <a:latin typeface="Fira Sans"/>
+              </a:rPr>
+              <a:t>Preferir el intervalo de confianza al valor p: muestra el tamaño del efecto y su precisión.</a:t>
+            </a:r>
+          </a:p>
+          <a:p>
+            <a:pPr>
+              <a:lnSpc>
+                <a:spcPct val="112000"/>
+              </a:lnSpc>
+              <a:spcAft>
+                <a:spcPts val="900"/>
+              </a:spcAft>
+            </a:pPr>
+            <a:r>
+              <a:rPr sz="1800" b="1">
+                <a:solidFill>
+                  <a:srgbClr val="E0A437"/>
+                </a:solidFill>
+                <a:latin typeface="Fira Sans"/>
+              </a:rPr>
+              <a:t>▸ </a:t>
+            </a:r>
+            <a:r>
+              <a:rPr sz="1800" b="0">
+                <a:solidFill>
+                  <a:srgbClr val="000000"/>
+                </a:solidFill>
+                <a:latin typeface="Fira Sans"/>
+              </a:rPr>
+              <a:t>Significativo no es importante, y correlación no es causalidad.</a:t>
             </a:r>
           </a:p>
         </p:txBody>
@@ -9235,7 +9074,7 @@
                 </a:solidFill>
                 <a:latin typeface="Fira Sans"/>
               </a:rPr>
-              <a:t>Próxima clase</a:t>
+              <a:t>Síntesis</a:t>
             </a:r>
           </a:p>
         </p:txBody>
@@ -9286,7 +9125,7 @@
                 </a:solidFill>
                 <a:latin typeface="Fira Sans"/>
               </a:rPr>
-              <a:t>Jueves 10: regresión lineal en profundidad: supuestos, diagnósticos con los residuos y evaluación fuera de la muestra.</a:t>
+              <a:t>Una muestra es una de muchas: todo número calculado se movería con otra muestra, y el error estándar mide cuánto.</a:t>
             </a:r>
           </a:p>
           <a:p>
@@ -9314,7 +9153,7 @@
                 </a:solidFill>
                 <a:latin typeface="Fira Sans"/>
               </a:rPr>
-              <a:t>Con lo de hoy ya se puede leer completo el summary de cualquier modelo.</a:t>
+              <a:t>El teorema central del límite: los promedios se distribuyen normal, aunque los datos no.</a:t>
             </a:r>
           </a:p>
           <a:p>
@@ -9336,13 +9175,97 @@
               <a:t>▸ </a:t>
             </a:r>
             <a:r>
+              <a:rPr sz="1800" b="0">
+                <a:solidFill>
+                  <a:srgbClr val="000000"/>
+                </a:solidFill>
+                <a:latin typeface="Fira Sans"/>
+              </a:rPr>
+              <a:t>El intervalo de confianza convierte el error estándar en un rango que atrapa el valor real el 95% de las veces.</a:t>
+            </a:r>
+          </a:p>
+          <a:p>
+            <a:pPr>
+              <a:lnSpc>
+                <a:spcPct val="112000"/>
+              </a:lnSpc>
+              <a:spcAft>
+                <a:spcPts val="900"/>
+              </a:spcAft>
+            </a:pPr>
+            <a:r>
               <a:rPr sz="1800" b="1">
                 <a:solidFill>
+                  <a:srgbClr val="E0A437"/>
+                </a:solidFill>
+                <a:latin typeface="Fira Sans"/>
+              </a:rPr>
+              <a:t>▸ </a:t>
+            </a:r>
+            <a:r>
+              <a:rPr sz="1800" b="0">
+                <a:solidFill>
+                  <a:srgbClr val="000000"/>
+                </a:solidFill>
+                <a:latin typeface="Fira Sans"/>
+              </a:rPr>
+              <a:t>El valor p responde: si el efecto real fuera cero, ¿qué tan raro sería lo observado? Con p &lt; 0,05, la pendiente de −4,8 es real.</a:t>
+            </a:r>
+          </a:p>
+          <a:p>
+            <a:pPr>
+              <a:lnSpc>
+                <a:spcPct val="112000"/>
+              </a:lnSpc>
+              <a:spcAft>
+                <a:spcPts val="900"/>
+              </a:spcAft>
+            </a:pPr>
+            <a:r>
+              <a:rPr sz="1800" b="1">
+                <a:solidFill>
+                  <a:srgbClr val="E0A437"/>
+                </a:solidFill>
+                <a:latin typeface="Fira Sans"/>
+              </a:rPr>
+              <a:t>▸ </a:t>
+            </a:r>
+            <a:r>
+              <a:rPr sz="1800" b="0">
+                <a:solidFill>
+                  <a:srgbClr val="000000"/>
+                </a:solidFill>
+                <a:latin typeface="Fira Sans"/>
+              </a:rPr>
+              <a:t>Para un sí o no, la regresión logística: la recta dentro de una sigmoide; clasificar es cortar en 0,5 y comparar con la base.</a:t>
+            </a:r>
+          </a:p>
+          <a:p>
+            <a:pPr>
+              <a:lnSpc>
+                <a:spcPct val="112000"/>
+              </a:lnSpc>
+              <a:spcAft>
+                <a:spcPts val="900"/>
+              </a:spcAft>
+            </a:pPr>
+            <a:r>
+              <a:rPr sz="1800" b="1">
+                <a:solidFill>
+                  <a:srgbClr val="E0A437"/>
+                </a:solidFill>
+                <a:latin typeface="Fira Sans"/>
+              </a:rPr>
+              <a:t>▸ </a:t>
+            </a:r>
+            <a:r>
+              <a:rPr sz="1800" b="1">
+                <a:solidFill>
                   <a:srgbClr val="1D3557"/>
                 </a:solidFill>
                 <a:latin typeface="Fira Sans"/>
               </a:rPr>
-              <a:t>El primer análisis exploratorio se entrega el lunes 15.</a:t>
+              <a:t>Para el EDA del lunes 15: intervalos, y cuidado con probar de todo.</a:t>
             </a:r>
           </a:p>
         </p:txBody>
@@ -9356,6 +9279,316 @@
 </file>
 
 <file path=ppt/slides/slide42.xml><?xml version="1.0" encoding="utf-8"?>
+<p:sld xmlns:a="http://schemas.openxmlformats.org/drawingml/2006/main" xmlns:p="http://schemas.openxmlformats.org/presentationml/2006/main" xmlns:r="http://schemas.openxmlformats.org/officeDocument/2006/relationships">
+  <p:cSld>
+    <p:spTree>
+      <p:nvGrpSpPr>
+        <p:cNvPr id="1" name=""/>
+        <p:cNvGrpSpPr/>
+        <p:nvPr/>
+      </p:nvGrpSpPr>
+      <p:grpSpPr/>
+      <p:sp>
+        <p:nvSpPr>
+          <p:cNvPr id="2" name="Rectangle 1"/>
+          <p:cNvSpPr/>
+          <p:nvPr/>
+        </p:nvSpPr>
+        <p:spPr>
+          <a:xfrm>
+            <a:off x="0" y="0"/>
+            <a:ext cx="9144000" cy="5138928"/>
+          </a:xfrm>
+          <a:prstGeom prst="rect">
+            <a:avLst/>
+          </a:prstGeom>
+          <a:solidFill>
+            <a:srgbClr val="1D3557"/>
+          </a:solidFill>
+          <a:ln>
+            <a:noFill/>
+          </a:ln>
+          <a:effectLst/>
+        </p:spPr>
+        <p:style>
+          <a:lnRef idx="1">
+            <a:schemeClr val="accent1"/>
+          </a:lnRef>
+          <a:fillRef idx="3">
+            <a:schemeClr val="accent1"/>
+          </a:fillRef>
+          <a:effectRef idx="2">
+            <a:schemeClr val="accent1"/>
+          </a:effectRef>
+          <a:fontRef idx="minor">
+            <a:schemeClr val="lt1"/>
+          </a:fontRef>
+        </p:style>
+        <p:txBody>
+          <a:bodyPr rtlCol="0" anchor="ctr"/>
+          <a:lstStyle/>
+          <a:p>
+            <a:pPr algn="ctr"/>
+          </a:p>
+        </p:txBody>
+      </p:sp>
+      <p:sp>
+        <p:nvSpPr>
+          <p:cNvPr id="3" name="TextBox 2"/>
+          <p:cNvSpPr txBox="1"/>
+          <p:nvPr/>
+        </p:nvSpPr>
+        <p:spPr>
+          <a:xfrm>
+            <a:off x="603504" y="1847088"/>
+            <a:ext cx="7946136" cy="1399032"/>
+          </a:xfrm>
+          <a:prstGeom prst="rect">
+            <a:avLst/>
+          </a:prstGeom>
+          <a:noFill/>
+        </p:spPr>
+        <p:txBody>
+          <a:bodyPr wrap="square">
+            <a:spAutoFit/>
+          </a:bodyPr>
+          <a:lstStyle/>
+          <a:p>
+            <a:r>
+              <a:rPr sz="3400" b="1">
+                <a:solidFill>
+                  <a:srgbClr val="FFFFFF"/>
+                </a:solidFill>
+                <a:latin typeface="Fira Sans"/>
+              </a:rPr>
+              <a:t>Recreo</a:t>
+            </a:r>
+          </a:p>
+          <a:p>
+            <a:r>
+              <a:rPr sz="1800" b="0">
+                <a:solidFill>
+                  <a:srgbClr val="E0A437"/>
+                </a:solidFill>
+                <a:latin typeface="Fira Sans"/>
+              </a:rPr>
+              <a:t>10 minutos · al volver: manos al teclado, con el notebook</a:t>
+            </a:r>
+          </a:p>
+        </p:txBody>
+      </p:sp>
+    </p:spTree>
+  </p:cSld>
+  <p:clrMapOvr>
+    <a:masterClrMapping/>
+  </p:clrMapOvr>
+</p:sld>
+</file>
+
+<file path=ppt/slides/slide43.xml><?xml version="1.0" encoding="utf-8"?>
+<p:sld xmlns:a="http://schemas.openxmlformats.org/drawingml/2006/main" xmlns:p="http://schemas.openxmlformats.org/presentationml/2006/main" xmlns:r="http://schemas.openxmlformats.org/officeDocument/2006/relationships">
+  <p:cSld>
+    <p:spTree>
+      <p:nvGrpSpPr>
+        <p:cNvPr id="1" name=""/>
+        <p:cNvGrpSpPr/>
+        <p:nvPr/>
+      </p:nvGrpSpPr>
+      <p:grpSpPr/>
+      <p:sp>
+        <p:nvSpPr>
+          <p:cNvPr id="2" name="Rectangle 1"/>
+          <p:cNvSpPr/>
+          <p:nvPr/>
+        </p:nvSpPr>
+        <p:spPr>
+          <a:xfrm>
+            <a:off x="0" y="0"/>
+            <a:ext cx="9144000" cy="5138928"/>
+          </a:xfrm>
+          <a:prstGeom prst="rect">
+            <a:avLst/>
+          </a:prstGeom>
+          <a:solidFill>
+            <a:srgbClr val="FAFBFC"/>
+          </a:solidFill>
+          <a:ln>
+            <a:noFill/>
+          </a:ln>
+          <a:effectLst/>
+        </p:spPr>
+        <p:style>
+          <a:lnRef idx="1">
+            <a:schemeClr val="accent1"/>
+          </a:lnRef>
+          <a:fillRef idx="3">
+            <a:schemeClr val="accent1"/>
+          </a:fillRef>
+          <a:effectRef idx="2">
+            <a:schemeClr val="accent1"/>
+          </a:effectRef>
+          <a:fontRef idx="minor">
+            <a:schemeClr val="lt1"/>
+          </a:fontRef>
+        </p:style>
+        <p:txBody>
+          <a:bodyPr rtlCol="0" anchor="ctr"/>
+          <a:lstStyle/>
+          <a:p>
+            <a:pPr algn="ctr"/>
+          </a:p>
+        </p:txBody>
+      </p:sp>
+      <p:sp>
+        <p:nvSpPr>
+          <p:cNvPr id="3" name="TextBox 2"/>
+          <p:cNvSpPr txBox="1"/>
+          <p:nvPr/>
+        </p:nvSpPr>
+        <p:spPr>
+          <a:xfrm>
+            <a:off x="402336" y="301752"/>
+            <a:ext cx="8348472" cy="795528"/>
+          </a:xfrm>
+          <a:prstGeom prst="rect">
+            <a:avLst/>
+          </a:prstGeom>
+          <a:noFill/>
+        </p:spPr>
+        <p:txBody>
+          <a:bodyPr wrap="square">
+            <a:spAutoFit/>
+          </a:bodyPr>
+          <a:lstStyle/>
+          <a:p>
+            <a:r>
+              <a:rPr sz="2800" b="1">
+                <a:solidFill>
+                  <a:srgbClr val="0F0F0F"/>
+                </a:solidFill>
+                <a:latin typeface="Fira Sans"/>
+              </a:rPr>
+              <a:t>Próxima clase</a:t>
+            </a:r>
+          </a:p>
+        </p:txBody>
+      </p:sp>
+      <p:sp>
+        <p:nvSpPr>
+          <p:cNvPr id="4" name="TextBox 3"/>
+          <p:cNvSpPr txBox="1"/>
+          <p:nvPr/>
+        </p:nvSpPr>
+        <p:spPr>
+          <a:xfrm>
+            <a:off x="704088" y="1353312"/>
+            <a:ext cx="7744968" cy="3300984"/>
+          </a:xfrm>
+          <a:prstGeom prst="rect">
+            <a:avLst/>
+          </a:prstGeom>
+          <a:noFill/>
+        </p:spPr>
+        <p:txBody>
+          <a:bodyPr wrap="square">
+            <a:spAutoFit/>
+          </a:bodyPr>
+          <a:lstStyle/>
+          <a:p>
+            <a:pPr>
+              <a:lnSpc>
+                <a:spcPct val="112000"/>
+              </a:lnSpc>
+              <a:spcAft>
+                <a:spcPts val="900"/>
+              </a:spcAft>
+            </a:pPr>
+            <a:r>
+              <a:rPr sz="1800" b="1">
+                <a:solidFill>
+                  <a:srgbClr val="E0A437"/>
+                </a:solidFill>
+                <a:latin typeface="Fira Sans"/>
+              </a:rPr>
+              <a:t>▸ </a:t>
+            </a:r>
+            <a:r>
+              <a:rPr sz="1800" b="0">
+                <a:solidFill>
+                  <a:srgbClr val="000000"/>
+                </a:solidFill>
+                <a:latin typeface="Fira Sans"/>
+              </a:rPr>
+              <a:t>Jueves 10: regresión lineal en profundidad: supuestos, diagnósticos con los residuos y evaluación fuera de la muestra.</a:t>
+            </a:r>
+          </a:p>
+          <a:p>
+            <a:pPr>
+              <a:lnSpc>
+                <a:spcPct val="112000"/>
+              </a:lnSpc>
+              <a:spcAft>
+                <a:spcPts val="900"/>
+              </a:spcAft>
+            </a:pPr>
+            <a:r>
+              <a:rPr sz="1800" b="1">
+                <a:solidFill>
+                  <a:srgbClr val="E0A437"/>
+                </a:solidFill>
+                <a:latin typeface="Fira Sans"/>
+              </a:rPr>
+              <a:t>▸ </a:t>
+            </a:r>
+            <a:r>
+              <a:rPr sz="1800" b="0">
+                <a:solidFill>
+                  <a:srgbClr val="000000"/>
+                </a:solidFill>
+                <a:latin typeface="Fira Sans"/>
+              </a:rPr>
+              <a:t>Con lo de hoy ya se puede leer completo el summary de cualquier modelo.</a:t>
+            </a:r>
+          </a:p>
+          <a:p>
+            <a:pPr>
+              <a:lnSpc>
+                <a:spcPct val="112000"/>
+              </a:lnSpc>
+              <a:spcAft>
+                <a:spcPts val="900"/>
+              </a:spcAft>
+            </a:pPr>
+            <a:r>
+              <a:rPr sz="1800" b="1">
+                <a:solidFill>
+                  <a:srgbClr val="E0A437"/>
+                </a:solidFill>
+                <a:latin typeface="Fira Sans"/>
+              </a:rPr>
+              <a:t>▸ </a:t>
+            </a:r>
+            <a:r>
+              <a:rPr sz="1800" b="1">
+                <a:solidFill>
+                  <a:srgbClr val="1D3557"/>
+                </a:solidFill>
+                <a:latin typeface="Fira Sans"/>
+              </a:rPr>
+              <a:t>El primer análisis exploratorio se entrega el lunes 15.</a:t>
+            </a:r>
+          </a:p>
+        </p:txBody>
+      </p:sp>
+    </p:spTree>
+  </p:cSld>
+  <p:clrMapOvr>
+    <a:masterClrMapping/>
+  </p:clrMapOvr>
+</p:sld>
+</file>
+
+<file path=ppt/slides/slide44.xml><?xml version="1.0" encoding="utf-8"?>
 <p:sld xmlns:a="http://schemas.openxmlformats.org/drawingml/2006/main" xmlns:p="http://schemas.openxmlformats.org/presentationml/2006/main" xmlns:r="http://schemas.openxmlformats.org/officeDocument/2006/relationships">
   <p:cSld>
     <p:spTree>

</xml_diff>